<commit_message>
docs: record the Day 3 re-measurement and refresh the report/PPT drafts
- Dual first query (gold 20 questions, OpenAI, off vs on, 1 run each): Scene
  Success@1 16/18 both, same two misses, search calls 80 -> 98, LLM calls and
  tokens unchanged. The flag stays off (ADR-0011).
- Chunk length (A/B only, Korean first query): 10/5 and 20/10 tie at 11/18,
  30/15 = 9, 40/20 = 5, so 20s/10s stays the default (ADR-0006).
- Report: fill the 3.3 latency/tool-call table, add the re-measurement to 3.4,
  appendix D (per-question results only) and E (chunk comparison), rewrite 5.1
  from the author's experience, move the 2.9 screenshots into appendix A.
- PPT: update slides 3 and 8 and backup B3 with the measured results.
- Generator scripts now resolve paths relative to docs/exec.

Co-Authored-By: Claude Sonnet 5.5 <noreply@anthropic.com>
</commit_message>
<xml_diff>
--- a/docs/exec/G078_문희주_발표.pptx
+++ b/docs/exec/G078_문희주_발표.pptx
@@ -858,7 +858,7 @@
           <a:lstStyle/>
           <a:p>
             <a:r>
-              <a:t>[백업] 질문 대비: 이중 첫 검색. Router 검색어가 번역 어휘와 달라 못 찾던 질문을, 질문 원문도 함께 검색해 보완한 시도입니다. 구현 중 점수 합산 방식에서 정답이 밀리는 문제를 실제 자막으로 확인해 순위 교차 방식으로 바꿨습니다. 정답 평가셋 재측정은 아직 하지 못했습니다.</a:t>
+              <a:t>[백업] 질문 대비: 이중 첫 검색. Router 검색어가 번역 어휘와 달라 못 찾던 질문을, 질문 원문도 함께 검색해 보완한 시도입니다. 구현 중 점수 합산 방식에서 정답이 밀리는 문제를 실제 자막으로 확인해 순위 교차 방식으로 바꿨습니다. 정답 평가셋 20문항으로 끈 실행과 켠 실행을 다시 측정했더니 1위 적중이 둘 다 16개로 같았고, 못 찾은 두 문항도 그대로였습니다. 검색만 80회에서 98회로 늘었고 LLM 호출과 토큰은 같아서 기본값은 꺼 두었습니다. 마니또처럼 못 찾던 질문이 찾아진 것은 평가셋 밖 직접 실행에서만 확인했습니다.</a:t>
             </a:r>
           </a:p>
         </p:txBody>
@@ -1068,7 +1068,7 @@
           <a:lstStyle/>
           <a:p>
             <a:r>
-              <a:t>[45초] 개선 전 v2와 후 v3를 같은 20문항 평가셋으로 비교했습니다. 1위 적중은 16개로 같았지만, 화자 질문 처리가 2개에서 3개로 늘었고, LLM 호출은 50회에서 42회로 16% 줄었습니다. 대신 입력 토큰은 24% 늘었습니다. 오른쪽은 같은 첫 검색어로 시작한 세 방식 비교로, 키워드 13, Hybrid 15, Agent 16입니다. 1에서 5문항 차이이고 한 번만 실행해서 우위를 단정하지는 않습니다. 대신 근거 없이 화자를 단정한 경우는 0건이었습니다.</a:t>
+              <a:t>[45초] 개선 전 v2와 후 v3를 같은 20문항 평가셋으로 비교했습니다. 1위 적중은 16개로 같았지만 화자 질문 처리가 2개에서 3개로 늘었고, LLM 호출은 16% 줄었습니다. 대신 입력 토큰은 24% 늘었습니다. 오른쪽은 같은 첫 검색어로 비교한 결과로 키워드 13, Hybrid 15, Agent 16입니다. 차이가 1에서 5문항이고 한 번만 실행해서 우위는 단정하지 않습니다. 이중 첫 검색을 켜도 16으로 같았습니다. 근거 없이 화자를 단정한 경우는 0건이었습니다.</a:t>
             </a:r>
           </a:p>
         </p:txBody>
@@ -1418,7 +1418,7 @@
           <a:lstStyle/>
           <a:p>
             <a:r>
-              <a:t>[45초] 한계와 이후입니다. 한계는 세 가지입니다. Agent 우위는 1에서 5문항 차이라 우연일 수 있고, 지연과 토큰이 늘었으며, 후속 질문이나 번역 어휘 차이에서 틀리거나 못 찾는 경우가 있습니다. 이후에는 Supervisor 구조 비교, 청크 길이 비교, 이중 첫 검색 재측정을 하려고 합니다. 이번에 가장 크게 배운 것은 문제가 구조보다 번역 자막의 단어 같은 데이터에 있었다는 점입니다. 감사합니다.</a:t>
+              <a:t>[45초] 한계와 결과입니다. 한계는 세 가지입니다. Agent 우위는 우연일 수 있고, 지연과 토큰이 늘었으며, 후속 질문이나 번역 어휘 차이에서 틀리거나 못 찾는 경우가 있습니다. 측정도 두 가지 마쳤습니다. 청크 길이는 20초와 10초를 유지했고, 이중 첫 검색은 16에서 16으로 이득이 없어 기본값을 끈 채 두었습니다. 이후에는 Supervisor 구조를 비교하려고 합니다. 가장 크게 배운 것은 문제가 구조보다 번역 자막의 단어 같은 데이터에 있었다는 점입니다. 감사합니다.</a:t>
             </a:r>
           </a:p>
         </p:txBody>
@@ -6484,7 +6484,7 @@
                 <a:ea typeface="Malgun Gothic"/>
                 <a:cs typeface="Malgun Gothic"/>
               </a:rPr>
-              <a:t>정답 평가셋 재측정은 미실시</a:t>
+              <a:t>평가셋 20문항: 16 → 16, 이득 없음</a:t>
             </a:r>
           </a:p>
         </p:txBody>
@@ -9076,8 +9076,8 @@
         </p:nvSpPr>
         <p:spPr>
           <a:xfrm>
-            <a:off x="6492240" y="5440680"/>
-            <a:ext cx="5029200" cy="731520"/>
+            <a:off x="6492240" y="5394960"/>
+            <a:ext cx="5029200" cy="822960"/>
           </a:xfrm>
           <a:prstGeom prst="rect">
             <a:avLst/>
@@ -9090,9 +9090,13 @@
           </a:bodyPr>
           <a:lstStyle/>
           <a:p>
-            <a:pPr algn="l"/>
-            <a:r>
-              <a:rPr sz="1600" b="0">
+            <a:pPr algn="l">
+              <a:spcAft>
+                <a:spcPts val="300"/>
+              </a:spcAft>
+            </a:pPr>
+            <a:r>
+              <a:rPr sz="1500" b="0">
                 <a:solidFill>
                   <a:srgbClr val="1C2540"/>
                 </a:solidFill>
@@ -9101,6 +9105,20 @@
                 <a:cs typeface="Malgun Gothic"/>
               </a:rPr>
               <a:t>1~5문항 차이, 1회 실행 → 우위 단정 안 함</a:t>
+            </a:r>
+          </a:p>
+          <a:p>
+            <a:pPr algn="l"/>
+            <a:r>
+              <a:rPr sz="1500" b="0">
+                <a:solidFill>
+                  <a:srgbClr val="1C2540"/>
+                </a:solidFill>
+                <a:latin typeface="Malgun Gothic"/>
+                <a:ea typeface="Malgun Gothic"/>
+                <a:cs typeface="Malgun Gothic"/>
+              </a:rPr>
+              <a:t>이중 첫 검색을 켜도 16 → 16, 검색만 80 → 98회</a:t>
             </a:r>
           </a:p>
         </p:txBody>
@@ -13463,7 +13481,7 @@
                 <a:ea typeface="Malgun Gothic"/>
                 <a:cs typeface="Malgun Gothic"/>
               </a:rPr>
-              <a:t>이후 개선</a:t>
+              <a:t>측정 결과와 이후</a:t>
             </a:r>
           </a:p>
         </p:txBody>
@@ -13651,7 +13669,7 @@
                 <a:ea typeface="Malgun Gothic"/>
                 <a:cs typeface="Malgun Gothic"/>
               </a:rPr>
-              <a:t>Supervisor 구조 비교</a:t>
+              <a:t>이후: Supervisor 구조 비교</a:t>
             </a:r>
           </a:p>
           <a:p>
@@ -13853,7 +13871,7 @@
                 <a:ea typeface="Malgun Gothic"/>
                 <a:cs typeface="Malgun Gothic"/>
               </a:rPr>
-              <a:t>청크 길이·RRF 비교</a:t>
+              <a:t>청크 길이: 20초/10초 유지</a:t>
             </a:r>
           </a:p>
           <a:p>
@@ -13867,7 +13885,7 @@
                 <a:ea typeface="Malgun Gothic"/>
                 <a:cs typeface="Malgun Gothic"/>
               </a:rPr>
-              <a:t>설정과 스크립트 준비, 맥북에서 측정</a:t>
+              <a:t>10/5와 같고 30/15·40/20은 하락 (B, 18문항)</a:t>
             </a:r>
           </a:p>
         </p:txBody>
@@ -13968,7 +13986,7 @@
                 <a:ea typeface="Malgun Gothic"/>
                 <a:cs typeface="Malgun Gothic"/>
               </a:rPr>
-              <a:t>후속 질문, 번역 어휘 차이</a:t>
+              <a:t>후속 질문, 번역 어휘 차이 (이중 검색도 해결 못 함)</a:t>
             </a:r>
           </a:p>
         </p:txBody>
@@ -14055,7 +14073,7 @@
                 <a:ea typeface="Malgun Gothic"/>
                 <a:cs typeface="Malgun Gothic"/>
               </a:rPr>
-              <a:t>이중 첫 검색 재측정</a:t>
+              <a:t>이중 첫 검색: 평가셋 이득 없음</a:t>
             </a:r>
           </a:p>
           <a:p>
@@ -14069,7 +14087,7 @@
                 <a:ea typeface="Malgun Gothic"/>
                 <a:cs typeface="Malgun Gothic"/>
               </a:rPr>
-              <a:t>질문 원문을 함께 검색, 평가셋으로 확인</a:t>
+              <a:t>16 → 16, 검색 +1회 → 기본 꺼짐 유지</a:t>
             </a:r>
           </a:p>
         </p:txBody>

</xml_diff>

<commit_message>
docs: apply review feedback to the report, add a compact variant, rework the PPT
- Report: summary now includes the found-precision drop (16/16 -> 16/17) and
  limits the safety claim to what was measured; metric definitions (3.1);
  fairness notes for A/B latency and the dual-query comparison; clarified what
  source-cue verification does and does not guarantee; cue selection details,
  top-3 limit and a failure-type check (4.2); shorter Multi-Agent section;
  reproducibility table (appendix B); fixed the gold-label provenance wording.
- Add make_report_compact.py and a 25-page compact variant (docx/PDF preview)
  next to the original so both can be compared.
- PPT: restructure into 2 min (topic, tasks, results) + 3 min (Agent Graph,
  MCP, RAG code); move the limits slide to the backup section.
- Remove self-referential sentences from the report text.

Co-Authored-By: Claude Sonnet 5.5 <noreply@anthropic.com>
</commit_message>
<xml_diff>
--- a/docs/exec/G078_문희주_발표.pptx
+++ b/docs/exec/G078_문희주_발표.pptx
@@ -998,7 +998,7 @@
           <a:lstStyle/>
           <a:p>
             <a:r>
-              <a:t>[35초] 팬들은 "마니또를 뽑다가 자기 자신을 뽑은 장면"처럼 상황만 기억하고, 제목이나 대사는 모릅니다. 한국어로 장면을 설명하면 자막에서 후보를 찾고, 원본 자막과 다시 대조해 검증한 시점을 알려 줍니다. 오른쪽이 실제 화면입니다. 다만 확보한 자막이 영어 번역본이고 말한 사람 표시가 없어서, 화자는 단정하지 않고 확인 불가로 안내합니다.</a:t>
+              <a:t>[40초] 팬들은 "마니또를 뽑다가 자기 자신을 뽑은 장면"처럼 상황만 기억하고 제목이나 대사는 모릅니다. 그래서 장면을 한국어로 설명하면 자막에서 후보를 찾고, 원본 자막과 다시 대조해 검증한 영상 시점을 알려 주는 Agent를 만들었습니다. 세부 task는 자막 파싱과 청킹, 하이브리드 검색, LangGraph Agent, MCP 서버, 웹 화면과 실시간 전송, 평가와 추적입니다. 자막이 영어 번역본이고 화자 표시가 없어서 화자는 단정하지 않습니다.</a:t>
             </a:r>
           </a:p>
         </p:txBody>
@@ -1068,7 +1068,7 @@
           <a:lstStyle/>
           <a:p>
             <a:r>
-              <a:t>[45초] 개선 전 v2와 후 v3를 같은 20문항 평가셋으로 비교했습니다. 1위 적중은 16개로 같았지만 화자 질문 처리가 2개에서 3개로 늘었고, LLM 호출은 16% 줄었습니다. 대신 입력 토큰은 24% 늘었습니다. 오른쪽은 같은 첫 검색어로 비교한 결과로 키워드 13, Hybrid 15, Agent 16입니다. 차이가 1에서 5문항이고 한 번만 실행해서 우위는 단정하지 않습니다. 이중 첫 검색을 켜도 16으로 같았습니다. 근거 없이 화자를 단정한 경우는 0건이었습니다.</a:t>
+              <a:t>[65초] 결과입니다. 같은 20문항 평가셋으로 Agent는 장면 질문 18개 중 16개를 1위로 맞혔고, 일반 검색은 11에서 15개였습니다. 차이가 1에서 5문항이고 한 번만 실행해서 우위는 단정하지 않습니다. 개선 전후로는 화자 질문 처리가 2개에서 3개로 늘고 LLM 호출이 16% 줄었지만 입력 토큰은 24% 늘었습니다. 근거 없이 화자를 단정한 경우는 0건이었습니다. 오늘 다시 측정한 이중 첫 검색은 켜도 16으로 같고 검색만 늘어 꺼 두었고, 청크는 20초와 10초를 유지했습니다. 한계는 후속 질문과 번역 어휘 차이, 그리고 Multi-Agent를 구현하지 않은 점입니다.</a:t>
             </a:r>
           </a:p>
         </p:txBody>
@@ -1138,7 +1138,7 @@
           <a:lstStyle/>
           <a:p>
             <a:r>
-              <a:t>[25초] 전체 구조입니다. 화면에서 질문이 오면 FastAPI가 LangGraph Agent를 호출하고, Agent는 MCP 서버를 통해서만 자막을 조회합니다. LLM은 환경변수 하나로 Ollama와 OpenAI를 바꾸도록 의존성 주입으로 설계했고, 백엔드 177개와 프런트 43개 테스트로 검증했습니다. 이제 핵심 코드를 설명드리겠습니다.</a:t>
+              <a:t>[15초] 전체 구조입니다. 화면의 질문은 FastAPI를 거쳐 LangGraph Agent로 가고, Agent는 MCP 서버를 통해서만 자막을 조회합니다. 이제 핵심 코드 세 가지, Agent Graph와 MCP, RAG를 설명드리겠습니다.</a:t>
             </a:r>
           </a:p>
         </p:txBody>
@@ -1208,7 +1208,7 @@
           <a:lstStyle/>
           <a:p>
             <a:r>
-              <a:t>[40초] Agent Graph입니다. LangGraph의 StateGraph에 분류, 검색, 원본 대조, 판정, 재검색, 정리 노드를 만들었습니다. 다음 노드는 add_conditional_edges의 조건 함수가 정하고, 판정에서 관련 후보가 없고 시간이 남을 때만 재검색으로 갑니다. 재검색은 최대 2번입니다. LLM이 판단하는 곳은 분류, 판정, 검색어 재작성 세 군데뿐이고, 인용과 시각은 코드가 원본에서 만듭니다. Multi-Agent가 아닌 단일 워크플로입니다.</a:t>
+              <a:t>[65초] Agent Graph입니다. 코드를 보면 StateGraph에 분류, 검색, 원본 대조, 판정, 재검색, 정리 여섯 노드를 add_node로 등록합니다. 다음 노드는 add_conditional_edges의 조건 함수가 정합니다. 분류에서 자막으로 알 수 없는 요청이면 곧바로 정리로 가고, 판정에서 관련 후보가 없고 시간이 남아 있을 때만 재검색으로 갑니다. MAX_REPLAN_ROUNDS가 2라서 재검색은 최대 두 번입니다. LLM이 판단하는 곳은 분류, 판정, 검색어 재작성 세 군데뿐이고, 인용과 시각은 코드가 원본 cue에서 만듭니다. Multi-Agent가 아닌 단일 워크플로입니다.</a:t>
             </a:r>
           </a:p>
         </p:txBody>
@@ -1278,7 +1278,7 @@
           <a:lstStyle/>
           <a:p>
             <a:r>
-              <a:t>[40초] MCP입니다. 공식 SDK 2.x의 MCPServer로 읽기 전용 도구 네 개를 만들고, 로컬 프로세스로 띄워 stdio로 통신합니다. Agent는 검색과 원본 조회 두 개를 쓰고, 나머지 두 개는 서버 시작과 화면의 앞뒤 자막용입니다. 핵심은 검색 결과를 그대로 믿지 않는 것입니다. 검색 도구가 준 청크는 가공된 텍스트라서, 인용과 시각은 get_scene_context의 원본 cue로 다시 확인합니다.</a:t>
+              <a:t>[50초] MCP입니다. 공식 SDK 2.x의 MCPServer에서 server.tool 데코레이터로 읽기 전용 도구 네 개를 만들고, 로컬 프로세스로 띄워 stdio로 통신합니다. Agent는 검색과 원본 조회 두 개를 쓰고, 나머지 두 개는 화면용입니다. 핵심은 검색 결과를 그대로 믿지 않는 것입니다. search_transcripts가 준 청크는 가공된 텍스트라서, 인용과 시각은 get_scene_context가 돌려주는 원본 cue로 다시 확인합니다. 검색은 계산이 무거워 동시에 한 건만 실행하도록 제한했습니다.</a:t>
             </a:r>
           </a:p>
         </p:txBody>
@@ -1348,7 +1348,7 @@
           <a:lstStyle/>
           <a:p>
             <a:r>
-              <a:t>[40초] RAG입니다. 자막 3,750줄을 영상별로 20초씩, 10초 겹치게 묶어 청크 869개를 만들었습니다. 키워드 검색 상위 20개와 의미 검색 상위 20개를 RRF로 합치는데, 코드의 한 줄처럼 순위가 r인 후보에 1 나누기 60 더하기 r 점수를 주고 더합니다. 청크는 cue 번호를 가지고 있어 결과가 항상 원본 자막 줄로 돌아갑니다. 20초, 10초, 60은 설계 때 정한 값이고 비교하지는 못했습니다.</a:t>
+              <a:t>[55초] RAG입니다. 자막 3,750줄을 영상별로 20초씩, 10초 겹치게 묶어 청크 869개를 만들었습니다. 키워드 검색 상위 20개와 의미 검색 상위 20개를 RRF로 합치는데, 순위가 r인 후보에 1 나누기 60 더하기 r 점수를 주고 더합니다. 청크는 cue 번호를 가지고 있어 결과가 항상 원본 자막 줄로 돌아갑니다. 청크 길이는 10초 5초, 30초 15초, 40초 20초와도 비교했고 20초 10초를 유지했습니다. 가장 크게 배운 것은 문제가 구조보다 번역 자막의 단어 같은 데이터에 있었다는 점입니다. 감사합니다.</a:t>
             </a:r>
           </a:p>
         </p:txBody>
@@ -1418,7 +1418,7 @@
           <a:lstStyle/>
           <a:p>
             <a:r>
-              <a:t>[45초] 한계와 결과입니다. 한계는 세 가지입니다. Agent 우위는 우연일 수 있고, 지연과 토큰이 늘었으며, 후속 질문이나 번역 어휘 차이에서 틀리거나 못 찾는 경우가 있습니다. 측정도 두 가지 마쳤습니다. 청크 길이는 20초와 10초를 유지했고, 이중 첫 검색은 16에서 16으로 이득이 없어 기본값을 끈 채 두었습니다. 이후에는 Supervisor 구조를 비교하려고 합니다. 가장 크게 배운 것은 문제가 구조보다 번역 자막의 단어 같은 데이터에 있었다는 점입니다. 감사합니다.</a:t>
+              <a:t>[백업] 질문 대비: 한계와 측정 결과. 한계는 세 가지입니다. Agent 우위는 우연일 수 있고, 지연과 토큰이 늘었으며, 후속 질문이나 번역 어휘 차이에서 틀리거나 못 찾는 경우가 있습니다. 측정도 두 가지 마쳤습니다. 청크 길이는 20초와 10초를 유지했고, 이중 첫 검색은 16에서 16으로 이득이 없어 기본값을 끈 채 두었습니다. 이후에는 서비스가 여러 장면을 연결해 조사하는 형태로 커질 때 Supervisor 구조를 비교하려고 합니다.</a:t>
             </a:r>
           </a:p>
         </p:txBody>
@@ -5789,7 +5789,7 @@
                 <a:ea typeface="Malgun Gothic"/>
                 <a:cs typeface="Malgun Gothic"/>
               </a:rPr>
-              <a:t>백엔드 177개 통과 (1개 건너뜀) · 프런트 43개 통과</a:t>
+              <a:t>백엔드 178개 통과 · 프런트 43개 통과</a:t>
             </a:r>
           </a:p>
           <a:p>
@@ -7162,7 +7162,7 @@
                           <a:ea typeface="Malgun Gothic"/>
                           <a:cs typeface="Malgun Gothic"/>
                         </a:rPr>
-                        <a:t>백엔드 177 · 프런트 43</a:t>
+                        <a:t>백엔드 178 · 프런트 43</a:t>
                       </a:r>
                     </a:p>
                   </a:txBody>
@@ -7499,8 +7499,8 @@
         </p:nvSpPr>
         <p:spPr>
           <a:xfrm>
-            <a:off x="548640" y="1508760"/>
-            <a:ext cx="5029200" cy="1371600"/>
+            <a:off x="548640" y="1417320"/>
+            <a:ext cx="5394960" cy="1097280"/>
           </a:xfrm>
           <a:prstGeom prst="roundRect">
             <a:avLst>
@@ -7545,8 +7545,8 @@
         </p:nvSpPr>
         <p:spPr>
           <a:xfrm>
-            <a:off x="777240" y="1709928"/>
-            <a:ext cx="868680" cy="384048"/>
+            <a:off x="777240" y="1545336"/>
+            <a:ext cx="868680" cy="365760"/>
           </a:xfrm>
           <a:prstGeom prst="roundRect">
             <a:avLst>
@@ -7581,7 +7581,7 @@
           <a:p>
             <a:pPr algn="ctr"/>
             <a:r>
-              <a:rPr sz="1600" b="1">
+              <a:rPr sz="1500" b="1">
                 <a:solidFill>
                   <a:srgbClr val="FFFFFF"/>
                 </a:solidFill>
@@ -7602,8 +7602,8 @@
         </p:nvSpPr>
         <p:spPr>
           <a:xfrm>
-            <a:off x="777240" y="2194560"/>
-            <a:ext cx="4663440" cy="640080"/>
+            <a:off x="777240" y="1965960"/>
+            <a:ext cx="5029200" cy="502920"/>
           </a:xfrm>
           <a:prstGeom prst="rect">
             <a:avLst/>
@@ -7618,11 +7618,11 @@
           <a:p>
             <a:pPr algn="l">
               <a:lnSpc>
-                <a:spcPct val="105000"/>
+                <a:spcPct val="100000"/>
               </a:lnSpc>
             </a:pPr>
             <a:r>
-              <a:rPr sz="1700" b="0">
+              <a:rPr sz="1500" b="0">
                 <a:solidFill>
                   <a:srgbClr val="1C2540"/>
                 </a:solidFill>
@@ -7644,8 +7644,8 @@
         </p:nvSpPr>
         <p:spPr>
           <a:xfrm>
-            <a:off x="548640" y="3081528"/>
-            <a:ext cx="5029200" cy="1371600"/>
+            <a:off x="548640" y="2606040"/>
+            <a:ext cx="5394960" cy="1097280"/>
           </a:xfrm>
           <a:prstGeom prst="roundRect">
             <a:avLst>
@@ -7690,8 +7690,8 @@
         </p:nvSpPr>
         <p:spPr>
           <a:xfrm>
-            <a:off x="777240" y="3282696"/>
-            <a:ext cx="868680" cy="384048"/>
+            <a:off x="777240" y="2734056"/>
+            <a:ext cx="868680" cy="365760"/>
           </a:xfrm>
           <a:prstGeom prst="roundRect">
             <a:avLst>
@@ -7726,7 +7726,7 @@
           <a:p>
             <a:pPr algn="ctr"/>
             <a:r>
-              <a:rPr sz="1600" b="1">
+              <a:rPr sz="1500" b="1">
                 <a:solidFill>
                   <a:srgbClr val="FFFFFF"/>
                 </a:solidFill>
@@ -7747,8 +7747,8 @@
         </p:nvSpPr>
         <p:spPr>
           <a:xfrm>
-            <a:off x="777240" y="3767328"/>
-            <a:ext cx="4663440" cy="640080"/>
+            <a:off x="777240" y="3154680"/>
+            <a:ext cx="5029200" cy="502920"/>
           </a:xfrm>
           <a:prstGeom prst="rect">
             <a:avLst/>
@@ -7763,11 +7763,11 @@
           <a:p>
             <a:pPr algn="l">
               <a:lnSpc>
-                <a:spcPct val="105000"/>
+                <a:spcPct val="100000"/>
               </a:lnSpc>
             </a:pPr>
             <a:r>
-              <a:rPr sz="1700" b="0">
+              <a:rPr sz="1500" b="0">
                 <a:solidFill>
                   <a:srgbClr val="1C2540"/>
                 </a:solidFill>
@@ -7789,8 +7789,8 @@
         </p:nvSpPr>
         <p:spPr>
           <a:xfrm>
-            <a:off x="548640" y="4654296"/>
-            <a:ext cx="5029200" cy="1371600"/>
+            <a:off x="548640" y="3794760"/>
+            <a:ext cx="5394960" cy="1097280"/>
           </a:xfrm>
           <a:prstGeom prst="roundRect">
             <a:avLst>
@@ -7835,8 +7835,8 @@
         </p:nvSpPr>
         <p:spPr>
           <a:xfrm>
-            <a:off x="777240" y="4855464"/>
-            <a:ext cx="868680" cy="384048"/>
+            <a:off x="777240" y="3922776"/>
+            <a:ext cx="868680" cy="365760"/>
           </a:xfrm>
           <a:prstGeom prst="roundRect">
             <a:avLst>
@@ -7871,7 +7871,7 @@
           <a:p>
             <a:pPr algn="ctr"/>
             <a:r>
-              <a:rPr sz="1600" b="1">
+              <a:rPr sz="1500" b="1">
                 <a:solidFill>
                   <a:srgbClr val="FFFFFF"/>
                 </a:solidFill>
@@ -7892,8 +7892,8 @@
         </p:nvSpPr>
         <p:spPr>
           <a:xfrm>
-            <a:off x="777240" y="5340096"/>
-            <a:ext cx="4663440" cy="640080"/>
+            <a:off x="777240" y="4343400"/>
+            <a:ext cx="5029200" cy="502920"/>
           </a:xfrm>
           <a:prstGeom prst="rect">
             <a:avLst/>
@@ -7908,11 +7908,11 @@
           <a:p>
             <a:pPr algn="l">
               <a:lnSpc>
-                <a:spcPct val="105000"/>
+                <a:spcPct val="100000"/>
               </a:lnSpc>
             </a:pPr>
             <a:r>
-              <a:rPr sz="1700" b="0">
+              <a:rPr sz="1500" b="0">
                 <a:solidFill>
                   <a:srgbClr val="1C2540"/>
                 </a:solidFill>
@@ -7942,8 +7942,8 @@
         </p:blipFill>
         <p:spPr>
           <a:xfrm>
-            <a:off x="5852160" y="1463040"/>
-            <a:ext cx="5852160" cy="3657600"/>
+            <a:off x="6400800" y="1417320"/>
+            <a:ext cx="5303520" cy="3314700"/>
           </a:xfrm>
           <a:prstGeom prst="rect">
             <a:avLst/>
@@ -7963,8 +7963,8 @@
         </p:nvSpPr>
         <p:spPr>
           <a:xfrm>
-            <a:off x="5852160" y="5257800"/>
-            <a:ext cx="5852160" cy="640080"/>
+            <a:off x="6400800" y="4754880"/>
+            <a:ext cx="5303520" cy="320040"/>
           </a:xfrm>
           <a:prstGeom prst="rect">
             <a:avLst/>
@@ -7979,7 +7979,7 @@
           <a:p>
             <a:pPr algn="l"/>
             <a:r>
-              <a:rPr sz="1300" b="0">
+              <a:rPr sz="1200" b="0">
                 <a:solidFill>
                   <a:srgbClr val="5A6580"/>
                 </a:solidFill>
@@ -7987,7 +7987,386 @@
                 <a:ea typeface="Malgun Gothic"/>
                 <a:cs typeface="Malgun Gothic"/>
               </a:rPr>
-              <a:t>결과 화면: 검증된 장면 카드, 선택 장면의 영상, 근거가 된 원본 앞뒤 자막</a:t>
+              <a:t>결과 화면: 검증된 장면 카드, 영상, 근거가 된 원본 앞뒤 자막</a:t>
+            </a:r>
+          </a:p>
+        </p:txBody>
+      </p:sp>
+      <p:sp>
+        <p:nvSpPr>
+          <p:cNvPr id="16" name="TextBox 15"/>
+          <p:cNvSpPr txBox="1"/>
+          <p:nvPr/>
+        </p:nvSpPr>
+        <p:spPr>
+          <a:xfrm>
+            <a:off x="548640" y="5138928"/>
+            <a:ext cx="5486400" cy="365760"/>
+          </a:xfrm>
+          <a:prstGeom prst="rect">
+            <a:avLst/>
+          </a:prstGeom>
+          <a:noFill/>
+        </p:spPr>
+        <p:txBody>
+          <a:bodyPr wrap="square" anchor="t" lIns="0" rIns="0" tIns="0" bIns="0">
+            <a:spAutoFit/>
+          </a:bodyPr>
+          <a:lstStyle/>
+          <a:p>
+            <a:pPr algn="l"/>
+            <a:r>
+              <a:rPr sz="1600" b="1">
+                <a:solidFill>
+                  <a:srgbClr val="1C2540"/>
+                </a:solidFill>
+                <a:latin typeface="Malgun Gothic"/>
+                <a:ea typeface="Malgun Gothic"/>
+                <a:cs typeface="Malgun Gothic"/>
+              </a:rPr>
+              <a:t>세부 task</a:t>
+            </a:r>
+          </a:p>
+        </p:txBody>
+      </p:sp>
+      <p:sp>
+        <p:nvSpPr>
+          <p:cNvPr id="17" name="Rounded Rectangle 16"/>
+          <p:cNvSpPr/>
+          <p:nvPr/>
+        </p:nvSpPr>
+        <p:spPr>
+          <a:xfrm>
+            <a:off x="548640" y="5577840"/>
+            <a:ext cx="1764792" cy="502920"/>
+          </a:xfrm>
+          <a:prstGeom prst="roundRect">
+            <a:avLst>
+              <a:gd name="adj" fmla="val 30000"/>
+            </a:avLst>
+          </a:prstGeom>
+          <a:solidFill>
+            <a:srgbClr val="6B7692"/>
+          </a:solidFill>
+          <a:ln>
+            <a:noFill/>
+          </a:ln>
+          <a:effectLst/>
+        </p:spPr>
+        <p:style>
+          <a:lnRef idx="1">
+            <a:schemeClr val="accent1"/>
+          </a:lnRef>
+          <a:fillRef idx="3">
+            <a:schemeClr val="accent1"/>
+          </a:fillRef>
+          <a:effectRef idx="2">
+            <a:schemeClr val="accent1"/>
+          </a:effectRef>
+          <a:fontRef idx="minor">
+            <a:schemeClr val="lt1"/>
+          </a:fontRef>
+        </p:style>
+        <p:txBody>
+          <a:bodyPr rtlCol="0" anchor="ctr" lIns="45720" rIns="45720" tIns="18288" bIns="18288"/>
+          <a:lstStyle/>
+          <a:p>
+            <a:pPr algn="ctr"/>
+            <a:r>
+              <a:rPr sz="1400" b="1">
+                <a:solidFill>
+                  <a:srgbClr val="FFFFFF"/>
+                </a:solidFill>
+                <a:latin typeface="Malgun Gothic"/>
+                <a:ea typeface="Malgun Gothic"/>
+                <a:cs typeface="Malgun Gothic"/>
+              </a:rPr>
+              <a:t>파싱·청킹</a:t>
+            </a:r>
+          </a:p>
+        </p:txBody>
+      </p:sp>
+      <p:sp>
+        <p:nvSpPr>
+          <p:cNvPr id="18" name="Rounded Rectangle 17"/>
+          <p:cNvSpPr/>
+          <p:nvPr/>
+        </p:nvSpPr>
+        <p:spPr>
+          <a:xfrm>
+            <a:off x="2404872" y="5577840"/>
+            <a:ext cx="1764792" cy="502920"/>
+          </a:xfrm>
+          <a:prstGeom prst="roundRect">
+            <a:avLst>
+              <a:gd name="adj" fmla="val 30000"/>
+            </a:avLst>
+          </a:prstGeom>
+          <a:solidFill>
+            <a:srgbClr val="2FA05F"/>
+          </a:solidFill>
+          <a:ln>
+            <a:noFill/>
+          </a:ln>
+          <a:effectLst/>
+        </p:spPr>
+        <p:style>
+          <a:lnRef idx="1">
+            <a:schemeClr val="accent1"/>
+          </a:lnRef>
+          <a:fillRef idx="3">
+            <a:schemeClr val="accent1"/>
+          </a:fillRef>
+          <a:effectRef idx="2">
+            <a:schemeClr val="accent1"/>
+          </a:effectRef>
+          <a:fontRef idx="minor">
+            <a:schemeClr val="lt1"/>
+          </a:fontRef>
+        </p:style>
+        <p:txBody>
+          <a:bodyPr rtlCol="0" anchor="ctr" lIns="45720" rIns="45720" tIns="18288" bIns="18288"/>
+          <a:lstStyle/>
+          <a:p>
+            <a:pPr algn="ctr"/>
+            <a:r>
+              <a:rPr sz="1400" b="1">
+                <a:solidFill>
+                  <a:srgbClr val="FFFFFF"/>
+                </a:solidFill>
+                <a:latin typeface="Malgun Gothic"/>
+                <a:ea typeface="Malgun Gothic"/>
+                <a:cs typeface="Malgun Gothic"/>
+              </a:rPr>
+              <a:t>Hybrid 검색</a:t>
+            </a:r>
+          </a:p>
+        </p:txBody>
+      </p:sp>
+      <p:sp>
+        <p:nvSpPr>
+          <p:cNvPr id="19" name="Rounded Rectangle 18"/>
+          <p:cNvSpPr/>
+          <p:nvPr/>
+        </p:nvSpPr>
+        <p:spPr>
+          <a:xfrm>
+            <a:off x="4261103" y="5577840"/>
+            <a:ext cx="1764792" cy="502920"/>
+          </a:xfrm>
+          <a:prstGeom prst="roundRect">
+            <a:avLst>
+              <a:gd name="adj" fmla="val 30000"/>
+            </a:avLst>
+          </a:prstGeom>
+          <a:solidFill>
+            <a:srgbClr val="3B6CF6"/>
+          </a:solidFill>
+          <a:ln>
+            <a:noFill/>
+          </a:ln>
+          <a:effectLst/>
+        </p:spPr>
+        <p:style>
+          <a:lnRef idx="1">
+            <a:schemeClr val="accent1"/>
+          </a:lnRef>
+          <a:fillRef idx="3">
+            <a:schemeClr val="accent1"/>
+          </a:fillRef>
+          <a:effectRef idx="2">
+            <a:schemeClr val="accent1"/>
+          </a:effectRef>
+          <a:fontRef idx="minor">
+            <a:schemeClr val="lt1"/>
+          </a:fontRef>
+        </p:style>
+        <p:txBody>
+          <a:bodyPr rtlCol="0" anchor="ctr" lIns="45720" rIns="45720" tIns="18288" bIns="18288"/>
+          <a:lstStyle/>
+          <a:p>
+            <a:pPr algn="ctr"/>
+            <a:r>
+              <a:rPr sz="1400" b="1">
+                <a:solidFill>
+                  <a:srgbClr val="FFFFFF"/>
+                </a:solidFill>
+                <a:latin typeface="Malgun Gothic"/>
+                <a:ea typeface="Malgun Gothic"/>
+                <a:cs typeface="Malgun Gothic"/>
+              </a:rPr>
+              <a:t>LangGraph</a:t>
+            </a:r>
+          </a:p>
+        </p:txBody>
+      </p:sp>
+      <p:sp>
+        <p:nvSpPr>
+          <p:cNvPr id="20" name="Rounded Rectangle 19"/>
+          <p:cNvSpPr/>
+          <p:nvPr/>
+        </p:nvSpPr>
+        <p:spPr>
+          <a:xfrm>
+            <a:off x="6117336" y="5577840"/>
+            <a:ext cx="1764792" cy="502920"/>
+          </a:xfrm>
+          <a:prstGeom prst="roundRect">
+            <a:avLst>
+              <a:gd name="adj" fmla="val 30000"/>
+            </a:avLst>
+          </a:prstGeom>
+          <a:solidFill>
+            <a:srgbClr val="2FA05F"/>
+          </a:solidFill>
+          <a:ln>
+            <a:noFill/>
+          </a:ln>
+          <a:effectLst/>
+        </p:spPr>
+        <p:style>
+          <a:lnRef idx="1">
+            <a:schemeClr val="accent1"/>
+          </a:lnRef>
+          <a:fillRef idx="3">
+            <a:schemeClr val="accent1"/>
+          </a:fillRef>
+          <a:effectRef idx="2">
+            <a:schemeClr val="accent1"/>
+          </a:effectRef>
+          <a:fontRef idx="minor">
+            <a:schemeClr val="lt1"/>
+          </a:fontRef>
+        </p:style>
+        <p:txBody>
+          <a:bodyPr rtlCol="0" anchor="ctr" lIns="45720" rIns="45720" tIns="18288" bIns="18288"/>
+          <a:lstStyle/>
+          <a:p>
+            <a:pPr algn="ctr"/>
+            <a:r>
+              <a:rPr sz="1400" b="1">
+                <a:solidFill>
+                  <a:srgbClr val="FFFFFF"/>
+                </a:solidFill>
+                <a:latin typeface="Malgun Gothic"/>
+                <a:ea typeface="Malgun Gothic"/>
+                <a:cs typeface="Malgun Gothic"/>
+              </a:rPr>
+              <a:t>MCP 서버</a:t>
+            </a:r>
+          </a:p>
+        </p:txBody>
+      </p:sp>
+      <p:sp>
+        <p:nvSpPr>
+          <p:cNvPr id="21" name="Rounded Rectangle 20"/>
+          <p:cNvSpPr/>
+          <p:nvPr/>
+        </p:nvSpPr>
+        <p:spPr>
+          <a:xfrm>
+            <a:off x="7973567" y="5577840"/>
+            <a:ext cx="1764792" cy="502920"/>
+          </a:xfrm>
+          <a:prstGeom prst="roundRect">
+            <a:avLst>
+              <a:gd name="adj" fmla="val 30000"/>
+            </a:avLst>
+          </a:prstGeom>
+          <a:solidFill>
+            <a:srgbClr val="E0951E"/>
+          </a:solidFill>
+          <a:ln>
+            <a:noFill/>
+          </a:ln>
+          <a:effectLst/>
+        </p:spPr>
+        <p:style>
+          <a:lnRef idx="1">
+            <a:schemeClr val="accent1"/>
+          </a:lnRef>
+          <a:fillRef idx="3">
+            <a:schemeClr val="accent1"/>
+          </a:fillRef>
+          <a:effectRef idx="2">
+            <a:schemeClr val="accent1"/>
+          </a:effectRef>
+          <a:fontRef idx="minor">
+            <a:schemeClr val="lt1"/>
+          </a:fontRef>
+        </p:style>
+        <p:txBody>
+          <a:bodyPr rtlCol="0" anchor="ctr" lIns="45720" rIns="45720" tIns="18288" bIns="18288"/>
+          <a:lstStyle/>
+          <a:p>
+            <a:pPr algn="ctr"/>
+            <a:r>
+              <a:rPr sz="1400" b="1">
+                <a:solidFill>
+                  <a:srgbClr val="FFFFFF"/>
+                </a:solidFill>
+                <a:latin typeface="Malgun Gothic"/>
+                <a:ea typeface="Malgun Gothic"/>
+                <a:cs typeface="Malgun Gothic"/>
+              </a:rPr>
+              <a:t>API·Vue·SSE</a:t>
+            </a:r>
+          </a:p>
+        </p:txBody>
+      </p:sp>
+      <p:sp>
+        <p:nvSpPr>
+          <p:cNvPr id="22" name="Rounded Rectangle 21"/>
+          <p:cNvSpPr/>
+          <p:nvPr/>
+        </p:nvSpPr>
+        <p:spPr>
+          <a:xfrm>
+            <a:off x="9829799" y="5577840"/>
+            <a:ext cx="1764792" cy="502920"/>
+          </a:xfrm>
+          <a:prstGeom prst="roundRect">
+            <a:avLst>
+              <a:gd name="adj" fmla="val 30000"/>
+            </a:avLst>
+          </a:prstGeom>
+          <a:solidFill>
+            <a:srgbClr val="6B7692"/>
+          </a:solidFill>
+          <a:ln>
+            <a:noFill/>
+          </a:ln>
+          <a:effectLst/>
+        </p:spPr>
+        <p:style>
+          <a:lnRef idx="1">
+            <a:schemeClr val="accent1"/>
+          </a:lnRef>
+          <a:fillRef idx="3">
+            <a:schemeClr val="accent1"/>
+          </a:fillRef>
+          <a:effectRef idx="2">
+            <a:schemeClr val="accent1"/>
+          </a:effectRef>
+          <a:fontRef idx="minor">
+            <a:schemeClr val="lt1"/>
+          </a:fontRef>
+        </p:style>
+        <p:txBody>
+          <a:bodyPr rtlCol="0" anchor="ctr" lIns="45720" rIns="45720" tIns="18288" bIns="18288"/>
+          <a:lstStyle/>
+          <a:p>
+            <a:pPr algn="ctr"/>
+            <a:r>
+              <a:rPr sz="1400" b="1">
+                <a:solidFill>
+                  <a:srgbClr val="FFFFFF"/>
+                </a:solidFill>
+                <a:latin typeface="Malgun Gothic"/>
+                <a:ea typeface="Malgun Gothic"/>
+                <a:cs typeface="Malgun Gothic"/>
+              </a:rPr>
+              <a:t>평가·추적</a:t>
             </a:r>
           </a:p>
         </p:txBody>
@@ -8054,7 +8433,7 @@
                 <a:ea typeface="Malgun Gothic"/>
                 <a:cs typeface="Malgun Gothic"/>
               </a:rPr>
-              <a:t>정답 수는 같고, 화자 처리와 호출 수는 나아졌다</a:t>
+              <a:t>결과: 16/18을 맞혔고, 근거 없는 화자 단정은 0건</a:t>
             </a:r>
           </a:p>
         </p:txBody>
@@ -8874,7 +9253,7 @@
         <p:spPr>
           <a:xfrm>
             <a:off x="7223760" y="4892040"/>
-            <a:ext cx="4480560" cy="274320"/>
+            <a:ext cx="4480560" cy="365760"/>
           </a:xfrm>
           <a:prstGeom prst="rect">
             <a:avLst/>
@@ -8897,7 +9276,7 @@
                 <a:ea typeface="Malgun Gothic"/>
                 <a:cs typeface="Malgun Gothic"/>
               </a:rPr>
-              <a:t>세 방식이 같은 영어 검색어로 시작한 조건</a:t>
+              <a:t>같은 영어 검색어 조건 · 1~5문항 차이, 1회 실행이라 우위 단정 안 함</a:t>
             </a:r>
           </a:p>
         </p:txBody>
@@ -8911,7 +9290,7 @@
         <p:spPr>
           <a:xfrm>
             <a:off x="548640" y="5349240"/>
-            <a:ext cx="5440680" cy="914400"/>
+            <a:ext cx="2697480" cy="960120"/>
           </a:xfrm>
           <a:prstGeom prst="roundRect">
             <a:avLst>
@@ -8956,8 +9335,8 @@
         </p:nvSpPr>
         <p:spPr>
           <a:xfrm>
-            <a:off x="777240" y="5440680"/>
-            <a:ext cx="1371600" cy="731520"/>
+            <a:off x="685800" y="5376672"/>
+            <a:ext cx="2423160" cy="411480"/>
           </a:xfrm>
           <a:prstGeom prst="rect">
             <a:avLst/>
@@ -8972,7 +9351,7 @@
           <a:p>
             <a:pPr algn="l"/>
             <a:r>
-              <a:rPr sz="3600" b="1">
+              <a:rPr sz="2200" b="1">
                 <a:solidFill>
                   <a:srgbClr val="2FA05F"/>
                 </a:solidFill>
@@ -8993,8 +9372,8 @@
         </p:nvSpPr>
         <p:spPr>
           <a:xfrm>
-            <a:off x="2148840" y="5440680"/>
-            <a:ext cx="3749039" cy="731520"/>
+            <a:off x="685800" y="5779008"/>
+            <a:ext cx="2423160" cy="502920"/>
           </a:xfrm>
           <a:prstGeom prst="rect">
             <a:avLst/>
@@ -9002,14 +9381,18 @@
           <a:noFill/>
         </p:spPr>
         <p:txBody>
-          <a:bodyPr wrap="square" anchor="ctr" lIns="0" rIns="0" tIns="0" bIns="0">
+          <a:bodyPr wrap="square" anchor="t" lIns="0" rIns="0" tIns="0" bIns="0">
             <a:spAutoFit/>
           </a:bodyPr>
           <a:lstStyle/>
           <a:p>
-            <a:pPr algn="l"/>
-            <a:r>
-              <a:rPr sz="1600" b="0">
+            <a:pPr algn="l">
+              <a:lnSpc>
+                <a:spcPct val="100000"/>
+              </a:lnSpc>
+            </a:pPr>
+            <a:r>
+              <a:rPr sz="1100" b="0">
                 <a:solidFill>
                   <a:srgbClr val="1C2540"/>
                 </a:solidFill>
@@ -9030,8 +9413,8 @@
         </p:nvSpPr>
         <p:spPr>
           <a:xfrm>
-            <a:off x="6263640" y="5349240"/>
-            <a:ext cx="5440680" cy="914400"/>
+            <a:off x="3355848" y="5349240"/>
+            <a:ext cx="2697480" cy="960120"/>
           </a:xfrm>
           <a:prstGeom prst="roundRect">
             <a:avLst>
@@ -9039,7 +9422,7 @@
             </a:avLst>
           </a:prstGeom>
           <a:solidFill>
-            <a:srgbClr val="FFF3DC"/>
+            <a:srgbClr val="EAF0FF"/>
           </a:solidFill>
           <a:ln>
             <a:noFill/>
@@ -9076,8 +9459,8 @@
         </p:nvSpPr>
         <p:spPr>
           <a:xfrm>
-            <a:off x="6492240" y="5394960"/>
-            <a:ext cx="5029200" cy="822960"/>
+            <a:off x="3493008" y="5376672"/>
+            <a:ext cx="2423160" cy="411480"/>
           </a:xfrm>
           <a:prstGeom prst="rect">
             <a:avLst/>
@@ -9090,27 +9473,50 @@
           </a:bodyPr>
           <a:lstStyle/>
           <a:p>
-            <a:pPr algn="l">
-              <a:spcAft>
-                <a:spcPts val="300"/>
-              </a:spcAft>
-            </a:pPr>
-            <a:r>
-              <a:rPr sz="1500" b="0">
-                <a:solidFill>
-                  <a:srgbClr val="1C2540"/>
+            <a:pPr algn="l"/>
+            <a:r>
+              <a:rPr sz="2200" b="1">
+                <a:solidFill>
+                  <a:srgbClr val="3B6CF6"/>
                 </a:solidFill>
                 <a:latin typeface="Malgun Gothic"/>
                 <a:ea typeface="Malgun Gothic"/>
                 <a:cs typeface="Malgun Gothic"/>
               </a:rPr>
-              <a:t>1~5문항 차이, 1회 실행 → 우위 단정 안 함</a:t>
-            </a:r>
-          </a:p>
-          <a:p>
-            <a:pPr algn="l"/>
-            <a:r>
-              <a:rPr sz="1500" b="0">
+              <a:t>16 → 16</a:t>
+            </a:r>
+          </a:p>
+        </p:txBody>
+      </p:sp>
+      <p:sp>
+        <p:nvSpPr>
+          <p:cNvPr id="15" name="TextBox 14"/>
+          <p:cNvSpPr txBox="1"/>
+          <p:nvPr/>
+        </p:nvSpPr>
+        <p:spPr>
+          <a:xfrm>
+            <a:off x="3493008" y="5779008"/>
+            <a:ext cx="2423160" cy="502920"/>
+          </a:xfrm>
+          <a:prstGeom prst="rect">
+            <a:avLst/>
+          </a:prstGeom>
+          <a:noFill/>
+        </p:spPr>
+        <p:txBody>
+          <a:bodyPr wrap="square" anchor="t" lIns="0" rIns="0" tIns="0" bIns="0">
+            <a:spAutoFit/>
+          </a:bodyPr>
+          <a:lstStyle/>
+          <a:p>
+            <a:pPr algn="l">
+              <a:lnSpc>
+                <a:spcPct val="100000"/>
+              </a:lnSpc>
+            </a:pPr>
+            <a:r>
+              <a:rPr sz="1100" b="0">
                 <a:solidFill>
                   <a:srgbClr val="1C2540"/>
                 </a:solidFill>
@@ -9118,7 +9524,255 @@
                 <a:ea typeface="Malgun Gothic"/>
                 <a:cs typeface="Malgun Gothic"/>
               </a:rPr>
-              <a:t>이중 첫 검색을 켜도 16 → 16, 검색만 80 → 98회</a:t>
+              <a:t>이중 첫 검색을 켜도 같음, 검색만 80 → 98회 → 기본 꺼짐</a:t>
+            </a:r>
+          </a:p>
+        </p:txBody>
+      </p:sp>
+      <p:sp>
+        <p:nvSpPr>
+          <p:cNvPr id="16" name="Rounded Rectangle 15"/>
+          <p:cNvSpPr/>
+          <p:nvPr/>
+        </p:nvSpPr>
+        <p:spPr>
+          <a:xfrm>
+            <a:off x="6163055" y="5349240"/>
+            <a:ext cx="2697480" cy="960120"/>
+          </a:xfrm>
+          <a:prstGeom prst="roundRect">
+            <a:avLst>
+              <a:gd name="adj" fmla="val 6000"/>
+            </a:avLst>
+          </a:prstGeom>
+          <a:solidFill>
+            <a:srgbClr val="EAF0FF"/>
+          </a:solidFill>
+          <a:ln>
+            <a:noFill/>
+          </a:ln>
+          <a:effectLst/>
+        </p:spPr>
+        <p:style>
+          <a:lnRef idx="1">
+            <a:schemeClr val="accent1"/>
+          </a:lnRef>
+          <a:fillRef idx="3">
+            <a:schemeClr val="accent1"/>
+          </a:fillRef>
+          <a:effectRef idx="2">
+            <a:schemeClr val="accent1"/>
+          </a:effectRef>
+          <a:fontRef idx="minor">
+            <a:schemeClr val="lt1"/>
+          </a:fontRef>
+        </p:style>
+        <p:txBody>
+          <a:bodyPr rtlCol="0" anchor="ctr"/>
+          <a:lstStyle/>
+          <a:p>
+            <a:pPr algn="ctr"/>
+          </a:p>
+        </p:txBody>
+      </p:sp>
+      <p:sp>
+        <p:nvSpPr>
+          <p:cNvPr id="17" name="TextBox 16"/>
+          <p:cNvSpPr txBox="1"/>
+          <p:nvPr/>
+        </p:nvSpPr>
+        <p:spPr>
+          <a:xfrm>
+            <a:off x="6300216" y="5376672"/>
+            <a:ext cx="2423160" cy="411480"/>
+          </a:xfrm>
+          <a:prstGeom prst="rect">
+            <a:avLst/>
+          </a:prstGeom>
+          <a:noFill/>
+        </p:spPr>
+        <p:txBody>
+          <a:bodyPr wrap="square" anchor="ctr" lIns="0" rIns="0" tIns="0" bIns="0">
+            <a:spAutoFit/>
+          </a:bodyPr>
+          <a:lstStyle/>
+          <a:p>
+            <a:pPr algn="l"/>
+            <a:r>
+              <a:rPr sz="2200" b="1">
+                <a:solidFill>
+                  <a:srgbClr val="3B6CF6"/>
+                </a:solidFill>
+                <a:latin typeface="Malgun Gothic"/>
+                <a:ea typeface="Malgun Gothic"/>
+                <a:cs typeface="Malgun Gothic"/>
+              </a:rPr>
+              <a:t>20초/10초</a:t>
+            </a:r>
+          </a:p>
+        </p:txBody>
+      </p:sp>
+      <p:sp>
+        <p:nvSpPr>
+          <p:cNvPr id="18" name="TextBox 17"/>
+          <p:cNvSpPr txBox="1"/>
+          <p:nvPr/>
+        </p:nvSpPr>
+        <p:spPr>
+          <a:xfrm>
+            <a:off x="6300216" y="5779008"/>
+            <a:ext cx="2423160" cy="502920"/>
+          </a:xfrm>
+          <a:prstGeom prst="rect">
+            <a:avLst/>
+          </a:prstGeom>
+          <a:noFill/>
+        </p:spPr>
+        <p:txBody>
+          <a:bodyPr wrap="square" anchor="t" lIns="0" rIns="0" tIns="0" bIns="0">
+            <a:spAutoFit/>
+          </a:bodyPr>
+          <a:lstStyle/>
+          <a:p>
+            <a:pPr algn="l">
+              <a:lnSpc>
+                <a:spcPct val="100000"/>
+              </a:lnSpc>
+            </a:pPr>
+            <a:r>
+              <a:rPr sz="1100" b="0">
+                <a:solidFill>
+                  <a:srgbClr val="1C2540"/>
+                </a:solidFill>
+                <a:latin typeface="Malgun Gothic"/>
+                <a:ea typeface="Malgun Gothic"/>
+                <a:cs typeface="Malgun Gothic"/>
+              </a:rPr>
+              <a:t>청크 길이 비교 후 유지 (30/15 이상은 하락)</a:t>
+            </a:r>
+          </a:p>
+        </p:txBody>
+      </p:sp>
+      <p:sp>
+        <p:nvSpPr>
+          <p:cNvPr id="19" name="Rounded Rectangle 18"/>
+          <p:cNvSpPr/>
+          <p:nvPr/>
+        </p:nvSpPr>
+        <p:spPr>
+          <a:xfrm>
+            <a:off x="8970263" y="5349240"/>
+            <a:ext cx="2697480" cy="960120"/>
+          </a:xfrm>
+          <a:prstGeom prst="roundRect">
+            <a:avLst>
+              <a:gd name="adj" fmla="val 6000"/>
+            </a:avLst>
+          </a:prstGeom>
+          <a:solidFill>
+            <a:srgbClr val="FFF3DC"/>
+          </a:solidFill>
+          <a:ln>
+            <a:noFill/>
+          </a:ln>
+          <a:effectLst/>
+        </p:spPr>
+        <p:style>
+          <a:lnRef idx="1">
+            <a:schemeClr val="accent1"/>
+          </a:lnRef>
+          <a:fillRef idx="3">
+            <a:schemeClr val="accent1"/>
+          </a:fillRef>
+          <a:effectRef idx="2">
+            <a:schemeClr val="accent1"/>
+          </a:effectRef>
+          <a:fontRef idx="minor">
+            <a:schemeClr val="lt1"/>
+          </a:fontRef>
+        </p:style>
+        <p:txBody>
+          <a:bodyPr rtlCol="0" anchor="ctr"/>
+          <a:lstStyle/>
+          <a:p>
+            <a:pPr algn="ctr"/>
+          </a:p>
+        </p:txBody>
+      </p:sp>
+      <p:sp>
+        <p:nvSpPr>
+          <p:cNvPr id="20" name="TextBox 19"/>
+          <p:cNvSpPr txBox="1"/>
+          <p:nvPr/>
+        </p:nvSpPr>
+        <p:spPr>
+          <a:xfrm>
+            <a:off x="9107424" y="5376672"/>
+            <a:ext cx="2423160" cy="411480"/>
+          </a:xfrm>
+          <a:prstGeom prst="rect">
+            <a:avLst/>
+          </a:prstGeom>
+          <a:noFill/>
+        </p:spPr>
+        <p:txBody>
+          <a:bodyPr wrap="square" anchor="ctr" lIns="0" rIns="0" tIns="0" bIns="0">
+            <a:spAutoFit/>
+          </a:bodyPr>
+          <a:lstStyle/>
+          <a:p>
+            <a:pPr algn="l"/>
+            <a:r>
+              <a:rPr sz="2200" b="1">
+                <a:solidFill>
+                  <a:srgbClr val="B9770E"/>
+                </a:solidFill>
+                <a:latin typeface="Malgun Gothic"/>
+                <a:ea typeface="Malgun Gothic"/>
+                <a:cs typeface="Malgun Gothic"/>
+              </a:rPr>
+              <a:t>한계</a:t>
+            </a:r>
+          </a:p>
+        </p:txBody>
+      </p:sp>
+      <p:sp>
+        <p:nvSpPr>
+          <p:cNvPr id="21" name="TextBox 20"/>
+          <p:cNvSpPr txBox="1"/>
+          <p:nvPr/>
+        </p:nvSpPr>
+        <p:spPr>
+          <a:xfrm>
+            <a:off x="9107424" y="5779008"/>
+            <a:ext cx="2423160" cy="502920"/>
+          </a:xfrm>
+          <a:prstGeom prst="rect">
+            <a:avLst/>
+          </a:prstGeom>
+          <a:noFill/>
+        </p:spPr>
+        <p:txBody>
+          <a:bodyPr wrap="square" anchor="t" lIns="0" rIns="0" tIns="0" bIns="0">
+            <a:spAutoFit/>
+          </a:bodyPr>
+          <a:lstStyle/>
+          <a:p>
+            <a:pPr algn="l">
+              <a:lnSpc>
+                <a:spcPct val="100000"/>
+              </a:lnSpc>
+            </a:pPr>
+            <a:r>
+              <a:rPr sz="1100" b="0">
+                <a:solidFill>
+                  <a:srgbClr val="1C2540"/>
+                </a:solidFill>
+                <a:latin typeface="Malgun Gothic"/>
+                <a:ea typeface="Malgun Gothic"/>
+                <a:cs typeface="Malgun Gothic"/>
+              </a:rPr>
+              <a:t>후속 질문·번역 어휘 차이, Multi-Agent 미구현</a:t>
             </a:r>
           </a:p>
         </p:txBody>
@@ -9969,7 +10623,7 @@
                 <a:ea typeface="Malgun Gothic"/>
                 <a:cs typeface="Malgun Gothic"/>
               </a:rPr>
-              <a:t>백엔드 177개 · 프런트 43개</a:t>
+              <a:t>백엔드 178개 · 프런트 43개</a:t>
             </a:r>
           </a:p>
         </p:txBody>
@@ -13266,7 +13920,7 @@
                 <a:ea typeface="Malgun Gothic"/>
                 <a:cs typeface="Malgun Gothic"/>
               </a:rPr>
-              <a:t>20초 · 10초 · 60은 설계 때 정한 값 (다른 값과 비교하지 않음)</a:t>
+              <a:t>청크 길이 비교(B, 18문항): 10/5=11 · 20/10=11 · 30/15=9 · 40/20=5 → 20/10 유지. 60은 미비교</a:t>
             </a:r>
           </a:p>
         </p:txBody>
@@ -13333,7 +13987,7 @@
                 <a:ea typeface="Malgun Gothic"/>
                 <a:cs typeface="Malgun Gothic"/>
               </a:rPr>
-              <a:t>한계와 이후: 구조보다 데이터가 문제였다</a:t>
+              <a:t>[백업] 한계와 측정 결과: 구조보다 데이터가 문제였다</a:t>
             </a:r>
           </a:p>
         </p:txBody>
@@ -13683,7 +14337,7 @@
                 <a:ea typeface="Malgun Gothic"/>
                 <a:cs typeface="Malgun Gothic"/>
               </a:rPr>
-              <a:t>Multi-Agent는 호출·지연이 늘어 미구현</a:t>
+              <a:t>더 복잡한 서비스로 넓힐 때 전환</a:t>
             </a:r>
           </a:p>
         </p:txBody>

</xml_diff>

<commit_message>
docs: revise the deck (cover, order, limits table, speaker script)
- Cover: remove the screenshot and add the class to the name.
- Slide 2: explicit line breaks in the table cells; table helper now honours
  newlines.
- Results slide stays before the structure slide; A/B/C are defined on the
  chart and in the narration.
- Limits and trade-offs (backup) rewritten as a table based on report ch. 4.
- Closing line aligned with report section 5.1.
- Add docs/exec/발표대본.md, generated with the deck from the speaker notes.
- Simplify the table-border XML to the minimal valid form.

Co-Authored-By: Claude Sonnet 5.5 <noreply@anthropic.com>
</commit_message>
<xml_diff>
--- a/docs/exec/G078_문희주_발표.pptx
+++ b/docs/exec/G078_문희주_발표.pptx
@@ -718,7 +718,7 @@
           <a:lstStyle/>
           <a:p>
             <a:r>
-              <a:t>[10초] 안녕하세요, G078 문희주입니다. 제 과제는 WISH FINDER입니다. 영상 속 장면이 어렴풋이만 기억날 때, 그 장면을 설명하면 영상의 정확한 시점을 찾아 주는 AI Agent입니다.</a:t>
+              <a:t>[10초] 안녕하세요, 광주 3반 G078 문희주입니다. 제 과제는 WISH FINDER입니다. 영상 속 장면이 어렴풋이만 기억날 때, 그 장면을 설명하면 영상의 정확한 시점을 찾아 주는 AI Agent입니다.</a:t>
             </a:r>
           </a:p>
         </p:txBody>
@@ -1068,7 +1068,7 @@
           <a:lstStyle/>
           <a:p>
             <a:r>
-              <a:t>[65초] 결과입니다. 같은 20문항 평가셋으로 Agent는 장면 질문 18개 중 16개를 1위로 맞혔고, 일반 검색은 11에서 15개였습니다. 차이가 1에서 5문항이고 한 번만 실행해서 우위는 단정하지 않습니다. 개선 전후로는 화자 질문 처리가 2개에서 3개로 늘고 LLM 호출이 16% 줄었지만 입력 토큰은 24% 늘었습니다. 근거 없이 화자를 단정한 경우는 0건이었습니다. 오늘 다시 측정한 이중 첫 검색은 켜도 16으로 같고 검색만 늘어 꺼 두었고, 청크는 20초와 10초를 유지했습니다. 한계는 후속 질문과 번역 어휘 차이, 그리고 Multi-Agent를 구현하지 않은 점입니다.</a:t>
+              <a:t>[55초] 결과입니다. A는 키워드 검색, B는 Hybrid 검색, C는 Hybrid에 검증과 재검색을 더한 Agent입니다. 같은 20문항 평가셋에서 Agent는 장면 질문 18개 중 16개를 1위로 맞혔고 일반 검색은 11에서 15개였습니다. 차이가 작고 한 번만 실행해서 우위는 단정하지 않습니다. 개선 전후로 화자 질문 처리는 2개에서 3개로 늘었지만 입력 토큰은 24% 늘었습니다. 근거 없이 화자를 단정한 경우는 0건이었습니다. 이중 첫 검색은 켜도 16으로 같아 꺼 두었고, 청크는 20초와 10초를 유지했습니다. 이제 이 결과를 만든 구조와 핵심 코드를 설명드리겠습니다.</a:t>
             </a:r>
           </a:p>
         </p:txBody>
@@ -1138,7 +1138,7 @@
           <a:lstStyle/>
           <a:p>
             <a:r>
-              <a:t>[15초] 전체 구조입니다. 화면의 질문은 FastAPI를 거쳐 LangGraph Agent로 가고, Agent는 MCP 서버를 통해서만 자막을 조회합니다. 이제 핵심 코드 세 가지, Agent Graph와 MCP, RAG를 설명드리겠습니다.</a:t>
+              <a:t>[20초] 전체 구조입니다. 화면의 질문은 FastAPI를 거쳐 LangGraph Agent로 가고, Agent는 MCP 서버를 통해서만 자막을 조회합니다. 자막 검색은 키워드와 의미 검색을 합친 Hybrid 방식입니다. 이제 핵심 코드 세 가지, Agent Graph와 MCP, RAG를 설명드리겠습니다.</a:t>
             </a:r>
           </a:p>
         </p:txBody>
@@ -1348,7 +1348,7 @@
           <a:lstStyle/>
           <a:p>
             <a:r>
-              <a:t>[55초] RAG입니다. 자막 3,750줄을 영상별로 20초씩, 10초 겹치게 묶어 청크 869개를 만들었습니다. 키워드 검색 상위 20개와 의미 검색 상위 20개를 RRF로 합치는데, 순위가 r인 후보에 1 나누기 60 더하기 r 점수를 주고 더합니다. 청크는 cue 번호를 가지고 있어 결과가 항상 원본 자막 줄로 돌아갑니다. 청크 길이는 10초 5초, 30초 15초, 40초 20초와도 비교했고 20초 10초를 유지했습니다. 가장 크게 배운 것은 문제가 구조보다 번역 자막의 단어 같은 데이터에 있었다는 점입니다. 감사합니다.</a:t>
+              <a:t>[55초] RAG입니다. 자막 3,750줄을 영상별로 20초씩, 10초 겹치게 묶어 청크 869개를 만들었습니다. 키워드 검색 상위 20개와 의미 검색 상위 20개를 RRF로 합치는데, 순위가 r인 후보에 1 나누기 60 더하기 r 점수를 주고 더합니다. 청크는 cue 번호를 가지고 있어 결과가 항상 원본 자막 줄로 돌아갑니다. 청크 길이는 10초 5초, 30초 15초, 40초 20초와도 비교했고 20초 10초를 유지했습니다. 가장 크게 배운 것은 같은 질문도 표현에 따라 결과가 달라져서, 한 번 잘 나온 결과를 믿지 말고 측정으로 확인해야 한다는 점입니다. 감사합니다.</a:t>
             </a:r>
           </a:p>
         </p:txBody>
@@ -1418,7 +1418,7 @@
           <a:lstStyle/>
           <a:p>
             <a:r>
-              <a:t>[백업] 질문 대비: 한계와 측정 결과. 한계는 세 가지입니다. Agent 우위는 우연일 수 있고, 지연과 토큰이 늘었으며, 후속 질문이나 번역 어휘 차이에서 틀리거나 못 찾는 경우가 있습니다. 측정도 두 가지 마쳤습니다. 청크 길이는 20초와 10초를 유지했고, 이중 첫 검색은 16에서 16으로 이득이 없어 기본값을 끈 채 두었습니다. 이후에는 서비스가 여러 장면을 연결해 조사하는 형태로 커질 때 Supervisor 구조를 비교하려고 합니다.</a:t>
+              <a:t>[백업] 질문 대비: 한계와 트레이드오프. 측정, 성능, 비용·범위 세 갈래로 정리합니다. 측정은 18문항에 질문당 1회라 1에서 2문항 차이는 우연일 수 있고, 정답 라벨은 어시스턴트가 원본 자막을 검토해 제안하고 제가 승인한 것이며 영상 대조는 9곳 표본입니다. 성능에서는 찾음 응답 17건 중 1건이 틀린 장면이었고, 정답 청크가 후보 3개 밖에 있던 문항이 두 개 있었습니다. 비용은 입력 토큰이 24% 늘고 평균 지연이 2.6초입니다. 범위로는 Multi-Agent를 구현하거나 비교하지 않았고, 영어 번역 자막이라 화자를 단정할 수 없습니다.</a:t>
             </a:r>
           </a:p>
         </p:txBody>
@@ -4534,7 +4534,7 @@
                 <a:ea typeface="Malgun Gothic"/>
                 <a:cs typeface="Malgun Gothic"/>
               </a:rPr>
-              <a:t>G078 문희주  ·  WISH FINDER</a:t>
+              <a:t>광주 3반 G078 문희주  ·  WISH FINDER</a:t>
             </a:r>
           </a:p>
         </p:txBody>
@@ -4547,8 +4547,8 @@
         </p:nvSpPr>
         <p:spPr>
           <a:xfrm>
-            <a:off x="731520" y="1554480"/>
-            <a:ext cx="6217920" cy="1097280"/>
+            <a:off x="1097280" y="1737360"/>
+            <a:ext cx="9966960" cy="1188720"/>
           </a:xfrm>
           <a:prstGeom prst="rect">
             <a:avLst/>
@@ -4563,7 +4563,7 @@
           <a:p>
             <a:pPr algn="l"/>
             <a:r>
-              <a:rPr sz="6000" b="1">
+              <a:rPr sz="7200" b="1">
                 <a:solidFill>
                   <a:srgbClr val="1B2437"/>
                 </a:solidFill>
@@ -4584,8 +4584,8 @@
         </p:nvSpPr>
         <p:spPr>
           <a:xfrm>
-            <a:off x="731520" y="2743200"/>
-            <a:ext cx="6035040" cy="1280160"/>
+            <a:off x="1097280" y="3017520"/>
+            <a:ext cx="9966960" cy="1371600"/>
           </a:xfrm>
           <a:prstGeom prst="rect">
             <a:avLst/>
@@ -4604,7 +4604,7 @@
               </a:spcAft>
             </a:pPr>
             <a:r>
-              <a:rPr sz="2800" b="0">
+              <a:rPr sz="3200" b="0">
                 <a:solidFill>
                   <a:srgbClr val="5B6577"/>
                 </a:solidFill>
@@ -4618,7 +4618,7 @@
           <a:p>
             <a:pPr algn="l"/>
             <a:r>
-              <a:rPr sz="2800" b="1">
+              <a:rPr sz="3200" b="1">
                 <a:solidFill>
                   <a:srgbClr val="2457D6"/>
                 </a:solidFill>
@@ -4639,8 +4639,8 @@
         </p:nvSpPr>
         <p:spPr>
           <a:xfrm>
-            <a:off x="731520" y="4343400"/>
-            <a:ext cx="2651760" cy="566928"/>
+            <a:off x="1097280" y="4572000"/>
+            <a:ext cx="4206240" cy="603504"/>
           </a:xfrm>
           <a:prstGeom prst="roundRect">
             <a:avLst>
@@ -4683,7 +4683,7 @@
                 <a:ea typeface="Malgun Gothic"/>
                 <a:cs typeface="Malgun Gothic"/>
               </a:rPr>
-              <a:t>G078  문희주</a:t>
+              <a:t>광주 3반  G078  문희주</a:t>
             </a:r>
           </a:p>
         </p:txBody>
@@ -4696,8 +4696,8 @@
         </p:nvSpPr>
         <p:spPr>
           <a:xfrm>
-            <a:off x="731520" y="5166360"/>
-            <a:ext cx="6035040" cy="822960"/>
+            <a:off x="1097280" y="5394960"/>
+            <a:ext cx="9966960" cy="822960"/>
           </a:xfrm>
           <a:prstGeom prst="rect">
             <a:avLst/>
@@ -4710,11 +4710,7 @@
           </a:bodyPr>
           <a:lstStyle/>
           <a:p>
-            <a:pPr algn="l">
-              <a:spcAft>
-                <a:spcPts val="400"/>
-              </a:spcAft>
-            </a:pPr>
+            <a:pPr algn="l"/>
             <a:r>
               <a:rPr sz="1800" b="0">
                 <a:solidFill>
@@ -4724,54 +4720,11 @@
                 <a:ea typeface="Malgun Gothic"/>
                 <a:cs typeface="Malgun Gothic"/>
               </a:rPr>
-              <a:t>AI 서비스 Mini Project  ·  과제 2 (신규 Agent)</a:t>
-            </a:r>
-          </a:p>
-          <a:p>
-            <a:pPr algn="l"/>
-            <a:r>
-              <a:rPr sz="1800" b="0">
-                <a:solidFill>
-                  <a:srgbClr val="5B6577"/>
-                </a:solidFill>
-                <a:latin typeface="Malgun Gothic"/>
-                <a:ea typeface="Malgun Gothic"/>
-                <a:cs typeface="Malgun Gothic"/>
-              </a:rPr>
-              <a:t>첫 적용 대상: NCT WISH 영상 3편</a:t>
-            </a:r>
-          </a:p>
-        </p:txBody>
-      </p:sp>
-      <p:pic>
-        <p:nvPicPr>
-          <p:cNvPr id="7" name="Picture 6" descr="01_home.png"/>
-          <p:cNvPicPr>
-            <a:picLocks noChangeAspect="1"/>
-          </p:cNvPicPr>
-          <p:nvPr/>
-        </p:nvPicPr>
-        <p:blipFill>
-          <a:blip r:embed="rId2"/>
-          <a:stretch>
-            <a:fillRect/>
-          </a:stretch>
-        </p:blipFill>
-        <p:spPr>
-          <a:xfrm>
-            <a:off x="7086600" y="1188720"/>
-            <a:ext cx="4617720" cy="2886075"/>
-          </a:xfrm>
-          <a:prstGeom prst="rect">
-            <a:avLst/>
-          </a:prstGeom>
-          <a:ln w="12700">
-            <a:solidFill>
-              <a:srgbClr val="D5DBEA"/>
-            </a:solidFill>
-          </a:ln>
-        </p:spPr>
-      </p:pic>
+              <a:t>AI 서비스 Mini Project  ·  과제 2 (신규 Agent)  ·  첫 적용 대상: NCT WISH 영상 3편</a:t>
+            </a:r>
+          </a:p>
+        </p:txBody>
+      </p:sp>
     </p:spTree>
   </p:cSld>
   <p:clrMapOvr>
@@ -4871,7 +4824,7 @@
                 <a:ea typeface="Malgun Gothic"/>
                 <a:cs typeface="Malgun Gothic"/>
               </a:rPr>
-              <a:t>G078 문희주  ·  WISH FINDER</a:t>
+              <a:t>광주 3반 G078 문희주  ·  WISH FINDER</a:t>
             </a:r>
           </a:p>
         </p:txBody>
@@ -5369,16 +5322,7 @@
                     </a:p>
                   </a:txBody>
                   <a:tcPr marL="91440" marR="91440" marT="36576" marB="36576" anchor="ctr">
-                    <a:lnL w="0">
-                      <a:noFill/>
-                    </a:lnL>
-                    <a:lnR w="0">
-                      <a:noFill/>
-                    </a:lnR>
-                    <a:lnT w="0">
-                      <a:noFill/>
-                    </a:lnT>
-                    <a:lnB w="9525" cap="flat" cmpd="sng" algn="ctr">
+                    <a:lnB w="9525">
                       <a:solidFill>
                         <a:srgbClr val="DDE2EC"/>
                       </a:solidFill>
@@ -5408,16 +5352,7 @@
                     </a:p>
                   </a:txBody>
                   <a:tcPr marL="91440" marR="91440" marT="36576" marB="36576" anchor="ctr">
-                    <a:lnL w="0">
-                      <a:noFill/>
-                    </a:lnL>
-                    <a:lnR w="0">
-                      <a:noFill/>
-                    </a:lnR>
-                    <a:lnT w="0">
-                      <a:noFill/>
-                    </a:lnT>
-                    <a:lnB w="9525" cap="flat" cmpd="sng" algn="ctr">
+                    <a:lnB w="9525">
                       <a:solidFill>
                         <a:srgbClr val="DDE2EC"/>
                       </a:solidFill>
@@ -5449,16 +5384,7 @@
                     </a:p>
                   </a:txBody>
                   <a:tcPr marL="91440" marR="91440" marT="36576" marB="36576" anchor="ctr">
-                    <a:lnL w="0">
-                      <a:noFill/>
-                    </a:lnL>
-                    <a:lnR w="0">
-                      <a:noFill/>
-                    </a:lnR>
-                    <a:lnT w="0">
-                      <a:noFill/>
-                    </a:lnT>
-                    <a:lnB w="9525" cap="flat" cmpd="sng" algn="ctr">
+                    <a:lnB w="9525">
                       <a:solidFill>
                         <a:srgbClr val="DDE2EC"/>
                       </a:solidFill>
@@ -5488,16 +5414,7 @@
                     </a:p>
                   </a:txBody>
                   <a:tcPr marL="91440" marR="91440" marT="36576" marB="36576" anchor="ctr">
-                    <a:lnL w="0">
-                      <a:noFill/>
-                    </a:lnL>
-                    <a:lnR w="0">
-                      <a:noFill/>
-                    </a:lnR>
-                    <a:lnT w="0">
-                      <a:noFill/>
-                    </a:lnT>
-                    <a:lnB w="9525" cap="flat" cmpd="sng" algn="ctr">
+                    <a:lnB w="9525">
                       <a:solidFill>
                         <a:srgbClr val="DDE2EC"/>
                       </a:solidFill>
@@ -5529,16 +5446,7 @@
                     </a:p>
                   </a:txBody>
                   <a:tcPr marL="91440" marR="91440" marT="36576" marB="36576" anchor="ctr">
-                    <a:lnL w="0">
-                      <a:noFill/>
-                    </a:lnL>
-                    <a:lnR w="0">
-                      <a:noFill/>
-                    </a:lnR>
-                    <a:lnT w="0">
-                      <a:noFill/>
-                    </a:lnT>
-                    <a:lnB w="9525" cap="flat" cmpd="sng" algn="ctr">
+                    <a:lnB w="9525">
                       <a:solidFill>
                         <a:srgbClr val="DDE2EC"/>
                       </a:solidFill>
@@ -5568,16 +5476,7 @@
                     </a:p>
                   </a:txBody>
                   <a:tcPr marL="91440" marR="91440" marT="36576" marB="36576" anchor="ctr">
-                    <a:lnL w="0">
-                      <a:noFill/>
-                    </a:lnL>
-                    <a:lnR w="0">
-                      <a:noFill/>
-                    </a:lnR>
-                    <a:lnT w="0">
-                      <a:noFill/>
-                    </a:lnT>
-                    <a:lnB w="9525" cap="flat" cmpd="sng" algn="ctr">
+                    <a:lnB w="9525">
                       <a:solidFill>
                         <a:srgbClr val="DDE2EC"/>
                       </a:solidFill>
@@ -5609,16 +5508,7 @@
                     </a:p>
                   </a:txBody>
                   <a:tcPr marL="91440" marR="91440" marT="36576" marB="36576" anchor="ctr">
-                    <a:lnL w="0">
-                      <a:noFill/>
-                    </a:lnL>
-                    <a:lnR w="0">
-                      <a:noFill/>
-                    </a:lnR>
-                    <a:lnT w="0">
-                      <a:noFill/>
-                    </a:lnT>
-                    <a:lnB w="9525" cap="flat" cmpd="sng" algn="ctr">
+                    <a:lnB w="9525">
                       <a:solidFill>
                         <a:srgbClr val="DDE2EC"/>
                       </a:solidFill>
@@ -5648,16 +5538,7 @@
                     </a:p>
                   </a:txBody>
                   <a:tcPr marL="91440" marR="91440" marT="36576" marB="36576" anchor="ctr">
-                    <a:lnL w="0">
-                      <a:noFill/>
-                    </a:lnL>
-                    <a:lnR w="0">
-                      <a:noFill/>
-                    </a:lnR>
-                    <a:lnT w="0">
-                      <a:noFill/>
-                    </a:lnT>
-                    <a:lnB w="9525" cap="flat" cmpd="sng" algn="ctr">
+                    <a:lnB w="9525">
                       <a:solidFill>
                         <a:srgbClr val="DDE2EC"/>
                       </a:solidFill>
@@ -5689,16 +5570,7 @@
                     </a:p>
                   </a:txBody>
                   <a:tcPr marL="91440" marR="91440" marT="36576" marB="36576" anchor="ctr">
-                    <a:lnL w="0">
-                      <a:noFill/>
-                    </a:lnL>
-                    <a:lnR w="0">
-                      <a:noFill/>
-                    </a:lnR>
-                    <a:lnT w="0">
-                      <a:noFill/>
-                    </a:lnT>
-                    <a:lnB w="9525" cap="flat" cmpd="sng" algn="ctr">
+                    <a:lnB w="9525">
                       <a:solidFill>
                         <a:srgbClr val="DDE2EC"/>
                       </a:solidFill>
@@ -5728,16 +5600,7 @@
                     </a:p>
                   </a:txBody>
                   <a:tcPr marL="91440" marR="91440" marT="36576" marB="36576" anchor="ctr">
-                    <a:lnL w="0">
-                      <a:noFill/>
-                    </a:lnL>
-                    <a:lnR w="0">
-                      <a:noFill/>
-                    </a:lnR>
-                    <a:lnT w="0">
-                      <a:noFill/>
-                    </a:lnT>
-                    <a:lnB w="9525" cap="flat" cmpd="sng" algn="ctr">
+                    <a:lnB w="9525">
                       <a:solidFill>
                         <a:srgbClr val="DDE2EC"/>
                       </a:solidFill>
@@ -5769,16 +5632,7 @@
                     </a:p>
                   </a:txBody>
                   <a:tcPr marL="91440" marR="91440" marT="36576" marB="36576" anchor="ctr">
-                    <a:lnL w="0">
-                      <a:noFill/>
-                    </a:lnL>
-                    <a:lnR w="0">
-                      <a:noFill/>
-                    </a:lnR>
-                    <a:lnT w="0">
-                      <a:noFill/>
-                    </a:lnT>
-                    <a:lnB w="9525" cap="flat" cmpd="sng" algn="ctr">
+                    <a:lnB w="9525">
                       <a:solidFill>
                         <a:srgbClr val="DDE2EC"/>
                       </a:solidFill>
@@ -5808,16 +5662,7 @@
                     </a:p>
                   </a:txBody>
                   <a:tcPr marL="91440" marR="91440" marT="36576" marB="36576" anchor="ctr">
-                    <a:lnL w="0">
-                      <a:noFill/>
-                    </a:lnL>
-                    <a:lnR w="0">
-                      <a:noFill/>
-                    </a:lnR>
-                    <a:lnT w="0">
-                      <a:noFill/>
-                    </a:lnT>
-                    <a:lnB w="9525" cap="flat" cmpd="sng" algn="ctr">
+                    <a:lnB w="9525">
                       <a:solidFill>
                         <a:srgbClr val="DDE2EC"/>
                       </a:solidFill>
@@ -5849,16 +5694,7 @@
                     </a:p>
                   </a:txBody>
                   <a:tcPr marL="91440" marR="91440" marT="36576" marB="36576" anchor="ctr">
-                    <a:lnL w="0">
-                      <a:noFill/>
-                    </a:lnL>
-                    <a:lnR w="0">
-                      <a:noFill/>
-                    </a:lnR>
-                    <a:lnT w="0">
-                      <a:noFill/>
-                    </a:lnT>
-                    <a:lnB w="9525" cap="flat" cmpd="sng" algn="ctr">
+                    <a:lnB w="9525">
                       <a:solidFill>
                         <a:srgbClr val="DDE2EC"/>
                       </a:solidFill>
@@ -5888,16 +5724,7 @@
                     </a:p>
                   </a:txBody>
                   <a:tcPr marL="91440" marR="91440" marT="36576" marB="36576" anchor="ctr">
-                    <a:lnL w="0">
-                      <a:noFill/>
-                    </a:lnL>
-                    <a:lnR w="0">
-                      <a:noFill/>
-                    </a:lnR>
-                    <a:lnT w="0">
-                      <a:noFill/>
-                    </a:lnT>
-                    <a:lnB w="9525" cap="flat" cmpd="sng" algn="ctr">
+                    <a:lnB w="9525">
                       <a:solidFill>
                         <a:srgbClr val="DDE2EC"/>
                       </a:solidFill>
@@ -6066,7 +5893,7 @@
                 <a:ea typeface="Malgun Gothic"/>
                 <a:cs typeface="Malgun Gothic"/>
               </a:rPr>
-              <a:t>G078 문희주  ·  WISH FINDER</a:t>
+              <a:t>광주 3반 G078 문희주  ·  WISH FINDER</a:t>
             </a:r>
           </a:p>
         </p:txBody>
@@ -6852,7 +6679,7 @@
                 <a:ea typeface="Malgun Gothic"/>
                 <a:cs typeface="Malgun Gothic"/>
               </a:rPr>
-              <a:t>G078 문희주  ·  WISH FINDER</a:t>
+              <a:t>광주 3반 G078 문희주  ·  WISH FINDER</a:t>
             </a:r>
           </a:p>
         </p:txBody>
@@ -6937,16 +6764,7 @@
                     </a:p>
                   </a:txBody>
                   <a:tcPr marL="91440" marR="91440" marT="36576" marB="36576" anchor="ctr">
-                    <a:lnL w="0">
-                      <a:noFill/>
-                    </a:lnL>
-                    <a:lnR w="0">
-                      <a:noFill/>
-                    </a:lnR>
-                    <a:lnT w="0">
-                      <a:noFill/>
-                    </a:lnT>
-                    <a:lnB w="9525" cap="flat" cmpd="sng" algn="ctr">
+                    <a:lnB w="9525">
                       <a:solidFill>
                         <a:srgbClr val="DDE2EC"/>
                       </a:solidFill>
@@ -6976,16 +6794,7 @@
                     </a:p>
                   </a:txBody>
                   <a:tcPr marL="91440" marR="91440" marT="36576" marB="36576" anchor="ctr">
-                    <a:lnL w="0">
-                      <a:noFill/>
-                    </a:lnL>
-                    <a:lnR w="0">
-                      <a:noFill/>
-                    </a:lnR>
-                    <a:lnT w="0">
-                      <a:noFill/>
-                    </a:lnT>
-                    <a:lnB w="9525" cap="flat" cmpd="sng" algn="ctr">
+                    <a:lnB w="9525">
                       <a:solidFill>
                         <a:srgbClr val="DDE2EC"/>
                       </a:solidFill>
@@ -7017,16 +6826,7 @@
                     </a:p>
                   </a:txBody>
                   <a:tcPr marL="91440" marR="91440" marT="36576" marB="36576" anchor="ctr">
-                    <a:lnL w="0">
-                      <a:noFill/>
-                    </a:lnL>
-                    <a:lnR w="0">
-                      <a:noFill/>
-                    </a:lnR>
-                    <a:lnT w="0">
-                      <a:noFill/>
-                    </a:lnT>
-                    <a:lnB w="9525" cap="flat" cmpd="sng" algn="ctr">
+                    <a:lnB w="9525">
                       <a:solidFill>
                         <a:srgbClr val="DDE2EC"/>
                       </a:solidFill>
@@ -7056,16 +6856,7 @@
                     </a:p>
                   </a:txBody>
                   <a:tcPr marL="91440" marR="91440" marT="36576" marB="36576" anchor="ctr">
-                    <a:lnL w="0">
-                      <a:noFill/>
-                    </a:lnL>
-                    <a:lnR w="0">
-                      <a:noFill/>
-                    </a:lnR>
-                    <a:lnT w="0">
-                      <a:noFill/>
-                    </a:lnT>
-                    <a:lnB w="9525" cap="flat" cmpd="sng" algn="ctr">
+                    <a:lnB w="9525">
                       <a:solidFill>
                         <a:srgbClr val="DDE2EC"/>
                       </a:solidFill>
@@ -7097,16 +6888,7 @@
                     </a:p>
                   </a:txBody>
                   <a:tcPr marL="91440" marR="91440" marT="36576" marB="36576" anchor="ctr">
-                    <a:lnL w="0">
-                      <a:noFill/>
-                    </a:lnL>
-                    <a:lnR w="0">
-                      <a:noFill/>
-                    </a:lnR>
-                    <a:lnT w="0">
-                      <a:noFill/>
-                    </a:lnT>
-                    <a:lnB w="9525" cap="flat" cmpd="sng" algn="ctr">
+                    <a:lnB w="9525">
                       <a:solidFill>
                         <a:srgbClr val="DDE2EC"/>
                       </a:solidFill>
@@ -7136,16 +6918,7 @@
                     </a:p>
                   </a:txBody>
                   <a:tcPr marL="91440" marR="91440" marT="36576" marB="36576" anchor="ctr">
-                    <a:lnL w="0">
-                      <a:noFill/>
-                    </a:lnL>
-                    <a:lnR w="0">
-                      <a:noFill/>
-                    </a:lnR>
-                    <a:lnT w="0">
-                      <a:noFill/>
-                    </a:lnT>
-                    <a:lnB w="9525" cap="flat" cmpd="sng" algn="ctr">
+                    <a:lnB w="9525">
                       <a:solidFill>
                         <a:srgbClr val="DDE2EC"/>
                       </a:solidFill>
@@ -7177,16 +6950,7 @@
                     </a:p>
                   </a:txBody>
                   <a:tcPr marL="91440" marR="91440" marT="36576" marB="36576" anchor="ctr">
-                    <a:lnL w="0">
-                      <a:noFill/>
-                    </a:lnL>
-                    <a:lnR w="0">
-                      <a:noFill/>
-                    </a:lnR>
-                    <a:lnT w="0">
-                      <a:noFill/>
-                    </a:lnT>
-                    <a:lnB w="9525" cap="flat" cmpd="sng" algn="ctr">
+                    <a:lnB w="9525">
                       <a:solidFill>
                         <a:srgbClr val="DDE2EC"/>
                       </a:solidFill>
@@ -7216,16 +6980,7 @@
                     </a:p>
                   </a:txBody>
                   <a:tcPr marL="91440" marR="91440" marT="36576" marB="36576" anchor="ctr">
-                    <a:lnL w="0">
-                      <a:noFill/>
-                    </a:lnL>
-                    <a:lnR w="0">
-                      <a:noFill/>
-                    </a:lnR>
-                    <a:lnT w="0">
-                      <a:noFill/>
-                    </a:lnT>
-                    <a:lnB w="9525" cap="flat" cmpd="sng" algn="ctr">
+                    <a:lnB w="9525">
                       <a:solidFill>
                         <a:srgbClr val="DDE2EC"/>
                       </a:solidFill>
@@ -7257,16 +7012,7 @@
                     </a:p>
                   </a:txBody>
                   <a:tcPr marL="91440" marR="91440" marT="36576" marB="36576" anchor="ctr">
-                    <a:lnL w="0">
-                      <a:noFill/>
-                    </a:lnL>
-                    <a:lnR w="0">
-                      <a:noFill/>
-                    </a:lnR>
-                    <a:lnT w="0">
-                      <a:noFill/>
-                    </a:lnT>
-                    <a:lnB w="9525" cap="flat" cmpd="sng" algn="ctr">
+                    <a:lnB w="9525">
                       <a:solidFill>
                         <a:srgbClr val="DDE2EC"/>
                       </a:solidFill>
@@ -7296,16 +7042,7 @@
                     </a:p>
                   </a:txBody>
                   <a:tcPr marL="91440" marR="91440" marT="36576" marB="36576" anchor="ctr">
-                    <a:lnL w="0">
-                      <a:noFill/>
-                    </a:lnL>
-                    <a:lnR w="0">
-                      <a:noFill/>
-                    </a:lnR>
-                    <a:lnT w="0">
-                      <a:noFill/>
-                    </a:lnT>
-                    <a:lnB w="9525" cap="flat" cmpd="sng" algn="ctr">
+                    <a:lnB w="9525">
                       <a:solidFill>
                         <a:srgbClr val="DDE2EC"/>
                       </a:solidFill>
@@ -7337,16 +7074,7 @@
                     </a:p>
                   </a:txBody>
                   <a:tcPr marL="91440" marR="91440" marT="36576" marB="36576" anchor="ctr">
-                    <a:lnL w="0">
-                      <a:noFill/>
-                    </a:lnL>
-                    <a:lnR w="0">
-                      <a:noFill/>
-                    </a:lnR>
-                    <a:lnT w="0">
-                      <a:noFill/>
-                    </a:lnT>
-                    <a:lnB w="9525" cap="flat" cmpd="sng" algn="ctr">
+                    <a:lnB w="9525">
                       <a:solidFill>
                         <a:srgbClr val="DDE2EC"/>
                       </a:solidFill>
@@ -7376,16 +7104,7 @@
                     </a:p>
                   </a:txBody>
                   <a:tcPr marL="91440" marR="91440" marT="36576" marB="36576" anchor="ctr">
-                    <a:lnL w="0">
-                      <a:noFill/>
-                    </a:lnL>
-                    <a:lnR w="0">
-                      <a:noFill/>
-                    </a:lnR>
-                    <a:lnT w="0">
-                      <a:noFill/>
-                    </a:lnT>
-                    <a:lnB w="9525" cap="flat" cmpd="sng" algn="ctr">
+                    <a:lnB w="9525">
                       <a:solidFill>
                         <a:srgbClr val="DDE2EC"/>
                       </a:solidFill>
@@ -7417,16 +7136,7 @@
                     </a:p>
                   </a:txBody>
                   <a:tcPr marL="91440" marR="91440" marT="36576" marB="36576" anchor="ctr">
-                    <a:lnL w="0">
-                      <a:noFill/>
-                    </a:lnL>
-                    <a:lnR w="0">
-                      <a:noFill/>
-                    </a:lnR>
-                    <a:lnT w="0">
-                      <a:noFill/>
-                    </a:lnT>
-                    <a:lnB w="9525" cap="flat" cmpd="sng" algn="ctr">
+                    <a:lnB w="9525">
                       <a:solidFill>
                         <a:srgbClr val="DDE2EC"/>
                       </a:solidFill>
@@ -7456,16 +7166,7 @@
                     </a:p>
                   </a:txBody>
                   <a:tcPr marL="91440" marR="91440" marT="36576" marB="36576" anchor="ctr">
-                    <a:lnL w="0">
-                      <a:noFill/>
-                    </a:lnL>
-                    <a:lnR w="0">
-                      <a:noFill/>
-                    </a:lnR>
-                    <a:lnT w="0">
-                      <a:noFill/>
-                    </a:lnT>
-                    <a:lnB w="9525" cap="flat" cmpd="sng" algn="ctr">
+                    <a:lnB w="9525">
                       <a:solidFill>
                         <a:srgbClr val="DDE2EC"/>
                       </a:solidFill>
@@ -7497,16 +7198,7 @@
                     </a:p>
                   </a:txBody>
                   <a:tcPr marL="91440" marR="91440" marT="36576" marB="36576" anchor="ctr">
-                    <a:lnL w="0">
-                      <a:noFill/>
-                    </a:lnL>
-                    <a:lnR w="0">
-                      <a:noFill/>
-                    </a:lnR>
-                    <a:lnT w="0">
-                      <a:noFill/>
-                    </a:lnT>
-                    <a:lnB w="9525" cap="flat" cmpd="sng" algn="ctr">
+                    <a:lnB w="9525">
                       <a:solidFill>
                         <a:srgbClr val="DDE2EC"/>
                       </a:solidFill>
@@ -7536,16 +7228,7 @@
                     </a:p>
                   </a:txBody>
                   <a:tcPr marL="91440" marR="91440" marT="36576" marB="36576" anchor="ctr">
-                    <a:lnL w="0">
-                      <a:noFill/>
-                    </a:lnL>
-                    <a:lnR w="0">
-                      <a:noFill/>
-                    </a:lnR>
-                    <a:lnT w="0">
-                      <a:noFill/>
-                    </a:lnT>
-                    <a:lnB w="9525" cap="flat" cmpd="sng" algn="ctr">
+                    <a:lnB w="9525">
                       <a:solidFill>
                         <a:srgbClr val="DDE2EC"/>
                       </a:solidFill>
@@ -7832,7 +7515,7 @@
                 <a:ea typeface="Malgun Gothic"/>
                 <a:cs typeface="Malgun Gothic"/>
               </a:rPr>
-              <a:t>G078 문희주  ·  WISH FINDER</a:t>
+              <a:t>광주 3반 G078 문희주  ·  WISH FINDER</a:t>
             </a:r>
           </a:p>
         </p:txBody>
@@ -7917,16 +7600,7 @@
                     </a:p>
                   </a:txBody>
                   <a:tcPr marL="91440" marR="91440" marT="36576" marB="36576" anchor="ctr">
-                    <a:lnL w="0">
-                      <a:noFill/>
-                    </a:lnL>
-                    <a:lnR w="0">
-                      <a:noFill/>
-                    </a:lnR>
-                    <a:lnT w="0">
-                      <a:noFill/>
-                    </a:lnT>
-                    <a:lnB w="9525" cap="flat" cmpd="sng" algn="ctr">
+                    <a:lnB w="9525">
                       <a:solidFill>
                         <a:srgbClr val="DDE2EC"/>
                       </a:solidFill>
@@ -7956,16 +7630,7 @@
                     </a:p>
                   </a:txBody>
                   <a:tcPr marL="91440" marR="91440" marT="36576" marB="36576" anchor="ctr">
-                    <a:lnL w="0">
-                      <a:noFill/>
-                    </a:lnL>
-                    <a:lnR w="0">
-                      <a:noFill/>
-                    </a:lnR>
-                    <a:lnT w="0">
-                      <a:noFill/>
-                    </a:lnT>
-                    <a:lnB w="9525" cap="flat" cmpd="sng" algn="ctr">
+                    <a:lnB w="9525">
                       <a:solidFill>
                         <a:srgbClr val="DDE2EC"/>
                       </a:solidFill>
@@ -7997,16 +7662,7 @@
                     </a:p>
                   </a:txBody>
                   <a:tcPr marL="91440" marR="91440" marT="36576" marB="36576" anchor="ctr">
-                    <a:lnL w="0">
-                      <a:noFill/>
-                    </a:lnL>
-                    <a:lnR w="0">
-                      <a:noFill/>
-                    </a:lnR>
-                    <a:lnT w="0">
-                      <a:noFill/>
-                    </a:lnT>
-                    <a:lnB w="9525" cap="flat" cmpd="sng" algn="ctr">
+                    <a:lnB w="9525">
                       <a:solidFill>
                         <a:srgbClr val="DDE2EC"/>
                       </a:solidFill>
@@ -8036,16 +7692,7 @@
                     </a:p>
                   </a:txBody>
                   <a:tcPr marL="91440" marR="91440" marT="36576" marB="36576" anchor="ctr">
-                    <a:lnL w="0">
-                      <a:noFill/>
-                    </a:lnL>
-                    <a:lnR w="0">
-                      <a:noFill/>
-                    </a:lnR>
-                    <a:lnT w="0">
-                      <a:noFill/>
-                    </a:lnT>
-                    <a:lnB w="9525" cap="flat" cmpd="sng" algn="ctr">
+                    <a:lnB w="9525">
                       <a:solidFill>
                         <a:srgbClr val="DDE2EC"/>
                       </a:solidFill>
@@ -8077,16 +7724,7 @@
                     </a:p>
                   </a:txBody>
                   <a:tcPr marL="91440" marR="91440" marT="36576" marB="36576" anchor="ctr">
-                    <a:lnL w="0">
-                      <a:noFill/>
-                    </a:lnL>
-                    <a:lnR w="0">
-                      <a:noFill/>
-                    </a:lnR>
-                    <a:lnT w="0">
-                      <a:noFill/>
-                    </a:lnT>
-                    <a:lnB w="9525" cap="flat" cmpd="sng" algn="ctr">
+                    <a:lnB w="9525">
                       <a:solidFill>
                         <a:srgbClr val="DDE2EC"/>
                       </a:solidFill>
@@ -8111,21 +7749,24 @@
                           <a:ea typeface="Malgun Gothic"/>
                           <a:cs typeface="Malgun Gothic"/>
                         </a:rPr>
-                        <a:t>검색 → 원본 cue 대조 → 의미 판정 → 영상 시점과 앞뒤 자막</a:t>
+                        <a:t>검색 → 원본 cue 대조 → 의미 판정</a:t>
+                      </a:r>
+                      <a:br/>
+                      <a:r>
+                        <a:rPr sz="1500" b="0">
+                          <a:solidFill>
+                            <a:srgbClr val="1B2437"/>
+                          </a:solidFill>
+                          <a:latin typeface="Malgun Gothic"/>
+                          <a:ea typeface="Malgun Gothic"/>
+                          <a:cs typeface="Malgun Gothic"/>
+                        </a:rPr>
+                        <a:t>→ 영상 시점과 앞뒤 자막</a:t>
                       </a:r>
                     </a:p>
                   </a:txBody>
                   <a:tcPr marL="91440" marR="91440" marT="36576" marB="36576" anchor="ctr">
-                    <a:lnL w="0">
-                      <a:noFill/>
-                    </a:lnL>
-                    <a:lnR w="0">
-                      <a:noFill/>
-                    </a:lnR>
-                    <a:lnT w="0">
-                      <a:noFill/>
-                    </a:lnT>
-                    <a:lnB w="9525" cap="flat" cmpd="sng" algn="ctr">
+                    <a:lnB w="9525">
                       <a:solidFill>
                         <a:srgbClr val="DDE2EC"/>
                       </a:solidFill>
@@ -8157,16 +7798,7 @@
                     </a:p>
                   </a:txBody>
                   <a:tcPr marL="91440" marR="91440" marT="36576" marB="36576" anchor="ctr">
-                    <a:lnL w="0">
-                      <a:noFill/>
-                    </a:lnL>
-                    <a:lnR w="0">
-                      <a:noFill/>
-                    </a:lnR>
-                    <a:lnT w="0">
-                      <a:noFill/>
-                    </a:lnT>
-                    <a:lnB w="9525" cap="flat" cmpd="sng" algn="ctr">
+                    <a:lnB w="9525">
                       <a:solidFill>
                         <a:srgbClr val="DDE2EC"/>
                       </a:solidFill>
@@ -8191,21 +7823,24 @@
                           <a:ea typeface="Malgun Gothic"/>
                           <a:cs typeface="Malgun Gothic"/>
                         </a:rPr>
-                        <a:t>자막은 영어 번역본이고 화자 표시가 없어, 화자는 단정하지 않는다</a:t>
+                        <a:t>자막은 영어 번역본이고 화자 표시가 없어,</a:t>
+                      </a:r>
+                      <a:br/>
+                      <a:r>
+                        <a:rPr sz="1500" b="0">
+                          <a:solidFill>
+                            <a:srgbClr val="1B2437"/>
+                          </a:solidFill>
+                          <a:latin typeface="Malgun Gothic"/>
+                          <a:ea typeface="Malgun Gothic"/>
+                          <a:cs typeface="Malgun Gothic"/>
+                        </a:rPr>
+                        <a:t>화자는 단정하지 않는다</a:t>
                       </a:r>
                     </a:p>
                   </a:txBody>
                   <a:tcPr marL="91440" marR="91440" marT="36576" marB="36576" anchor="ctr">
-                    <a:lnL w="0">
-                      <a:noFill/>
-                    </a:lnL>
-                    <a:lnR w="0">
-                      <a:noFill/>
-                    </a:lnR>
-                    <a:lnT w="0">
-                      <a:noFill/>
-                    </a:lnT>
-                    <a:lnB w="9525" cap="flat" cmpd="sng" algn="ctr">
+                    <a:lnB w="9525">
                       <a:solidFill>
                         <a:srgbClr val="DDE2EC"/>
                       </a:solidFill>
@@ -8370,16 +8005,7 @@
                     </a:p>
                   </a:txBody>
                   <a:tcPr marL="91440" marR="91440" marT="36576" marB="36576" anchor="ctr">
-                    <a:lnL w="0">
-                      <a:noFill/>
-                    </a:lnL>
-                    <a:lnR w="0">
-                      <a:noFill/>
-                    </a:lnR>
-                    <a:lnT w="0">
-                      <a:noFill/>
-                    </a:lnT>
-                    <a:lnB w="9525" cap="flat" cmpd="sng" algn="ctr">
+                    <a:lnB w="9525">
                       <a:solidFill>
                         <a:srgbClr val="DDE2EC"/>
                       </a:solidFill>
@@ -8409,16 +8035,7 @@
                     </a:p>
                   </a:txBody>
                   <a:tcPr marL="91440" marR="91440" marT="36576" marB="36576" anchor="ctr">
-                    <a:lnL w="0">
-                      <a:noFill/>
-                    </a:lnL>
-                    <a:lnR w="0">
-                      <a:noFill/>
-                    </a:lnR>
-                    <a:lnT w="0">
-                      <a:noFill/>
-                    </a:lnT>
-                    <a:lnB w="9525" cap="flat" cmpd="sng" algn="ctr">
+                    <a:lnB w="9525">
                       <a:solidFill>
                         <a:srgbClr val="DDE2EC"/>
                       </a:solidFill>
@@ -8448,16 +8065,7 @@
                     </a:p>
                   </a:txBody>
                   <a:tcPr marL="91440" marR="91440" marT="36576" marB="36576" anchor="ctr">
-                    <a:lnL w="0">
-                      <a:noFill/>
-                    </a:lnL>
-                    <a:lnR w="0">
-                      <a:noFill/>
-                    </a:lnR>
-                    <a:lnT w="0">
-                      <a:noFill/>
-                    </a:lnT>
-                    <a:lnB w="9525" cap="flat" cmpd="sng" algn="ctr">
+                    <a:lnB w="9525">
                       <a:solidFill>
                         <a:srgbClr val="DDE2EC"/>
                       </a:solidFill>
@@ -8487,16 +8095,7 @@
                     </a:p>
                   </a:txBody>
                   <a:tcPr marL="91440" marR="91440" marT="36576" marB="36576" anchor="ctr">
-                    <a:lnL w="0">
-                      <a:noFill/>
-                    </a:lnL>
-                    <a:lnR w="0">
-                      <a:noFill/>
-                    </a:lnR>
-                    <a:lnT w="0">
-                      <a:noFill/>
-                    </a:lnT>
-                    <a:lnB w="9525" cap="flat" cmpd="sng" algn="ctr">
+                    <a:lnB w="9525">
                       <a:solidFill>
                         <a:srgbClr val="DDE2EC"/>
                       </a:solidFill>
@@ -8526,16 +8125,7 @@
                     </a:p>
                   </a:txBody>
                   <a:tcPr marL="91440" marR="91440" marT="36576" marB="36576" anchor="ctr">
-                    <a:lnL w="0">
-                      <a:noFill/>
-                    </a:lnL>
-                    <a:lnR w="0">
-                      <a:noFill/>
-                    </a:lnR>
-                    <a:lnT w="0">
-                      <a:noFill/>
-                    </a:lnT>
-                    <a:lnB w="9525" cap="flat" cmpd="sng" algn="ctr">
+                    <a:lnB w="9525">
                       <a:solidFill>
                         <a:srgbClr val="DDE2EC"/>
                       </a:solidFill>
@@ -8565,16 +8155,7 @@
                     </a:p>
                   </a:txBody>
                   <a:tcPr marL="91440" marR="91440" marT="36576" marB="36576" anchor="ctr">
-                    <a:lnL w="0">
-                      <a:noFill/>
-                    </a:lnL>
-                    <a:lnR w="0">
-                      <a:noFill/>
-                    </a:lnR>
-                    <a:lnT w="0">
-                      <a:noFill/>
-                    </a:lnT>
-                    <a:lnB w="9525" cap="flat" cmpd="sng" algn="ctr">
+                    <a:lnB w="9525">
                       <a:solidFill>
                         <a:srgbClr val="DDE2EC"/>
                       </a:solidFill>
@@ -8606,16 +8187,7 @@
                     </a:p>
                   </a:txBody>
                   <a:tcPr marL="91440" marR="91440" marT="36576" marB="36576" anchor="ctr">
-                    <a:lnL w="0">
-                      <a:noFill/>
-                    </a:lnL>
-                    <a:lnR w="0">
-                      <a:noFill/>
-                    </a:lnR>
-                    <a:lnT w="0">
-                      <a:noFill/>
-                    </a:lnT>
-                    <a:lnB w="9525" cap="flat" cmpd="sng" algn="ctr">
+                    <a:lnB w="9525">
                       <a:solidFill>
                         <a:srgbClr val="DDE2EC"/>
                       </a:solidFill>
@@ -8645,16 +8217,7 @@
                     </a:p>
                   </a:txBody>
                   <a:tcPr marL="91440" marR="91440" marT="36576" marB="36576" anchor="ctr">
-                    <a:lnL w="0">
-                      <a:noFill/>
-                    </a:lnL>
-                    <a:lnR w="0">
-                      <a:noFill/>
-                    </a:lnR>
-                    <a:lnT w="0">
-                      <a:noFill/>
-                    </a:lnT>
-                    <a:lnB w="9525" cap="flat" cmpd="sng" algn="ctr">
+                    <a:lnB w="9525">
                       <a:solidFill>
                         <a:srgbClr val="DDE2EC"/>
                       </a:solidFill>
@@ -8684,16 +8247,7 @@
                     </a:p>
                   </a:txBody>
                   <a:tcPr marL="91440" marR="91440" marT="36576" marB="36576" anchor="ctr">
-                    <a:lnL w="0">
-                      <a:noFill/>
-                    </a:lnL>
-                    <a:lnR w="0">
-                      <a:noFill/>
-                    </a:lnR>
-                    <a:lnT w="0">
-                      <a:noFill/>
-                    </a:lnT>
-                    <a:lnB w="9525" cap="flat" cmpd="sng" algn="ctr">
+                    <a:lnB w="9525">
                       <a:solidFill>
                         <a:srgbClr val="DDE2EC"/>
                       </a:solidFill>
@@ -8723,16 +8277,7 @@
                     </a:p>
                   </a:txBody>
                   <a:tcPr marL="91440" marR="91440" marT="36576" marB="36576" anchor="ctr">
-                    <a:lnL w="0">
-                      <a:noFill/>
-                    </a:lnL>
-                    <a:lnR w="0">
-                      <a:noFill/>
-                    </a:lnR>
-                    <a:lnT w="0">
-                      <a:noFill/>
-                    </a:lnT>
-                    <a:lnB w="9525" cap="flat" cmpd="sng" algn="ctr">
+                    <a:lnB w="9525">
                       <a:solidFill>
                         <a:srgbClr val="DDE2EC"/>
                       </a:solidFill>
@@ -8762,16 +8307,7 @@
                     </a:p>
                   </a:txBody>
                   <a:tcPr marL="91440" marR="91440" marT="36576" marB="36576" anchor="ctr">
-                    <a:lnL w="0">
-                      <a:noFill/>
-                    </a:lnL>
-                    <a:lnR w="0">
-                      <a:noFill/>
-                    </a:lnR>
-                    <a:lnT w="0">
-                      <a:noFill/>
-                    </a:lnT>
-                    <a:lnB w="9525" cap="flat" cmpd="sng" algn="ctr">
+                    <a:lnB w="9525">
                       <a:solidFill>
                         <a:srgbClr val="DDE2EC"/>
                       </a:solidFill>
@@ -8801,16 +8337,7 @@
                     </a:p>
                   </a:txBody>
                   <a:tcPr marL="91440" marR="91440" marT="36576" marB="36576" anchor="ctr">
-                    <a:lnL w="0">
-                      <a:noFill/>
-                    </a:lnL>
-                    <a:lnR w="0">
-                      <a:noFill/>
-                    </a:lnR>
-                    <a:lnT w="0">
-                      <a:noFill/>
-                    </a:lnT>
-                    <a:lnB w="9525" cap="flat" cmpd="sng" algn="ctr">
+                    <a:lnB w="9525">
                       <a:solidFill>
                         <a:srgbClr val="DDE2EC"/>
                       </a:solidFill>
@@ -8924,7 +8451,7 @@
                 <a:ea typeface="Malgun Gothic"/>
                 <a:cs typeface="Malgun Gothic"/>
               </a:rPr>
-              <a:t>G078 문희주  ·  WISH FINDER</a:t>
+              <a:t>광주 3반 G078 문희주  ·  WISH FINDER</a:t>
             </a:r>
           </a:p>
         </p:txBody>
@@ -9048,16 +8575,7 @@
                     </a:p>
                   </a:txBody>
                   <a:tcPr marL="91440" marR="91440" marT="36576" marB="36576" anchor="ctr">
-                    <a:lnL w="0">
-                      <a:noFill/>
-                    </a:lnL>
-                    <a:lnR w="0">
-                      <a:noFill/>
-                    </a:lnR>
-                    <a:lnT w="0">
-                      <a:noFill/>
-                    </a:lnT>
-                    <a:lnB w="9525" cap="flat" cmpd="sng" algn="ctr">
+                    <a:lnB w="9525">
                       <a:solidFill>
                         <a:srgbClr val="DDE2EC"/>
                       </a:solidFill>
@@ -9087,16 +8605,7 @@
                     </a:p>
                   </a:txBody>
                   <a:tcPr marL="91440" marR="91440" marT="36576" marB="36576" anchor="ctr">
-                    <a:lnL w="0">
-                      <a:noFill/>
-                    </a:lnL>
-                    <a:lnR w="0">
-                      <a:noFill/>
-                    </a:lnR>
-                    <a:lnT w="0">
-                      <a:noFill/>
-                    </a:lnT>
-                    <a:lnB w="9525" cap="flat" cmpd="sng" algn="ctr">
+                    <a:lnB w="9525">
                       <a:solidFill>
                         <a:srgbClr val="DDE2EC"/>
                       </a:solidFill>
@@ -9126,16 +8635,7 @@
                     </a:p>
                   </a:txBody>
                   <a:tcPr marL="91440" marR="91440" marT="36576" marB="36576" anchor="ctr">
-                    <a:lnL w="0">
-                      <a:noFill/>
-                    </a:lnL>
-                    <a:lnR w="0">
-                      <a:noFill/>
-                    </a:lnR>
-                    <a:lnT w="0">
-                      <a:noFill/>
-                    </a:lnT>
-                    <a:lnB w="9525" cap="flat" cmpd="sng" algn="ctr">
+                    <a:lnB w="9525">
                       <a:solidFill>
                         <a:srgbClr val="DDE2EC"/>
                       </a:solidFill>
@@ -9165,16 +8665,7 @@
                     </a:p>
                   </a:txBody>
                   <a:tcPr marL="91440" marR="91440" marT="36576" marB="36576" anchor="ctr">
-                    <a:lnL w="0">
-                      <a:noFill/>
-                    </a:lnL>
-                    <a:lnR w="0">
-                      <a:noFill/>
-                    </a:lnR>
-                    <a:lnT w="0">
-                      <a:noFill/>
-                    </a:lnT>
-                    <a:lnB w="9525" cap="flat" cmpd="sng" algn="ctr">
+                    <a:lnB w="9525">
                       <a:solidFill>
                         <a:srgbClr val="DDE2EC"/>
                       </a:solidFill>
@@ -9206,16 +8697,7 @@
                     </a:p>
                   </a:txBody>
                   <a:tcPr marL="91440" marR="91440" marT="36576" marB="36576" anchor="ctr">
-                    <a:lnL w="0">
-                      <a:noFill/>
-                    </a:lnL>
-                    <a:lnR w="0">
-                      <a:noFill/>
-                    </a:lnR>
-                    <a:lnT w="0">
-                      <a:noFill/>
-                    </a:lnT>
-                    <a:lnB w="9525" cap="flat" cmpd="sng" algn="ctr">
+                    <a:lnB w="9525">
                       <a:solidFill>
                         <a:srgbClr val="DDE2EC"/>
                       </a:solidFill>
@@ -9245,16 +8727,7 @@
                     </a:p>
                   </a:txBody>
                   <a:tcPr marL="91440" marR="91440" marT="36576" marB="36576" anchor="ctr">
-                    <a:lnL w="0">
-                      <a:noFill/>
-                    </a:lnL>
-                    <a:lnR w="0">
-                      <a:noFill/>
-                    </a:lnR>
-                    <a:lnT w="0">
-                      <a:noFill/>
-                    </a:lnT>
-                    <a:lnB w="9525" cap="flat" cmpd="sng" algn="ctr">
+                    <a:lnB w="9525">
                       <a:solidFill>
                         <a:srgbClr val="DDE2EC"/>
                       </a:solidFill>
@@ -9284,16 +8757,7 @@
                     </a:p>
                   </a:txBody>
                   <a:tcPr marL="91440" marR="91440" marT="36576" marB="36576" anchor="ctr">
-                    <a:lnL w="0">
-                      <a:noFill/>
-                    </a:lnL>
-                    <a:lnR w="0">
-                      <a:noFill/>
-                    </a:lnR>
-                    <a:lnT w="0">
-                      <a:noFill/>
-                    </a:lnT>
-                    <a:lnB w="9525" cap="flat" cmpd="sng" algn="ctr">
+                    <a:lnB w="9525">
                       <a:solidFill>
                         <a:srgbClr val="DDE2EC"/>
                       </a:solidFill>
@@ -9323,16 +8787,7 @@
                     </a:p>
                   </a:txBody>
                   <a:tcPr marL="91440" marR="91440" marT="36576" marB="36576" anchor="ctr">
-                    <a:lnL w="0">
-                      <a:noFill/>
-                    </a:lnL>
-                    <a:lnR w="0">
-                      <a:noFill/>
-                    </a:lnR>
-                    <a:lnT w="0">
-                      <a:noFill/>
-                    </a:lnT>
-                    <a:lnB w="9525" cap="flat" cmpd="sng" algn="ctr">
+                    <a:lnB w="9525">
                       <a:solidFill>
                         <a:srgbClr val="DDE2EC"/>
                       </a:solidFill>
@@ -9364,16 +8819,7 @@
                     </a:p>
                   </a:txBody>
                   <a:tcPr marL="91440" marR="91440" marT="36576" marB="36576" anchor="ctr">
-                    <a:lnL w="0">
-                      <a:noFill/>
-                    </a:lnL>
-                    <a:lnR w="0">
-                      <a:noFill/>
-                    </a:lnR>
-                    <a:lnT w="0">
-                      <a:noFill/>
-                    </a:lnT>
-                    <a:lnB w="9525" cap="flat" cmpd="sng" algn="ctr">
+                    <a:lnB w="9525">
                       <a:solidFill>
                         <a:srgbClr val="DDE2EC"/>
                       </a:solidFill>
@@ -9403,16 +8849,7 @@
                     </a:p>
                   </a:txBody>
                   <a:tcPr marL="91440" marR="91440" marT="36576" marB="36576" anchor="ctr">
-                    <a:lnL w="0">
-                      <a:noFill/>
-                    </a:lnL>
-                    <a:lnR w="0">
-                      <a:noFill/>
-                    </a:lnR>
-                    <a:lnT w="0">
-                      <a:noFill/>
-                    </a:lnT>
-                    <a:lnB w="9525" cap="flat" cmpd="sng" algn="ctr">
+                    <a:lnB w="9525">
                       <a:solidFill>
                         <a:srgbClr val="DDE2EC"/>
                       </a:solidFill>
@@ -9442,16 +8879,7 @@
                     </a:p>
                   </a:txBody>
                   <a:tcPr marL="91440" marR="91440" marT="36576" marB="36576" anchor="ctr">
-                    <a:lnL w="0">
-                      <a:noFill/>
-                    </a:lnL>
-                    <a:lnR w="0">
-                      <a:noFill/>
-                    </a:lnR>
-                    <a:lnT w="0">
-                      <a:noFill/>
-                    </a:lnT>
-                    <a:lnB w="9525" cap="flat" cmpd="sng" algn="ctr">
+                    <a:lnB w="9525">
                       <a:solidFill>
                         <a:srgbClr val="DDE2EC"/>
                       </a:solidFill>
@@ -9481,16 +8909,7 @@
                     </a:p>
                   </a:txBody>
                   <a:tcPr marL="91440" marR="91440" marT="36576" marB="36576" anchor="ctr">
-                    <a:lnL w="0">
-                      <a:noFill/>
-                    </a:lnL>
-                    <a:lnR w="0">
-                      <a:noFill/>
-                    </a:lnR>
-                    <a:lnT w="0">
-                      <a:noFill/>
-                    </a:lnT>
-                    <a:lnB w="9525" cap="flat" cmpd="sng" algn="ctr">
+                    <a:lnB w="9525">
                       <a:solidFill>
                         <a:srgbClr val="DDE2EC"/>
                       </a:solidFill>
@@ -9522,16 +8941,7 @@
                     </a:p>
                   </a:txBody>
                   <a:tcPr marL="91440" marR="91440" marT="36576" marB="36576" anchor="ctr">
-                    <a:lnL w="0">
-                      <a:noFill/>
-                    </a:lnL>
-                    <a:lnR w="0">
-                      <a:noFill/>
-                    </a:lnR>
-                    <a:lnT w="0">
-                      <a:noFill/>
-                    </a:lnT>
-                    <a:lnB w="9525" cap="flat" cmpd="sng" algn="ctr">
+                    <a:lnB w="9525">
                       <a:solidFill>
                         <a:srgbClr val="DDE2EC"/>
                       </a:solidFill>
@@ -9561,16 +8971,7 @@
                     </a:p>
                   </a:txBody>
                   <a:tcPr marL="91440" marR="91440" marT="36576" marB="36576" anchor="ctr">
-                    <a:lnL w="0">
-                      <a:noFill/>
-                    </a:lnL>
-                    <a:lnR w="0">
-                      <a:noFill/>
-                    </a:lnR>
-                    <a:lnT w="0">
-                      <a:noFill/>
-                    </a:lnT>
-                    <a:lnB w="9525" cap="flat" cmpd="sng" algn="ctr">
+                    <a:lnB w="9525">
                       <a:solidFill>
                         <a:srgbClr val="DDE2EC"/>
                       </a:solidFill>
@@ -9600,16 +9001,7 @@
                     </a:p>
                   </a:txBody>
                   <a:tcPr marL="91440" marR="91440" marT="36576" marB="36576" anchor="ctr">
-                    <a:lnL w="0">
-                      <a:noFill/>
-                    </a:lnL>
-                    <a:lnR w="0">
-                      <a:noFill/>
-                    </a:lnR>
-                    <a:lnT w="0">
-                      <a:noFill/>
-                    </a:lnT>
-                    <a:lnB w="9525" cap="flat" cmpd="sng" algn="ctr">
+                    <a:lnB w="9525">
                       <a:solidFill>
                         <a:srgbClr val="DDE2EC"/>
                       </a:solidFill>
@@ -9639,16 +9031,7 @@
                     </a:p>
                   </a:txBody>
                   <a:tcPr marL="91440" marR="91440" marT="36576" marB="36576" anchor="ctr">
-                    <a:lnL w="0">
-                      <a:noFill/>
-                    </a:lnL>
-                    <a:lnR w="0">
-                      <a:noFill/>
-                    </a:lnR>
-                    <a:lnT w="0">
-                      <a:noFill/>
-                    </a:lnT>
-                    <a:lnB w="9525" cap="flat" cmpd="sng" algn="ctr">
+                    <a:lnB w="9525">
                       <a:solidFill>
                         <a:srgbClr val="DDE2EC"/>
                       </a:solidFill>
@@ -9680,16 +9063,7 @@
                     </a:p>
                   </a:txBody>
                   <a:tcPr marL="91440" marR="91440" marT="36576" marB="36576" anchor="ctr">
-                    <a:lnL w="0">
-                      <a:noFill/>
-                    </a:lnL>
-                    <a:lnR w="0">
-                      <a:noFill/>
-                    </a:lnR>
-                    <a:lnT w="0">
-                      <a:noFill/>
-                    </a:lnT>
-                    <a:lnB w="9525" cap="flat" cmpd="sng" algn="ctr">
+                    <a:lnB w="9525">
                       <a:solidFill>
                         <a:srgbClr val="DDE2EC"/>
                       </a:solidFill>
@@ -9719,16 +9093,7 @@
                     </a:p>
                   </a:txBody>
                   <a:tcPr marL="91440" marR="91440" marT="36576" marB="36576" anchor="ctr">
-                    <a:lnL w="0">
-                      <a:noFill/>
-                    </a:lnL>
-                    <a:lnR w="0">
-                      <a:noFill/>
-                    </a:lnR>
-                    <a:lnT w="0">
-                      <a:noFill/>
-                    </a:lnT>
-                    <a:lnB w="9525" cap="flat" cmpd="sng" algn="ctr">
+                    <a:lnB w="9525">
                       <a:solidFill>
                         <a:srgbClr val="DDE2EC"/>
                       </a:solidFill>
@@ -9758,16 +9123,7 @@
                     </a:p>
                   </a:txBody>
                   <a:tcPr marL="91440" marR="91440" marT="36576" marB="36576" anchor="ctr">
-                    <a:lnL w="0">
-                      <a:noFill/>
-                    </a:lnL>
-                    <a:lnR w="0">
-                      <a:noFill/>
-                    </a:lnR>
-                    <a:lnT w="0">
-                      <a:noFill/>
-                    </a:lnT>
-                    <a:lnB w="9525" cap="flat" cmpd="sng" algn="ctr">
+                    <a:lnB w="9525">
                       <a:solidFill>
                         <a:srgbClr val="DDE2EC"/>
                       </a:solidFill>
@@ -9797,16 +9153,7 @@
                     </a:p>
                   </a:txBody>
                   <a:tcPr marL="91440" marR="91440" marT="36576" marB="36576" anchor="ctr">
-                    <a:lnL w="0">
-                      <a:noFill/>
-                    </a:lnL>
-                    <a:lnR w="0">
-                      <a:noFill/>
-                    </a:lnR>
-                    <a:lnT w="0">
-                      <a:noFill/>
-                    </a:lnT>
-                    <a:lnB w="9525" cap="flat" cmpd="sng" algn="ctr">
+                    <a:lnB w="9525">
                       <a:solidFill>
                         <a:srgbClr val="DDE2EC"/>
                       </a:solidFill>
@@ -9838,16 +9185,7 @@
                     </a:p>
                   </a:txBody>
                   <a:tcPr marL="91440" marR="91440" marT="36576" marB="36576" anchor="ctr">
-                    <a:lnL w="0">
-                      <a:noFill/>
-                    </a:lnL>
-                    <a:lnR w="0">
-                      <a:noFill/>
-                    </a:lnR>
-                    <a:lnT w="0">
-                      <a:noFill/>
-                    </a:lnT>
-                    <a:lnB w="9525" cap="flat" cmpd="sng" algn="ctr">
+                    <a:lnB w="9525">
                       <a:solidFill>
                         <a:srgbClr val="DDE2EC"/>
                       </a:solidFill>
@@ -9877,16 +9215,7 @@
                     </a:p>
                   </a:txBody>
                   <a:tcPr marL="91440" marR="91440" marT="36576" marB="36576" anchor="ctr">
-                    <a:lnL w="0">
-                      <a:noFill/>
-                    </a:lnL>
-                    <a:lnR w="0">
-                      <a:noFill/>
-                    </a:lnR>
-                    <a:lnT w="0">
-                      <a:noFill/>
-                    </a:lnT>
-                    <a:lnB w="9525" cap="flat" cmpd="sng" algn="ctr">
+                    <a:lnB w="9525">
                       <a:solidFill>
                         <a:srgbClr val="DDE2EC"/>
                       </a:solidFill>
@@ -9916,16 +9245,7 @@
                     </a:p>
                   </a:txBody>
                   <a:tcPr marL="91440" marR="91440" marT="36576" marB="36576" anchor="ctr">
-                    <a:lnL w="0">
-                      <a:noFill/>
-                    </a:lnL>
-                    <a:lnR w="0">
-                      <a:noFill/>
-                    </a:lnR>
-                    <a:lnT w="0">
-                      <a:noFill/>
-                    </a:lnT>
-                    <a:lnB w="9525" cap="flat" cmpd="sng" algn="ctr">
+                    <a:lnB w="9525">
                       <a:solidFill>
                         <a:srgbClr val="DDE2EC"/>
                       </a:solidFill>
@@ -9955,16 +9275,7 @@
                     </a:p>
                   </a:txBody>
                   <a:tcPr marL="91440" marR="91440" marT="36576" marB="36576" anchor="ctr">
-                    <a:lnL w="0">
-                      <a:noFill/>
-                    </a:lnL>
-                    <a:lnR w="0">
-                      <a:noFill/>
-                    </a:lnR>
-                    <a:lnT w="0">
-                      <a:noFill/>
-                    </a:lnT>
-                    <a:lnB w="9525" cap="flat" cmpd="sng" algn="ctr">
+                    <a:lnB w="9525">
                       <a:solidFill>
                         <a:srgbClr val="DDE2EC"/>
                       </a:solidFill>
@@ -10026,7 +9337,7 @@
         </p:nvGraphicFramePr>
         <p:xfrm>
           <a:off x="7132320" y="1737360"/>
-          <a:ext cx="4572000" cy="3154680"/>
+          <a:ext cx="4572000" cy="2926080"/>
         </p:xfrm>
         <a:graphic>
           <a:graphicData uri="http://schemas.openxmlformats.org/drawingml/2006/chart">
@@ -10042,8 +9353,8 @@
         </p:nvSpPr>
         <p:spPr>
           <a:xfrm>
-            <a:off x="7223760" y="4892040"/>
-            <a:ext cx="4480560" cy="365760"/>
+            <a:off x="7223760" y="4727448"/>
+            <a:ext cx="4480560" cy="502920"/>
           </a:xfrm>
           <a:prstGeom prst="rect">
             <a:avLst/>
@@ -10056,9 +9367,27 @@
           </a:bodyPr>
           <a:lstStyle/>
           <a:p>
+            <a:pPr algn="l">
+              <a:spcAft>
+                <a:spcPts val="100"/>
+              </a:spcAft>
+            </a:pPr>
+            <a:r>
+              <a:rPr sz="1100" b="0">
+                <a:solidFill>
+                  <a:srgbClr val="5B6577"/>
+                </a:solidFill>
+                <a:latin typeface="Malgun Gothic"/>
+                <a:ea typeface="Malgun Gothic"/>
+                <a:cs typeface="Malgun Gothic"/>
+              </a:rPr>
+              <a:t>A 키워드 · B Hybrid(키워드+의미) · C Agent(Hybrid+검증·재검색)</a:t>
+            </a:r>
+          </a:p>
+          <a:p>
             <a:pPr algn="l"/>
             <a:r>
-              <a:rPr sz="1200" b="0">
+              <a:rPr sz="1100" b="0">
                 <a:solidFill>
                   <a:srgbClr val="5B6577"/>
                 </a:solidFill>
@@ -10666,7 +9995,7 @@
                 <a:ea typeface="Malgun Gothic"/>
                 <a:cs typeface="Malgun Gothic"/>
               </a:rPr>
-              <a:t>G078 문희주  ·  WISH FINDER</a:t>
+              <a:t>광주 3반 G078 문희주  ·  WISH FINDER</a:t>
             </a:r>
           </a:p>
         </p:txBody>
@@ -10775,16 +10104,7 @@
                     </a:p>
                   </a:txBody>
                   <a:tcPr marL="91440" marR="91440" marT="36576" marB="36576" anchor="ctr">
-                    <a:lnL w="0">
-                      <a:noFill/>
-                    </a:lnL>
-                    <a:lnR w="0">
-                      <a:noFill/>
-                    </a:lnR>
-                    <a:lnT w="0">
-                      <a:noFill/>
-                    </a:lnT>
-                    <a:lnB w="9525" cap="flat" cmpd="sng" algn="ctr">
+                    <a:lnB w="9525">
                       <a:solidFill>
                         <a:srgbClr val="DDE2EC"/>
                       </a:solidFill>
@@ -10814,16 +10134,7 @@
                     </a:p>
                   </a:txBody>
                   <a:tcPr marL="91440" marR="91440" marT="36576" marB="36576" anchor="ctr">
-                    <a:lnL w="0">
-                      <a:noFill/>
-                    </a:lnL>
-                    <a:lnR w="0">
-                      <a:noFill/>
-                    </a:lnR>
-                    <a:lnT w="0">
-                      <a:noFill/>
-                    </a:lnT>
-                    <a:lnB w="9525" cap="flat" cmpd="sng" algn="ctr">
+                    <a:lnB w="9525">
                       <a:solidFill>
                         <a:srgbClr val="DDE2EC"/>
                       </a:solidFill>
@@ -10855,16 +10166,7 @@
                     </a:p>
                   </a:txBody>
                   <a:tcPr marL="91440" marR="91440" marT="36576" marB="36576" anchor="ctr">
-                    <a:lnL w="0">
-                      <a:noFill/>
-                    </a:lnL>
-                    <a:lnR w="0">
-                      <a:noFill/>
-                    </a:lnR>
-                    <a:lnT w="0">
-                      <a:noFill/>
-                    </a:lnT>
-                    <a:lnB w="9525" cap="flat" cmpd="sng" algn="ctr">
+                    <a:lnB w="9525">
                       <a:solidFill>
                         <a:srgbClr val="DDE2EC"/>
                       </a:solidFill>
@@ -10894,16 +10196,7 @@
                     </a:p>
                   </a:txBody>
                   <a:tcPr marL="91440" marR="91440" marT="36576" marB="36576" anchor="ctr">
-                    <a:lnL w="0">
-                      <a:noFill/>
-                    </a:lnL>
-                    <a:lnR w="0">
-                      <a:noFill/>
-                    </a:lnR>
-                    <a:lnT w="0">
-                      <a:noFill/>
-                    </a:lnT>
-                    <a:lnB w="9525" cap="flat" cmpd="sng" algn="ctr">
+                    <a:lnB w="9525">
                       <a:solidFill>
                         <a:srgbClr val="DDE2EC"/>
                       </a:solidFill>
@@ -10935,16 +10228,7 @@
                     </a:p>
                   </a:txBody>
                   <a:tcPr marL="91440" marR="91440" marT="36576" marB="36576" anchor="ctr">
-                    <a:lnL w="0">
-                      <a:noFill/>
-                    </a:lnL>
-                    <a:lnR w="0">
-                      <a:noFill/>
-                    </a:lnR>
-                    <a:lnT w="0">
-                      <a:noFill/>
-                    </a:lnT>
-                    <a:lnB w="9525" cap="flat" cmpd="sng" algn="ctr">
+                    <a:lnB w="9525">
                       <a:solidFill>
                         <a:srgbClr val="DDE2EC"/>
                       </a:solidFill>
@@ -10974,16 +10258,7 @@
                     </a:p>
                   </a:txBody>
                   <a:tcPr marL="91440" marR="91440" marT="36576" marB="36576" anchor="ctr">
-                    <a:lnL w="0">
-                      <a:noFill/>
-                    </a:lnL>
-                    <a:lnR w="0">
-                      <a:noFill/>
-                    </a:lnR>
-                    <a:lnT w="0">
-                      <a:noFill/>
-                    </a:lnT>
-                    <a:lnB w="9525" cap="flat" cmpd="sng" algn="ctr">
+                    <a:lnB w="9525">
                       <a:solidFill>
                         <a:srgbClr val="DDE2EC"/>
                       </a:solidFill>
@@ -11015,16 +10290,7 @@
                     </a:p>
                   </a:txBody>
                   <a:tcPr marL="91440" marR="91440" marT="36576" marB="36576" anchor="ctr">
-                    <a:lnL w="0">
-                      <a:noFill/>
-                    </a:lnL>
-                    <a:lnR w="0">
-                      <a:noFill/>
-                    </a:lnR>
-                    <a:lnT w="0">
-                      <a:noFill/>
-                    </a:lnT>
-                    <a:lnB w="9525" cap="flat" cmpd="sng" algn="ctr">
+                    <a:lnB w="9525">
                       <a:solidFill>
                         <a:srgbClr val="DDE2EC"/>
                       </a:solidFill>
@@ -11054,16 +10320,7 @@
                     </a:p>
                   </a:txBody>
                   <a:tcPr marL="91440" marR="91440" marT="36576" marB="36576" anchor="ctr">
-                    <a:lnL w="0">
-                      <a:noFill/>
-                    </a:lnL>
-                    <a:lnR w="0">
-                      <a:noFill/>
-                    </a:lnR>
-                    <a:lnT w="0">
-                      <a:noFill/>
-                    </a:lnT>
-                    <a:lnB w="9525" cap="flat" cmpd="sng" algn="ctr">
+                    <a:lnB w="9525">
                       <a:solidFill>
                         <a:srgbClr val="DDE2EC"/>
                       </a:solidFill>
@@ -11095,16 +10352,7 @@
                     </a:p>
                   </a:txBody>
                   <a:tcPr marL="91440" marR="91440" marT="36576" marB="36576" anchor="ctr">
-                    <a:lnL w="0">
-                      <a:noFill/>
-                    </a:lnL>
-                    <a:lnR w="0">
-                      <a:noFill/>
-                    </a:lnR>
-                    <a:lnT w="0">
-                      <a:noFill/>
-                    </a:lnT>
-                    <a:lnB w="9525" cap="flat" cmpd="sng" algn="ctr">
+                    <a:lnB w="9525">
                       <a:solidFill>
                         <a:srgbClr val="DDE2EC"/>
                       </a:solidFill>
@@ -11134,16 +10382,7 @@
                     </a:p>
                   </a:txBody>
                   <a:tcPr marL="91440" marR="91440" marT="36576" marB="36576" anchor="ctr">
-                    <a:lnL w="0">
-                      <a:noFill/>
-                    </a:lnL>
-                    <a:lnR w="0">
-                      <a:noFill/>
-                    </a:lnR>
-                    <a:lnT w="0">
-                      <a:noFill/>
-                    </a:lnT>
-                    <a:lnB w="9525" cap="flat" cmpd="sng" algn="ctr">
+                    <a:lnB w="9525">
                       <a:solidFill>
                         <a:srgbClr val="DDE2EC"/>
                       </a:solidFill>
@@ -11175,16 +10414,7 @@
                     </a:p>
                   </a:txBody>
                   <a:tcPr marL="91440" marR="91440" marT="36576" marB="36576" anchor="ctr">
-                    <a:lnL w="0">
-                      <a:noFill/>
-                    </a:lnL>
-                    <a:lnR w="0">
-                      <a:noFill/>
-                    </a:lnR>
-                    <a:lnT w="0">
-                      <a:noFill/>
-                    </a:lnT>
-                    <a:lnB w="9525" cap="flat" cmpd="sng" algn="ctr">
+                    <a:lnB w="9525">
                       <a:solidFill>
                         <a:srgbClr val="DDE2EC"/>
                       </a:solidFill>
@@ -11214,16 +10444,7 @@
                     </a:p>
                   </a:txBody>
                   <a:tcPr marL="91440" marR="91440" marT="36576" marB="36576" anchor="ctr">
-                    <a:lnL w="0">
-                      <a:noFill/>
-                    </a:lnL>
-                    <a:lnR w="0">
-                      <a:noFill/>
-                    </a:lnR>
-                    <a:lnT w="0">
-                      <a:noFill/>
-                    </a:lnT>
-                    <a:lnB w="9525" cap="flat" cmpd="sng" algn="ctr">
+                    <a:lnB w="9525">
                       <a:solidFill>
                         <a:srgbClr val="DDE2EC"/>
                       </a:solidFill>
@@ -11255,16 +10476,7 @@
                     </a:p>
                   </a:txBody>
                   <a:tcPr marL="91440" marR="91440" marT="36576" marB="36576" anchor="ctr">
-                    <a:lnL w="0">
-                      <a:noFill/>
-                    </a:lnL>
-                    <a:lnR w="0">
-                      <a:noFill/>
-                    </a:lnR>
-                    <a:lnT w="0">
-                      <a:noFill/>
-                    </a:lnT>
-                    <a:lnB w="9525" cap="flat" cmpd="sng" algn="ctr">
+                    <a:lnB w="9525">
                       <a:solidFill>
                         <a:srgbClr val="DDE2EC"/>
                       </a:solidFill>
@@ -11294,16 +10506,7 @@
                     </a:p>
                   </a:txBody>
                   <a:tcPr marL="91440" marR="91440" marT="36576" marB="36576" anchor="ctr">
-                    <a:lnL w="0">
-                      <a:noFill/>
-                    </a:lnL>
-                    <a:lnR w="0">
-                      <a:noFill/>
-                    </a:lnR>
-                    <a:lnT w="0">
-                      <a:noFill/>
-                    </a:lnT>
-                    <a:lnB w="9525" cap="flat" cmpd="sng" algn="ctr">
+                    <a:lnB w="9525">
                       <a:solidFill>
                         <a:srgbClr val="DDE2EC"/>
                       </a:solidFill>
@@ -11335,16 +10538,7 @@
                     </a:p>
                   </a:txBody>
                   <a:tcPr marL="91440" marR="91440" marT="36576" marB="36576" anchor="ctr">
-                    <a:lnL w="0">
-                      <a:noFill/>
-                    </a:lnL>
-                    <a:lnR w="0">
-                      <a:noFill/>
-                    </a:lnR>
-                    <a:lnT w="0">
-                      <a:noFill/>
-                    </a:lnT>
-                    <a:lnB w="9525" cap="flat" cmpd="sng" algn="ctr">
+                    <a:lnB w="9525">
                       <a:solidFill>
                         <a:srgbClr val="DDE2EC"/>
                       </a:solidFill>
@@ -11374,16 +10568,7 @@
                     </a:p>
                   </a:txBody>
                   <a:tcPr marL="91440" marR="91440" marT="36576" marB="36576" anchor="ctr">
-                    <a:lnL w="0">
-                      <a:noFill/>
-                    </a:lnL>
-                    <a:lnR w="0">
-                      <a:noFill/>
-                    </a:lnR>
-                    <a:lnT w="0">
-                      <a:noFill/>
-                    </a:lnT>
-                    <a:lnB w="9525" cap="flat" cmpd="sng" algn="ctr">
+                    <a:lnB w="9525">
                       <a:solidFill>
                         <a:srgbClr val="DDE2EC"/>
                       </a:solidFill>
@@ -11497,7 +10682,7 @@
                 <a:ea typeface="Malgun Gothic"/>
                 <a:cs typeface="Malgun Gothic"/>
               </a:rPr>
-              <a:t>G078 문희주  ·  WISH FINDER</a:t>
+              <a:t>광주 3반 G078 문희주  ·  WISH FINDER</a:t>
             </a:r>
           </a:p>
         </p:txBody>
@@ -11606,16 +10791,7 @@
                     </a:p>
                   </a:txBody>
                   <a:tcPr marL="91440" marR="91440" marT="36576" marB="36576" anchor="ctr">
-                    <a:lnL w="0">
-                      <a:noFill/>
-                    </a:lnL>
-                    <a:lnR w="0">
-                      <a:noFill/>
-                    </a:lnR>
-                    <a:lnT w="0">
-                      <a:noFill/>
-                    </a:lnT>
-                    <a:lnB w="9525" cap="flat" cmpd="sng" algn="ctr">
+                    <a:lnB w="9525">
                       <a:solidFill>
                         <a:srgbClr val="DDE2EC"/>
                       </a:solidFill>
@@ -11645,16 +10821,7 @@
                     </a:p>
                   </a:txBody>
                   <a:tcPr marL="91440" marR="91440" marT="36576" marB="36576" anchor="ctr">
-                    <a:lnL w="0">
-                      <a:noFill/>
-                    </a:lnL>
-                    <a:lnR w="0">
-                      <a:noFill/>
-                    </a:lnR>
-                    <a:lnT w="0">
-                      <a:noFill/>
-                    </a:lnT>
-                    <a:lnB w="9525" cap="flat" cmpd="sng" algn="ctr">
+                    <a:lnB w="9525">
                       <a:solidFill>
                         <a:srgbClr val="DDE2EC"/>
                       </a:solidFill>
@@ -11686,16 +10853,7 @@
                     </a:p>
                   </a:txBody>
                   <a:tcPr marL="91440" marR="91440" marT="36576" marB="36576" anchor="ctr">
-                    <a:lnL w="0">
-                      <a:noFill/>
-                    </a:lnL>
-                    <a:lnR w="0">
-                      <a:noFill/>
-                    </a:lnR>
-                    <a:lnT w="0">
-                      <a:noFill/>
-                    </a:lnT>
-                    <a:lnB w="9525" cap="flat" cmpd="sng" algn="ctr">
+                    <a:lnB w="9525">
                       <a:solidFill>
                         <a:srgbClr val="DDE2EC"/>
                       </a:solidFill>
@@ -11725,16 +10883,7 @@
                     </a:p>
                   </a:txBody>
                   <a:tcPr marL="91440" marR="91440" marT="36576" marB="36576" anchor="ctr">
-                    <a:lnL w="0">
-                      <a:noFill/>
-                    </a:lnL>
-                    <a:lnR w="0">
-                      <a:noFill/>
-                    </a:lnR>
-                    <a:lnT w="0">
-                      <a:noFill/>
-                    </a:lnT>
-                    <a:lnB w="9525" cap="flat" cmpd="sng" algn="ctr">
+                    <a:lnB w="9525">
                       <a:solidFill>
                         <a:srgbClr val="DDE2EC"/>
                       </a:solidFill>
@@ -11766,16 +10915,7 @@
                     </a:p>
                   </a:txBody>
                   <a:tcPr marL="91440" marR="91440" marT="36576" marB="36576" anchor="ctr">
-                    <a:lnL w="0">
-                      <a:noFill/>
-                    </a:lnL>
-                    <a:lnR w="0">
-                      <a:noFill/>
-                    </a:lnR>
-                    <a:lnT w="0">
-                      <a:noFill/>
-                    </a:lnT>
-                    <a:lnB w="9525" cap="flat" cmpd="sng" algn="ctr">
+                    <a:lnB w="9525">
                       <a:solidFill>
                         <a:srgbClr val="DDE2EC"/>
                       </a:solidFill>
@@ -11805,16 +10945,7 @@
                     </a:p>
                   </a:txBody>
                   <a:tcPr marL="91440" marR="91440" marT="36576" marB="36576" anchor="ctr">
-                    <a:lnL w="0">
-                      <a:noFill/>
-                    </a:lnL>
-                    <a:lnR w="0">
-                      <a:noFill/>
-                    </a:lnR>
-                    <a:lnT w="0">
-                      <a:noFill/>
-                    </a:lnT>
-                    <a:lnB w="9525" cap="flat" cmpd="sng" algn="ctr">
+                    <a:lnB w="9525">
                       <a:solidFill>
                         <a:srgbClr val="DDE2EC"/>
                       </a:solidFill>
@@ -11846,16 +10977,7 @@
                     </a:p>
                   </a:txBody>
                   <a:tcPr marL="91440" marR="91440" marT="36576" marB="36576" anchor="ctr">
-                    <a:lnL w="0">
-                      <a:noFill/>
-                    </a:lnL>
-                    <a:lnR w="0">
-                      <a:noFill/>
-                    </a:lnR>
-                    <a:lnT w="0">
-                      <a:noFill/>
-                    </a:lnT>
-                    <a:lnB w="9525" cap="flat" cmpd="sng" algn="ctr">
+                    <a:lnB w="9525">
                       <a:solidFill>
                         <a:srgbClr val="DDE2EC"/>
                       </a:solidFill>
@@ -11885,16 +11007,7 @@
                     </a:p>
                   </a:txBody>
                   <a:tcPr marL="91440" marR="91440" marT="36576" marB="36576" anchor="ctr">
-                    <a:lnL w="0">
-                      <a:noFill/>
-                    </a:lnL>
-                    <a:lnR w="0">
-                      <a:noFill/>
-                    </a:lnR>
-                    <a:lnT w="0">
-                      <a:noFill/>
-                    </a:lnT>
-                    <a:lnB w="9525" cap="flat" cmpd="sng" algn="ctr">
+                    <a:lnB w="9525">
                       <a:solidFill>
                         <a:srgbClr val="DDE2EC"/>
                       </a:solidFill>
@@ -11926,16 +11039,7 @@
                     </a:p>
                   </a:txBody>
                   <a:tcPr marL="91440" marR="91440" marT="36576" marB="36576" anchor="ctr">
-                    <a:lnL w="0">
-                      <a:noFill/>
-                    </a:lnL>
-                    <a:lnR w="0">
-                      <a:noFill/>
-                    </a:lnR>
-                    <a:lnT w="0">
-                      <a:noFill/>
-                    </a:lnT>
-                    <a:lnB w="9525" cap="flat" cmpd="sng" algn="ctr">
+                    <a:lnB w="9525">
                       <a:solidFill>
                         <a:srgbClr val="DDE2EC"/>
                       </a:solidFill>
@@ -11965,16 +11069,7 @@
                     </a:p>
                   </a:txBody>
                   <a:tcPr marL="91440" marR="91440" marT="36576" marB="36576" anchor="ctr">
-                    <a:lnL w="0">
-                      <a:noFill/>
-                    </a:lnL>
-                    <a:lnR w="0">
-                      <a:noFill/>
-                    </a:lnR>
-                    <a:lnT w="0">
-                      <a:noFill/>
-                    </a:lnT>
-                    <a:lnB w="9525" cap="flat" cmpd="sng" algn="ctr">
+                    <a:lnB w="9525">
                       <a:solidFill>
                         <a:srgbClr val="DDE2EC"/>
                       </a:solidFill>
@@ -12006,16 +11101,7 @@
                     </a:p>
                   </a:txBody>
                   <a:tcPr marL="91440" marR="91440" marT="36576" marB="36576" anchor="ctr">
-                    <a:lnL w="0">
-                      <a:noFill/>
-                    </a:lnL>
-                    <a:lnR w="0">
-                      <a:noFill/>
-                    </a:lnR>
-                    <a:lnT w="0">
-                      <a:noFill/>
-                    </a:lnT>
-                    <a:lnB w="9525" cap="flat" cmpd="sng" algn="ctr">
+                    <a:lnB w="9525">
                       <a:solidFill>
                         <a:srgbClr val="DDE2EC"/>
                       </a:solidFill>
@@ -12045,16 +11131,7 @@
                     </a:p>
                   </a:txBody>
                   <a:tcPr marL="91440" marR="91440" marT="36576" marB="36576" anchor="ctr">
-                    <a:lnL w="0">
-                      <a:noFill/>
-                    </a:lnL>
-                    <a:lnR w="0">
-                      <a:noFill/>
-                    </a:lnR>
-                    <a:lnT w="0">
-                      <a:noFill/>
-                    </a:lnT>
-                    <a:lnB w="9525" cap="flat" cmpd="sng" algn="ctr">
+                    <a:lnB w="9525">
                       <a:solidFill>
                         <a:srgbClr val="DDE2EC"/>
                       </a:solidFill>
@@ -12673,7 +11750,7 @@
                 <a:ea typeface="Malgun Gothic"/>
                 <a:cs typeface="Malgun Gothic"/>
               </a:rPr>
-              <a:t>G078 문희주  ·  WISH FINDER</a:t>
+              <a:t>광주 3반 G078 문희주  ·  WISH FINDER</a:t>
             </a:r>
           </a:p>
         </p:txBody>
@@ -12758,16 +11835,7 @@
                     </a:p>
                   </a:txBody>
                   <a:tcPr marL="91440" marR="91440" marT="36576" marB="36576" anchor="ctr">
-                    <a:lnL w="0">
-                      <a:noFill/>
-                    </a:lnL>
-                    <a:lnR w="0">
-                      <a:noFill/>
-                    </a:lnR>
-                    <a:lnT w="0">
-                      <a:noFill/>
-                    </a:lnT>
-                    <a:lnB w="9525" cap="flat" cmpd="sng" algn="ctr">
+                    <a:lnB w="9525">
                       <a:solidFill>
                         <a:srgbClr val="DDE2EC"/>
                       </a:solidFill>
@@ -12797,16 +11865,7 @@
                     </a:p>
                   </a:txBody>
                   <a:tcPr marL="91440" marR="91440" marT="36576" marB="36576" anchor="ctr">
-                    <a:lnL w="0">
-                      <a:noFill/>
-                    </a:lnL>
-                    <a:lnR w="0">
-                      <a:noFill/>
-                    </a:lnR>
-                    <a:lnT w="0">
-                      <a:noFill/>
-                    </a:lnT>
-                    <a:lnB w="9525" cap="flat" cmpd="sng" algn="ctr">
+                    <a:lnB w="9525">
                       <a:solidFill>
                         <a:srgbClr val="DDE2EC"/>
                       </a:solidFill>
@@ -12838,16 +11897,7 @@
                     </a:p>
                   </a:txBody>
                   <a:tcPr marL="91440" marR="91440" marT="36576" marB="36576" anchor="ctr">
-                    <a:lnL w="0">
-                      <a:noFill/>
-                    </a:lnL>
-                    <a:lnR w="0">
-                      <a:noFill/>
-                    </a:lnR>
-                    <a:lnT w="0">
-                      <a:noFill/>
-                    </a:lnT>
-                    <a:lnB w="9525" cap="flat" cmpd="sng" algn="ctr">
+                    <a:lnB w="9525">
                       <a:solidFill>
                         <a:srgbClr val="DDE2EC"/>
                       </a:solidFill>
@@ -12877,16 +11927,7 @@
                     </a:p>
                   </a:txBody>
                   <a:tcPr marL="91440" marR="91440" marT="36576" marB="36576" anchor="ctr">
-                    <a:lnL w="0">
-                      <a:noFill/>
-                    </a:lnL>
-                    <a:lnR w="0">
-                      <a:noFill/>
-                    </a:lnR>
-                    <a:lnT w="0">
-                      <a:noFill/>
-                    </a:lnT>
-                    <a:lnB w="9525" cap="flat" cmpd="sng" algn="ctr">
+                    <a:lnB w="9525">
                       <a:solidFill>
                         <a:srgbClr val="DDE2EC"/>
                       </a:solidFill>
@@ -12918,16 +11959,7 @@
                     </a:p>
                   </a:txBody>
                   <a:tcPr marL="91440" marR="91440" marT="36576" marB="36576" anchor="ctr">
-                    <a:lnL w="0">
-                      <a:noFill/>
-                    </a:lnL>
-                    <a:lnR w="0">
-                      <a:noFill/>
-                    </a:lnR>
-                    <a:lnT w="0">
-                      <a:noFill/>
-                    </a:lnT>
-                    <a:lnB w="9525" cap="flat" cmpd="sng" algn="ctr">
+                    <a:lnB w="9525">
                       <a:solidFill>
                         <a:srgbClr val="DDE2EC"/>
                       </a:solidFill>
@@ -12957,16 +11989,7 @@
                     </a:p>
                   </a:txBody>
                   <a:tcPr marL="91440" marR="91440" marT="36576" marB="36576" anchor="ctr">
-                    <a:lnL w="0">
-                      <a:noFill/>
-                    </a:lnL>
-                    <a:lnR w="0">
-                      <a:noFill/>
-                    </a:lnR>
-                    <a:lnT w="0">
-                      <a:noFill/>
-                    </a:lnT>
-                    <a:lnB w="9525" cap="flat" cmpd="sng" algn="ctr">
+                    <a:lnB w="9525">
                       <a:solidFill>
                         <a:srgbClr val="DDE2EC"/>
                       </a:solidFill>
@@ -12998,16 +12021,7 @@
                     </a:p>
                   </a:txBody>
                   <a:tcPr marL="91440" marR="91440" marT="36576" marB="36576" anchor="ctr">
-                    <a:lnL w="0">
-                      <a:noFill/>
-                    </a:lnL>
-                    <a:lnR w="0">
-                      <a:noFill/>
-                    </a:lnR>
-                    <a:lnT w="0">
-                      <a:noFill/>
-                    </a:lnT>
-                    <a:lnB w="9525" cap="flat" cmpd="sng" algn="ctr">
+                    <a:lnB w="9525">
                       <a:solidFill>
                         <a:srgbClr val="DDE2EC"/>
                       </a:solidFill>
@@ -13037,16 +12051,7 @@
                     </a:p>
                   </a:txBody>
                   <a:tcPr marL="91440" marR="91440" marT="36576" marB="36576" anchor="ctr">
-                    <a:lnL w="0">
-                      <a:noFill/>
-                    </a:lnL>
-                    <a:lnR w="0">
-                      <a:noFill/>
-                    </a:lnR>
-                    <a:lnT w="0">
-                      <a:noFill/>
-                    </a:lnT>
-                    <a:lnB w="9525" cap="flat" cmpd="sng" algn="ctr">
+                    <a:lnB w="9525">
                       <a:solidFill>
                         <a:srgbClr val="DDE2EC"/>
                       </a:solidFill>
@@ -13078,16 +12083,7 @@
                     </a:p>
                   </a:txBody>
                   <a:tcPr marL="91440" marR="91440" marT="36576" marB="36576" anchor="ctr">
-                    <a:lnL w="0">
-                      <a:noFill/>
-                    </a:lnL>
-                    <a:lnR w="0">
-                      <a:noFill/>
-                    </a:lnR>
-                    <a:lnT w="0">
-                      <a:noFill/>
-                    </a:lnT>
-                    <a:lnB w="9525" cap="flat" cmpd="sng" algn="ctr">
+                    <a:lnB w="9525">
                       <a:solidFill>
                         <a:srgbClr val="DDE2EC"/>
                       </a:solidFill>
@@ -13117,16 +12113,7 @@
                     </a:p>
                   </a:txBody>
                   <a:tcPr marL="91440" marR="91440" marT="36576" marB="36576" anchor="ctr">
-                    <a:lnL w="0">
-                      <a:noFill/>
-                    </a:lnL>
-                    <a:lnR w="0">
-                      <a:noFill/>
-                    </a:lnR>
-                    <a:lnT w="0">
-                      <a:noFill/>
-                    </a:lnT>
-                    <a:lnB w="9525" cap="flat" cmpd="sng" algn="ctr">
+                    <a:lnB w="9525">
                       <a:solidFill>
                         <a:srgbClr val="DDE2EC"/>
                       </a:solidFill>
@@ -13184,16 +12171,7 @@
                     </a:p>
                   </a:txBody>
                   <a:tcPr marL="91440" marR="91440" marT="36576" marB="36576" anchor="ctr">
-                    <a:lnL w="0">
-                      <a:noFill/>
-                    </a:lnL>
-                    <a:lnR w="0">
-                      <a:noFill/>
-                    </a:lnR>
-                    <a:lnT w="0">
-                      <a:noFill/>
-                    </a:lnT>
-                    <a:lnB w="9525" cap="flat" cmpd="sng" algn="ctr">
+                    <a:lnB w="9525">
                       <a:solidFill>
                         <a:srgbClr val="DDE2EC"/>
                       </a:solidFill>
@@ -13223,16 +12201,7 @@
                     </a:p>
                   </a:txBody>
                   <a:tcPr marL="91440" marR="91440" marT="36576" marB="36576" anchor="ctr">
-                    <a:lnL w="0">
-                      <a:noFill/>
-                    </a:lnL>
-                    <a:lnR w="0">
-                      <a:noFill/>
-                    </a:lnR>
-                    <a:lnT w="0">
-                      <a:noFill/>
-                    </a:lnT>
-                    <a:lnB w="9525" cap="flat" cmpd="sng" algn="ctr">
+                    <a:lnB w="9525">
                       <a:solidFill>
                         <a:srgbClr val="DDE2EC"/>
                       </a:solidFill>
@@ -13264,16 +12233,7 @@
                     </a:p>
                   </a:txBody>
                   <a:tcPr marL="91440" marR="91440" marT="36576" marB="36576" anchor="ctr">
-                    <a:lnL w="0">
-                      <a:noFill/>
-                    </a:lnL>
-                    <a:lnR w="0">
-                      <a:noFill/>
-                    </a:lnR>
-                    <a:lnT w="0">
-                      <a:noFill/>
-                    </a:lnT>
-                    <a:lnB w="9525" cap="flat" cmpd="sng" algn="ctr">
+                    <a:lnB w="9525">
                       <a:solidFill>
                         <a:srgbClr val="DDE2EC"/>
                       </a:solidFill>
@@ -13303,16 +12263,7 @@
                     </a:p>
                   </a:txBody>
                   <a:tcPr marL="91440" marR="91440" marT="36576" marB="36576" anchor="ctr">
-                    <a:lnL w="0">
-                      <a:noFill/>
-                    </a:lnL>
-                    <a:lnR w="0">
-                      <a:noFill/>
-                    </a:lnR>
-                    <a:lnT w="0">
-                      <a:noFill/>
-                    </a:lnT>
-                    <a:lnB w="9525" cap="flat" cmpd="sng" algn="ctr">
+                    <a:lnB w="9525">
                       <a:solidFill>
                         <a:srgbClr val="DDE2EC"/>
                       </a:solidFill>
@@ -13344,16 +12295,7 @@
                     </a:p>
                   </a:txBody>
                   <a:tcPr marL="91440" marR="91440" marT="36576" marB="36576" anchor="ctr">
-                    <a:lnL w="0">
-                      <a:noFill/>
-                    </a:lnL>
-                    <a:lnR w="0">
-                      <a:noFill/>
-                    </a:lnR>
-                    <a:lnT w="0">
-                      <a:noFill/>
-                    </a:lnT>
-                    <a:lnB w="9525" cap="flat" cmpd="sng" algn="ctr">
+                    <a:lnB w="9525">
                       <a:solidFill>
                         <a:srgbClr val="DDE2EC"/>
                       </a:solidFill>
@@ -13383,16 +12325,7 @@
                     </a:p>
                   </a:txBody>
                   <a:tcPr marL="91440" marR="91440" marT="36576" marB="36576" anchor="ctr">
-                    <a:lnL w="0">
-                      <a:noFill/>
-                    </a:lnL>
-                    <a:lnR w="0">
-                      <a:noFill/>
-                    </a:lnR>
-                    <a:lnT w="0">
-                      <a:noFill/>
-                    </a:lnT>
-                    <a:lnB w="9525" cap="flat" cmpd="sng" algn="ctr">
+                    <a:lnB w="9525">
                       <a:solidFill>
                         <a:srgbClr val="DDE2EC"/>
                       </a:solidFill>
@@ -13424,16 +12357,7 @@
                     </a:p>
                   </a:txBody>
                   <a:tcPr marL="91440" marR="91440" marT="36576" marB="36576" anchor="ctr">
-                    <a:lnL w="0">
-                      <a:noFill/>
-                    </a:lnL>
-                    <a:lnR w="0">
-                      <a:noFill/>
-                    </a:lnR>
-                    <a:lnT w="0">
-                      <a:noFill/>
-                    </a:lnT>
-                    <a:lnB w="9525" cap="flat" cmpd="sng" algn="ctr">
+                    <a:lnB w="9525">
                       <a:solidFill>
                         <a:srgbClr val="DDE2EC"/>
                       </a:solidFill>
@@ -13463,16 +12387,7 @@
                     </a:p>
                   </a:txBody>
                   <a:tcPr marL="91440" marR="91440" marT="36576" marB="36576" anchor="ctr">
-                    <a:lnL w="0">
-                      <a:noFill/>
-                    </a:lnL>
-                    <a:lnR w="0">
-                      <a:noFill/>
-                    </a:lnR>
-                    <a:lnT w="0">
-                      <a:noFill/>
-                    </a:lnT>
-                    <a:lnB w="9525" cap="flat" cmpd="sng" algn="ctr">
+                    <a:lnB w="9525">
                       <a:solidFill>
                         <a:srgbClr val="DDE2EC"/>
                       </a:solidFill>
@@ -14091,7 +13006,7 @@
                 <a:ea typeface="Malgun Gothic"/>
                 <a:cs typeface="Malgun Gothic"/>
               </a:rPr>
-              <a:t>G078 문희주  ·  WISH FINDER</a:t>
+              <a:t>광주 3반 G078 문희주  ·  WISH FINDER</a:t>
             </a:r>
           </a:p>
         </p:txBody>
@@ -15227,7 +14142,7 @@
                 <a:ea typeface="Malgun Gothic"/>
                 <a:cs typeface="Malgun Gothic"/>
               </a:rPr>
-              <a:t>[백업] 한계와 측정 결과: 구조보다 데이터가 문제였다</a:t>
+              <a:t>[백업] 한계와 트레이드오프</a:t>
             </a:r>
           </a:p>
         </p:txBody>
@@ -15264,7 +14179,7 @@
                 <a:ea typeface="Malgun Gothic"/>
                 <a:cs typeface="Malgun Gothic"/>
               </a:rPr>
-              <a:t>G078 문희주  ·  WISH FINDER</a:t>
+              <a:t>광주 3반 G078 문희주  ·  WISH FINDER</a:t>
             </a:r>
           </a:p>
         </p:txBody>
@@ -15306,769 +14221,677 @@
           </a:p>
         </p:txBody>
       </p:sp>
-      <p:sp>
-        <p:nvSpPr>
-          <p:cNvPr id="5" name="TextBox 4"/>
-          <p:cNvSpPr txBox="1"/>
+      <p:graphicFrame>
+        <p:nvGraphicFramePr>
+          <p:cNvPr id="5" name="Table 4"/>
+          <p:cNvGraphicFramePr>
+            <a:graphicFrameLocks noGrp="1"/>
+          </p:cNvGraphicFramePr>
           <p:nvPr/>
-        </p:nvSpPr>
-        <p:spPr>
-          <a:xfrm>
-            <a:off x="548640" y="1371600"/>
-            <a:ext cx="5394960" cy="411480"/>
-          </a:xfrm>
-          <a:prstGeom prst="rect">
-            <a:avLst/>
-          </a:prstGeom>
-          <a:noFill/>
-        </p:spPr>
-        <p:txBody>
-          <a:bodyPr wrap="square" anchor="t" lIns="0" rIns="0" tIns="0" bIns="0">
-            <a:spAutoFit/>
-          </a:bodyPr>
-          <a:lstStyle/>
-          <a:p>
-            <a:pPr algn="l"/>
-            <a:r>
-              <a:rPr sz="2000" b="1">
-                <a:solidFill>
-                  <a:srgbClr val="1B2437"/>
-                </a:solidFill>
-                <a:latin typeface="Malgun Gothic"/>
-                <a:ea typeface="Malgun Gothic"/>
-                <a:cs typeface="Malgun Gothic"/>
-              </a:rPr>
-              <a:t>한계와 트레이드오프</a:t>
-            </a:r>
-          </a:p>
-        </p:txBody>
-      </p:sp>
-      <p:sp>
-        <p:nvSpPr>
-          <p:cNvPr id="6" name="TextBox 5"/>
-          <p:cNvSpPr txBox="1"/>
-          <p:nvPr/>
-        </p:nvSpPr>
-        <p:spPr>
-          <a:xfrm>
-            <a:off x="6263640" y="1371600"/>
-            <a:ext cx="5394960" cy="411480"/>
-          </a:xfrm>
-          <a:prstGeom prst="rect">
-            <a:avLst/>
-          </a:prstGeom>
-          <a:noFill/>
-        </p:spPr>
-        <p:txBody>
-          <a:bodyPr wrap="square" anchor="t" lIns="0" rIns="0" tIns="0" bIns="0">
-            <a:spAutoFit/>
-          </a:bodyPr>
-          <a:lstStyle/>
-          <a:p>
-            <a:pPr algn="l"/>
-            <a:r>
-              <a:rPr sz="2000" b="1">
-                <a:solidFill>
-                  <a:srgbClr val="2457D6"/>
-                </a:solidFill>
-                <a:latin typeface="Malgun Gothic"/>
-                <a:ea typeface="Malgun Gothic"/>
-                <a:cs typeface="Malgun Gothic"/>
-              </a:rPr>
-              <a:t>측정 결과와 이후</a:t>
-            </a:r>
-          </a:p>
-        </p:txBody>
-      </p:sp>
-      <p:sp>
-        <p:nvSpPr>
-          <p:cNvPr id="7" name="Rounded Rectangle 6"/>
-          <p:cNvSpPr/>
-          <p:nvPr/>
-        </p:nvSpPr>
-        <p:spPr>
-          <a:xfrm>
-            <a:off x="548640" y="1874519"/>
-            <a:ext cx="5394960" cy="1024128"/>
-          </a:xfrm>
-          <a:prstGeom prst="roundRect">
-            <a:avLst>
-              <a:gd name="adj" fmla="val 6000"/>
-            </a:avLst>
-          </a:prstGeom>
-          <a:solidFill>
-            <a:srgbClr val="F3F5F9"/>
-          </a:solidFill>
-          <a:ln>
-            <a:noFill/>
-          </a:ln>
-          <a:effectLst/>
-        </p:spPr>
-        <p:style>
-          <a:lnRef idx="1">
-            <a:schemeClr val="accent1"/>
-          </a:lnRef>
-          <a:fillRef idx="3">
-            <a:schemeClr val="accent1"/>
-          </a:fillRef>
-          <a:effectRef idx="2">
-            <a:schemeClr val="accent1"/>
-          </a:effectRef>
-          <a:fontRef idx="minor">
-            <a:schemeClr val="lt1"/>
-          </a:fontRef>
-        </p:style>
-        <p:txBody>
-          <a:bodyPr rtlCol="0" anchor="ctr"/>
-          <a:lstStyle/>
-          <a:p>
-            <a:pPr algn="ctr"/>
-          </a:p>
-        </p:txBody>
-      </p:sp>
-      <p:sp>
-        <p:nvSpPr>
-          <p:cNvPr id="8" name="TextBox 7"/>
-          <p:cNvSpPr txBox="1"/>
-          <p:nvPr/>
-        </p:nvSpPr>
-        <p:spPr>
-          <a:xfrm>
-            <a:off x="777240" y="1965960"/>
-            <a:ext cx="4937760" cy="868680"/>
-          </a:xfrm>
-          <a:prstGeom prst="rect">
-            <a:avLst/>
-          </a:prstGeom>
-          <a:noFill/>
-        </p:spPr>
-        <p:txBody>
-          <a:bodyPr wrap="square" anchor="ctr" lIns="0" rIns="0" tIns="0" bIns="0">
-            <a:spAutoFit/>
-          </a:bodyPr>
-          <a:lstStyle/>
-          <a:p>
-            <a:pPr algn="l">
-              <a:spcAft>
-                <a:spcPts val="300"/>
-              </a:spcAft>
-            </a:pPr>
-            <a:r>
-              <a:rPr sz="1800" b="1">
-                <a:solidFill>
-                  <a:srgbClr val="1B2437"/>
-                </a:solidFill>
-                <a:latin typeface="Malgun Gothic"/>
-                <a:ea typeface="Malgun Gothic"/>
-                <a:cs typeface="Malgun Gothic"/>
-              </a:rPr>
-              <a:t>Agent 우위가 불확실</a:t>
-            </a:r>
-          </a:p>
-          <a:p>
-            <a:pPr algn="l"/>
-            <a:r>
-              <a:rPr sz="1500" b="0">
-                <a:solidFill>
-                  <a:srgbClr val="5B6577"/>
-                </a:solidFill>
-                <a:latin typeface="Malgun Gothic"/>
-                <a:ea typeface="Malgun Gothic"/>
-                <a:cs typeface="Malgun Gothic"/>
-              </a:rPr>
-              <a:t>1~5문항 차이, 질문당 1회 실행</a:t>
-            </a:r>
-          </a:p>
-        </p:txBody>
-      </p:sp>
-      <p:sp>
-        <p:nvSpPr>
-          <p:cNvPr id="9" name="Rounded Rectangle 8"/>
-          <p:cNvSpPr/>
-          <p:nvPr/>
-        </p:nvSpPr>
-        <p:spPr>
-          <a:xfrm>
-            <a:off x="6263640" y="1874519"/>
-            <a:ext cx="5394960" cy="1024128"/>
-          </a:xfrm>
-          <a:prstGeom prst="roundRect">
-            <a:avLst>
-              <a:gd name="adj" fmla="val 6000"/>
-            </a:avLst>
-          </a:prstGeom>
-          <a:solidFill>
-            <a:srgbClr val="F3F5F9"/>
-          </a:solidFill>
-          <a:ln>
-            <a:noFill/>
-          </a:ln>
-          <a:effectLst/>
-        </p:spPr>
-        <p:style>
-          <a:lnRef idx="1">
-            <a:schemeClr val="accent1"/>
-          </a:lnRef>
-          <a:fillRef idx="3">
-            <a:schemeClr val="accent1"/>
-          </a:fillRef>
-          <a:effectRef idx="2">
-            <a:schemeClr val="accent1"/>
-          </a:effectRef>
-          <a:fontRef idx="minor">
-            <a:schemeClr val="lt1"/>
-          </a:fontRef>
-        </p:style>
-        <p:txBody>
-          <a:bodyPr rtlCol="0" anchor="ctr"/>
-          <a:lstStyle/>
-          <a:p>
-            <a:pPr algn="ctr"/>
-          </a:p>
-        </p:txBody>
-      </p:sp>
-      <p:sp>
-        <p:nvSpPr>
-          <p:cNvPr id="10" name="TextBox 9"/>
-          <p:cNvSpPr txBox="1"/>
-          <p:nvPr/>
-        </p:nvSpPr>
-        <p:spPr>
-          <a:xfrm>
-            <a:off x="6492240" y="1965960"/>
-            <a:ext cx="4937760" cy="868680"/>
-          </a:xfrm>
-          <a:prstGeom prst="rect">
-            <a:avLst/>
-          </a:prstGeom>
-          <a:noFill/>
-        </p:spPr>
-        <p:txBody>
-          <a:bodyPr wrap="square" anchor="ctr" lIns="0" rIns="0" tIns="0" bIns="0">
-            <a:spAutoFit/>
-          </a:bodyPr>
-          <a:lstStyle/>
-          <a:p>
-            <a:pPr algn="l">
-              <a:spcAft>
-                <a:spcPts val="300"/>
-              </a:spcAft>
-            </a:pPr>
-            <a:r>
-              <a:rPr sz="1800" b="1">
-                <a:solidFill>
-                  <a:srgbClr val="1B2437"/>
-                </a:solidFill>
-                <a:latin typeface="Malgun Gothic"/>
-                <a:ea typeface="Malgun Gothic"/>
-                <a:cs typeface="Malgun Gothic"/>
-              </a:rPr>
-              <a:t>이후: Supervisor 구조 비교</a:t>
-            </a:r>
-          </a:p>
-          <a:p>
-            <a:pPr algn="l"/>
-            <a:r>
-              <a:rPr sz="1500" b="0">
-                <a:solidFill>
-                  <a:srgbClr val="5B6577"/>
-                </a:solidFill>
-                <a:latin typeface="Malgun Gothic"/>
-                <a:ea typeface="Malgun Gothic"/>
-                <a:cs typeface="Malgun Gothic"/>
-              </a:rPr>
-              <a:t>더 복잡한 서비스로 넓힐 때 전환</a:t>
-            </a:r>
-          </a:p>
-        </p:txBody>
-      </p:sp>
-      <p:sp>
-        <p:nvSpPr>
-          <p:cNvPr id="11" name="Rounded Rectangle 10"/>
-          <p:cNvSpPr/>
-          <p:nvPr/>
-        </p:nvSpPr>
-        <p:spPr>
-          <a:xfrm>
-            <a:off x="548640" y="3044952"/>
-            <a:ext cx="5394960" cy="1024128"/>
-          </a:xfrm>
-          <a:prstGeom prst="roundRect">
-            <a:avLst>
-              <a:gd name="adj" fmla="val 6000"/>
-            </a:avLst>
-          </a:prstGeom>
-          <a:solidFill>
-            <a:srgbClr val="F3F5F9"/>
-          </a:solidFill>
-          <a:ln>
-            <a:noFill/>
-          </a:ln>
-          <a:effectLst/>
-        </p:spPr>
-        <p:style>
-          <a:lnRef idx="1">
-            <a:schemeClr val="accent1"/>
-          </a:lnRef>
-          <a:fillRef idx="3">
-            <a:schemeClr val="accent1"/>
-          </a:fillRef>
-          <a:effectRef idx="2">
-            <a:schemeClr val="accent1"/>
-          </a:effectRef>
-          <a:fontRef idx="minor">
-            <a:schemeClr val="lt1"/>
-          </a:fontRef>
-        </p:style>
-        <p:txBody>
-          <a:bodyPr rtlCol="0" anchor="ctr"/>
-          <a:lstStyle/>
-          <a:p>
-            <a:pPr algn="ctr"/>
-          </a:p>
-        </p:txBody>
-      </p:sp>
-      <p:sp>
-        <p:nvSpPr>
-          <p:cNvPr id="12" name="TextBox 11"/>
-          <p:cNvSpPr txBox="1"/>
-          <p:nvPr/>
-        </p:nvSpPr>
-        <p:spPr>
-          <a:xfrm>
-            <a:off x="777240" y="3136392"/>
-            <a:ext cx="4937760" cy="868680"/>
-          </a:xfrm>
-          <a:prstGeom prst="rect">
-            <a:avLst/>
-          </a:prstGeom>
-          <a:noFill/>
-        </p:spPr>
-        <p:txBody>
-          <a:bodyPr wrap="square" anchor="ctr" lIns="0" rIns="0" tIns="0" bIns="0">
-            <a:spAutoFit/>
-          </a:bodyPr>
-          <a:lstStyle/>
-          <a:p>
-            <a:pPr algn="l">
-              <a:spcAft>
-                <a:spcPts val="300"/>
-              </a:spcAft>
-            </a:pPr>
-            <a:r>
-              <a:rPr sz="1800" b="1">
-                <a:solidFill>
-                  <a:srgbClr val="1B2437"/>
-                </a:solidFill>
-                <a:latin typeface="Malgun Gothic"/>
-                <a:ea typeface="Malgun Gothic"/>
-                <a:cs typeface="Malgun Gothic"/>
-              </a:rPr>
-              <a:t>지연과 토큰 증가</a:t>
-            </a:r>
-          </a:p>
-          <a:p>
-            <a:pPr algn="l"/>
-            <a:r>
-              <a:rPr sz="1500" b="0">
-                <a:solidFill>
-                  <a:srgbClr val="5B6577"/>
-                </a:solidFill>
-                <a:latin typeface="Malgun Gothic"/>
-                <a:ea typeface="Malgun Gothic"/>
-                <a:cs typeface="Malgun Gothic"/>
-              </a:rPr>
-              <a:t>평균 2.6초, 입력 토큰 +24%</a:t>
-            </a:r>
-          </a:p>
-        </p:txBody>
-      </p:sp>
-      <p:sp>
-        <p:nvSpPr>
-          <p:cNvPr id="13" name="Rounded Rectangle 12"/>
-          <p:cNvSpPr/>
-          <p:nvPr/>
-        </p:nvSpPr>
-        <p:spPr>
-          <a:xfrm>
-            <a:off x="6263640" y="3044952"/>
-            <a:ext cx="5394960" cy="1024128"/>
-          </a:xfrm>
-          <a:prstGeom prst="roundRect">
-            <a:avLst>
-              <a:gd name="adj" fmla="val 6000"/>
-            </a:avLst>
-          </a:prstGeom>
-          <a:solidFill>
-            <a:srgbClr val="F3F5F9"/>
-          </a:solidFill>
-          <a:ln>
-            <a:noFill/>
-          </a:ln>
-          <a:effectLst/>
-        </p:spPr>
-        <p:style>
-          <a:lnRef idx="1">
-            <a:schemeClr val="accent1"/>
-          </a:lnRef>
-          <a:fillRef idx="3">
-            <a:schemeClr val="accent1"/>
-          </a:fillRef>
-          <a:effectRef idx="2">
-            <a:schemeClr val="accent1"/>
-          </a:effectRef>
-          <a:fontRef idx="minor">
-            <a:schemeClr val="lt1"/>
-          </a:fontRef>
-        </p:style>
-        <p:txBody>
-          <a:bodyPr rtlCol="0" anchor="ctr"/>
-          <a:lstStyle/>
-          <a:p>
-            <a:pPr algn="ctr"/>
-          </a:p>
-        </p:txBody>
-      </p:sp>
-      <p:sp>
-        <p:nvSpPr>
-          <p:cNvPr id="14" name="TextBox 13"/>
-          <p:cNvSpPr txBox="1"/>
-          <p:nvPr/>
-        </p:nvSpPr>
-        <p:spPr>
-          <a:xfrm>
-            <a:off x="6492240" y="3136392"/>
-            <a:ext cx="4937760" cy="868680"/>
-          </a:xfrm>
-          <a:prstGeom prst="rect">
-            <a:avLst/>
-          </a:prstGeom>
-          <a:noFill/>
-        </p:spPr>
-        <p:txBody>
-          <a:bodyPr wrap="square" anchor="ctr" lIns="0" rIns="0" tIns="0" bIns="0">
-            <a:spAutoFit/>
-          </a:bodyPr>
-          <a:lstStyle/>
-          <a:p>
-            <a:pPr algn="l">
-              <a:spcAft>
-                <a:spcPts val="300"/>
-              </a:spcAft>
-            </a:pPr>
-            <a:r>
-              <a:rPr sz="1800" b="1">
-                <a:solidFill>
-                  <a:srgbClr val="1B2437"/>
-                </a:solidFill>
-                <a:latin typeface="Malgun Gothic"/>
-                <a:ea typeface="Malgun Gothic"/>
-                <a:cs typeface="Malgun Gothic"/>
-              </a:rPr>
-              <a:t>청크 길이: 20초/10초 유지</a:t>
-            </a:r>
-          </a:p>
-          <a:p>
-            <a:pPr algn="l"/>
-            <a:r>
-              <a:rPr sz="1500" b="0">
-                <a:solidFill>
-                  <a:srgbClr val="5B6577"/>
-                </a:solidFill>
-                <a:latin typeface="Malgun Gothic"/>
-                <a:ea typeface="Malgun Gothic"/>
-                <a:cs typeface="Malgun Gothic"/>
-              </a:rPr>
-              <a:t>10/5와 같고 30/15·40/20은 하락 (B, 18문항)</a:t>
-            </a:r>
-          </a:p>
-        </p:txBody>
-      </p:sp>
-      <p:sp>
-        <p:nvSpPr>
-          <p:cNvPr id="15" name="Rounded Rectangle 14"/>
-          <p:cNvSpPr/>
-          <p:nvPr/>
-        </p:nvSpPr>
-        <p:spPr>
-          <a:xfrm>
-            <a:off x="548640" y="4215383"/>
-            <a:ext cx="5394960" cy="1024128"/>
-          </a:xfrm>
-          <a:prstGeom prst="roundRect">
-            <a:avLst>
-              <a:gd name="adj" fmla="val 6000"/>
-            </a:avLst>
-          </a:prstGeom>
-          <a:solidFill>
-            <a:srgbClr val="F3F5F9"/>
-          </a:solidFill>
-          <a:ln>
-            <a:noFill/>
-          </a:ln>
-          <a:effectLst/>
-        </p:spPr>
-        <p:style>
-          <a:lnRef idx="1">
-            <a:schemeClr val="accent1"/>
-          </a:lnRef>
-          <a:fillRef idx="3">
-            <a:schemeClr val="accent1"/>
-          </a:fillRef>
-          <a:effectRef idx="2">
-            <a:schemeClr val="accent1"/>
-          </a:effectRef>
-          <a:fontRef idx="minor">
-            <a:schemeClr val="lt1"/>
-          </a:fontRef>
-        </p:style>
-        <p:txBody>
-          <a:bodyPr rtlCol="0" anchor="ctr"/>
-          <a:lstStyle/>
-          <a:p>
-            <a:pPr algn="ctr"/>
-          </a:p>
-        </p:txBody>
-      </p:sp>
-      <p:sp>
-        <p:nvSpPr>
-          <p:cNvPr id="16" name="TextBox 15"/>
-          <p:cNvSpPr txBox="1"/>
-          <p:nvPr/>
-        </p:nvSpPr>
-        <p:spPr>
-          <a:xfrm>
-            <a:off x="777240" y="4306823"/>
-            <a:ext cx="4937760" cy="868680"/>
-          </a:xfrm>
-          <a:prstGeom prst="rect">
-            <a:avLst/>
-          </a:prstGeom>
-          <a:noFill/>
-        </p:spPr>
-        <p:txBody>
-          <a:bodyPr wrap="square" anchor="ctr" lIns="0" rIns="0" tIns="0" bIns="0">
-            <a:spAutoFit/>
-          </a:bodyPr>
-          <a:lstStyle/>
-          <a:p>
-            <a:pPr algn="l">
-              <a:spcAft>
-                <a:spcPts val="300"/>
-              </a:spcAft>
-            </a:pPr>
-            <a:r>
-              <a:rPr sz="1800" b="1">
-                <a:solidFill>
-                  <a:srgbClr val="1B2437"/>
-                </a:solidFill>
-                <a:latin typeface="Malgun Gothic"/>
-                <a:ea typeface="Malgun Gothic"/>
-                <a:cs typeface="Malgun Gothic"/>
-              </a:rPr>
-              <a:t>틀리거나 못 찾는 경우</a:t>
-            </a:r>
-          </a:p>
-          <a:p>
-            <a:pPr algn="l"/>
-            <a:r>
-              <a:rPr sz="1500" b="0">
-                <a:solidFill>
-                  <a:srgbClr val="5B6577"/>
-                </a:solidFill>
-                <a:latin typeface="Malgun Gothic"/>
-                <a:ea typeface="Malgun Gothic"/>
-                <a:cs typeface="Malgun Gothic"/>
-              </a:rPr>
-              <a:t>후속 질문, 번역 어휘 차이 (이중 검색도 해결 못 함)</a:t>
-            </a:r>
-          </a:p>
-        </p:txBody>
-      </p:sp>
-      <p:sp>
-        <p:nvSpPr>
-          <p:cNvPr id="17" name="Rounded Rectangle 16"/>
-          <p:cNvSpPr/>
-          <p:nvPr/>
-        </p:nvSpPr>
-        <p:spPr>
-          <a:xfrm>
-            <a:off x="6263640" y="4215383"/>
-            <a:ext cx="5394960" cy="1024128"/>
-          </a:xfrm>
-          <a:prstGeom prst="roundRect">
-            <a:avLst>
-              <a:gd name="adj" fmla="val 6000"/>
-            </a:avLst>
-          </a:prstGeom>
-          <a:solidFill>
-            <a:srgbClr val="F3F5F9"/>
-          </a:solidFill>
-          <a:ln>
-            <a:noFill/>
-          </a:ln>
-          <a:effectLst/>
-        </p:spPr>
-        <p:style>
-          <a:lnRef idx="1">
-            <a:schemeClr val="accent1"/>
-          </a:lnRef>
-          <a:fillRef idx="3">
-            <a:schemeClr val="accent1"/>
-          </a:fillRef>
-          <a:effectRef idx="2">
-            <a:schemeClr val="accent1"/>
-          </a:effectRef>
-          <a:fontRef idx="minor">
-            <a:schemeClr val="lt1"/>
-          </a:fontRef>
-        </p:style>
-        <p:txBody>
-          <a:bodyPr rtlCol="0" anchor="ctr"/>
-          <a:lstStyle/>
-          <a:p>
-            <a:pPr algn="ctr"/>
-          </a:p>
-        </p:txBody>
-      </p:sp>
-      <p:sp>
-        <p:nvSpPr>
-          <p:cNvPr id="18" name="TextBox 17"/>
-          <p:cNvSpPr txBox="1"/>
-          <p:nvPr/>
-        </p:nvSpPr>
-        <p:spPr>
-          <a:xfrm>
-            <a:off x="6492240" y="4306823"/>
-            <a:ext cx="4937760" cy="868680"/>
-          </a:xfrm>
-          <a:prstGeom prst="rect">
-            <a:avLst/>
-          </a:prstGeom>
-          <a:noFill/>
-        </p:spPr>
-        <p:txBody>
-          <a:bodyPr wrap="square" anchor="ctr" lIns="0" rIns="0" tIns="0" bIns="0">
-            <a:spAutoFit/>
-          </a:bodyPr>
-          <a:lstStyle/>
-          <a:p>
-            <a:pPr algn="l">
-              <a:spcAft>
-                <a:spcPts val="300"/>
-              </a:spcAft>
-            </a:pPr>
-            <a:r>
-              <a:rPr sz="1800" b="1">
-                <a:solidFill>
-                  <a:srgbClr val="1B2437"/>
-                </a:solidFill>
-                <a:latin typeface="Malgun Gothic"/>
-                <a:ea typeface="Malgun Gothic"/>
-                <a:cs typeface="Malgun Gothic"/>
-              </a:rPr>
-              <a:t>이중 첫 검색: 평가셋 이득 없음</a:t>
-            </a:r>
-          </a:p>
-          <a:p>
-            <a:pPr algn="l"/>
-            <a:r>
-              <a:rPr sz="1500" b="0">
-                <a:solidFill>
-                  <a:srgbClr val="5B6577"/>
-                </a:solidFill>
-                <a:latin typeface="Malgun Gothic"/>
-                <a:ea typeface="Malgun Gothic"/>
-                <a:cs typeface="Malgun Gothic"/>
-              </a:rPr>
-              <a:t>16 → 16, 검색 +1회 → 기본 꺼짐 유지</a:t>
-            </a:r>
-          </a:p>
-        </p:txBody>
-      </p:sp>
-      <p:sp>
-        <p:nvSpPr>
-          <p:cNvPr id="19" name="Rounded Rectangle 18"/>
-          <p:cNvSpPr/>
-          <p:nvPr/>
-        </p:nvSpPr>
-        <p:spPr>
-          <a:xfrm>
-            <a:off x="548640" y="5440680"/>
-            <a:ext cx="11109960" cy="822960"/>
-          </a:xfrm>
-          <a:prstGeom prst="roundRect">
-            <a:avLst>
-              <a:gd name="adj" fmla="val 6000"/>
-            </a:avLst>
-          </a:prstGeom>
-          <a:solidFill>
-            <a:srgbClr val="E8EEFC"/>
-          </a:solidFill>
-          <a:ln>
-            <a:noFill/>
-          </a:ln>
-          <a:effectLst/>
-        </p:spPr>
-        <p:style>
-          <a:lnRef idx="1">
-            <a:schemeClr val="accent1"/>
-          </a:lnRef>
-          <a:fillRef idx="3">
-            <a:schemeClr val="accent1"/>
-          </a:fillRef>
-          <a:effectRef idx="2">
-            <a:schemeClr val="accent1"/>
-          </a:effectRef>
-          <a:fontRef idx="minor">
-            <a:schemeClr val="lt1"/>
-          </a:fontRef>
-        </p:style>
-        <p:txBody>
-          <a:bodyPr rtlCol="0" anchor="ctr"/>
-          <a:lstStyle/>
-          <a:p>
-            <a:pPr algn="ctr"/>
-          </a:p>
-        </p:txBody>
-      </p:sp>
-      <p:sp>
-        <p:nvSpPr>
-          <p:cNvPr id="20" name="TextBox 19"/>
-          <p:cNvSpPr txBox="1"/>
-          <p:nvPr/>
-        </p:nvSpPr>
-        <p:spPr>
-          <a:xfrm>
-            <a:off x="822960" y="5440680"/>
-            <a:ext cx="10607040" cy="822960"/>
-          </a:xfrm>
-          <a:prstGeom prst="rect">
-            <a:avLst/>
-          </a:prstGeom>
-          <a:noFill/>
-        </p:spPr>
-        <p:txBody>
-          <a:bodyPr wrap="square" anchor="ctr" lIns="0" rIns="0" tIns="0" bIns="0">
-            <a:spAutoFit/>
-          </a:bodyPr>
-          <a:lstStyle/>
-          <a:p>
-            <a:pPr algn="l"/>
-            <a:r>
-              <a:rPr sz="1900" b="1">
-                <a:solidFill>
-                  <a:srgbClr val="2457D6"/>
-                </a:solidFill>
-                <a:latin typeface="Malgun Gothic"/>
-                <a:ea typeface="Malgun Gothic"/>
-                <a:cs typeface="Malgun Gothic"/>
-              </a:rPr>
-              <a:t>원인은 구조가 아니라 번역 자막의 단어("마니또" ↔ "Secret Santa")였다</a:t>
-            </a:r>
-          </a:p>
-        </p:txBody>
-      </p:sp>
+        </p:nvGraphicFramePr>
+        <p:xfrm>
+          <a:off x="548640" y="1371600"/>
+          <a:ext cx="11109960" cy="4736592"/>
+        </p:xfrm>
+        <a:graphic>
+          <a:graphicData uri="http://schemas.openxmlformats.org/drawingml/2006/table">
+            <a:tbl>
+              <a:tblPr firstRow="1" bandRow="0">
+                <a:tableStyleId>{5C22544A-7EE6-4342-B048-85BDC9FD1C3A}</a:tableStyleId>
+              </a:tblPr>
+              <a:tblGrid>
+                <a:gridCol w="1371600"/>
+                <a:gridCol w="7589520"/>
+                <a:gridCol w="2148840"/>
+              </a:tblGrid>
+              <a:tr h="676656">
+                <a:tc>
+                  <a:txBody>
+                    <a:bodyPr wrap="square"/>
+                    <a:lstStyle/>
+                    <a:p>
+                      <a:pPr algn="l"/>
+                      <a:r>
+                        <a:rPr sz="1400" b="1">
+                          <a:solidFill>
+                            <a:srgbClr val="1B2437"/>
+                          </a:solidFill>
+                          <a:latin typeface="Malgun Gothic"/>
+                          <a:ea typeface="Malgun Gothic"/>
+                          <a:cs typeface="Malgun Gothic"/>
+                        </a:rPr>
+                        <a:t>구분</a:t>
+                      </a:r>
+                    </a:p>
+                  </a:txBody>
+                  <a:tcPr marL="91440" marR="91440" marT="36576" marB="36576" anchor="ctr">
+                    <a:lnB w="9525">
+                      <a:solidFill>
+                        <a:srgbClr val="DDE2EC"/>
+                      </a:solidFill>
+                    </a:lnB>
+                    <a:solidFill>
+                      <a:srgbClr val="F3F5F9"/>
+                    </a:solidFill>
+                  </a:tcPr>
+                </a:tc>
+                <a:tc>
+                  <a:txBody>
+                    <a:bodyPr wrap="square"/>
+                    <a:lstStyle/>
+                    <a:p>
+                      <a:pPr algn="l"/>
+                      <a:r>
+                        <a:rPr sz="1400" b="1">
+                          <a:solidFill>
+                            <a:srgbClr val="1B2437"/>
+                          </a:solidFill>
+                          <a:latin typeface="Malgun Gothic"/>
+                          <a:ea typeface="Malgun Gothic"/>
+                          <a:cs typeface="Malgun Gothic"/>
+                        </a:rPr>
+                        <a:t>한계</a:t>
+                      </a:r>
+                    </a:p>
+                  </a:txBody>
+                  <a:tcPr marL="91440" marR="91440" marT="36576" marB="36576" anchor="ctr">
+                    <a:lnB w="9525">
+                      <a:solidFill>
+                        <a:srgbClr val="DDE2EC"/>
+                      </a:solidFill>
+                    </a:lnB>
+                    <a:solidFill>
+                      <a:srgbClr val="F3F5F9"/>
+                    </a:solidFill>
+                  </a:tcPr>
+                </a:tc>
+                <a:tc>
+                  <a:txBody>
+                    <a:bodyPr wrap="square"/>
+                    <a:lstStyle/>
+                    <a:p>
+                      <a:pPr algn="l"/>
+                      <a:r>
+                        <a:rPr sz="1400" b="1">
+                          <a:solidFill>
+                            <a:srgbClr val="1B2437"/>
+                          </a:solidFill>
+                          <a:latin typeface="Malgun Gothic"/>
+                          <a:ea typeface="Malgun Gothic"/>
+                          <a:cs typeface="Malgun Gothic"/>
+                        </a:rPr>
+                        <a:t>근거</a:t>
+                      </a:r>
+                    </a:p>
+                  </a:txBody>
+                  <a:tcPr marL="91440" marR="91440" marT="36576" marB="36576" anchor="ctr">
+                    <a:lnB w="9525">
+                      <a:solidFill>
+                        <a:srgbClr val="DDE2EC"/>
+                      </a:solidFill>
+                    </a:lnB>
+                    <a:solidFill>
+                      <a:srgbClr val="F3F5F9"/>
+                    </a:solidFill>
+                  </a:tcPr>
+                </a:tc>
+              </a:tr>
+              <a:tr h="676656">
+                <a:tc>
+                  <a:txBody>
+                    <a:bodyPr wrap="square"/>
+                    <a:lstStyle/>
+                    <a:p>
+                      <a:pPr algn="l"/>
+                      <a:r>
+                        <a:rPr sz="1400" b="1">
+                          <a:solidFill>
+                            <a:srgbClr val="1B2437"/>
+                          </a:solidFill>
+                          <a:latin typeface="Malgun Gothic"/>
+                          <a:ea typeface="Malgun Gothic"/>
+                          <a:cs typeface="Malgun Gothic"/>
+                        </a:rPr>
+                        <a:t>측정</a:t>
+                      </a:r>
+                    </a:p>
+                  </a:txBody>
+                  <a:tcPr marL="91440" marR="91440" marT="36576" marB="36576" anchor="ctr">
+                    <a:lnB w="9525">
+                      <a:solidFill>
+                        <a:srgbClr val="DDE2EC"/>
+                      </a:solidFill>
+                    </a:lnB>
+                    <a:solidFill>
+                      <a:srgbClr val="FFFFFF"/>
+                    </a:solidFill>
+                  </a:tcPr>
+                </a:tc>
+                <a:tc>
+                  <a:txBody>
+                    <a:bodyPr wrap="square"/>
+                    <a:lstStyle/>
+                    <a:p>
+                      <a:pPr algn="l"/>
+                      <a:r>
+                        <a:rPr sz="1400" b="0">
+                          <a:solidFill>
+                            <a:srgbClr val="1B2437"/>
+                          </a:solidFill>
+                          <a:latin typeface="Malgun Gothic"/>
+                          <a:ea typeface="Malgun Gothic"/>
+                          <a:cs typeface="Malgun Gothic"/>
+                        </a:rPr>
+                        <a:t>18문항·질문당 1회, Router 검색어가 실행마다 달라져 1~2문항 차이는 노이즈일 수 있다</a:t>
+                      </a:r>
+                    </a:p>
+                  </a:txBody>
+                  <a:tcPr marL="91440" marR="91440" marT="36576" marB="36576" anchor="ctr">
+                    <a:lnB w="9525">
+                      <a:solidFill>
+                        <a:srgbClr val="DDE2EC"/>
+                      </a:solidFill>
+                    </a:lnB>
+                    <a:solidFill>
+                      <a:srgbClr val="FFFFFF"/>
+                    </a:solidFill>
+                  </a:tcPr>
+                </a:tc>
+                <a:tc>
+                  <a:txBody>
+                    <a:bodyPr wrap="square"/>
+                    <a:lstStyle/>
+                    <a:p>
+                      <a:pPr algn="l"/>
+                      <a:r>
+                        <a:rPr sz="1400" b="0">
+                          <a:solidFill>
+                            <a:srgbClr val="1B2437"/>
+                          </a:solidFill>
+                          <a:latin typeface="Malgun Gothic"/>
+                          <a:ea typeface="Malgun Gothic"/>
+                          <a:cs typeface="Malgun Gothic"/>
+                        </a:rPr>
+                        <a:t>보고서 3.4·4.3절</a:t>
+                      </a:r>
+                    </a:p>
+                  </a:txBody>
+                  <a:tcPr marL="91440" marR="91440" marT="36576" marB="36576" anchor="ctr">
+                    <a:lnB w="9525">
+                      <a:solidFill>
+                        <a:srgbClr val="DDE2EC"/>
+                      </a:solidFill>
+                    </a:lnB>
+                    <a:solidFill>
+                      <a:srgbClr val="FFFFFF"/>
+                    </a:solidFill>
+                  </a:tcPr>
+                </a:tc>
+              </a:tr>
+              <a:tr h="676656">
+                <a:tc>
+                  <a:txBody>
+                    <a:bodyPr wrap="square"/>
+                    <a:lstStyle/>
+                    <a:p>
+                      <a:pPr algn="l"/>
+                      <a:r>
+                        <a:rPr sz="1400" b="1">
+                          <a:solidFill>
+                            <a:srgbClr val="1B2437"/>
+                          </a:solidFill>
+                          <a:latin typeface="Malgun Gothic"/>
+                          <a:ea typeface="Malgun Gothic"/>
+                          <a:cs typeface="Malgun Gothic"/>
+                        </a:rPr>
+                        <a:t>측정</a:t>
+                      </a:r>
+                    </a:p>
+                  </a:txBody>
+                  <a:tcPr marL="91440" marR="91440" marT="36576" marB="36576" anchor="ctr">
+                    <a:lnB w="9525">
+                      <a:solidFill>
+                        <a:srgbClr val="DDE2EC"/>
+                      </a:solidFill>
+                    </a:lnB>
+                    <a:solidFill>
+                      <a:srgbClr val="FFFFFF"/>
+                    </a:solidFill>
+                  </a:tcPr>
+                </a:tc>
+                <a:tc>
+                  <a:txBody>
+                    <a:bodyPr wrap="square"/>
+                    <a:lstStyle/>
+                    <a:p>
+                      <a:pPr algn="l"/>
+                      <a:r>
+                        <a:rPr sz="1400" b="0">
+                          <a:solidFill>
+                            <a:srgbClr val="1B2437"/>
+                          </a:solidFill>
+                          <a:latin typeface="Malgun Gothic"/>
+                          <a:ea typeface="Malgun Gothic"/>
+                          <a:cs typeface="Malgun Gothic"/>
+                        </a:rPr>
+                        <a:t>정답 라벨은 어시스턴트가 원본 cue를 검토해 제안하고 사용자가 승인. 영상 대조는 9곳 표본</a:t>
+                      </a:r>
+                    </a:p>
+                  </a:txBody>
+                  <a:tcPr marL="91440" marR="91440" marT="36576" marB="36576" anchor="ctr">
+                    <a:lnB w="9525">
+                      <a:solidFill>
+                        <a:srgbClr val="DDE2EC"/>
+                      </a:solidFill>
+                    </a:lnB>
+                    <a:solidFill>
+                      <a:srgbClr val="FFFFFF"/>
+                    </a:solidFill>
+                  </a:tcPr>
+                </a:tc>
+                <a:tc>
+                  <a:txBody>
+                    <a:bodyPr wrap="square"/>
+                    <a:lstStyle/>
+                    <a:p>
+                      <a:pPr algn="l"/>
+                      <a:r>
+                        <a:rPr sz="1400" b="0">
+                          <a:solidFill>
+                            <a:srgbClr val="1B2437"/>
+                          </a:solidFill>
+                          <a:latin typeface="Malgun Gothic"/>
+                          <a:ea typeface="Malgun Gothic"/>
+                          <a:cs typeface="Malgun Gothic"/>
+                        </a:rPr>
+                        <a:t>보고서 4.3절</a:t>
+                      </a:r>
+                    </a:p>
+                  </a:txBody>
+                  <a:tcPr marL="91440" marR="91440" marT="36576" marB="36576" anchor="ctr">
+                    <a:lnB w="9525">
+                      <a:solidFill>
+                        <a:srgbClr val="DDE2EC"/>
+                      </a:solidFill>
+                    </a:lnB>
+                    <a:solidFill>
+                      <a:srgbClr val="FFFFFF"/>
+                    </a:solidFill>
+                  </a:tcPr>
+                </a:tc>
+              </a:tr>
+              <a:tr h="676656">
+                <a:tc>
+                  <a:txBody>
+                    <a:bodyPr wrap="square"/>
+                    <a:lstStyle/>
+                    <a:p>
+                      <a:pPr algn="l"/>
+                      <a:r>
+                        <a:rPr sz="1400" b="1">
+                          <a:solidFill>
+                            <a:srgbClr val="1B2437"/>
+                          </a:solidFill>
+                          <a:latin typeface="Malgun Gothic"/>
+                          <a:ea typeface="Malgun Gothic"/>
+                          <a:cs typeface="Malgun Gothic"/>
+                        </a:rPr>
+                        <a:t>성능</a:t>
+                      </a:r>
+                    </a:p>
+                  </a:txBody>
+                  <a:tcPr marL="91440" marR="91440" marT="36576" marB="36576" anchor="ctr">
+                    <a:lnB w="9525">
+                      <a:solidFill>
+                        <a:srgbClr val="DDE2EC"/>
+                      </a:solidFill>
+                    </a:lnB>
+                    <a:solidFill>
+                      <a:srgbClr val="FFFFFF"/>
+                    </a:solidFill>
+                  </a:tcPr>
+                </a:tc>
+                <a:tc>
+                  <a:txBody>
+                    <a:bodyPr wrap="square"/>
+                    <a:lstStyle/>
+                    <a:p>
+                      <a:pPr algn="l"/>
+                      <a:r>
+                        <a:rPr sz="1400" b="0">
+                          <a:solidFill>
+                            <a:srgbClr val="1B2437"/>
+                          </a:solidFill>
+                          <a:latin typeface="Malgun Gothic"/>
+                          <a:ea typeface="Malgun Gothic"/>
+                          <a:cs typeface="Malgun Gothic"/>
+                        </a:rPr>
+                        <a:t>"찾음" 응답 17건 중 1건이 틀린 장면(16/17). 원본 대조는 의도 일치를 보장하지 않는다</a:t>
+                      </a:r>
+                    </a:p>
+                  </a:txBody>
+                  <a:tcPr marL="91440" marR="91440" marT="36576" marB="36576" anchor="ctr">
+                    <a:lnB w="9525">
+                      <a:solidFill>
+                        <a:srgbClr val="DDE2EC"/>
+                      </a:solidFill>
+                    </a:lnB>
+                    <a:solidFill>
+                      <a:srgbClr val="FFFFFF"/>
+                    </a:solidFill>
+                  </a:tcPr>
+                </a:tc>
+                <a:tc>
+                  <a:txBody>
+                    <a:bodyPr wrap="square"/>
+                    <a:lstStyle/>
+                    <a:p>
+                      <a:pPr algn="l"/>
+                      <a:r>
+                        <a:rPr sz="1400" b="0">
+                          <a:solidFill>
+                            <a:srgbClr val="1B2437"/>
+                          </a:solidFill>
+                          <a:latin typeface="Malgun Gothic"/>
+                          <a:ea typeface="Malgun Gothic"/>
+                          <a:cs typeface="Malgun Gothic"/>
+                        </a:rPr>
+                        <a:t>보고서 3.2·4.2절</a:t>
+                      </a:r>
+                    </a:p>
+                  </a:txBody>
+                  <a:tcPr marL="91440" marR="91440" marT="36576" marB="36576" anchor="ctr">
+                    <a:lnB w="9525">
+                      <a:solidFill>
+                        <a:srgbClr val="DDE2EC"/>
+                      </a:solidFill>
+                    </a:lnB>
+                    <a:solidFill>
+                      <a:srgbClr val="FFFFFF"/>
+                    </a:solidFill>
+                  </a:tcPr>
+                </a:tc>
+              </a:tr>
+              <a:tr h="676656">
+                <a:tc>
+                  <a:txBody>
+                    <a:bodyPr wrap="square"/>
+                    <a:lstStyle/>
+                    <a:p>
+                      <a:pPr algn="l"/>
+                      <a:r>
+                        <a:rPr sz="1400" b="1">
+                          <a:solidFill>
+                            <a:srgbClr val="1B2437"/>
+                          </a:solidFill>
+                          <a:latin typeface="Malgun Gothic"/>
+                          <a:ea typeface="Malgun Gothic"/>
+                          <a:cs typeface="Malgun Gothic"/>
+                        </a:rPr>
+                        <a:t>성능</a:t>
+                      </a:r>
+                    </a:p>
+                  </a:txBody>
+                  <a:tcPr marL="91440" marR="91440" marT="36576" marB="36576" anchor="ctr">
+                    <a:lnB w="9525">
+                      <a:solidFill>
+                        <a:srgbClr val="DDE2EC"/>
+                      </a:solidFill>
+                    </a:lnB>
+                    <a:solidFill>
+                      <a:srgbClr val="FFFFFF"/>
+                    </a:solidFill>
+                  </a:tcPr>
+                </a:tc>
+                <a:tc>
+                  <a:txBody>
+                    <a:bodyPr wrap="square"/>
+                    <a:lstStyle/>
+                    <a:p>
+                      <a:pPr algn="l"/>
+                      <a:r>
+                        <a:rPr sz="1400" b="0">
+                          <a:solidFill>
+                            <a:srgbClr val="1B2437"/>
+                          </a:solidFill>
+                          <a:latin typeface="Malgun Gothic"/>
+                          <a:ea typeface="Malgun Gothic"/>
+                          <a:cs typeface="Malgun Gothic"/>
+                        </a:rPr>
+                        <a:t>정답 청크가 후보 3개 밖(10위·18위)인 2문항은 판정 이전 단계의 한계. 번역 어휘·후속 질문도 약점</a:t>
+                      </a:r>
+                    </a:p>
+                  </a:txBody>
+                  <a:tcPr marL="91440" marR="91440" marT="36576" marB="36576" anchor="ctr">
+                    <a:lnB w="9525">
+                      <a:solidFill>
+                        <a:srgbClr val="DDE2EC"/>
+                      </a:solidFill>
+                    </a:lnB>
+                    <a:solidFill>
+                      <a:srgbClr val="FFFFFF"/>
+                    </a:solidFill>
+                  </a:tcPr>
+                </a:tc>
+                <a:tc>
+                  <a:txBody>
+                    <a:bodyPr wrap="square"/>
+                    <a:lstStyle/>
+                    <a:p>
+                      <a:pPr algn="l"/>
+                      <a:r>
+                        <a:rPr sz="1400" b="0">
+                          <a:solidFill>
+                            <a:srgbClr val="1B2437"/>
+                          </a:solidFill>
+                          <a:latin typeface="Malgun Gothic"/>
+                          <a:ea typeface="Malgun Gothic"/>
+                          <a:cs typeface="Malgun Gothic"/>
+                        </a:rPr>
+                        <a:t>보고서 4.2절</a:t>
+                      </a:r>
+                    </a:p>
+                  </a:txBody>
+                  <a:tcPr marL="91440" marR="91440" marT="36576" marB="36576" anchor="ctr">
+                    <a:lnB w="9525">
+                      <a:solidFill>
+                        <a:srgbClr val="DDE2EC"/>
+                      </a:solidFill>
+                    </a:lnB>
+                    <a:solidFill>
+                      <a:srgbClr val="FFFFFF"/>
+                    </a:solidFill>
+                  </a:tcPr>
+                </a:tc>
+              </a:tr>
+              <a:tr h="676656">
+                <a:tc>
+                  <a:txBody>
+                    <a:bodyPr wrap="square"/>
+                    <a:lstStyle/>
+                    <a:p>
+                      <a:pPr algn="l"/>
+                      <a:r>
+                        <a:rPr sz="1400" b="1">
+                          <a:solidFill>
+                            <a:srgbClr val="1B2437"/>
+                          </a:solidFill>
+                          <a:latin typeface="Malgun Gothic"/>
+                          <a:ea typeface="Malgun Gothic"/>
+                          <a:cs typeface="Malgun Gothic"/>
+                        </a:rPr>
+                        <a:t>비용</a:t>
+                      </a:r>
+                    </a:p>
+                  </a:txBody>
+                  <a:tcPr marL="91440" marR="91440" marT="36576" marB="36576" anchor="ctr">
+                    <a:lnB w="9525">
+                      <a:solidFill>
+                        <a:srgbClr val="DDE2EC"/>
+                      </a:solidFill>
+                    </a:lnB>
+                    <a:solidFill>
+                      <a:srgbClr val="FFFFFF"/>
+                    </a:solidFill>
+                  </a:tcPr>
+                </a:tc>
+                <a:tc>
+                  <a:txBody>
+                    <a:bodyPr wrap="square"/>
+                    <a:lstStyle/>
+                    <a:p>
+                      <a:pPr algn="l"/>
+                      <a:r>
+                        <a:rPr sz="1400" b="0">
+                          <a:solidFill>
+                            <a:srgbClr val="1B2437"/>
+                          </a:solidFill>
+                          <a:latin typeface="Malgun Gothic"/>
+                          <a:ea typeface="Malgun Gothic"/>
+                          <a:cs typeface="Malgun Gothic"/>
+                        </a:rPr>
+                        <a:t>입력 토큰 +24%, 평균 지연 2.6초(Hybrid 0.2초대), 이중 첫 검색은 검색 +1회</a:t>
+                      </a:r>
+                    </a:p>
+                  </a:txBody>
+                  <a:tcPr marL="91440" marR="91440" marT="36576" marB="36576" anchor="ctr">
+                    <a:lnB w="9525">
+                      <a:solidFill>
+                        <a:srgbClr val="DDE2EC"/>
+                      </a:solidFill>
+                    </a:lnB>
+                    <a:solidFill>
+                      <a:srgbClr val="FFFFFF"/>
+                    </a:solidFill>
+                  </a:tcPr>
+                </a:tc>
+                <a:tc>
+                  <a:txBody>
+                    <a:bodyPr wrap="square"/>
+                    <a:lstStyle/>
+                    <a:p>
+                      <a:pPr algn="l"/>
+                      <a:r>
+                        <a:rPr sz="1400" b="0">
+                          <a:solidFill>
+                            <a:srgbClr val="1B2437"/>
+                          </a:solidFill>
+                          <a:latin typeface="Malgun Gothic"/>
+                          <a:ea typeface="Malgun Gothic"/>
+                          <a:cs typeface="Malgun Gothic"/>
+                        </a:rPr>
+                        <a:t>보고서 3.2·3.3절</a:t>
+                      </a:r>
+                    </a:p>
+                  </a:txBody>
+                  <a:tcPr marL="91440" marR="91440" marT="36576" marB="36576" anchor="ctr">
+                    <a:lnB w="9525">
+                      <a:solidFill>
+                        <a:srgbClr val="DDE2EC"/>
+                      </a:solidFill>
+                    </a:lnB>
+                    <a:solidFill>
+                      <a:srgbClr val="FFFFFF"/>
+                    </a:solidFill>
+                  </a:tcPr>
+                </a:tc>
+              </a:tr>
+              <a:tr h="676656">
+                <a:tc>
+                  <a:txBody>
+                    <a:bodyPr wrap="square"/>
+                    <a:lstStyle/>
+                    <a:p>
+                      <a:pPr algn="l"/>
+                      <a:r>
+                        <a:rPr sz="1400" b="1">
+                          <a:solidFill>
+                            <a:srgbClr val="1B2437"/>
+                          </a:solidFill>
+                          <a:latin typeface="Malgun Gothic"/>
+                          <a:ea typeface="Malgun Gothic"/>
+                          <a:cs typeface="Malgun Gothic"/>
+                        </a:rPr>
+                        <a:t>범위</a:t>
+                      </a:r>
+                    </a:p>
+                  </a:txBody>
+                  <a:tcPr marL="91440" marR="91440" marT="36576" marB="36576" anchor="ctr">
+                    <a:lnB w="9525">
+                      <a:solidFill>
+                        <a:srgbClr val="DDE2EC"/>
+                      </a:solidFill>
+                    </a:lnB>
+                    <a:solidFill>
+                      <a:srgbClr val="FFFFFF"/>
+                    </a:solidFill>
+                  </a:tcPr>
+                </a:tc>
+                <a:tc>
+                  <a:txBody>
+                    <a:bodyPr wrap="square"/>
+                    <a:lstStyle/>
+                    <a:p>
+                      <a:pPr algn="l"/>
+                      <a:r>
+                        <a:rPr sz="1400" b="0">
+                          <a:solidFill>
+                            <a:srgbClr val="1B2437"/>
+                          </a:solidFill>
+                          <a:latin typeface="Malgun Gothic"/>
+                          <a:ea typeface="Malgun Gothic"/>
+                          <a:cs typeface="Malgun Gothic"/>
+                        </a:rPr>
+                        <a:t>Multi-Agent 미구현·미비교, 영어 번역 자막, 화자 단정 불가</a:t>
+                      </a:r>
+                    </a:p>
+                  </a:txBody>
+                  <a:tcPr marL="91440" marR="91440" marT="36576" marB="36576" anchor="ctr">
+                    <a:lnB w="9525">
+                      <a:solidFill>
+                        <a:srgbClr val="DDE2EC"/>
+                      </a:solidFill>
+                    </a:lnB>
+                    <a:solidFill>
+                      <a:srgbClr val="FFFFFF"/>
+                    </a:solidFill>
+                  </a:tcPr>
+                </a:tc>
+                <a:tc>
+                  <a:txBody>
+                    <a:bodyPr wrap="square"/>
+                    <a:lstStyle/>
+                    <a:p>
+                      <a:pPr algn="l"/>
+                      <a:r>
+                        <a:rPr sz="1400" b="0">
+                          <a:solidFill>
+                            <a:srgbClr val="1B2437"/>
+                          </a:solidFill>
+                          <a:latin typeface="Malgun Gothic"/>
+                          <a:ea typeface="Malgun Gothic"/>
+                          <a:cs typeface="Malgun Gothic"/>
+                        </a:rPr>
+                        <a:t>보고서 4.1·4.3절</a:t>
+                      </a:r>
+                    </a:p>
+                  </a:txBody>
+                  <a:tcPr marL="91440" marR="91440" marT="36576" marB="36576" anchor="ctr">
+                    <a:lnB w="9525">
+                      <a:solidFill>
+                        <a:srgbClr val="DDE2EC"/>
+                      </a:solidFill>
+                    </a:lnB>
+                    <a:solidFill>
+                      <a:srgbClr val="FFFFFF"/>
+                    </a:solidFill>
+                  </a:tcPr>
+                </a:tc>
+              </a:tr>
+            </a:tbl>
+          </a:graphicData>
+        </a:graphic>
+      </p:graphicFrame>
     </p:spTree>
   </p:cSld>
   <p:clrMapOvr>
@@ -16168,7 +14991,7 @@
                 <a:ea typeface="Malgun Gothic"/>
                 <a:cs typeface="Malgun Gothic"/>
               </a:rPr>
-              <a:t>G078 문희주  ·  WISH FINDER</a:t>
+              <a:t>광주 3반 G078 문희주  ·  WISH FINDER</a:t>
             </a:r>
           </a:p>
         </p:txBody>

</xml_diff>

<commit_message>
docs: rework the results slide (chart first, v2/v3 explanation) and the script
- Results slide: A/B/C chart on the left, v2/v3 table on the right with a
  "wrong scene reported as found" row and a line listing what v3 changed.
- Cards: dual-first-query wording split into three lines, chunk-length
  numbers (10/5=11, 20/10=11, 30/15=9, 40/20=5) and the limits card.
- Narration: define A/B/C with one consistent set of numbers (13/15/16),
  explain the v3 improvements and costs, mention the limits; shorter slide 2.
- Regenerate the deck, its PDF preview and the speaker script.

Co-Authored-By: Claude Sonnet 5.5 <noreply@anthropic.com>
</commit_message>
<xml_diff>
--- a/docs/exec/G078_문희주_발표.pptx
+++ b/docs/exec/G078_문희주_발표.pptx
@@ -998,7 +998,7 @@
           <a:lstStyle/>
           <a:p>
             <a:r>
-              <a:t>[40초] 팬들은 "마니또를 뽑다가 자기 자신을 뽑은 장면"처럼 상황만 기억하고 제목이나 대사는 모릅니다. 그래서 장면을 한국어로 설명하면 자막에서 후보를 찾고, 원본 자막과 다시 대조해 검증한 영상 시점을 알려 주는 Agent를 만들었습니다. 세부 task는 자막 파싱과 청킹, 하이브리드 검색, LangGraph Agent, MCP 서버, 웹 화면과 실시간 전송, 평가와 추적입니다. 자막이 영어 번역본이고 화자 표시가 없어서 화자는 단정하지 않습니다.</a:t>
+              <a:t>[40초] 팬들은 "마니또를 뽑다가 자기 자신을 뽑은 장면"처럼 상황만 기억하고 제목이나 대사는 모릅니다. 그래서 장면을 설명하면 원본 자막으로 검증한 영상 시점을 알려 주는 Agent를 만들었습니다. 세부 task는 파싱·청킹, Hybrid 검색, LangGraph, MCP 서버, 웹 화면, 평가입니다. 자막이 영어 번역본이고 화자 표시가 없어 화자는 단정하지 않습니다.</a:t>
             </a:r>
           </a:p>
         </p:txBody>
@@ -1068,7 +1068,7 @@
           <a:lstStyle/>
           <a:p>
             <a:r>
-              <a:t>[55초] 결과입니다. A는 키워드 검색, B는 Hybrid 검색, C는 Hybrid에 검증과 재검색을 더한 Agent입니다. 같은 20문항 평가셋에서 Agent는 장면 질문 18개 중 16개를 1위로 맞혔고 일반 검색은 11에서 15개였습니다. 차이가 작고 한 번만 실행해서 우위는 단정하지 않습니다. 개선 전후로 화자 질문 처리는 2개에서 3개로 늘었지만 입력 토큰은 24% 늘었습니다. 근거 없이 화자를 단정한 경우는 0건이었습니다. 이중 첫 검색은 켜도 16으로 같아 꺼 두었고, 청크는 20초와 10초를 유지했습니다. 이제 이 결과를 만든 구조와 핵심 코드를 설명드리겠습니다.</a:t>
+              <a:t>[60초] 결과입니다. 평가는 20문항이고, 장면 질문 18개 중 1위로 정답을 맞힌 수는 키워드 검색 A가 13개, Hybrid 검색 B가 15개, 검증과 재검색을 더한 Agent C가 16개입니다. 차이가 작고 한 번만 실행해서 우위는 단정하지 않습니다. 개선한 v3는 화자 질문 판정 기준, 번역 자막 대응, 중복 재검색 제거, 검색어 재작성을 고쳤습니다. 그 결과 화자 질문 처리가 2개에서 3개로 늘고 LLM 호출이 16% 줄었지만, 입력 토큰은 24% 늘고 틀린 장면을 찾음으로 답한 사례가 1건 생겼습니다. 근거 없는 화자 단정은 0건입니다. 이중 첫 검색은 켜도 결과가 같아 꺼 두었고, 청크는 20초와 10초를 유지했습니다. 한계는 후속 질문과 번역 어휘 차이, Multi-Agent 미구현입니다. 이제 구조와 핵심 코드를 설명드리겠습니다.</a:t>
             </a:r>
           </a:p>
         </p:txBody>
@@ -8502,7 +8502,7 @@
         <p:spPr>
           <a:xfrm>
             <a:off x="548640" y="1371600"/>
-            <a:ext cx="6309360" cy="365760"/>
+            <a:ext cx="5120640" cy="365760"/>
           </a:xfrm>
           <a:prstGeom prst="rect">
             <a:avLst/>
@@ -8525,22 +8525,132 @@
                 <a:ea typeface="Malgun Gothic"/>
                 <a:cs typeface="Malgun Gothic"/>
               </a:rPr>
-              <a:t>개선 전/후 (OpenAI, 같은 평가셋·같은 모델)</a:t>
+              <a:t>A / B / C 1위 적중 수 (18문항 중)</a:t>
             </a:r>
           </a:p>
         </p:txBody>
       </p:sp>
       <p:graphicFrame>
         <p:nvGraphicFramePr>
-          <p:cNvPr id="6" name="Table 5"/>
+          <p:cNvPr id="6" name="Chart 5"/>
           <p:cNvGraphicFramePr>
             <a:graphicFrameLocks noGrp="1"/>
           </p:cNvGraphicFramePr>
           <p:nvPr/>
         </p:nvGraphicFramePr>
         <p:xfrm>
-          <a:off x="548640" y="1783080"/>
-          <a:ext cx="6309360" cy="3072384"/>
+          <a:off x="457200" y="1737360"/>
+          <a:ext cx="5212080" cy="2743200"/>
+        </p:xfrm>
+        <a:graphic>
+          <a:graphicData uri="http://schemas.openxmlformats.org/drawingml/2006/chart">
+            <c:chart xmlns:c="http://schemas.openxmlformats.org/drawingml/2006/chart" r:id="rId2"/>
+          </a:graphicData>
+        </a:graphic>
+      </p:graphicFrame>
+      <p:sp>
+        <p:nvSpPr>
+          <p:cNvPr id="7" name="TextBox 6"/>
+          <p:cNvSpPr txBox="1"/>
+          <p:nvPr/>
+        </p:nvSpPr>
+        <p:spPr>
+          <a:xfrm>
+            <a:off x="548640" y="4526280"/>
+            <a:ext cx="5120640" cy="640080"/>
+          </a:xfrm>
+          <a:prstGeom prst="rect">
+            <a:avLst/>
+          </a:prstGeom>
+          <a:noFill/>
+        </p:spPr>
+        <p:txBody>
+          <a:bodyPr wrap="square" anchor="t" lIns="0" rIns="0" tIns="0" bIns="0">
+            <a:spAutoFit/>
+          </a:bodyPr>
+          <a:lstStyle/>
+          <a:p>
+            <a:pPr algn="l">
+              <a:spcAft>
+                <a:spcPts val="100"/>
+              </a:spcAft>
+            </a:pPr>
+            <a:r>
+              <a:rPr sz="1200" b="0">
+                <a:solidFill>
+                  <a:srgbClr val="5B6577"/>
+                </a:solidFill>
+                <a:latin typeface="Malgun Gothic"/>
+                <a:ea typeface="Malgun Gothic"/>
+                <a:cs typeface="Malgun Gothic"/>
+              </a:rPr>
+              <a:t>A 키워드 · B Hybrid(키워드+의미) · C Agent(Hybrid+검증·재검색)</a:t>
+            </a:r>
+          </a:p>
+          <a:p>
+            <a:pPr algn="l"/>
+            <a:r>
+              <a:rPr sz="1200" b="0">
+                <a:solidFill>
+                  <a:srgbClr val="5B6577"/>
+                </a:solidFill>
+                <a:latin typeface="Malgun Gothic"/>
+                <a:ea typeface="Malgun Gothic"/>
+                <a:cs typeface="Malgun Gothic"/>
+              </a:rPr>
+              <a:t>같은 영어 검색어 조건 · 1~3문항 차이, 1회 실행이라 우위 단정 안 함</a:t>
+            </a:r>
+          </a:p>
+        </p:txBody>
+      </p:sp>
+      <p:sp>
+        <p:nvSpPr>
+          <p:cNvPr id="8" name="TextBox 7"/>
+          <p:cNvSpPr txBox="1"/>
+          <p:nvPr/>
+        </p:nvSpPr>
+        <p:spPr>
+          <a:xfrm>
+            <a:off x="6035040" y="1371600"/>
+            <a:ext cx="5669280" cy="365760"/>
+          </a:xfrm>
+          <a:prstGeom prst="rect">
+            <a:avLst/>
+          </a:prstGeom>
+          <a:noFill/>
+        </p:spPr>
+        <p:txBody>
+          <a:bodyPr wrap="square" anchor="t" lIns="0" rIns="0" tIns="0" bIns="0">
+            <a:spAutoFit/>
+          </a:bodyPr>
+          <a:lstStyle/>
+          <a:p>
+            <a:pPr algn="l"/>
+            <a:r>
+              <a:rPr sz="1600" b="1">
+                <a:solidFill>
+                  <a:srgbClr val="5B6577"/>
+                </a:solidFill>
+                <a:latin typeface="Malgun Gothic"/>
+                <a:ea typeface="Malgun Gothic"/>
+                <a:cs typeface="Malgun Gothic"/>
+              </a:rPr>
+              <a:t>개선 전/후 (OpenAI, 같은 평가셋)</a:t>
+            </a:r>
+          </a:p>
+        </p:txBody>
+      </p:sp>
+      <p:graphicFrame>
+        <p:nvGraphicFramePr>
+          <p:cNvPr id="9" name="Table 8"/>
+          <p:cNvGraphicFramePr>
+            <a:graphicFrameLocks noGrp="1"/>
+          </p:cNvGraphicFramePr>
+          <p:nvPr/>
+        </p:nvGraphicFramePr>
+        <p:xfrm>
+          <a:off x="6035040" y="1783080"/>
+          <a:ext cx="5623560" cy="2880360"/>
         </p:xfrm>
         <a:graphic>
           <a:graphicData uri="http://schemas.openxmlformats.org/drawingml/2006/table">
@@ -8549,12 +8659,12 @@
                 <a:tableStyleId>{5C22544A-7EE6-4342-B048-85BDC9FD1C3A}</a:tableStyleId>
               </a:tblPr>
               <a:tblGrid>
-                <a:gridCol w="3017520"/>
-                <a:gridCol w="1097280"/>
-                <a:gridCol w="1097280"/>
+                <a:gridCol w="2697480"/>
+                <a:gridCol w="914400"/>
+                <a:gridCol w="914400"/>
                 <a:gridCol w="1097280"/>
               </a:tblGrid>
-              <a:tr h="512064">
+              <a:tr h="411480">
                 <a:tc>
                   <a:txBody>
                     <a:bodyPr wrap="square"/>
@@ -8562,7 +8672,7 @@
                     <a:p>
                       <a:pPr algn="l"/>
                       <a:r>
-                        <a:rPr sz="1600" b="1">
+                        <a:rPr sz="1400" b="1">
                           <a:solidFill>
                             <a:srgbClr val="1B2437"/>
                           </a:solidFill>
@@ -8592,7 +8702,7 @@
                     <a:p>
                       <a:pPr algn="ctr"/>
                       <a:r>
-                        <a:rPr sz="1600" b="1">
+                        <a:rPr sz="1400" b="1">
                           <a:solidFill>
                             <a:srgbClr val="1B2437"/>
                           </a:solidFill>
@@ -8622,7 +8732,7 @@
                     <a:p>
                       <a:pPr algn="ctr"/>
                       <a:r>
-                        <a:rPr sz="1600" b="1">
+                        <a:rPr sz="1400" b="1">
                           <a:solidFill>
                             <a:srgbClr val="1B2437"/>
                           </a:solidFill>
@@ -8652,7 +8762,7 @@
                     <a:p>
                       <a:pPr algn="ctr"/>
                       <a:r>
-                        <a:rPr sz="1600" b="1">
+                        <a:rPr sz="1400" b="1">
                           <a:solidFill>
                             <a:srgbClr val="1B2437"/>
                           </a:solidFill>
@@ -8676,7 +8786,7 @@
                   </a:tcPr>
                 </a:tc>
               </a:tr>
-              <a:tr h="512064">
+              <a:tr h="411480">
                 <a:tc>
                   <a:txBody>
                     <a:bodyPr wrap="square"/>
@@ -8684,7 +8794,7 @@
                     <a:p>
                       <a:pPr algn="l"/>
                       <a:r>
-                        <a:rPr sz="1600" b="0">
+                        <a:rPr sz="1400" b="0">
                           <a:solidFill>
                             <a:srgbClr val="1B2437"/>
                           </a:solidFill>
@@ -8714,7 +8824,7 @@
                     <a:p>
                       <a:pPr algn="ctr"/>
                       <a:r>
-                        <a:rPr sz="1600" b="0">
+                        <a:rPr sz="1400" b="0">
                           <a:solidFill>
                             <a:srgbClr val="1B2437"/>
                           </a:solidFill>
@@ -8744,7 +8854,7 @@
                     <a:p>
                       <a:pPr algn="ctr"/>
                       <a:r>
-                        <a:rPr sz="1600" b="0">
+                        <a:rPr sz="1400" b="0">
                           <a:solidFill>
                             <a:srgbClr val="1B2437"/>
                           </a:solidFill>
@@ -8774,7 +8884,7 @@
                     <a:p>
                       <a:pPr algn="ctr"/>
                       <a:r>
-                        <a:rPr sz="1600" b="0">
+                        <a:rPr sz="1400" b="0">
                           <a:solidFill>
                             <a:srgbClr val="1B2437"/>
                           </a:solidFill>
@@ -8798,7 +8908,7 @@
                   </a:tcPr>
                 </a:tc>
               </a:tr>
-              <a:tr h="512064">
+              <a:tr h="411480">
                 <a:tc>
                   <a:txBody>
                     <a:bodyPr wrap="square"/>
@@ -8806,7 +8916,7 @@
                     <a:p>
                       <a:pPr algn="l"/>
                       <a:r>
-                        <a:rPr sz="1600" b="0">
+                        <a:rPr sz="1400" b="0">
                           <a:solidFill>
                             <a:srgbClr val="1B2437"/>
                           </a:solidFill>
@@ -8836,7 +8946,7 @@
                     <a:p>
                       <a:pPr algn="ctr"/>
                       <a:r>
-                        <a:rPr sz="1600" b="0">
+                        <a:rPr sz="1400" b="0">
                           <a:solidFill>
                             <a:srgbClr val="1B2437"/>
                           </a:solidFill>
@@ -8866,7 +8976,7 @@
                     <a:p>
                       <a:pPr algn="ctr"/>
                       <a:r>
-                        <a:rPr sz="1600" b="0">
+                        <a:rPr sz="1400" b="0">
                           <a:solidFill>
                             <a:srgbClr val="1B2437"/>
                           </a:solidFill>
@@ -8896,7 +9006,7 @@
                     <a:p>
                       <a:pPr algn="ctr"/>
                       <a:r>
-                        <a:rPr sz="1600" b="0">
+                        <a:rPr sz="1400" b="0">
                           <a:solidFill>
                             <a:srgbClr val="1B2437"/>
                           </a:solidFill>
@@ -8920,7 +9030,7 @@
                   </a:tcPr>
                 </a:tc>
               </a:tr>
-              <a:tr h="512064">
+              <a:tr h="411480">
                 <a:tc>
                   <a:txBody>
                     <a:bodyPr wrap="square"/>
@@ -8928,7 +9038,7 @@
                     <a:p>
                       <a:pPr algn="l"/>
                       <a:r>
-                        <a:rPr sz="1600" b="0">
+                        <a:rPr sz="1400" b="0">
                           <a:solidFill>
                             <a:srgbClr val="1B2437"/>
                           </a:solidFill>
@@ -8958,7 +9068,7 @@
                     <a:p>
                       <a:pPr algn="ctr"/>
                       <a:r>
-                        <a:rPr sz="1600" b="0">
+                        <a:rPr sz="1400" b="0">
                           <a:solidFill>
                             <a:srgbClr val="1B2437"/>
                           </a:solidFill>
@@ -8988,7 +9098,7 @@
                     <a:p>
                       <a:pPr algn="ctr"/>
                       <a:r>
-                        <a:rPr sz="1600" b="0">
+                        <a:rPr sz="1400" b="0">
                           <a:solidFill>
                             <a:srgbClr val="1B2437"/>
                           </a:solidFill>
@@ -9018,7 +9128,7 @@
                     <a:p>
                       <a:pPr algn="ctr"/>
                       <a:r>
-                        <a:rPr sz="1600" b="0">
+                        <a:rPr sz="1400" b="0">
                           <a:solidFill>
                             <a:srgbClr val="1B2437"/>
                           </a:solidFill>
@@ -9042,7 +9152,7 @@
                   </a:tcPr>
                 </a:tc>
               </a:tr>
-              <a:tr h="512064">
+              <a:tr h="411480">
                 <a:tc>
                   <a:txBody>
                     <a:bodyPr wrap="square"/>
@@ -9050,7 +9160,7 @@
                     <a:p>
                       <a:pPr algn="l"/>
                       <a:r>
-                        <a:rPr sz="1600" b="0">
+                        <a:rPr sz="1400" b="0">
                           <a:solidFill>
                             <a:srgbClr val="1B2437"/>
                           </a:solidFill>
@@ -9080,7 +9190,7 @@
                     <a:p>
                       <a:pPr algn="ctr"/>
                       <a:r>
-                        <a:rPr sz="1600" b="0">
+                        <a:rPr sz="1400" b="0">
                           <a:solidFill>
                             <a:srgbClr val="1B2437"/>
                           </a:solidFill>
@@ -9110,7 +9220,7 @@
                     <a:p>
                       <a:pPr algn="ctr"/>
                       <a:r>
-                        <a:rPr sz="1600" b="0">
+                        <a:rPr sz="1400" b="0">
                           <a:solidFill>
                             <a:srgbClr val="1B2437"/>
                           </a:solidFill>
@@ -9140,7 +9250,7 @@
                     <a:p>
                       <a:pPr algn="ctr"/>
                       <a:r>
-                        <a:rPr sz="1600" b="0">
+                        <a:rPr sz="1400" b="0">
                           <a:solidFill>
                             <a:srgbClr val="1B2437"/>
                           </a:solidFill>
@@ -9164,7 +9274,7 @@
                   </a:tcPr>
                 </a:tc>
               </a:tr>
-              <a:tr h="512064">
+              <a:tr h="411480">
                 <a:tc>
                   <a:txBody>
                     <a:bodyPr wrap="square"/>
@@ -9172,7 +9282,7 @@
                     <a:p>
                       <a:pPr algn="l"/>
                       <a:r>
-                        <a:rPr sz="1600" b="0">
+                        <a:rPr sz="1400" b="0">
                           <a:solidFill>
                             <a:srgbClr val="1B2437"/>
                           </a:solidFill>
@@ -9202,7 +9312,7 @@
                     <a:p>
                       <a:pPr algn="ctr"/>
                       <a:r>
-                        <a:rPr sz="1600" b="0">
+                        <a:rPr sz="1400" b="0">
                           <a:solidFill>
                             <a:srgbClr val="1B2437"/>
                           </a:solidFill>
@@ -9232,7 +9342,7 @@
                     <a:p>
                       <a:pPr algn="ctr"/>
                       <a:r>
-                        <a:rPr sz="1600" b="0">
+                        <a:rPr sz="1400" b="0">
                           <a:solidFill>
                             <a:srgbClr val="1B2437"/>
                           </a:solidFill>
@@ -9262,7 +9372,7 @@
                     <a:p>
                       <a:pPr algn="ctr"/>
                       <a:r>
-                        <a:rPr sz="1600" b="0">
+                        <a:rPr sz="1400" b="0">
                           <a:solidFill>
                             <a:srgbClr val="1B2437"/>
                           </a:solidFill>
@@ -9286,20 +9396,142 @@
                   </a:tcPr>
                 </a:tc>
               </a:tr>
+              <a:tr h="411480">
+                <a:tc>
+                  <a:txBody>
+                    <a:bodyPr wrap="square"/>
+                    <a:lstStyle/>
+                    <a:p>
+                      <a:pPr algn="l"/>
+                      <a:r>
+                        <a:rPr sz="1400" b="0">
+                          <a:solidFill>
+                            <a:srgbClr val="1B2437"/>
+                          </a:solidFill>
+                          <a:latin typeface="Malgun Gothic"/>
+                          <a:ea typeface="Malgun Gothic"/>
+                          <a:cs typeface="Malgun Gothic"/>
+                        </a:rPr>
+                        <a:t>틀린 장면을 "찾음"</a:t>
+                      </a:r>
+                    </a:p>
+                  </a:txBody>
+                  <a:tcPr marL="91440" marR="91440" marT="36576" marB="36576" anchor="ctr">
+                    <a:lnB w="9525">
+                      <a:solidFill>
+                        <a:srgbClr val="DDE2EC"/>
+                      </a:solidFill>
+                    </a:lnB>
+                    <a:solidFill>
+                      <a:srgbClr val="E8EEFC"/>
+                    </a:solidFill>
+                  </a:tcPr>
+                </a:tc>
+                <a:tc>
+                  <a:txBody>
+                    <a:bodyPr wrap="square"/>
+                    <a:lstStyle/>
+                    <a:p>
+                      <a:pPr algn="ctr"/>
+                      <a:r>
+                        <a:rPr sz="1400" b="0">
+                          <a:solidFill>
+                            <a:srgbClr val="1B2437"/>
+                          </a:solidFill>
+                          <a:latin typeface="Malgun Gothic"/>
+                          <a:ea typeface="Malgun Gothic"/>
+                          <a:cs typeface="Malgun Gothic"/>
+                        </a:rPr>
+                        <a:t>0건</a:t>
+                      </a:r>
+                    </a:p>
+                  </a:txBody>
+                  <a:tcPr marL="91440" marR="91440" marT="36576" marB="36576" anchor="ctr">
+                    <a:lnB w="9525">
+                      <a:solidFill>
+                        <a:srgbClr val="DDE2EC"/>
+                      </a:solidFill>
+                    </a:lnB>
+                    <a:solidFill>
+                      <a:srgbClr val="E8EEFC"/>
+                    </a:solidFill>
+                  </a:tcPr>
+                </a:tc>
+                <a:tc>
+                  <a:txBody>
+                    <a:bodyPr wrap="square"/>
+                    <a:lstStyle/>
+                    <a:p>
+                      <a:pPr algn="ctr"/>
+                      <a:r>
+                        <a:rPr sz="1400" b="0">
+                          <a:solidFill>
+                            <a:srgbClr val="1B2437"/>
+                          </a:solidFill>
+                          <a:latin typeface="Malgun Gothic"/>
+                          <a:ea typeface="Malgun Gothic"/>
+                          <a:cs typeface="Malgun Gothic"/>
+                        </a:rPr>
+                        <a:t>1건</a:t>
+                      </a:r>
+                    </a:p>
+                  </a:txBody>
+                  <a:tcPr marL="91440" marR="91440" marT="36576" marB="36576" anchor="ctr">
+                    <a:lnB w="9525">
+                      <a:solidFill>
+                        <a:srgbClr val="DDE2EC"/>
+                      </a:solidFill>
+                    </a:lnB>
+                    <a:solidFill>
+                      <a:srgbClr val="E8EEFC"/>
+                    </a:solidFill>
+                  </a:tcPr>
+                </a:tc>
+                <a:tc>
+                  <a:txBody>
+                    <a:bodyPr wrap="square"/>
+                    <a:lstStyle/>
+                    <a:p>
+                      <a:pPr algn="ctr"/>
+                      <a:r>
+                        <a:rPr sz="1400" b="0">
+                          <a:solidFill>
+                            <a:srgbClr val="1B2437"/>
+                          </a:solidFill>
+                          <a:latin typeface="Malgun Gothic"/>
+                          <a:ea typeface="Malgun Gothic"/>
+                          <a:cs typeface="Malgun Gothic"/>
+                        </a:rPr>
+                        <a:t>+1</a:t>
+                      </a:r>
+                    </a:p>
+                  </a:txBody>
+                  <a:tcPr marL="91440" marR="91440" marT="36576" marB="36576" anchor="ctr">
+                    <a:lnB w="9525">
+                      <a:solidFill>
+                        <a:srgbClr val="DDE2EC"/>
+                      </a:solidFill>
+                    </a:lnB>
+                    <a:solidFill>
+                      <a:srgbClr val="E8EEFC"/>
+                    </a:solidFill>
+                  </a:tcPr>
+                </a:tc>
+              </a:tr>
             </a:tbl>
           </a:graphicData>
         </a:graphic>
       </p:graphicFrame>
       <p:sp>
         <p:nvSpPr>
-          <p:cNvPr id="7" name="TextBox 6"/>
+          <p:cNvPr id="10" name="TextBox 9"/>
           <p:cNvSpPr txBox="1"/>
           <p:nvPr/>
         </p:nvSpPr>
         <p:spPr>
           <a:xfrm>
-            <a:off x="7223760" y="1371600"/>
-            <a:ext cx="4480560" cy="365760"/>
+            <a:off x="6035040" y="4681728"/>
+            <a:ext cx="5623560" cy="548640"/>
           </a:xfrm>
           <a:prstGeom prst="rect">
             <a:avLst/>
@@ -9314,7 +9546,7 @@
           <a:p>
             <a:pPr algn="l"/>
             <a:r>
-              <a:rPr sz="1600" b="1">
+              <a:rPr sz="1200" b="0">
                 <a:solidFill>
                   <a:srgbClr val="5B6577"/>
                 </a:solidFill>
@@ -9322,94 +9554,21 @@
                 <a:ea typeface="Malgun Gothic"/>
                 <a:cs typeface="Malgun Gothic"/>
               </a:rPr>
-              <a:t>A / B / C 1위 적중 수 (18문항 중)</a:t>
-            </a:r>
-          </a:p>
-        </p:txBody>
-      </p:sp>
-      <p:graphicFrame>
-        <p:nvGraphicFramePr>
-          <p:cNvPr id="8" name="Chart 7"/>
-          <p:cNvGraphicFramePr>
-            <a:graphicFrameLocks noGrp="1"/>
-          </p:cNvGraphicFramePr>
-          <p:nvPr/>
-        </p:nvGraphicFramePr>
-        <p:xfrm>
-          <a:off x="7132320" y="1737360"/>
-          <a:ext cx="4572000" cy="2926080"/>
-        </p:xfrm>
-        <a:graphic>
-          <a:graphicData uri="http://schemas.openxmlformats.org/drawingml/2006/chart">
-            <c:chart xmlns:c="http://schemas.openxmlformats.org/drawingml/2006/chart" r:id="rId2"/>
-          </a:graphicData>
-        </a:graphic>
-      </p:graphicFrame>
-      <p:sp>
-        <p:nvSpPr>
-          <p:cNvPr id="9" name="TextBox 8"/>
-          <p:cNvSpPr txBox="1"/>
+              <a:t>v3 개선: 화자 질문 판정 기준 · 번역 자막 대응 · 중복 재검색 제거 · 검색어 재작성</a:t>
+            </a:r>
+          </a:p>
+        </p:txBody>
+      </p:sp>
+      <p:sp>
+        <p:nvSpPr>
+          <p:cNvPr id="11" name="Rounded Rectangle 10"/>
+          <p:cNvSpPr/>
           <p:nvPr/>
         </p:nvSpPr>
         <p:spPr>
           <a:xfrm>
-            <a:off x="7223760" y="4727448"/>
-            <a:ext cx="4480560" cy="502920"/>
-          </a:xfrm>
-          <a:prstGeom prst="rect">
-            <a:avLst/>
-          </a:prstGeom>
-          <a:noFill/>
-        </p:spPr>
-        <p:txBody>
-          <a:bodyPr wrap="square" anchor="t" lIns="0" rIns="0" tIns="0" bIns="0">
-            <a:spAutoFit/>
-          </a:bodyPr>
-          <a:lstStyle/>
-          <a:p>
-            <a:pPr algn="l">
-              <a:spcAft>
-                <a:spcPts val="100"/>
-              </a:spcAft>
-            </a:pPr>
-            <a:r>
-              <a:rPr sz="1100" b="0">
-                <a:solidFill>
-                  <a:srgbClr val="5B6577"/>
-                </a:solidFill>
-                <a:latin typeface="Malgun Gothic"/>
-                <a:ea typeface="Malgun Gothic"/>
-                <a:cs typeface="Malgun Gothic"/>
-              </a:rPr>
-              <a:t>A 키워드 · B Hybrid(키워드+의미) · C Agent(Hybrid+검증·재검색)</a:t>
-            </a:r>
-          </a:p>
-          <a:p>
-            <a:pPr algn="l"/>
-            <a:r>
-              <a:rPr sz="1100" b="0">
-                <a:solidFill>
-                  <a:srgbClr val="5B6577"/>
-                </a:solidFill>
-                <a:latin typeface="Malgun Gothic"/>
-                <a:ea typeface="Malgun Gothic"/>
-                <a:cs typeface="Malgun Gothic"/>
-              </a:rPr>
-              <a:t>같은 영어 검색어 조건 · 1~5문항 차이, 1회 실행이라 우위 단정 안 함</a:t>
-            </a:r>
-          </a:p>
-        </p:txBody>
-      </p:sp>
-      <p:sp>
-        <p:nvSpPr>
-          <p:cNvPr id="10" name="Rounded Rectangle 9"/>
-          <p:cNvSpPr/>
-          <p:nvPr/>
-        </p:nvSpPr>
-        <p:spPr>
-          <a:xfrm>
-            <a:off x="548640" y="5285232"/>
-            <a:ext cx="2697480" cy="1051560"/>
+            <a:off x="548640" y="5230368"/>
+            <a:ext cx="2697480" cy="1143000"/>
           </a:xfrm>
           <a:prstGeom prst="roundRect">
             <a:avLst>
@@ -9448,14 +9607,14 @@
       </p:sp>
       <p:sp>
         <p:nvSpPr>
-          <p:cNvPr id="11" name="TextBox 10"/>
+          <p:cNvPr id="12" name="TextBox 11"/>
           <p:cNvSpPr txBox="1"/>
           <p:nvPr/>
         </p:nvSpPr>
         <p:spPr>
           <a:xfrm>
-            <a:off x="685800" y="5303520"/>
-            <a:ext cx="2423160" cy="411480"/>
+            <a:off x="685800" y="5248656"/>
+            <a:ext cx="2423160" cy="365760"/>
           </a:xfrm>
           <a:prstGeom prst="rect">
             <a:avLst/>
@@ -9470,7 +9629,7 @@
           <a:p>
             <a:pPr algn="l"/>
             <a:r>
-              <a:rPr sz="2200" b="1">
+              <a:rPr sz="2000" b="1">
                 <a:solidFill>
                   <a:srgbClr val="2457D6"/>
                 </a:solidFill>
@@ -9485,14 +9644,14 @@
       </p:sp>
       <p:sp>
         <p:nvSpPr>
-          <p:cNvPr id="12" name="TextBox 11"/>
+          <p:cNvPr id="13" name="TextBox 12"/>
           <p:cNvSpPr txBox="1"/>
           <p:nvPr/>
         </p:nvSpPr>
         <p:spPr>
           <a:xfrm>
-            <a:off x="685800" y="5733288"/>
-            <a:ext cx="2423160" cy="566928"/>
+            <a:off x="685800" y="5632704"/>
+            <a:ext cx="2423160" cy="713232"/>
           </a:xfrm>
           <a:prstGeom prst="rect">
             <a:avLst/>
@@ -9509,6 +9668,9 @@
               <a:lnSpc>
                 <a:spcPct val="100000"/>
               </a:lnSpc>
+              <a:spcAft>
+                <a:spcPts val="0"/>
+              </a:spcAft>
             </a:pPr>
             <a:r>
               <a:rPr sz="1200" b="0">
@@ -9526,14 +9688,14 @@
       </p:sp>
       <p:sp>
         <p:nvSpPr>
-          <p:cNvPr id="13" name="Rounded Rectangle 12"/>
+          <p:cNvPr id="14" name="Rounded Rectangle 13"/>
           <p:cNvSpPr/>
           <p:nvPr/>
         </p:nvSpPr>
         <p:spPr>
           <a:xfrm>
-            <a:off x="3355848" y="5285232"/>
-            <a:ext cx="2697480" cy="1051560"/>
+            <a:off x="3355848" y="5230368"/>
+            <a:ext cx="2697480" cy="1143000"/>
           </a:xfrm>
           <a:prstGeom prst="roundRect">
             <a:avLst>
@@ -9572,14 +9734,14 @@
       </p:sp>
       <p:sp>
         <p:nvSpPr>
-          <p:cNvPr id="14" name="TextBox 13"/>
+          <p:cNvPr id="15" name="TextBox 14"/>
           <p:cNvSpPr txBox="1"/>
           <p:nvPr/>
         </p:nvSpPr>
         <p:spPr>
           <a:xfrm>
-            <a:off x="3493008" y="5303520"/>
-            <a:ext cx="2423160" cy="411480"/>
+            <a:off x="3493008" y="5248656"/>
+            <a:ext cx="2423160" cy="365760"/>
           </a:xfrm>
           <a:prstGeom prst="rect">
             <a:avLst/>
@@ -9594,7 +9756,7 @@
           <a:p>
             <a:pPr algn="l"/>
             <a:r>
-              <a:rPr sz="2200" b="1">
+              <a:rPr sz="2000" b="1">
                 <a:solidFill>
                   <a:srgbClr val="2457D6"/>
                 </a:solidFill>
@@ -9609,14 +9771,14 @@
       </p:sp>
       <p:sp>
         <p:nvSpPr>
-          <p:cNvPr id="15" name="TextBox 14"/>
+          <p:cNvPr id="16" name="TextBox 15"/>
           <p:cNvSpPr txBox="1"/>
           <p:nvPr/>
         </p:nvSpPr>
         <p:spPr>
           <a:xfrm>
-            <a:off x="3493008" y="5733288"/>
-            <a:ext cx="2423160" cy="566928"/>
+            <a:off x="3493008" y="5632704"/>
+            <a:ext cx="2423160" cy="713232"/>
           </a:xfrm>
           <a:prstGeom prst="rect">
             <a:avLst/>
@@ -9633,6 +9795,9 @@
               <a:lnSpc>
                 <a:spcPct val="100000"/>
               </a:lnSpc>
+              <a:spcAft>
+                <a:spcPts val="0"/>
+              </a:spcAft>
             </a:pPr>
             <a:r>
               <a:rPr sz="1200" b="0">
@@ -9643,21 +9808,63 @@
                 <a:ea typeface="Malgun Gothic"/>
                 <a:cs typeface="Malgun Gothic"/>
               </a:rPr>
-              <a:t>이중 첫 검색을 켜도 같음, 검색만 80 → 98회 → 기본 꺼짐</a:t>
-            </a:r>
-          </a:p>
-        </p:txBody>
-      </p:sp>
-      <p:sp>
-        <p:nvSpPr>
-          <p:cNvPr id="16" name="Rounded Rectangle 15"/>
+              <a:t>이중 첫 검색을 켜도 결과 같음.</a:t>
+            </a:r>
+          </a:p>
+          <a:p>
+            <a:pPr algn="l">
+              <a:lnSpc>
+                <a:spcPct val="100000"/>
+              </a:lnSpc>
+              <a:spcAft>
+                <a:spcPts val="0"/>
+              </a:spcAft>
+            </a:pPr>
+            <a:r>
+              <a:rPr sz="1200" b="0">
+                <a:solidFill>
+                  <a:srgbClr val="1B2437"/>
+                </a:solidFill>
+                <a:latin typeface="Malgun Gothic"/>
+                <a:ea typeface="Malgun Gothic"/>
+                <a:cs typeface="Malgun Gothic"/>
+              </a:rPr>
+              <a:t>검색만 80 → 98회</a:t>
+            </a:r>
+          </a:p>
+          <a:p>
+            <a:pPr algn="l">
+              <a:lnSpc>
+                <a:spcPct val="100000"/>
+              </a:lnSpc>
+              <a:spcAft>
+                <a:spcPts val="0"/>
+              </a:spcAft>
+            </a:pPr>
+            <a:r>
+              <a:rPr sz="1200" b="0">
+                <a:solidFill>
+                  <a:srgbClr val="1B2437"/>
+                </a:solidFill>
+                <a:latin typeface="Malgun Gothic"/>
+                <a:ea typeface="Malgun Gothic"/>
+                <a:cs typeface="Malgun Gothic"/>
+              </a:rPr>
+              <a:t>기본 꺼짐으로 설정</a:t>
+            </a:r>
+          </a:p>
+        </p:txBody>
+      </p:sp>
+      <p:sp>
+        <p:nvSpPr>
+          <p:cNvPr id="17" name="Rounded Rectangle 16"/>
           <p:cNvSpPr/>
           <p:nvPr/>
         </p:nvSpPr>
         <p:spPr>
           <a:xfrm>
-            <a:off x="6163055" y="5285232"/>
-            <a:ext cx="2697480" cy="1051560"/>
+            <a:off x="6163055" y="5230368"/>
+            <a:ext cx="2697480" cy="1143000"/>
           </a:xfrm>
           <a:prstGeom prst="roundRect">
             <a:avLst>
@@ -9696,14 +9903,14 @@
       </p:sp>
       <p:sp>
         <p:nvSpPr>
-          <p:cNvPr id="17" name="TextBox 16"/>
+          <p:cNvPr id="18" name="TextBox 17"/>
           <p:cNvSpPr txBox="1"/>
           <p:nvPr/>
         </p:nvSpPr>
         <p:spPr>
           <a:xfrm>
-            <a:off x="6300216" y="5303520"/>
-            <a:ext cx="2423160" cy="411480"/>
+            <a:off x="6300216" y="5248656"/>
+            <a:ext cx="2423160" cy="365760"/>
           </a:xfrm>
           <a:prstGeom prst="rect">
             <a:avLst/>
@@ -9718,7 +9925,7 @@
           <a:p>
             <a:pPr algn="l"/>
             <a:r>
-              <a:rPr sz="2200" b="1">
+              <a:rPr sz="2000" b="1">
                 <a:solidFill>
                   <a:srgbClr val="2457D6"/>
                 </a:solidFill>
@@ -9733,14 +9940,14 @@
       </p:sp>
       <p:sp>
         <p:nvSpPr>
-          <p:cNvPr id="18" name="TextBox 17"/>
+          <p:cNvPr id="19" name="TextBox 18"/>
           <p:cNvSpPr txBox="1"/>
           <p:nvPr/>
         </p:nvSpPr>
         <p:spPr>
           <a:xfrm>
-            <a:off x="6300216" y="5733288"/>
-            <a:ext cx="2423160" cy="566928"/>
+            <a:off x="6300216" y="5632704"/>
+            <a:ext cx="2423160" cy="713232"/>
           </a:xfrm>
           <a:prstGeom prst="rect">
             <a:avLst/>
@@ -9757,6 +9964,9 @@
               <a:lnSpc>
                 <a:spcPct val="100000"/>
               </a:lnSpc>
+              <a:spcAft>
+                <a:spcPts val="0"/>
+              </a:spcAft>
             </a:pPr>
             <a:r>
               <a:rPr sz="1200" b="0">
@@ -9767,21 +9977,63 @@
                 <a:ea typeface="Malgun Gothic"/>
                 <a:cs typeface="Malgun Gothic"/>
               </a:rPr>
-              <a:t>청크 길이 비교 후 유지 (30/15 이상은 하락)</a:t>
-            </a:r>
-          </a:p>
-        </p:txBody>
-      </p:sp>
-      <p:sp>
-        <p:nvSpPr>
-          <p:cNvPr id="19" name="Rounded Rectangle 18"/>
+              <a:t>청크 길이 비교 후 유지</a:t>
+            </a:r>
+          </a:p>
+          <a:p>
+            <a:pPr algn="l">
+              <a:lnSpc>
+                <a:spcPct val="100000"/>
+              </a:lnSpc>
+              <a:spcAft>
+                <a:spcPts val="0"/>
+              </a:spcAft>
+            </a:pPr>
+            <a:r>
+              <a:rPr sz="1200" b="0">
+                <a:solidFill>
+                  <a:srgbClr val="1B2437"/>
+                </a:solidFill>
+                <a:latin typeface="Malgun Gothic"/>
+                <a:ea typeface="Malgun Gothic"/>
+                <a:cs typeface="Malgun Gothic"/>
+              </a:rPr>
+              <a:t>1위 적중: 10/5=11 · 20/10=11</a:t>
+            </a:r>
+          </a:p>
+          <a:p>
+            <a:pPr algn="l">
+              <a:lnSpc>
+                <a:spcPct val="100000"/>
+              </a:lnSpc>
+              <a:spcAft>
+                <a:spcPts val="0"/>
+              </a:spcAft>
+            </a:pPr>
+            <a:r>
+              <a:rPr sz="1200" b="0">
+                <a:solidFill>
+                  <a:srgbClr val="1B2437"/>
+                </a:solidFill>
+                <a:latin typeface="Malgun Gothic"/>
+                <a:ea typeface="Malgun Gothic"/>
+                <a:cs typeface="Malgun Gothic"/>
+              </a:rPr>
+              <a:t>30/15=9 · 40/20=5</a:t>
+            </a:r>
+          </a:p>
+        </p:txBody>
+      </p:sp>
+      <p:sp>
+        <p:nvSpPr>
+          <p:cNvPr id="20" name="Rounded Rectangle 19"/>
           <p:cNvSpPr/>
           <p:nvPr/>
         </p:nvSpPr>
         <p:spPr>
           <a:xfrm>
-            <a:off x="8970263" y="5285232"/>
-            <a:ext cx="2697480" cy="1051560"/>
+            <a:off x="8970263" y="5230368"/>
+            <a:ext cx="2697480" cy="1143000"/>
           </a:xfrm>
           <a:prstGeom prst="roundRect">
             <a:avLst>
@@ -9820,14 +10072,14 @@
       </p:sp>
       <p:sp>
         <p:nvSpPr>
-          <p:cNvPr id="20" name="TextBox 19"/>
+          <p:cNvPr id="21" name="TextBox 20"/>
           <p:cNvSpPr txBox="1"/>
           <p:nvPr/>
         </p:nvSpPr>
         <p:spPr>
           <a:xfrm>
-            <a:off x="9107424" y="5303520"/>
-            <a:ext cx="2423160" cy="411480"/>
+            <a:off x="9107424" y="5248656"/>
+            <a:ext cx="2423160" cy="365760"/>
           </a:xfrm>
           <a:prstGeom prst="rect">
             <a:avLst/>
@@ -9842,7 +10094,7 @@
           <a:p>
             <a:pPr algn="l"/>
             <a:r>
-              <a:rPr sz="2200" b="1">
+              <a:rPr sz="2000" b="1">
                 <a:solidFill>
                   <a:srgbClr val="1B2437"/>
                 </a:solidFill>
@@ -9857,14 +10109,14 @@
       </p:sp>
       <p:sp>
         <p:nvSpPr>
-          <p:cNvPr id="21" name="TextBox 20"/>
+          <p:cNvPr id="22" name="TextBox 21"/>
           <p:cNvSpPr txBox="1"/>
           <p:nvPr/>
         </p:nvSpPr>
         <p:spPr>
           <a:xfrm>
-            <a:off x="9107424" y="5733288"/>
-            <a:ext cx="2423160" cy="566928"/>
+            <a:off x="9107424" y="5632704"/>
+            <a:ext cx="2423160" cy="713232"/>
           </a:xfrm>
           <a:prstGeom prst="rect">
             <a:avLst/>
@@ -9881,6 +10133,9 @@
               <a:lnSpc>
                 <a:spcPct val="100000"/>
               </a:lnSpc>
+              <a:spcAft>
+                <a:spcPts val="0"/>
+              </a:spcAft>
             </a:pPr>
             <a:r>
               <a:rPr sz="1200" b="0">
@@ -9891,7 +10146,28 @@
                 <a:ea typeface="Malgun Gothic"/>
                 <a:cs typeface="Malgun Gothic"/>
               </a:rPr>
-              <a:t>후속 질문·번역 어휘 차이, Multi-Agent 미구현</a:t>
+              <a:t>후속 질문·번역 어휘 차이</a:t>
+            </a:r>
+          </a:p>
+          <a:p>
+            <a:pPr algn="l">
+              <a:lnSpc>
+                <a:spcPct val="100000"/>
+              </a:lnSpc>
+              <a:spcAft>
+                <a:spcPts val="0"/>
+              </a:spcAft>
+            </a:pPr>
+            <a:r>
+              <a:rPr sz="1200" b="0">
+                <a:solidFill>
+                  <a:srgbClr val="1B2437"/>
+                </a:solidFill>
+                <a:latin typeface="Malgun Gothic"/>
+                <a:ea typeface="Malgun Gothic"/>
+                <a:cs typeface="Malgun Gothic"/>
+              </a:rPr>
+              <a:t>Multi-Agent 미구현</a:t>
             </a:r>
           </a:p>
         </p:txBody>

</xml_diff>

<commit_message>
docs: keep the speaker script as a hand-edited markdown file
- make_ppt.py no longer writes 발표대본.md or embeds speaker notes, so the
  script is never overwritten when the deck is regenerated.
- Regenerate the deck without notes.
- Update 발표대본.md with the author's edits.

Co-Authored-By: Claude Sonnet 5.5 <noreply@anthropic.com>
</commit_message>
<xml_diff>
--- a/docs/exec/G078_문희주_발표.pptx
+++ b/docs/exec/G078_문희주_발표.pptx
@@ -321,1196 +321,6 @@
     <c:autoUpdate val="0"/>
   </c:externalData>
 </c:chartSpace>
-</file>
-
-<file path=ppt/notesMasters/notesMaster1.xml><?xml version="1.0" encoding="utf-8"?>
-<p:notesMaster xmlns:a="http://schemas.openxmlformats.org/drawingml/2006/main" xmlns:p="http://schemas.openxmlformats.org/presentationml/2006/main" xmlns:r="http://schemas.openxmlformats.org/officeDocument/2006/relationships">
-  <p:cSld>
-    <p:bg>
-      <p:bgRef idx="1001">
-        <a:schemeClr val="bg1"/>
-      </p:bgRef>
-    </p:bg>
-    <p:spTree>
-      <p:nvGrpSpPr>
-        <p:cNvPr id="1" name=""/>
-        <p:cNvGrpSpPr/>
-        <p:nvPr/>
-      </p:nvGrpSpPr>
-      <p:grpSpPr>
-        <a:xfrm>
-          <a:off x="0" y="0"/>
-          <a:ext cx="0" cy="0"/>
-          <a:chOff x="0" y="0"/>
-          <a:chExt cx="0" cy="0"/>
-        </a:xfrm>
-      </p:grpSpPr>
-      <p:sp>
-        <p:nvSpPr>
-          <p:cNvPr id="2" name="Header Placeholder 1"/>
-          <p:cNvSpPr>
-            <a:spLocks noGrp="1"/>
-          </p:cNvSpPr>
-          <p:nvPr>
-            <p:ph type="hdr" sz="quarter"/>
-          </p:nvPr>
-        </p:nvSpPr>
-        <p:spPr>
-          <a:xfrm>
-            <a:off x="0" y="0"/>
-            <a:ext cx="2971800" cy="457200"/>
-          </a:xfrm>
-          <a:prstGeom prst="rect">
-            <a:avLst/>
-          </a:prstGeom>
-        </p:spPr>
-        <p:txBody>
-          <a:bodyPr vert="horz" lIns="91440" tIns="45720" rIns="91440" bIns="45720" rtlCol="0"/>
-          <a:lstStyle>
-            <a:lvl1pPr algn="l">
-              <a:defRPr sz="1200"/>
-            </a:lvl1pPr>
-          </a:lstStyle>
-          <a:p>
-            <a:endParaRPr lang="en-US"/>
-          </a:p>
-        </p:txBody>
-      </p:sp>
-      <p:sp>
-        <p:nvSpPr>
-          <p:cNvPr id="3" name="Date Placeholder 2"/>
-          <p:cNvSpPr>
-            <a:spLocks noGrp="1"/>
-          </p:cNvSpPr>
-          <p:nvPr>
-            <p:ph type="dt" idx="1"/>
-          </p:nvPr>
-        </p:nvSpPr>
-        <p:spPr>
-          <a:xfrm>
-            <a:off x="3884613" y="0"/>
-            <a:ext cx="2971800" cy="457200"/>
-          </a:xfrm>
-          <a:prstGeom prst="rect">
-            <a:avLst/>
-          </a:prstGeom>
-        </p:spPr>
-        <p:txBody>
-          <a:bodyPr vert="horz" lIns="91440" tIns="45720" rIns="91440" bIns="45720" rtlCol="0"/>
-          <a:lstStyle>
-            <a:lvl1pPr algn="r">
-              <a:defRPr sz="1200"/>
-            </a:lvl1pPr>
-          </a:lstStyle>
-          <a:p>
-            <a:fld id="{0F89C1C7-3DCD-1040-A9CF-14679D8B5DDD}" type="datetimeFigureOut">
-              <a:rPr lang="en-US" smtClean="0"/>
-              <a:t>10/17/16</a:t>
-            </a:fld>
-            <a:endParaRPr lang="en-US"/>
-          </a:p>
-        </p:txBody>
-      </p:sp>
-      <p:sp>
-        <p:nvSpPr>
-          <p:cNvPr id="4" name="Slide Image Placeholder 3"/>
-          <p:cNvSpPr>
-            <a:spLocks noGrp="1" noRot="1" noChangeAspect="1"/>
-          </p:cNvSpPr>
-          <p:nvPr>
-            <p:ph type="sldImg" idx="2"/>
-          </p:nvPr>
-        </p:nvSpPr>
-        <p:spPr>
-          <a:xfrm>
-            <a:off x="1143000" y="685800"/>
-            <a:ext cx="4572000" cy="3429000"/>
-          </a:xfrm>
-          <a:prstGeom prst="rect">
-            <a:avLst/>
-          </a:prstGeom>
-          <a:noFill/>
-          <a:ln w="12700">
-            <a:solidFill>
-              <a:prstClr val="black"/>
-            </a:solidFill>
-          </a:ln>
-        </p:spPr>
-        <p:txBody>
-          <a:bodyPr vert="horz" lIns="91440" tIns="45720" rIns="91440" bIns="45720" rtlCol="0" anchor="ctr"/>
-          <a:lstStyle/>
-          <a:p>
-            <a:endParaRPr lang="en-US"/>
-          </a:p>
-        </p:txBody>
-      </p:sp>
-      <p:sp>
-        <p:nvSpPr>
-          <p:cNvPr id="5" name="Notes Placeholder 4"/>
-          <p:cNvSpPr>
-            <a:spLocks noGrp="1"/>
-          </p:cNvSpPr>
-          <p:nvPr>
-            <p:ph type="body" sz="quarter" idx="3"/>
-          </p:nvPr>
-        </p:nvSpPr>
-        <p:spPr>
-          <a:xfrm>
-            <a:off x="685800" y="4343400"/>
-            <a:ext cx="5486400" cy="4114800"/>
-          </a:xfrm>
-          <a:prstGeom prst="rect">
-            <a:avLst/>
-          </a:prstGeom>
-        </p:spPr>
-        <p:txBody>
-          <a:bodyPr vert="horz" lIns="91440" tIns="45720" rIns="91440" bIns="45720" rtlCol="0"/>
-          <a:lstStyle/>
-          <a:p>
-            <a:pPr lvl="0"/>
-            <a:r>
-              <a:rPr lang="en-US" smtClean="0"/>
-              <a:t>Click to edit Master text styles</a:t>
-            </a:r>
-          </a:p>
-          <a:p>
-            <a:pPr lvl="1"/>
-            <a:r>
-              <a:rPr lang="en-US" smtClean="0"/>
-              <a:t>Second level</a:t>
-            </a:r>
-          </a:p>
-          <a:p>
-            <a:pPr lvl="2"/>
-            <a:r>
-              <a:rPr lang="en-US" smtClean="0"/>
-              <a:t>Third level</a:t>
-            </a:r>
-          </a:p>
-          <a:p>
-            <a:pPr lvl="3"/>
-            <a:r>
-              <a:rPr lang="en-US" smtClean="0"/>
-              <a:t>Fourth level</a:t>
-            </a:r>
-          </a:p>
-          <a:p>
-            <a:pPr lvl="4"/>
-            <a:r>
-              <a:rPr lang="en-US" smtClean="0"/>
-              <a:t>Fifth level</a:t>
-            </a:r>
-            <a:endParaRPr lang="en-US"/>
-          </a:p>
-        </p:txBody>
-      </p:sp>
-      <p:sp>
-        <p:nvSpPr>
-          <p:cNvPr id="6" name="Footer Placeholder 5"/>
-          <p:cNvSpPr>
-            <a:spLocks noGrp="1"/>
-          </p:cNvSpPr>
-          <p:nvPr>
-            <p:ph type="ftr" sz="quarter" idx="4"/>
-          </p:nvPr>
-        </p:nvSpPr>
-        <p:spPr>
-          <a:xfrm>
-            <a:off x="0" y="8685213"/>
-            <a:ext cx="2971800" cy="457200"/>
-          </a:xfrm>
-          <a:prstGeom prst="rect">
-            <a:avLst/>
-          </a:prstGeom>
-        </p:spPr>
-        <p:txBody>
-          <a:bodyPr vert="horz" lIns="91440" tIns="45720" rIns="91440" bIns="45720" rtlCol="0" anchor="b"/>
-          <a:lstStyle>
-            <a:lvl1pPr algn="l">
-              <a:defRPr sz="1200"/>
-            </a:lvl1pPr>
-          </a:lstStyle>
-          <a:p>
-            <a:endParaRPr lang="en-US"/>
-          </a:p>
-        </p:txBody>
-      </p:sp>
-      <p:sp>
-        <p:nvSpPr>
-          <p:cNvPr id="7" name="Slide Number Placeholder 6"/>
-          <p:cNvSpPr>
-            <a:spLocks noGrp="1"/>
-          </p:cNvSpPr>
-          <p:nvPr>
-            <p:ph type="sldNum" sz="quarter" idx="5"/>
-          </p:nvPr>
-        </p:nvSpPr>
-        <p:spPr>
-          <a:xfrm>
-            <a:off x="3884613" y="8685213"/>
-            <a:ext cx="2971800" cy="457200"/>
-          </a:xfrm>
-          <a:prstGeom prst="rect">
-            <a:avLst/>
-          </a:prstGeom>
-        </p:spPr>
-        <p:txBody>
-          <a:bodyPr vert="horz" lIns="91440" tIns="45720" rIns="91440" bIns="45720" rtlCol="0" anchor="b"/>
-          <a:lstStyle>
-            <a:lvl1pPr algn="r">
-              <a:defRPr sz="1200"/>
-            </a:lvl1pPr>
-          </a:lstStyle>
-          <a:p>
-            <a:fld id="{BB5E49A5-4136-284D-997B-48E1D791AD67}" type="slidenum">
-              <a:rPr lang="en-US" smtClean="0"/>
-              <a:t>‹#›</a:t>
-            </a:fld>
-            <a:endParaRPr lang="en-US"/>
-          </a:p>
-        </p:txBody>
-      </p:sp>
-    </p:spTree>
-    <p:extLst>
-      <p:ext uri="{BB962C8B-B14F-4D97-AF65-F5344CB8AC3E}">
-        <p14:creationId xmlns:p14="http://schemas.microsoft.com/office/powerpoint/2010/main" val="2623252185"/>
-      </p:ext>
-    </p:extLst>
-  </p:cSld>
-  <p:clrMap bg1="lt1" tx1="dk1" bg2="lt2" tx2="dk2" accent1="accent1" accent2="accent2" accent3="accent3" accent4="accent4" accent5="accent5" accent6="accent6" hlink="hlink" folHlink="folHlink"/>
-  <p:notesStyle>
-    <a:lvl1pPr marL="0" algn="l" defTabSz="457200" rtl="0" eaLnBrk="1" latinLnBrk="0" hangingPunct="1">
-      <a:defRPr sz="1200" kern="1200">
-        <a:solidFill>
-          <a:schemeClr val="tx1"/>
-        </a:solidFill>
-        <a:latin typeface="+mn-lt"/>
-        <a:ea typeface="+mn-ea"/>
-        <a:cs typeface="+mn-cs"/>
-      </a:defRPr>
-    </a:lvl1pPr>
-    <a:lvl2pPr marL="457200" algn="l" defTabSz="457200" rtl="0" eaLnBrk="1" latinLnBrk="0" hangingPunct="1">
-      <a:defRPr sz="1200" kern="1200">
-        <a:solidFill>
-          <a:schemeClr val="tx1"/>
-        </a:solidFill>
-        <a:latin typeface="+mn-lt"/>
-        <a:ea typeface="+mn-ea"/>
-        <a:cs typeface="+mn-cs"/>
-      </a:defRPr>
-    </a:lvl2pPr>
-    <a:lvl3pPr marL="914400" algn="l" defTabSz="457200" rtl="0" eaLnBrk="1" latinLnBrk="0" hangingPunct="1">
-      <a:defRPr sz="1200" kern="1200">
-        <a:solidFill>
-          <a:schemeClr val="tx1"/>
-        </a:solidFill>
-        <a:latin typeface="+mn-lt"/>
-        <a:ea typeface="+mn-ea"/>
-        <a:cs typeface="+mn-cs"/>
-      </a:defRPr>
-    </a:lvl3pPr>
-    <a:lvl4pPr marL="1371600" algn="l" defTabSz="457200" rtl="0" eaLnBrk="1" latinLnBrk="0" hangingPunct="1">
-      <a:defRPr sz="1200" kern="1200">
-        <a:solidFill>
-          <a:schemeClr val="tx1"/>
-        </a:solidFill>
-        <a:latin typeface="+mn-lt"/>
-        <a:ea typeface="+mn-ea"/>
-        <a:cs typeface="+mn-cs"/>
-      </a:defRPr>
-    </a:lvl4pPr>
-    <a:lvl5pPr marL="1828800" algn="l" defTabSz="457200" rtl="0" eaLnBrk="1" latinLnBrk="0" hangingPunct="1">
-      <a:defRPr sz="1200" kern="1200">
-        <a:solidFill>
-          <a:schemeClr val="tx1"/>
-        </a:solidFill>
-        <a:latin typeface="+mn-lt"/>
-        <a:ea typeface="+mn-ea"/>
-        <a:cs typeface="+mn-cs"/>
-      </a:defRPr>
-    </a:lvl5pPr>
-    <a:lvl6pPr marL="2286000" algn="l" defTabSz="457200" rtl="0" eaLnBrk="1" latinLnBrk="0" hangingPunct="1">
-      <a:defRPr sz="1200" kern="1200">
-        <a:solidFill>
-          <a:schemeClr val="tx1"/>
-        </a:solidFill>
-        <a:latin typeface="+mn-lt"/>
-        <a:ea typeface="+mn-ea"/>
-        <a:cs typeface="+mn-cs"/>
-      </a:defRPr>
-    </a:lvl6pPr>
-    <a:lvl7pPr marL="2743200" algn="l" defTabSz="457200" rtl="0" eaLnBrk="1" latinLnBrk="0" hangingPunct="1">
-      <a:defRPr sz="1200" kern="1200">
-        <a:solidFill>
-          <a:schemeClr val="tx1"/>
-        </a:solidFill>
-        <a:latin typeface="+mn-lt"/>
-        <a:ea typeface="+mn-ea"/>
-        <a:cs typeface="+mn-cs"/>
-      </a:defRPr>
-    </a:lvl7pPr>
-    <a:lvl8pPr marL="3200400" algn="l" defTabSz="457200" rtl="0" eaLnBrk="1" latinLnBrk="0" hangingPunct="1">
-      <a:defRPr sz="1200" kern="1200">
-        <a:solidFill>
-          <a:schemeClr val="tx1"/>
-        </a:solidFill>
-        <a:latin typeface="+mn-lt"/>
-        <a:ea typeface="+mn-ea"/>
-        <a:cs typeface="+mn-cs"/>
-      </a:defRPr>
-    </a:lvl8pPr>
-    <a:lvl9pPr marL="3657600" algn="l" defTabSz="457200" rtl="0" eaLnBrk="1" latinLnBrk="0" hangingPunct="1">
-      <a:defRPr sz="1200" kern="1200">
-        <a:solidFill>
-          <a:schemeClr val="tx1"/>
-        </a:solidFill>
-        <a:latin typeface="+mn-lt"/>
-        <a:ea typeface="+mn-ea"/>
-        <a:cs typeface="+mn-cs"/>
-      </a:defRPr>
-    </a:lvl9pPr>
-  </p:notesStyle>
-</p:notesMaster>
-</file>
-
-<file path=ppt/notesSlides/notesSlide1.xml><?xml version="1.0" encoding="utf-8"?>
-<p:notes xmlns:a="http://schemas.openxmlformats.org/drawingml/2006/main" xmlns:p="http://schemas.openxmlformats.org/presentationml/2006/main" xmlns:r="http://schemas.openxmlformats.org/officeDocument/2006/relationships">
-  <p:cSld>
-    <p:spTree>
-      <p:nvGrpSpPr>
-        <p:cNvPr id="1" name=""/>
-        <p:cNvGrpSpPr/>
-        <p:nvPr/>
-      </p:nvGrpSpPr>
-      <p:grpSpPr>
-        <a:xfrm>
-          <a:off x="0" y="0"/>
-          <a:ext cx="0" cy="0"/>
-          <a:chOff x="0" y="0"/>
-          <a:chExt cx="0" cy="0"/>
-        </a:xfrm>
-      </p:grpSpPr>
-      <p:sp>
-        <p:nvSpPr>
-          <p:cNvPr id="2" name="Slide Image Placeholder 1"/>
-          <p:cNvSpPr>
-            <a:spLocks noGrp="1"/>
-          </p:cNvSpPr>
-          <p:nvPr>
-            <p:ph type="sldImg" idx="2"/>
-          </p:nvPr>
-        </p:nvSpPr>
-        <p:spPr/>
-      </p:sp>
-      <p:sp>
-        <p:nvSpPr>
-          <p:cNvPr id="3" name="Notes Placeholder 2"/>
-          <p:cNvSpPr>
-            <a:spLocks noGrp="1"/>
-          </p:cNvSpPr>
-          <p:nvPr>
-            <p:ph type="body" idx="3" sz="quarter"/>
-          </p:nvPr>
-        </p:nvSpPr>
-        <p:spPr/>
-        <p:txBody>
-          <a:bodyPr/>
-          <a:lstStyle/>
-          <a:p>
-            <a:r>
-              <a:t>[10초] 안녕하세요, 광주 3반 G078 문희주입니다. 제 과제는 WISH FINDER입니다. 영상 속 장면이 어렴풋이만 기억날 때, 그 장면을 설명하면 영상의 정확한 시점을 찾아 주는 AI Agent입니다.</a:t>
-            </a:r>
-          </a:p>
-        </p:txBody>
-      </p:sp>
-      <p:sp>
-        <p:nvSpPr>
-          <p:cNvPr id="4" name="Slide Number Placeholder 3"/>
-          <p:cNvSpPr>
-            <a:spLocks noGrp="1"/>
-          </p:cNvSpPr>
-          <p:nvPr>
-            <p:ph type="sldNum" idx="5" sz="quarter"/>
-          </p:nvPr>
-        </p:nvSpPr>
-        <p:spPr/>
-      </p:sp>
-    </p:spTree>
-  </p:cSld>
-  <p:clrMapOvr>
-    <a:masterClrMapping/>
-  </p:clrMapOvr>
-</p:notes>
-</file>
-
-<file path=ppt/notesSlides/notesSlide10.xml><?xml version="1.0" encoding="utf-8"?>
-<p:notes xmlns:a="http://schemas.openxmlformats.org/drawingml/2006/main" xmlns:p="http://schemas.openxmlformats.org/presentationml/2006/main" xmlns:r="http://schemas.openxmlformats.org/officeDocument/2006/relationships">
-  <p:cSld>
-    <p:spTree>
-      <p:nvGrpSpPr>
-        <p:cNvPr id="1" name=""/>
-        <p:cNvGrpSpPr/>
-        <p:nvPr/>
-      </p:nvGrpSpPr>
-      <p:grpSpPr>
-        <a:xfrm>
-          <a:off x="0" y="0"/>
-          <a:ext cx="0" cy="0"/>
-          <a:chOff x="0" y="0"/>
-          <a:chExt cx="0" cy="0"/>
-        </a:xfrm>
-      </p:grpSpPr>
-      <p:sp>
-        <p:nvSpPr>
-          <p:cNvPr id="2" name="Slide Image Placeholder 1"/>
-          <p:cNvSpPr>
-            <a:spLocks noGrp="1"/>
-          </p:cNvSpPr>
-          <p:nvPr>
-            <p:ph type="sldImg" idx="2"/>
-          </p:nvPr>
-        </p:nvSpPr>
-        <p:spPr/>
-      </p:sp>
-      <p:sp>
-        <p:nvSpPr>
-          <p:cNvPr id="3" name="Notes Placeholder 2"/>
-          <p:cNvSpPr>
-            <a:spLocks noGrp="1"/>
-          </p:cNvSpPr>
-          <p:nvPr>
-            <p:ph type="body" idx="3" sz="quarter"/>
-          </p:nvPr>
-        </p:nvSpPr>
-        <p:spPr/>
-        <p:txBody>
-          <a:bodyPr/>
-          <a:lstStyle/>
-          <a:p>
-            <a:r>
-              <a:t>[백업] 질문 대비: 의존성 주입과 테스트. FinderAgent는 모든 의존성을 생성자로 받고 테스트에서는 가짜 모델과 가짜 연결을 넣습니다. 모델 호출을 가짜로 대신해 과금이 없고 결과가 항상 같습니다.</a:t>
-            </a:r>
-          </a:p>
-        </p:txBody>
-      </p:sp>
-      <p:sp>
-        <p:nvSpPr>
-          <p:cNvPr id="4" name="Slide Number Placeholder 3"/>
-          <p:cNvSpPr>
-            <a:spLocks noGrp="1"/>
-          </p:cNvSpPr>
-          <p:nvPr>
-            <p:ph type="sldNum" idx="5" sz="quarter"/>
-          </p:nvPr>
-        </p:nvSpPr>
-        <p:spPr/>
-      </p:sp>
-    </p:spTree>
-  </p:cSld>
-  <p:clrMapOvr>
-    <a:masterClrMapping/>
-  </p:clrMapOvr>
-</p:notes>
-</file>
-
-<file path=ppt/notesSlides/notesSlide11.xml><?xml version="1.0" encoding="utf-8"?>
-<p:notes xmlns:a="http://schemas.openxmlformats.org/drawingml/2006/main" xmlns:p="http://schemas.openxmlformats.org/presentationml/2006/main" xmlns:r="http://schemas.openxmlformats.org/officeDocument/2006/relationships">
-  <p:cSld>
-    <p:spTree>
-      <p:nvGrpSpPr>
-        <p:cNvPr id="1" name=""/>
-        <p:cNvGrpSpPr/>
-        <p:nvPr/>
-      </p:nvGrpSpPr>
-      <p:grpSpPr>
-        <a:xfrm>
-          <a:off x="0" y="0"/>
-          <a:ext cx="0" cy="0"/>
-          <a:chOff x="0" y="0"/>
-          <a:chExt cx="0" cy="0"/>
-        </a:xfrm>
-      </p:grpSpPr>
-      <p:sp>
-        <p:nvSpPr>
-          <p:cNvPr id="2" name="Slide Image Placeholder 1"/>
-          <p:cNvSpPr>
-            <a:spLocks noGrp="1"/>
-          </p:cNvSpPr>
-          <p:nvPr>
-            <p:ph type="sldImg" idx="2"/>
-          </p:nvPr>
-        </p:nvSpPr>
-        <p:spPr/>
-      </p:sp>
-      <p:sp>
-        <p:nvSpPr>
-          <p:cNvPr id="3" name="Notes Placeholder 2"/>
-          <p:cNvSpPr>
-            <a:spLocks noGrp="1"/>
-          </p:cNvSpPr>
-          <p:nvPr>
-            <p:ph type="body" idx="3" sz="quarter"/>
-          </p:nvPr>
-        </p:nvSpPr>
-        <p:spPr/>
-        <p:txBody>
-          <a:bodyPr/>
-          <a:lstStyle/>
-          <a:p>
-            <a:r>
-              <a:t>[백업] 질문 대비: 이중 첫 검색. Router 검색어가 번역 어휘와 달라 못 찾던 질문을, 질문 원문도 함께 검색해 보완한 시도입니다. 구현 중 점수 합산 방식에서 정답이 밀리는 문제를 실제 자막으로 확인해 순위 교차 방식으로 바꿨습니다. 정답 평가셋 20문항으로 끈 실행과 켠 실행을 다시 측정했더니 1위 적중이 둘 다 16개로 같았고, 못 찾은 두 문항도 그대로였습니다. 검색만 80회에서 98회로 늘었고 LLM 호출과 토큰은 같아서 기본값은 꺼 두었습니다. 마니또처럼 못 찾던 질문이 찾아진 것은 평가셋 밖 직접 실행에서만 확인했습니다.</a:t>
-            </a:r>
-          </a:p>
-        </p:txBody>
-      </p:sp>
-      <p:sp>
-        <p:nvSpPr>
-          <p:cNvPr id="4" name="Slide Number Placeholder 3"/>
-          <p:cNvSpPr>
-            <a:spLocks noGrp="1"/>
-          </p:cNvSpPr>
-          <p:nvPr>
-            <p:ph type="sldNum" idx="5" sz="quarter"/>
-          </p:nvPr>
-        </p:nvSpPr>
-        <p:spPr/>
-      </p:sp>
-    </p:spTree>
-  </p:cSld>
-  <p:clrMapOvr>
-    <a:masterClrMapping/>
-  </p:clrMapOvr>
-</p:notes>
-</file>
-
-<file path=ppt/notesSlides/notesSlide12.xml><?xml version="1.0" encoding="utf-8"?>
-<p:notes xmlns:a="http://schemas.openxmlformats.org/drawingml/2006/main" xmlns:p="http://schemas.openxmlformats.org/presentationml/2006/main" xmlns:r="http://schemas.openxmlformats.org/officeDocument/2006/relationships">
-  <p:cSld>
-    <p:spTree>
-      <p:nvGrpSpPr>
-        <p:cNvPr id="1" name=""/>
-        <p:cNvGrpSpPr/>
-        <p:nvPr/>
-      </p:nvGrpSpPr>
-      <p:grpSpPr>
-        <a:xfrm>
-          <a:off x="0" y="0"/>
-          <a:ext cx="0" cy="0"/>
-          <a:chOff x="0" y="0"/>
-          <a:chExt cx="0" cy="0"/>
-        </a:xfrm>
-      </p:grpSpPr>
-      <p:sp>
-        <p:nvSpPr>
-          <p:cNvPr id="2" name="Slide Image Placeholder 1"/>
-          <p:cNvSpPr>
-            <a:spLocks noGrp="1"/>
-          </p:cNvSpPr>
-          <p:nvPr>
-            <p:ph type="sldImg" idx="2"/>
-          </p:nvPr>
-        </p:nvSpPr>
-        <p:spPr/>
-      </p:sp>
-      <p:sp>
-        <p:nvSpPr>
-          <p:cNvPr id="3" name="Notes Placeholder 2"/>
-          <p:cNvSpPr>
-            <a:spLocks noGrp="1"/>
-          </p:cNvSpPr>
-          <p:nvPr>
-            <p:ph type="body" idx="3" sz="quarter"/>
-          </p:nvPr>
-        </p:nvSpPr>
-        <p:spPr/>
-        <p:txBody>
-          <a:bodyPr/>
-          <a:lstStyle/>
-          <a:p>
-            <a:r>
-              <a:t>[백업] 질문 대비: 기술 요소와 Multi-Agent. Multi-Agent는 호출·지연·실패 지점이 늘고 실제 원인이 구조가 아니라 어휘였기 때문에 구현하지 않았습니다. 설계안은 Supervisor, Search Agent, Verifier Agent의 허브-스포크 구조입니다.</a:t>
-            </a:r>
-          </a:p>
-        </p:txBody>
-      </p:sp>
-      <p:sp>
-        <p:nvSpPr>
-          <p:cNvPr id="4" name="Slide Number Placeholder 3"/>
-          <p:cNvSpPr>
-            <a:spLocks noGrp="1"/>
-          </p:cNvSpPr>
-          <p:nvPr>
-            <p:ph type="sldNum" idx="5" sz="quarter"/>
-          </p:nvPr>
-        </p:nvSpPr>
-        <p:spPr/>
-      </p:sp>
-    </p:spTree>
-  </p:cSld>
-  <p:clrMapOvr>
-    <a:masterClrMapping/>
-  </p:clrMapOvr>
-</p:notes>
-</file>
-
-<file path=ppt/notesSlides/notesSlide2.xml><?xml version="1.0" encoding="utf-8"?>
-<p:notes xmlns:a="http://schemas.openxmlformats.org/drawingml/2006/main" xmlns:p="http://schemas.openxmlformats.org/presentationml/2006/main" xmlns:r="http://schemas.openxmlformats.org/officeDocument/2006/relationships">
-  <p:cSld>
-    <p:spTree>
-      <p:nvGrpSpPr>
-        <p:cNvPr id="1" name=""/>
-        <p:cNvGrpSpPr/>
-        <p:nvPr/>
-      </p:nvGrpSpPr>
-      <p:grpSpPr>
-        <a:xfrm>
-          <a:off x="0" y="0"/>
-          <a:ext cx="0" cy="0"/>
-          <a:chOff x="0" y="0"/>
-          <a:chExt cx="0" cy="0"/>
-        </a:xfrm>
-      </p:grpSpPr>
-      <p:sp>
-        <p:nvSpPr>
-          <p:cNvPr id="2" name="Slide Image Placeholder 1"/>
-          <p:cNvSpPr>
-            <a:spLocks noGrp="1"/>
-          </p:cNvSpPr>
-          <p:nvPr>
-            <p:ph type="sldImg" idx="2"/>
-          </p:nvPr>
-        </p:nvSpPr>
-        <p:spPr/>
-      </p:sp>
-      <p:sp>
-        <p:nvSpPr>
-          <p:cNvPr id="3" name="Notes Placeholder 2"/>
-          <p:cNvSpPr>
-            <a:spLocks noGrp="1"/>
-          </p:cNvSpPr>
-          <p:nvPr>
-            <p:ph type="body" idx="3" sz="quarter"/>
-          </p:nvPr>
-        </p:nvSpPr>
-        <p:spPr/>
-        <p:txBody>
-          <a:bodyPr/>
-          <a:lstStyle/>
-          <a:p>
-            <a:r>
-              <a:t>[40초] 팬들은 "마니또를 뽑다가 자기 자신을 뽑은 장면"처럼 상황만 기억하고 제목이나 대사는 모릅니다. 그래서 장면을 설명하면 원본 자막으로 검증한 영상 시점을 알려 주는 Agent를 만들었습니다. 세부 task는 파싱·청킹, Hybrid 검색, LangGraph, MCP 서버, 웹 화면, 평가입니다. 자막이 영어 번역본이고 화자 표시가 없어 화자는 단정하지 않습니다.</a:t>
-            </a:r>
-          </a:p>
-        </p:txBody>
-      </p:sp>
-      <p:sp>
-        <p:nvSpPr>
-          <p:cNvPr id="4" name="Slide Number Placeholder 3"/>
-          <p:cNvSpPr>
-            <a:spLocks noGrp="1"/>
-          </p:cNvSpPr>
-          <p:nvPr>
-            <p:ph type="sldNum" idx="5" sz="quarter"/>
-          </p:nvPr>
-        </p:nvSpPr>
-        <p:spPr/>
-      </p:sp>
-    </p:spTree>
-  </p:cSld>
-  <p:clrMapOvr>
-    <a:masterClrMapping/>
-  </p:clrMapOvr>
-</p:notes>
-</file>
-
-<file path=ppt/notesSlides/notesSlide3.xml><?xml version="1.0" encoding="utf-8"?>
-<p:notes xmlns:a="http://schemas.openxmlformats.org/drawingml/2006/main" xmlns:p="http://schemas.openxmlformats.org/presentationml/2006/main" xmlns:r="http://schemas.openxmlformats.org/officeDocument/2006/relationships">
-  <p:cSld>
-    <p:spTree>
-      <p:nvGrpSpPr>
-        <p:cNvPr id="1" name=""/>
-        <p:cNvGrpSpPr/>
-        <p:nvPr/>
-      </p:nvGrpSpPr>
-      <p:grpSpPr>
-        <a:xfrm>
-          <a:off x="0" y="0"/>
-          <a:ext cx="0" cy="0"/>
-          <a:chOff x="0" y="0"/>
-          <a:chExt cx="0" cy="0"/>
-        </a:xfrm>
-      </p:grpSpPr>
-      <p:sp>
-        <p:nvSpPr>
-          <p:cNvPr id="2" name="Slide Image Placeholder 1"/>
-          <p:cNvSpPr>
-            <a:spLocks noGrp="1"/>
-          </p:cNvSpPr>
-          <p:nvPr>
-            <p:ph type="sldImg" idx="2"/>
-          </p:nvPr>
-        </p:nvSpPr>
-        <p:spPr/>
-      </p:sp>
-      <p:sp>
-        <p:nvSpPr>
-          <p:cNvPr id="3" name="Notes Placeholder 2"/>
-          <p:cNvSpPr>
-            <a:spLocks noGrp="1"/>
-          </p:cNvSpPr>
-          <p:nvPr>
-            <p:ph type="body" idx="3" sz="quarter"/>
-          </p:nvPr>
-        </p:nvSpPr>
-        <p:spPr/>
-        <p:txBody>
-          <a:bodyPr/>
-          <a:lstStyle/>
-          <a:p>
-            <a:r>
-              <a:t>[60초] 결과입니다. 평가는 20문항이고, 장면 질문 18개 중 1위로 정답을 맞힌 수는 키워드 검색 A가 13개, Hybrid 검색 B가 15개, 검증과 재검색을 더한 Agent C가 16개입니다. 차이가 작고 한 번만 실행해서 우위는 단정하지 않습니다. 개선한 v3는 화자 질문 판정 기준, 번역 자막 대응, 중복 재검색 제거, 검색어 재작성을 고쳤습니다. 그 결과 화자 질문 처리가 2개에서 3개로 늘고 LLM 호출이 16% 줄었지만, 입력 토큰은 24% 늘고 틀린 장면을 찾음으로 답한 사례가 1건 생겼습니다. 근거 없는 화자 단정은 0건입니다. 이중 첫 검색은 켜도 결과가 같아 꺼 두었고, 청크는 20초와 10초를 유지했습니다. 한계는 후속 질문과 번역 어휘 차이, Multi-Agent 미구현입니다. 이제 구조와 핵심 코드를 설명드리겠습니다.</a:t>
-            </a:r>
-          </a:p>
-        </p:txBody>
-      </p:sp>
-      <p:sp>
-        <p:nvSpPr>
-          <p:cNvPr id="4" name="Slide Number Placeholder 3"/>
-          <p:cNvSpPr>
-            <a:spLocks noGrp="1"/>
-          </p:cNvSpPr>
-          <p:nvPr>
-            <p:ph type="sldNum" idx="5" sz="quarter"/>
-          </p:nvPr>
-        </p:nvSpPr>
-        <p:spPr/>
-      </p:sp>
-    </p:spTree>
-  </p:cSld>
-  <p:clrMapOvr>
-    <a:masterClrMapping/>
-  </p:clrMapOvr>
-</p:notes>
-</file>
-
-<file path=ppt/notesSlides/notesSlide4.xml><?xml version="1.0" encoding="utf-8"?>
-<p:notes xmlns:a="http://schemas.openxmlformats.org/drawingml/2006/main" xmlns:p="http://schemas.openxmlformats.org/presentationml/2006/main" xmlns:r="http://schemas.openxmlformats.org/officeDocument/2006/relationships">
-  <p:cSld>
-    <p:spTree>
-      <p:nvGrpSpPr>
-        <p:cNvPr id="1" name=""/>
-        <p:cNvGrpSpPr/>
-        <p:nvPr/>
-      </p:nvGrpSpPr>
-      <p:grpSpPr>
-        <a:xfrm>
-          <a:off x="0" y="0"/>
-          <a:ext cx="0" cy="0"/>
-          <a:chOff x="0" y="0"/>
-          <a:chExt cx="0" cy="0"/>
-        </a:xfrm>
-      </p:grpSpPr>
-      <p:sp>
-        <p:nvSpPr>
-          <p:cNvPr id="2" name="Slide Image Placeholder 1"/>
-          <p:cNvSpPr>
-            <a:spLocks noGrp="1"/>
-          </p:cNvSpPr>
-          <p:nvPr>
-            <p:ph type="sldImg" idx="2"/>
-          </p:nvPr>
-        </p:nvSpPr>
-        <p:spPr/>
-      </p:sp>
-      <p:sp>
-        <p:nvSpPr>
-          <p:cNvPr id="3" name="Notes Placeholder 2"/>
-          <p:cNvSpPr>
-            <a:spLocks noGrp="1"/>
-          </p:cNvSpPr>
-          <p:nvPr>
-            <p:ph type="body" idx="3" sz="quarter"/>
-          </p:nvPr>
-        </p:nvSpPr>
-        <p:spPr/>
-        <p:txBody>
-          <a:bodyPr/>
-          <a:lstStyle/>
-          <a:p>
-            <a:r>
-              <a:t>[20초] 전체 구조입니다. 화면의 질문은 FastAPI를 거쳐 LangGraph Agent로 가고, Agent는 MCP 서버를 통해서만 자막을 조회합니다. 자막 검색은 키워드와 의미 검색을 합친 Hybrid 방식입니다. 이제 핵심 코드 세 가지, Agent Graph와 MCP, RAG를 설명드리겠습니다.</a:t>
-            </a:r>
-          </a:p>
-        </p:txBody>
-      </p:sp>
-      <p:sp>
-        <p:nvSpPr>
-          <p:cNvPr id="4" name="Slide Number Placeholder 3"/>
-          <p:cNvSpPr>
-            <a:spLocks noGrp="1"/>
-          </p:cNvSpPr>
-          <p:nvPr>
-            <p:ph type="sldNum" idx="5" sz="quarter"/>
-          </p:nvPr>
-        </p:nvSpPr>
-        <p:spPr/>
-      </p:sp>
-    </p:spTree>
-  </p:cSld>
-  <p:clrMapOvr>
-    <a:masterClrMapping/>
-  </p:clrMapOvr>
-</p:notes>
-</file>
-
-<file path=ppt/notesSlides/notesSlide5.xml><?xml version="1.0" encoding="utf-8"?>
-<p:notes xmlns:a="http://schemas.openxmlformats.org/drawingml/2006/main" xmlns:p="http://schemas.openxmlformats.org/presentationml/2006/main" xmlns:r="http://schemas.openxmlformats.org/officeDocument/2006/relationships">
-  <p:cSld>
-    <p:spTree>
-      <p:nvGrpSpPr>
-        <p:cNvPr id="1" name=""/>
-        <p:cNvGrpSpPr/>
-        <p:nvPr/>
-      </p:nvGrpSpPr>
-      <p:grpSpPr>
-        <a:xfrm>
-          <a:off x="0" y="0"/>
-          <a:ext cx="0" cy="0"/>
-          <a:chOff x="0" y="0"/>
-          <a:chExt cx="0" cy="0"/>
-        </a:xfrm>
-      </p:grpSpPr>
-      <p:sp>
-        <p:nvSpPr>
-          <p:cNvPr id="2" name="Slide Image Placeholder 1"/>
-          <p:cNvSpPr>
-            <a:spLocks noGrp="1"/>
-          </p:cNvSpPr>
-          <p:nvPr>
-            <p:ph type="sldImg" idx="2"/>
-          </p:nvPr>
-        </p:nvSpPr>
-        <p:spPr/>
-      </p:sp>
-      <p:sp>
-        <p:nvSpPr>
-          <p:cNvPr id="3" name="Notes Placeholder 2"/>
-          <p:cNvSpPr>
-            <a:spLocks noGrp="1"/>
-          </p:cNvSpPr>
-          <p:nvPr>
-            <p:ph type="body" idx="3" sz="quarter"/>
-          </p:nvPr>
-        </p:nvSpPr>
-        <p:spPr/>
-        <p:txBody>
-          <a:bodyPr/>
-          <a:lstStyle/>
-          <a:p>
-            <a:r>
-              <a:t>[65초] Agent Graph입니다. 코드를 보면 StateGraph에 분류, 검색, 원본 대조, 판정, 재검색, 정리 여섯 노드를 add_node로 등록합니다. 다음 노드는 add_conditional_edges의 조건 함수가 정합니다. 분류에서 자막으로 알 수 없는 요청이면 곧바로 정리로 가고, 판정에서 관련 후보가 없고 시간이 남아 있을 때만 재검색으로 갑니다. MAX_REPLAN_ROUNDS가 2라서 재검색은 최대 두 번입니다. LLM이 판단하는 곳은 분류, 판정, 검색어 재작성 세 군데뿐이고, 인용과 시각은 코드가 원본 cue에서 만듭니다. Multi-Agent가 아닌 단일 워크플로입니다.</a:t>
-            </a:r>
-          </a:p>
-        </p:txBody>
-      </p:sp>
-      <p:sp>
-        <p:nvSpPr>
-          <p:cNvPr id="4" name="Slide Number Placeholder 3"/>
-          <p:cNvSpPr>
-            <a:spLocks noGrp="1"/>
-          </p:cNvSpPr>
-          <p:nvPr>
-            <p:ph type="sldNum" idx="5" sz="quarter"/>
-          </p:nvPr>
-        </p:nvSpPr>
-        <p:spPr/>
-      </p:sp>
-    </p:spTree>
-  </p:cSld>
-  <p:clrMapOvr>
-    <a:masterClrMapping/>
-  </p:clrMapOvr>
-</p:notes>
-</file>
-
-<file path=ppt/notesSlides/notesSlide6.xml><?xml version="1.0" encoding="utf-8"?>
-<p:notes xmlns:a="http://schemas.openxmlformats.org/drawingml/2006/main" xmlns:p="http://schemas.openxmlformats.org/presentationml/2006/main" xmlns:r="http://schemas.openxmlformats.org/officeDocument/2006/relationships">
-  <p:cSld>
-    <p:spTree>
-      <p:nvGrpSpPr>
-        <p:cNvPr id="1" name=""/>
-        <p:cNvGrpSpPr/>
-        <p:nvPr/>
-      </p:nvGrpSpPr>
-      <p:grpSpPr>
-        <a:xfrm>
-          <a:off x="0" y="0"/>
-          <a:ext cx="0" cy="0"/>
-          <a:chOff x="0" y="0"/>
-          <a:chExt cx="0" cy="0"/>
-        </a:xfrm>
-      </p:grpSpPr>
-      <p:sp>
-        <p:nvSpPr>
-          <p:cNvPr id="2" name="Slide Image Placeholder 1"/>
-          <p:cNvSpPr>
-            <a:spLocks noGrp="1"/>
-          </p:cNvSpPr>
-          <p:nvPr>
-            <p:ph type="sldImg" idx="2"/>
-          </p:nvPr>
-        </p:nvSpPr>
-        <p:spPr/>
-      </p:sp>
-      <p:sp>
-        <p:nvSpPr>
-          <p:cNvPr id="3" name="Notes Placeholder 2"/>
-          <p:cNvSpPr>
-            <a:spLocks noGrp="1"/>
-          </p:cNvSpPr>
-          <p:nvPr>
-            <p:ph type="body" idx="3" sz="quarter"/>
-          </p:nvPr>
-        </p:nvSpPr>
-        <p:spPr/>
-        <p:txBody>
-          <a:bodyPr/>
-          <a:lstStyle/>
-          <a:p>
-            <a:r>
-              <a:t>[50초] MCP입니다. 공식 SDK 2.x의 MCPServer에서 server.tool 데코레이터로 읽기 전용 도구 네 개를 만들고, 로컬 프로세스로 띄워 stdio로 통신합니다. Agent는 검색과 원본 조회 두 개를 쓰고, 나머지 두 개는 화면용입니다. 핵심은 검색 결과를 그대로 믿지 않는 것입니다. search_transcripts가 준 청크는 가공된 텍스트라서, 인용과 시각은 get_scene_context가 돌려주는 원본 cue로 다시 확인합니다. 검색은 계산이 무거워 동시에 한 건만 실행하도록 제한했습니다.</a:t>
-            </a:r>
-          </a:p>
-        </p:txBody>
-      </p:sp>
-      <p:sp>
-        <p:nvSpPr>
-          <p:cNvPr id="4" name="Slide Number Placeholder 3"/>
-          <p:cNvSpPr>
-            <a:spLocks noGrp="1"/>
-          </p:cNvSpPr>
-          <p:nvPr>
-            <p:ph type="sldNum" idx="5" sz="quarter"/>
-          </p:nvPr>
-        </p:nvSpPr>
-        <p:spPr/>
-      </p:sp>
-    </p:spTree>
-  </p:cSld>
-  <p:clrMapOvr>
-    <a:masterClrMapping/>
-  </p:clrMapOvr>
-</p:notes>
-</file>
-
-<file path=ppt/notesSlides/notesSlide7.xml><?xml version="1.0" encoding="utf-8"?>
-<p:notes xmlns:a="http://schemas.openxmlformats.org/drawingml/2006/main" xmlns:p="http://schemas.openxmlformats.org/presentationml/2006/main" xmlns:r="http://schemas.openxmlformats.org/officeDocument/2006/relationships">
-  <p:cSld>
-    <p:spTree>
-      <p:nvGrpSpPr>
-        <p:cNvPr id="1" name=""/>
-        <p:cNvGrpSpPr/>
-        <p:nvPr/>
-      </p:nvGrpSpPr>
-      <p:grpSpPr>
-        <a:xfrm>
-          <a:off x="0" y="0"/>
-          <a:ext cx="0" cy="0"/>
-          <a:chOff x="0" y="0"/>
-          <a:chExt cx="0" cy="0"/>
-        </a:xfrm>
-      </p:grpSpPr>
-      <p:sp>
-        <p:nvSpPr>
-          <p:cNvPr id="2" name="Slide Image Placeholder 1"/>
-          <p:cNvSpPr>
-            <a:spLocks noGrp="1"/>
-          </p:cNvSpPr>
-          <p:nvPr>
-            <p:ph type="sldImg" idx="2"/>
-          </p:nvPr>
-        </p:nvSpPr>
-        <p:spPr/>
-      </p:sp>
-      <p:sp>
-        <p:nvSpPr>
-          <p:cNvPr id="3" name="Notes Placeholder 2"/>
-          <p:cNvSpPr>
-            <a:spLocks noGrp="1"/>
-          </p:cNvSpPr>
-          <p:nvPr>
-            <p:ph type="body" idx="3" sz="quarter"/>
-          </p:nvPr>
-        </p:nvSpPr>
-        <p:spPr/>
-        <p:txBody>
-          <a:bodyPr/>
-          <a:lstStyle/>
-          <a:p>
-            <a:r>
-              <a:t>[55초] RAG입니다. 자막 3,750줄을 영상별로 20초씩, 10초 겹치게 묶어 청크 869개를 만들었습니다. 키워드 검색 상위 20개와 의미 검색 상위 20개를 RRF로 합치는데, 순위가 r인 후보에 1 나누기 60 더하기 r 점수를 주고 더합니다. 청크는 cue 번호를 가지고 있어 결과가 항상 원본 자막 줄로 돌아갑니다. 청크 길이는 10초 5초, 30초 15초, 40초 20초와도 비교했고 20초 10초를 유지했습니다. 가장 크게 배운 것은 같은 질문도 표현에 따라 결과가 달라져서, 한 번 잘 나온 결과를 믿지 말고 측정으로 확인해야 한다는 점입니다. 감사합니다.</a:t>
-            </a:r>
-          </a:p>
-        </p:txBody>
-      </p:sp>
-      <p:sp>
-        <p:nvSpPr>
-          <p:cNvPr id="4" name="Slide Number Placeholder 3"/>
-          <p:cNvSpPr>
-            <a:spLocks noGrp="1"/>
-          </p:cNvSpPr>
-          <p:nvPr>
-            <p:ph type="sldNum" idx="5" sz="quarter"/>
-          </p:nvPr>
-        </p:nvSpPr>
-        <p:spPr/>
-      </p:sp>
-    </p:spTree>
-  </p:cSld>
-  <p:clrMapOvr>
-    <a:masterClrMapping/>
-  </p:clrMapOvr>
-</p:notes>
-</file>
-
-<file path=ppt/notesSlides/notesSlide8.xml><?xml version="1.0" encoding="utf-8"?>
-<p:notes xmlns:a="http://schemas.openxmlformats.org/drawingml/2006/main" xmlns:p="http://schemas.openxmlformats.org/presentationml/2006/main" xmlns:r="http://schemas.openxmlformats.org/officeDocument/2006/relationships">
-  <p:cSld>
-    <p:spTree>
-      <p:nvGrpSpPr>
-        <p:cNvPr id="1" name=""/>
-        <p:cNvGrpSpPr/>
-        <p:nvPr/>
-      </p:nvGrpSpPr>
-      <p:grpSpPr>
-        <a:xfrm>
-          <a:off x="0" y="0"/>
-          <a:ext cx="0" cy="0"/>
-          <a:chOff x="0" y="0"/>
-          <a:chExt cx="0" cy="0"/>
-        </a:xfrm>
-      </p:grpSpPr>
-      <p:sp>
-        <p:nvSpPr>
-          <p:cNvPr id="2" name="Slide Image Placeholder 1"/>
-          <p:cNvSpPr>
-            <a:spLocks noGrp="1"/>
-          </p:cNvSpPr>
-          <p:nvPr>
-            <p:ph type="sldImg" idx="2"/>
-          </p:nvPr>
-        </p:nvSpPr>
-        <p:spPr/>
-      </p:sp>
-      <p:sp>
-        <p:nvSpPr>
-          <p:cNvPr id="3" name="Notes Placeholder 2"/>
-          <p:cNvSpPr>
-            <a:spLocks noGrp="1"/>
-          </p:cNvSpPr>
-          <p:nvPr>
-            <p:ph type="body" idx="3" sz="quarter"/>
-          </p:nvPr>
-        </p:nvSpPr>
-        <p:spPr/>
-        <p:txBody>
-          <a:bodyPr/>
-          <a:lstStyle/>
-          <a:p>
-            <a:r>
-              <a:t>[백업] 질문 대비: 한계와 트레이드오프. 측정, 성능, 비용·범위 세 갈래로 정리합니다. 측정은 18문항에 질문당 1회라 1에서 2문항 차이는 우연일 수 있고, 정답 라벨은 어시스턴트가 원본 자막을 검토해 제안하고 제가 승인한 것이며 영상 대조는 9곳 표본입니다. 성능에서는 찾음 응답 17건 중 1건이 틀린 장면이었고, 정답 청크가 후보 3개 밖에 있던 문항이 두 개 있었습니다. 비용은 입력 토큰이 24% 늘고 평균 지연이 2.6초입니다. 범위로는 Multi-Agent를 구현하거나 비교하지 않았고, 영어 번역 자막이라 화자를 단정할 수 없습니다.</a:t>
-            </a:r>
-          </a:p>
-        </p:txBody>
-      </p:sp>
-      <p:sp>
-        <p:nvSpPr>
-          <p:cNvPr id="4" name="Slide Number Placeholder 3"/>
-          <p:cNvSpPr>
-            <a:spLocks noGrp="1"/>
-          </p:cNvSpPr>
-          <p:nvPr>
-            <p:ph type="sldNum" idx="5" sz="quarter"/>
-          </p:nvPr>
-        </p:nvSpPr>
-        <p:spPr/>
-      </p:sp>
-    </p:spTree>
-  </p:cSld>
-  <p:clrMapOvr>
-    <a:masterClrMapping/>
-  </p:clrMapOvr>
-</p:notes>
-</file>
-
-<file path=ppt/notesSlides/notesSlide9.xml><?xml version="1.0" encoding="utf-8"?>
-<p:notes xmlns:a="http://schemas.openxmlformats.org/drawingml/2006/main" xmlns:p="http://schemas.openxmlformats.org/presentationml/2006/main" xmlns:r="http://schemas.openxmlformats.org/officeDocument/2006/relationships">
-  <p:cSld>
-    <p:spTree>
-      <p:nvGrpSpPr>
-        <p:cNvPr id="1" name=""/>
-        <p:cNvGrpSpPr/>
-        <p:nvPr/>
-      </p:nvGrpSpPr>
-      <p:grpSpPr>
-        <a:xfrm>
-          <a:off x="0" y="0"/>
-          <a:ext cx="0" cy="0"/>
-          <a:chOff x="0" y="0"/>
-          <a:chExt cx="0" cy="0"/>
-        </a:xfrm>
-      </p:grpSpPr>
-      <p:sp>
-        <p:nvSpPr>
-          <p:cNvPr id="2" name="Slide Image Placeholder 1"/>
-          <p:cNvSpPr>
-            <a:spLocks noGrp="1"/>
-          </p:cNvSpPr>
-          <p:nvPr>
-            <p:ph type="sldImg" idx="2"/>
-          </p:nvPr>
-        </p:nvSpPr>
-        <p:spPr/>
-      </p:sp>
-      <p:sp>
-        <p:nvSpPr>
-          <p:cNvPr id="3" name="Notes Placeholder 2"/>
-          <p:cNvSpPr>
-            <a:spLocks noGrp="1"/>
-          </p:cNvSpPr>
-          <p:nvPr>
-            <p:ph type="body" idx="3" sz="quarter"/>
-          </p:nvPr>
-        </p:nvSpPr>
-        <p:spPr/>
-        <p:txBody>
-          <a:bodyPr/>
-          <a:lstStyle/>
-          <a:p>
-            <a:r>
-              <a:t>[백업] 질문 대비: LangSmith 추적. 평가 두 번의 합계가 트레이스 160개, 모델 호출 188회, 토큰 135.5K, 비용 $0.30입니다. 재검색이 있으면 지연·LLM 호출·토큰이 대략 두 배가 됩니다.</a:t>
-            </a:r>
-          </a:p>
-        </p:txBody>
-      </p:sp>
-      <p:sp>
-        <p:nvSpPr>
-          <p:cNvPr id="4" name="Slide Number Placeholder 3"/>
-          <p:cNvSpPr>
-            <a:spLocks noGrp="1"/>
-          </p:cNvSpPr>
-          <p:nvPr>
-            <p:ph type="sldNum" idx="5" sz="quarter"/>
-          </p:nvPr>
-        </p:nvSpPr>
-        <p:spPr/>
-      </p:sp>
-    </p:spTree>
-  </p:cSld>
-  <p:clrMapOvr>
-    <a:masterClrMapping/>
-  </p:clrMapOvr>
-</p:notes>
 </file>
 
 <file path=ppt/slideLayouts/slideLayout1.xml><?xml version="1.0" encoding="utf-8"?>
@@ -15832,324 +14642,4 @@
   </a:objectDefaults>
   <a:extraClrSchemeLst/>
 </a:theme>
-</file>
-
-<file path=ppt/theme/theme2.xml><?xml version="1.0" encoding="utf-8"?>
-<a:theme xmlns:a="http://schemas.openxmlformats.org/drawingml/2006/main" name="Office Theme">
-  <a:themeElements>
-    <a:clrScheme name="Office">
-      <a:dk1>
-        <a:sysClr val="windowText" lastClr="000000"/>
-      </a:dk1>
-      <a:lt1>
-        <a:sysClr val="window" lastClr="FFFFFF"/>
-      </a:lt1>
-      <a:dk2>
-        <a:srgbClr val="1F497D"/>
-      </a:dk2>
-      <a:lt2>
-        <a:srgbClr val="EEECE1"/>
-      </a:lt2>
-      <a:accent1>
-        <a:srgbClr val="4F81BD"/>
-      </a:accent1>
-      <a:accent2>
-        <a:srgbClr val="C0504D"/>
-      </a:accent2>
-      <a:accent3>
-        <a:srgbClr val="9BBB59"/>
-      </a:accent3>
-      <a:accent4>
-        <a:srgbClr val="8064A2"/>
-      </a:accent4>
-      <a:accent5>
-        <a:srgbClr val="4BACC6"/>
-      </a:accent5>
-      <a:accent6>
-        <a:srgbClr val="F79646"/>
-      </a:accent6>
-      <a:hlink>
-        <a:srgbClr val="0000FF"/>
-      </a:hlink>
-      <a:folHlink>
-        <a:srgbClr val="800080"/>
-      </a:folHlink>
-    </a:clrScheme>
-    <a:fontScheme name="Office">
-      <a:majorFont>
-        <a:latin typeface="Calibri"/>
-        <a:ea typeface=""/>
-        <a:cs typeface=""/>
-        <a:font script="Jpan" typeface="ＭＳ Ｐゴシック"/>
-        <a:font script="Hang" typeface="맑은 고딕"/>
-        <a:font script="Hans" typeface="宋体"/>
-        <a:font script="Hant" typeface="新細明體"/>
-        <a:font script="Arab" typeface="Times New Roman"/>
-        <a:font script="Hebr" typeface="Times New Roman"/>
-        <a:font script="Thai" typeface="Angsana New"/>
-        <a:font script="Ethi" typeface="Nyala"/>
-        <a:font script="Beng" typeface="Vrinda"/>
-        <a:font script="Gujr" typeface="Shruti"/>
-        <a:font script="Khmr" typeface="MoolBoran"/>
-        <a:font script="Knda" typeface="Tunga"/>
-        <a:font script="Guru" typeface="Raavi"/>
-        <a:font script="Cans" typeface="Euphemia"/>
-        <a:font script="Cher" typeface="Plantagenet Cherokee"/>
-        <a:font script="Yiii" typeface="Microsoft Yi Baiti"/>
-        <a:font script="Tibt" typeface="Microsoft Himalaya"/>
-        <a:font script="Thaa" typeface="MV Boli"/>
-        <a:font script="Deva" typeface="Mangal"/>
-        <a:font script="Telu" typeface="Gautami"/>
-        <a:font script="Taml" typeface="Latha"/>
-        <a:font script="Syrc" typeface="Estrangelo Edessa"/>
-        <a:font script="Orya" typeface="Kalinga"/>
-        <a:font script="Mlym" typeface="Kartika"/>
-        <a:font script="Laoo" typeface="DokChampa"/>
-        <a:font script="Sinh" typeface="Iskoola Pota"/>
-        <a:font script="Mong" typeface="Mongolian Baiti"/>
-        <a:font script="Viet" typeface="Times New Roman"/>
-        <a:font script="Uigh" typeface="Microsoft Uighur"/>
-        <a:font script="Geor" typeface="Sylfaen"/>
-      </a:majorFont>
-      <a:minorFont>
-        <a:latin typeface="Calibri"/>
-        <a:ea typeface=""/>
-        <a:cs typeface=""/>
-        <a:font script="Jpan" typeface="ＭＳ Ｐゴシック"/>
-        <a:font script="Hang" typeface="맑은 고딕"/>
-        <a:font script="Hans" typeface="宋体"/>
-        <a:font script="Hant" typeface="新細明體"/>
-        <a:font script="Arab" typeface="Arial"/>
-        <a:font script="Hebr" typeface="Arial"/>
-        <a:font script="Thai" typeface="Cordia New"/>
-        <a:font script="Ethi" typeface="Nyala"/>
-        <a:font script="Beng" typeface="Vrinda"/>
-        <a:font script="Gujr" typeface="Shruti"/>
-        <a:font script="Khmr" typeface="DaunPenh"/>
-        <a:font script="Knda" typeface="Tunga"/>
-        <a:font script="Guru" typeface="Raavi"/>
-        <a:font script="Cans" typeface="Euphemia"/>
-        <a:font script="Cher" typeface="Plantagenet Cherokee"/>
-        <a:font script="Yiii" typeface="Microsoft Yi Baiti"/>
-        <a:font script="Tibt" typeface="Microsoft Himalaya"/>
-        <a:font script="Thaa" typeface="MV Boli"/>
-        <a:font script="Deva" typeface="Mangal"/>
-        <a:font script="Telu" typeface="Gautami"/>
-        <a:font script="Taml" typeface="Latha"/>
-        <a:font script="Syrc" typeface="Estrangelo Edessa"/>
-        <a:font script="Orya" typeface="Kalinga"/>
-        <a:font script="Mlym" typeface="Kartika"/>
-        <a:font script="Laoo" typeface="DokChampa"/>
-        <a:font script="Sinh" typeface="Iskoola Pota"/>
-        <a:font script="Mong" typeface="Mongolian Baiti"/>
-        <a:font script="Viet" typeface="Arial"/>
-        <a:font script="Uigh" typeface="Microsoft Uighur"/>
-        <a:font script="Geor" typeface="Sylfaen"/>
-      </a:minorFont>
-    </a:fontScheme>
-    <a:fmtScheme name="Office">
-      <a:fillStyleLst>
-        <a:solidFill>
-          <a:schemeClr val="phClr"/>
-        </a:solidFill>
-        <a:gradFill rotWithShape="1">
-          <a:gsLst>
-            <a:gs pos="0">
-              <a:schemeClr val="phClr">
-                <a:tint val="50000"/>
-                <a:satMod val="300000"/>
-              </a:schemeClr>
-            </a:gs>
-            <a:gs pos="35000">
-              <a:schemeClr val="phClr">
-                <a:tint val="37000"/>
-                <a:satMod val="300000"/>
-              </a:schemeClr>
-            </a:gs>
-            <a:gs pos="100000">
-              <a:schemeClr val="phClr">
-                <a:tint val="15000"/>
-                <a:satMod val="350000"/>
-              </a:schemeClr>
-            </a:gs>
-          </a:gsLst>
-          <a:lin ang="16200000" scaled="1"/>
-        </a:gradFill>
-        <a:gradFill rotWithShape="1">
-          <a:gsLst>
-            <a:gs pos="0">
-              <a:schemeClr val="phClr">
-                <a:tint val="100000"/>
-                <a:shade val="100000"/>
-                <a:satMod val="130000"/>
-              </a:schemeClr>
-            </a:gs>
-            <a:gs pos="100000">
-              <a:schemeClr val="phClr">
-                <a:tint val="50000"/>
-                <a:shade val="100000"/>
-                <a:satMod val="350000"/>
-              </a:schemeClr>
-            </a:gs>
-          </a:gsLst>
-          <a:lin ang="16200000" scaled="0"/>
-        </a:gradFill>
-      </a:fillStyleLst>
-      <a:lnStyleLst>
-        <a:ln w="9525" cap="flat" cmpd="sng" algn="ctr">
-          <a:solidFill>
-            <a:schemeClr val="phClr">
-              <a:shade val="95000"/>
-              <a:satMod val="105000"/>
-            </a:schemeClr>
-          </a:solidFill>
-          <a:prstDash val="solid"/>
-        </a:ln>
-        <a:ln w="25400" cap="flat" cmpd="sng" algn="ctr">
-          <a:solidFill>
-            <a:schemeClr val="phClr"/>
-          </a:solidFill>
-          <a:prstDash val="solid"/>
-        </a:ln>
-        <a:ln w="38100" cap="flat" cmpd="sng" algn="ctr">
-          <a:solidFill>
-            <a:schemeClr val="phClr"/>
-          </a:solidFill>
-          <a:prstDash val="solid"/>
-        </a:ln>
-      </a:lnStyleLst>
-      <a:effectStyleLst>
-        <a:effectStyle>
-          <a:effectLst>
-            <a:outerShdw blurRad="40000" dist="20000" dir="5400000" rotWithShape="0">
-              <a:srgbClr val="000000">
-                <a:alpha val="38000"/>
-              </a:srgbClr>
-            </a:outerShdw>
-          </a:effectLst>
-        </a:effectStyle>
-        <a:effectStyle>
-          <a:effectLst>
-            <a:outerShdw blurRad="40000" dist="23000" dir="5400000" rotWithShape="0">
-              <a:srgbClr val="000000">
-                <a:alpha val="35000"/>
-              </a:srgbClr>
-            </a:outerShdw>
-          </a:effectLst>
-        </a:effectStyle>
-        <a:effectStyle>
-          <a:effectLst>
-            <a:outerShdw blurRad="40000" dist="23000" dir="5400000" rotWithShape="0">
-              <a:srgbClr val="000000">
-                <a:alpha val="35000"/>
-              </a:srgbClr>
-            </a:outerShdw>
-          </a:effectLst>
-          <a:scene3d>
-            <a:camera prst="orthographicFront">
-              <a:rot lat="0" lon="0" rev="0"/>
-            </a:camera>
-            <a:lightRig rig="threePt" dir="t">
-              <a:rot lat="0" lon="0" rev="1200000"/>
-            </a:lightRig>
-          </a:scene3d>
-          <a:sp3d>
-            <a:bevelT w="63500" h="25400"/>
-          </a:sp3d>
-        </a:effectStyle>
-      </a:effectStyleLst>
-      <a:bgFillStyleLst>
-        <a:solidFill>
-          <a:schemeClr val="phClr"/>
-        </a:solidFill>
-        <a:gradFill rotWithShape="1">
-          <a:gsLst>
-            <a:gs pos="0">
-              <a:schemeClr val="phClr">
-                <a:tint val="40000"/>
-                <a:satMod val="350000"/>
-              </a:schemeClr>
-            </a:gs>
-            <a:gs pos="40000">
-              <a:schemeClr val="phClr">
-                <a:tint val="45000"/>
-                <a:shade val="99000"/>
-                <a:satMod val="350000"/>
-              </a:schemeClr>
-            </a:gs>
-            <a:gs pos="100000">
-              <a:schemeClr val="phClr">
-                <a:shade val="20000"/>
-                <a:satMod val="255000"/>
-              </a:schemeClr>
-            </a:gs>
-          </a:gsLst>
-          <a:path path="circle">
-            <a:fillToRect l="50000" t="-80000" r="50000" b="180000"/>
-          </a:path>
-        </a:gradFill>
-        <a:gradFill rotWithShape="1">
-          <a:gsLst>
-            <a:gs pos="0">
-              <a:schemeClr val="phClr">
-                <a:tint val="80000"/>
-                <a:satMod val="300000"/>
-              </a:schemeClr>
-            </a:gs>
-            <a:gs pos="100000">
-              <a:schemeClr val="phClr">
-                <a:shade val="30000"/>
-                <a:satMod val="200000"/>
-              </a:schemeClr>
-            </a:gs>
-          </a:gsLst>
-          <a:path path="circle">
-            <a:fillToRect l="50000" t="50000" r="50000" b="50000"/>
-          </a:path>
-        </a:gradFill>
-      </a:bgFillStyleLst>
-    </a:fmtScheme>
-  </a:themeElements>
-  <a:objectDefaults>
-    <a:spDef>
-      <a:spPr/>
-      <a:bodyPr/>
-      <a:lstStyle/>
-      <a:style>
-        <a:lnRef idx="1">
-          <a:schemeClr val="accent1"/>
-        </a:lnRef>
-        <a:fillRef idx="3">
-          <a:schemeClr val="accent1"/>
-        </a:fillRef>
-        <a:effectRef idx="2">
-          <a:schemeClr val="accent1"/>
-        </a:effectRef>
-        <a:fontRef idx="minor">
-          <a:schemeClr val="lt1"/>
-        </a:fontRef>
-      </a:style>
-    </a:spDef>
-    <a:lnDef>
-      <a:spPr/>
-      <a:bodyPr/>
-      <a:lstStyle/>
-      <a:style>
-        <a:lnRef idx="2">
-          <a:schemeClr val="accent1"/>
-        </a:lnRef>
-        <a:fillRef idx="0">
-          <a:schemeClr val="accent1"/>
-        </a:fillRef>
-        <a:effectRef idx="1">
-          <a:schemeClr val="accent1"/>
-        </a:effectRef>
-        <a:fontRef idx="minor">
-          <a:schemeClr val="tx1"/>
-        </a:fontRef>
-      </a:style>
-    </a:lnDef>
-  </a:objectDefaults>
-  <a:extraClrSchemeLst/>
-</a:theme>
 </file>
</xml_diff>

<commit_message>
docs: drop the limits backup slide from the deck and update the script
- Remove the "[백업] 한계와 트레이드오프" slide; the deck and its PDF preview
  are now 11 slides (7 main + 4 backup).
- Update 발표대본.md with the author's edits.

Co-Authored-By: Claude Sonnet 5.5 <noreply@anthropic.com>
</commit_message>
<xml_diff>
--- a/docs/exec/G078_문희주_발표.pptx
+++ b/docs/exec/G078_문희주_발표.pptx
@@ -16,7 +16,6 @@
     <p:sldId id="264" r:id="rId15"/>
     <p:sldId id="265" r:id="rId16"/>
     <p:sldId id="266" r:id="rId17"/>
-    <p:sldId id="267" r:id="rId18"/>
   </p:sldIdLst>
   <p:sldSz cx="12191695" cy="6858000" type="screen4x3"/>
   <p:notesSz cx="6858000" cy="9144000"/>
@@ -3597,7 +3596,7 @@
                 <a:ea typeface="Malgun Gothic"/>
                 <a:cs typeface="Malgun Gothic"/>
               </a:rPr>
-              <a:t>[백업] 의존성 주입과 테스트</a:t>
+              <a:t>[백업] 이중 첫 검색: 번역 어휘 차이를 질문 원문 검색으로 보완</a:t>
             </a:r>
           </a:p>
         </p:txBody>
@@ -3672,1075 +3671,6 @@
                 <a:cs typeface="Malgun Gothic"/>
               </a:rPr>
               <a:t>10</a:t>
-            </a:r>
-          </a:p>
-        </p:txBody>
-      </p:sp>
-      <p:sp>
-        <p:nvSpPr>
-          <p:cNvPr id="5" name="Rounded Rectangle 4"/>
-          <p:cNvSpPr/>
-          <p:nvPr/>
-        </p:nvSpPr>
-        <p:spPr>
-          <a:xfrm>
-            <a:off x="548640" y="1371600"/>
-            <a:ext cx="5760720" cy="3200400"/>
-          </a:xfrm>
-          <a:prstGeom prst="roundRect">
-            <a:avLst>
-              <a:gd name="adj" fmla="val 2500"/>
-            </a:avLst>
-          </a:prstGeom>
-          <a:solidFill>
-            <a:srgbClr val="1E2433"/>
-          </a:solidFill>
-          <a:ln>
-            <a:noFill/>
-          </a:ln>
-          <a:effectLst/>
-        </p:spPr>
-        <p:style>
-          <a:lnRef idx="1">
-            <a:schemeClr val="accent1"/>
-          </a:lnRef>
-          <a:fillRef idx="3">
-            <a:schemeClr val="accent1"/>
-          </a:fillRef>
-          <a:effectRef idx="2">
-            <a:schemeClr val="accent1"/>
-          </a:effectRef>
-          <a:fontRef idx="minor">
-            <a:schemeClr val="lt1"/>
-          </a:fontRef>
-        </p:style>
-        <p:txBody>
-          <a:bodyPr rtlCol="0" anchor="ctr"/>
-          <a:lstStyle/>
-          <a:p>
-            <a:pPr algn="ctr"/>
-          </a:p>
-        </p:txBody>
-      </p:sp>
-      <p:sp>
-        <p:nvSpPr>
-          <p:cNvPr id="6" name="TextBox 5"/>
-          <p:cNvSpPr txBox="1"/>
-          <p:nvPr/>
-        </p:nvSpPr>
-        <p:spPr>
-          <a:xfrm>
-            <a:off x="731520" y="1536192"/>
-            <a:ext cx="5394959" cy="2871216"/>
-          </a:xfrm>
-          <a:prstGeom prst="rect">
-            <a:avLst/>
-          </a:prstGeom>
-          <a:noFill/>
-        </p:spPr>
-        <p:txBody>
-          <a:bodyPr wrap="square" anchor="t" lIns="0" rIns="0" tIns="0" bIns="0">
-            <a:spAutoFit/>
-          </a:bodyPr>
-          <a:lstStyle/>
-          <a:p>
-            <a:pPr algn="l">
-              <a:lnSpc>
-                <a:spcPct val="108000"/>
-              </a:lnSpc>
-              <a:spcAft>
-                <a:spcPts val="0"/>
-              </a:spcAft>
-            </a:pPr>
-            <a:r>
-              <a:rPr sz="1300" b="0">
-                <a:solidFill>
-                  <a:srgbClr val="E6E9F2"/>
-                </a:solidFill>
-                <a:latin typeface="Consolas"/>
-                <a:ea typeface="Consolas"/>
-                <a:cs typeface="Consolas"/>
-              </a:rPr>
-              <a:t>class FinderAgent:</a:t>
-            </a:r>
-          </a:p>
-          <a:p>
-            <a:pPr algn="l">
-              <a:lnSpc>
-                <a:spcPct val="108000"/>
-              </a:lnSpc>
-              <a:spcAft>
-                <a:spcPts val="0"/>
-              </a:spcAft>
-            </a:pPr>
-            <a:r>
-              <a:rPr sz="1300" b="0">
-                <a:solidFill>
-                  <a:srgbClr val="9DB7FF"/>
-                </a:solidFill>
-                <a:latin typeface="Consolas"/>
-                <a:ea typeface="Consolas"/>
-                <a:cs typeface="Consolas"/>
-              </a:rPr>
-              <a:t>    def __init__(self, session, metadata, model, *,</a:t>
-            </a:r>
-          </a:p>
-          <a:p>
-            <a:pPr algn="l">
-              <a:lnSpc>
-                <a:spcPct val="108000"/>
-              </a:lnSpc>
-              <a:spcAft>
-                <a:spcPts val="0"/>
-              </a:spcAft>
-            </a:pPr>
-            <a:r>
-              <a:rPr sz="1300" b="0">
-                <a:solidFill>
-                  <a:srgbClr val="E6E9F2"/>
-                </a:solidFill>
-                <a:latin typeface="Consolas"/>
-                <a:ea typeface="Consolas"/>
-                <a:cs typeface="Consolas"/>
-              </a:rPr>
-              <a:t>                 mode='hybrid',</a:t>
-            </a:r>
-          </a:p>
-          <a:p>
-            <a:pPr algn="l">
-              <a:lnSpc>
-                <a:spcPct val="108000"/>
-              </a:lnSpc>
-              <a:spcAft>
-                <a:spcPts val="0"/>
-              </a:spcAft>
-            </a:pPr>
-            <a:r>
-              <a:rPr sz="1300" b="0">
-                <a:solidFill>
-                  <a:srgbClr val="E6E9F2"/>
-                </a:solidFill>
-                <a:latin typeface="Consolas"/>
-                <a:ea typeface="Consolas"/>
-                <a:cs typeface="Consolas"/>
-              </a:rPr>
-              <a:t>                 tool_call=call_tool,</a:t>
-            </a:r>
-          </a:p>
-          <a:p>
-            <a:pPr algn="l">
-              <a:lnSpc>
-                <a:spcPct val="108000"/>
-              </a:lnSpc>
-              <a:spcAft>
-                <a:spcPts val="0"/>
-              </a:spcAft>
-            </a:pPr>
-            <a:r>
-              <a:rPr sz="1300" b="0">
-                <a:solidFill>
-                  <a:srgbClr val="E6E9F2"/>
-                </a:solidFill>
-                <a:latin typeface="Consolas"/>
-                <a:ea typeface="Consolas"/>
-                <a:cs typeface="Consolas"/>
-              </a:rPr>
-              <a:t>                 timeout=60,</a:t>
-            </a:r>
-          </a:p>
-          <a:p>
-            <a:pPr algn="l">
-              <a:lnSpc>
-                <a:spcPct val="108000"/>
-              </a:lnSpc>
-              <a:spcAft>
-                <a:spcPts val="0"/>
-              </a:spcAft>
-            </a:pPr>
-            <a:r>
-              <a:rPr sz="1300" b="0">
-                <a:solidFill>
-                  <a:srgbClr val="E6E9F2"/>
-                </a:solidFill>
-                <a:latin typeface="Consolas"/>
-                <a:ea typeface="Consolas"/>
-                <a:cs typeface="Consolas"/>
-              </a:rPr>
-              <a:t>                 telemetry=None,</a:t>
-            </a:r>
-          </a:p>
-          <a:p>
-            <a:pPr algn="l">
-              <a:lnSpc>
-                <a:spcPct val="108000"/>
-              </a:lnSpc>
-              <a:spcAft>
-                <a:spcPts val="0"/>
-              </a:spcAft>
-            </a:pPr>
-            <a:r>
-              <a:rPr sz="1300" b="0">
-                <a:solidFill>
-                  <a:srgbClr val="E6E9F2"/>
-                </a:solidFill>
-                <a:latin typeface="Consolas"/>
-                <a:ea typeface="Consolas"/>
-                <a:cs typeface="Consolas"/>
-              </a:rPr>
-              <a:t>                 dual_query=False, ...):</a:t>
-            </a:r>
-          </a:p>
-          <a:p>
-            <a:pPr algn="l">
-              <a:lnSpc>
-                <a:spcPct val="108000"/>
-              </a:lnSpc>
-              <a:spcAft>
-                <a:spcPts val="0"/>
-              </a:spcAft>
-            </a:pPr>
-            <a:r>
-              <a:rPr sz="1300" b="0">
-                <a:solidFill>
-                  <a:srgbClr val="9DB7FF"/>
-                </a:solidFill>
-                <a:latin typeface="Consolas"/>
-                <a:ea typeface="Consolas"/>
-                <a:cs typeface="Consolas"/>
-              </a:rPr>
-              <a:t>        self.session = session   # MCP session</a:t>
-            </a:r>
-          </a:p>
-          <a:p>
-            <a:pPr algn="l">
-              <a:lnSpc>
-                <a:spcPct val="108000"/>
-              </a:lnSpc>
-              <a:spcAft>
-                <a:spcPts val="0"/>
-              </a:spcAft>
-            </a:pPr>
-            <a:r>
-              <a:rPr sz="1300" b="0">
-                <a:solidFill>
-                  <a:srgbClr val="9DB7FF"/>
-                </a:solidFill>
-                <a:latin typeface="Consolas"/>
-                <a:ea typeface="Consolas"/>
-                <a:cs typeface="Consolas"/>
-              </a:rPr>
-              <a:t>        self.model = model       # Ollama | OpenAI</a:t>
-            </a:r>
-          </a:p>
-          <a:p>
-            <a:pPr algn="l">
-              <a:lnSpc>
-                <a:spcPct val="108000"/>
-              </a:lnSpc>
-              <a:spcAft>
-                <a:spcPts val="0"/>
-              </a:spcAft>
-            </a:pPr>
-            <a:r>
-              <a:rPr sz="1300" b="0">
-                <a:solidFill>
-                  <a:srgbClr val="E6E9F2"/>
-                </a:solidFill>
-                <a:latin typeface="Consolas"/>
-                <a:ea typeface="Consolas"/>
-                <a:cs typeface="Consolas"/>
-              </a:rPr>
-              <a:t> </a:t>
-            </a:r>
-          </a:p>
-          <a:p>
-            <a:pPr algn="l">
-              <a:lnSpc>
-                <a:spcPct val="108000"/>
-              </a:lnSpc>
-              <a:spcAft>
-                <a:spcPts val="0"/>
-              </a:spcAft>
-            </a:pPr>
-            <a:r>
-              <a:rPr sz="1300" b="0">
-                <a:solidFill>
-                  <a:srgbClr val="8FA1C7"/>
-                </a:solidFill>
-                <a:latin typeface="Consolas"/>
-                <a:ea typeface="Consolas"/>
-                <a:cs typeface="Consolas"/>
-              </a:rPr>
-              <a:t># production: real session + build_model()</a:t>
-            </a:r>
-          </a:p>
-          <a:p>
-            <a:pPr algn="l">
-              <a:lnSpc>
-                <a:spcPct val="108000"/>
-              </a:lnSpc>
-              <a:spcAft>
-                <a:spcPts val="0"/>
-              </a:spcAft>
-            </a:pPr>
-            <a:r>
-              <a:rPr sz="1300" b="0">
-                <a:solidFill>
-                  <a:srgbClr val="8FA1C7"/>
-                </a:solidFill>
-                <a:latin typeface="Consolas"/>
-                <a:ea typeface="Consolas"/>
-                <a:cs typeface="Consolas"/>
-              </a:rPr>
-              <a:t># tests: FakeSession + ScriptedModel</a:t>
-            </a:r>
-          </a:p>
-        </p:txBody>
-      </p:sp>
-      <p:sp>
-        <p:nvSpPr>
-          <p:cNvPr id="7" name="TextBox 6"/>
-          <p:cNvSpPr txBox="1"/>
-          <p:nvPr/>
-        </p:nvSpPr>
-        <p:spPr>
-          <a:xfrm>
-            <a:off x="548640" y="4626864"/>
-            <a:ext cx="5760720" cy="274320"/>
-          </a:xfrm>
-          <a:prstGeom prst="rect">
-            <a:avLst/>
-          </a:prstGeom>
-          <a:noFill/>
-        </p:spPr>
-        <p:txBody>
-          <a:bodyPr wrap="square" anchor="t" lIns="0" rIns="0" tIns="0" bIns="0">
-            <a:spAutoFit/>
-          </a:bodyPr>
-          <a:lstStyle/>
-          <a:p>
-            <a:pPr algn="l"/>
-            <a:r>
-              <a:rPr sz="1100" b="0">
-                <a:solidFill>
-                  <a:srgbClr val="5B6577"/>
-                </a:solidFill>
-                <a:latin typeface="Malgun Gothic"/>
-                <a:ea typeface="Malgun Gothic"/>
-                <a:cs typeface="Malgun Gothic"/>
-              </a:rPr>
-              <a:t>backend/app/agent/graph.py (발췌)</a:t>
-            </a:r>
-          </a:p>
-        </p:txBody>
-      </p:sp>
-      <p:sp>
-        <p:nvSpPr>
-          <p:cNvPr id="8" name="TextBox 7"/>
-          <p:cNvSpPr txBox="1"/>
-          <p:nvPr/>
-        </p:nvSpPr>
-        <p:spPr>
-          <a:xfrm>
-            <a:off x="548640" y="5029200"/>
-            <a:ext cx="5760720" cy="1188720"/>
-          </a:xfrm>
-          <a:prstGeom prst="rect">
-            <a:avLst/>
-          </a:prstGeom>
-          <a:noFill/>
-        </p:spPr>
-        <p:txBody>
-          <a:bodyPr wrap="square" anchor="t" lIns="0" rIns="0" tIns="0" bIns="0">
-            <a:spAutoFit/>
-          </a:bodyPr>
-          <a:lstStyle/>
-          <a:p>
-            <a:pPr algn="l">
-              <a:spcAft>
-                <a:spcPts val="300"/>
-              </a:spcAft>
-            </a:pPr>
-            <a:r>
-              <a:rPr sz="1600" b="1">
-                <a:solidFill>
-                  <a:srgbClr val="1B2437"/>
-                </a:solidFill>
-                <a:latin typeface="Malgun Gothic"/>
-                <a:ea typeface="Malgun Gothic"/>
-                <a:cs typeface="Malgun Gothic"/>
-              </a:rPr>
-              <a:t>LLM 교체: WISH_LLM_BACKEND 환경변수 하나</a:t>
-            </a:r>
-          </a:p>
-          <a:p>
-            <a:pPr algn="l"/>
-            <a:r>
-              <a:rPr sz="1400" b="0">
-                <a:solidFill>
-                  <a:srgbClr val="5B6577"/>
-                </a:solidFill>
-                <a:latin typeface="Malgun Gothic"/>
-                <a:ea typeface="Malgun Gothic"/>
-                <a:cs typeface="Malgun Gothic"/>
-              </a:rPr>
-              <a:t>Ollama(개발) ↔ OpenAI(제출), 나머지 코드는 그대로</a:t>
-            </a:r>
-          </a:p>
-        </p:txBody>
-      </p:sp>
-      <p:graphicFrame>
-        <p:nvGraphicFramePr>
-          <p:cNvPr id="9" name="Table 8"/>
-          <p:cNvGraphicFramePr>
-            <a:graphicFrameLocks noGrp="1"/>
-          </p:cNvGraphicFramePr>
-          <p:nvPr/>
-        </p:nvGraphicFramePr>
-        <p:xfrm>
-          <a:off x="6583680" y="1417320"/>
-          <a:ext cx="5120640" cy="3200400"/>
-        </p:xfrm>
-        <a:graphic>
-          <a:graphicData uri="http://schemas.openxmlformats.org/drawingml/2006/table">
-            <a:tbl>
-              <a:tblPr firstRow="1" bandRow="0">
-                <a:tableStyleId>{5C22544A-7EE6-4342-B048-85BDC9FD1C3A}</a:tableStyleId>
-              </a:tblPr>
-              <a:tblGrid>
-                <a:gridCol w="3566160"/>
-                <a:gridCol w="1554480"/>
-              </a:tblGrid>
-              <a:tr h="457200">
-                <a:tc>
-                  <a:txBody>
-                    <a:bodyPr wrap="square"/>
-                    <a:lstStyle/>
-                    <a:p>
-                      <a:pPr algn="l"/>
-                      <a:r>
-                        <a:rPr sz="1500" b="1">
-                          <a:solidFill>
-                            <a:srgbClr val="1B2437"/>
-                          </a:solidFill>
-                          <a:latin typeface="Malgun Gothic"/>
-                          <a:ea typeface="Malgun Gothic"/>
-                          <a:cs typeface="Malgun Gothic"/>
-                        </a:rPr>
-                        <a:t>백엔드 테스트 영역</a:t>
-                      </a:r>
-                    </a:p>
-                  </a:txBody>
-                  <a:tcPr marL="91440" marR="91440" marT="36576" marB="36576" anchor="ctr">
-                    <a:lnB w="9525">
-                      <a:solidFill>
-                        <a:srgbClr val="DDE2EC"/>
-                      </a:solidFill>
-                    </a:lnB>
-                    <a:solidFill>
-                      <a:srgbClr val="F3F5F9"/>
-                    </a:solidFill>
-                  </a:tcPr>
-                </a:tc>
-                <a:tc>
-                  <a:txBody>
-                    <a:bodyPr wrap="square"/>
-                    <a:lstStyle/>
-                    <a:p>
-                      <a:pPr algn="ctr"/>
-                      <a:r>
-                        <a:rPr sz="1500" b="1">
-                          <a:solidFill>
-                            <a:srgbClr val="1B2437"/>
-                          </a:solidFill>
-                          <a:latin typeface="Malgun Gothic"/>
-                          <a:ea typeface="Malgun Gothic"/>
-                          <a:cs typeface="Malgun Gothic"/>
-                        </a:rPr>
-                        <a:t>개수</a:t>
-                      </a:r>
-                    </a:p>
-                  </a:txBody>
-                  <a:tcPr marL="91440" marR="91440" marT="36576" marB="36576" anchor="ctr">
-                    <a:lnB w="9525">
-                      <a:solidFill>
-                        <a:srgbClr val="DDE2EC"/>
-                      </a:solidFill>
-                    </a:lnB>
-                    <a:solidFill>
-                      <a:srgbClr val="F3F5F9"/>
-                    </a:solidFill>
-                  </a:tcPr>
-                </a:tc>
-              </a:tr>
-              <a:tr h="457200">
-                <a:tc>
-                  <a:txBody>
-                    <a:bodyPr wrap="square"/>
-                    <a:lstStyle/>
-                    <a:p>
-                      <a:pPr algn="l"/>
-                      <a:r>
-                        <a:rPr sz="1500" b="0">
-                          <a:solidFill>
-                            <a:srgbClr val="1B2437"/>
-                          </a:solidFill>
-                          <a:latin typeface="Malgun Gothic"/>
-                          <a:ea typeface="Malgun Gothic"/>
-                          <a:cs typeface="Malgun Gothic"/>
-                        </a:rPr>
-                        <a:t>Agent 그래프</a:t>
-                      </a:r>
-                    </a:p>
-                  </a:txBody>
-                  <a:tcPr marL="91440" marR="91440" marT="36576" marB="36576" anchor="ctr">
-                    <a:lnB w="9525">
-                      <a:solidFill>
-                        <a:srgbClr val="DDE2EC"/>
-                      </a:solidFill>
-                    </a:lnB>
-                    <a:solidFill>
-                      <a:srgbClr val="FFFFFF"/>
-                    </a:solidFill>
-                  </a:tcPr>
-                </a:tc>
-                <a:tc>
-                  <a:txBody>
-                    <a:bodyPr wrap="square"/>
-                    <a:lstStyle/>
-                    <a:p>
-                      <a:pPr algn="ctr"/>
-                      <a:r>
-                        <a:rPr sz="1500" b="0">
-                          <a:solidFill>
-                            <a:srgbClr val="1B2437"/>
-                          </a:solidFill>
-                          <a:latin typeface="Malgun Gothic"/>
-                          <a:ea typeface="Malgun Gothic"/>
-                          <a:cs typeface="Malgun Gothic"/>
-                        </a:rPr>
-                        <a:t>55</a:t>
-                      </a:r>
-                    </a:p>
-                  </a:txBody>
-                  <a:tcPr marL="91440" marR="91440" marT="36576" marB="36576" anchor="ctr">
-                    <a:lnB w="9525">
-                      <a:solidFill>
-                        <a:srgbClr val="DDE2EC"/>
-                      </a:solidFill>
-                    </a:lnB>
-                    <a:solidFill>
-                      <a:srgbClr val="FFFFFF"/>
-                    </a:solidFill>
-                  </a:tcPr>
-                </a:tc>
-              </a:tr>
-              <a:tr h="457200">
-                <a:tc>
-                  <a:txBody>
-                    <a:bodyPr wrap="square"/>
-                    <a:lstStyle/>
-                    <a:p>
-                      <a:pPr algn="l"/>
-                      <a:r>
-                        <a:rPr sz="1500" b="0">
-                          <a:solidFill>
-                            <a:srgbClr val="1B2437"/>
-                          </a:solidFill>
-                          <a:latin typeface="Malgun Gothic"/>
-                          <a:ea typeface="Malgun Gothic"/>
-                          <a:cs typeface="Malgun Gothic"/>
-                        </a:rPr>
-                        <a:t>LLM 교체</a:t>
-                      </a:r>
-                    </a:p>
-                  </a:txBody>
-                  <a:tcPr marL="91440" marR="91440" marT="36576" marB="36576" anchor="ctr">
-                    <a:lnB w="9525">
-                      <a:solidFill>
-                        <a:srgbClr val="DDE2EC"/>
-                      </a:solidFill>
-                    </a:lnB>
-                    <a:solidFill>
-                      <a:srgbClr val="FFFFFF"/>
-                    </a:solidFill>
-                  </a:tcPr>
-                </a:tc>
-                <a:tc>
-                  <a:txBody>
-                    <a:bodyPr wrap="square"/>
-                    <a:lstStyle/>
-                    <a:p>
-                      <a:pPr algn="ctr"/>
-                      <a:r>
-                        <a:rPr sz="1500" b="0">
-                          <a:solidFill>
-                            <a:srgbClr val="1B2437"/>
-                          </a:solidFill>
-                          <a:latin typeface="Malgun Gothic"/>
-                          <a:ea typeface="Malgun Gothic"/>
-                          <a:cs typeface="Malgun Gothic"/>
-                        </a:rPr>
-                        <a:t>19</a:t>
-                      </a:r>
-                    </a:p>
-                  </a:txBody>
-                  <a:tcPr marL="91440" marR="91440" marT="36576" marB="36576" anchor="ctr">
-                    <a:lnB w="9525">
-                      <a:solidFill>
-                        <a:srgbClr val="DDE2EC"/>
-                      </a:solidFill>
-                    </a:lnB>
-                    <a:solidFill>
-                      <a:srgbClr val="FFFFFF"/>
-                    </a:solidFill>
-                  </a:tcPr>
-                </a:tc>
-              </a:tr>
-              <a:tr h="457200">
-                <a:tc>
-                  <a:txBody>
-                    <a:bodyPr wrap="square"/>
-                    <a:lstStyle/>
-                    <a:p>
-                      <a:pPr algn="l"/>
-                      <a:r>
-                        <a:rPr sz="1500" b="0">
-                          <a:solidFill>
-                            <a:srgbClr val="1B2437"/>
-                          </a:solidFill>
-                          <a:latin typeface="Malgun Gothic"/>
-                          <a:ea typeface="Malgun Gothic"/>
-                          <a:cs typeface="Malgun Gothic"/>
-                        </a:rPr>
-                        <a:t>자막·검색</a:t>
-                      </a:r>
-                    </a:p>
-                  </a:txBody>
-                  <a:tcPr marL="91440" marR="91440" marT="36576" marB="36576" anchor="ctr">
-                    <a:lnB w="9525">
-                      <a:solidFill>
-                        <a:srgbClr val="DDE2EC"/>
-                      </a:solidFill>
-                    </a:lnB>
-                    <a:solidFill>
-                      <a:srgbClr val="FFFFFF"/>
-                    </a:solidFill>
-                  </a:tcPr>
-                </a:tc>
-                <a:tc>
-                  <a:txBody>
-                    <a:bodyPr wrap="square"/>
-                    <a:lstStyle/>
-                    <a:p>
-                      <a:pPr algn="ctr"/>
-                      <a:r>
-                        <a:rPr sz="1500" b="0">
-                          <a:solidFill>
-                            <a:srgbClr val="1B2437"/>
-                          </a:solidFill>
-                          <a:latin typeface="Malgun Gothic"/>
-                          <a:ea typeface="Malgun Gothic"/>
-                          <a:cs typeface="Malgun Gothic"/>
-                        </a:rPr>
-                        <a:t>37</a:t>
-                      </a:r>
-                    </a:p>
-                  </a:txBody>
-                  <a:tcPr marL="91440" marR="91440" marT="36576" marB="36576" anchor="ctr">
-                    <a:lnB w="9525">
-                      <a:solidFill>
-                        <a:srgbClr val="DDE2EC"/>
-                      </a:solidFill>
-                    </a:lnB>
-                    <a:solidFill>
-                      <a:srgbClr val="FFFFFF"/>
-                    </a:solidFill>
-                  </a:tcPr>
-                </a:tc>
-              </a:tr>
-              <a:tr h="457200">
-                <a:tc>
-                  <a:txBody>
-                    <a:bodyPr wrap="square"/>
-                    <a:lstStyle/>
-                    <a:p>
-                      <a:pPr algn="l"/>
-                      <a:r>
-                        <a:rPr sz="1500" b="0">
-                          <a:solidFill>
-                            <a:srgbClr val="1B2437"/>
-                          </a:solidFill>
-                          <a:latin typeface="Malgun Gothic"/>
-                          <a:ea typeface="Malgun Gothic"/>
-                          <a:cs typeface="Malgun Gothic"/>
-                        </a:rPr>
-                        <a:t>설정·API·실시간 전송</a:t>
-                      </a:r>
-                    </a:p>
-                  </a:txBody>
-                  <a:tcPr marL="91440" marR="91440" marT="36576" marB="36576" anchor="ctr">
-                    <a:lnB w="9525">
-                      <a:solidFill>
-                        <a:srgbClr val="DDE2EC"/>
-                      </a:solidFill>
-                    </a:lnB>
-                    <a:solidFill>
-                      <a:srgbClr val="FFFFFF"/>
-                    </a:solidFill>
-                  </a:tcPr>
-                </a:tc>
-                <a:tc>
-                  <a:txBody>
-                    <a:bodyPr wrap="square"/>
-                    <a:lstStyle/>
-                    <a:p>
-                      <a:pPr algn="ctr"/>
-                      <a:r>
-                        <a:rPr sz="1500" b="0">
-                          <a:solidFill>
-                            <a:srgbClr val="1B2437"/>
-                          </a:solidFill>
-                          <a:latin typeface="Malgun Gothic"/>
-                          <a:ea typeface="Malgun Gothic"/>
-                          <a:cs typeface="Malgun Gothic"/>
-                        </a:rPr>
-                        <a:t>33</a:t>
-                      </a:r>
-                    </a:p>
-                  </a:txBody>
-                  <a:tcPr marL="91440" marR="91440" marT="36576" marB="36576" anchor="ctr">
-                    <a:lnB w="9525">
-                      <a:solidFill>
-                        <a:srgbClr val="DDE2EC"/>
-                      </a:solidFill>
-                    </a:lnB>
-                    <a:solidFill>
-                      <a:srgbClr val="FFFFFF"/>
-                    </a:solidFill>
-                  </a:tcPr>
-                </a:tc>
-              </a:tr>
-              <a:tr h="457200">
-                <a:tc>
-                  <a:txBody>
-                    <a:bodyPr wrap="square"/>
-                    <a:lstStyle/>
-                    <a:p>
-                      <a:pPr algn="l"/>
-                      <a:r>
-                        <a:rPr sz="1500" b="0">
-                          <a:solidFill>
-                            <a:srgbClr val="1B2437"/>
-                          </a:solidFill>
-                          <a:latin typeface="Malgun Gothic"/>
-                          <a:ea typeface="Malgun Gothic"/>
-                          <a:cs typeface="Malgun Gothic"/>
-                        </a:rPr>
-                        <a:t>평가 도구</a:t>
-                      </a:r>
-                    </a:p>
-                  </a:txBody>
-                  <a:tcPr marL="91440" marR="91440" marT="36576" marB="36576" anchor="ctr">
-                    <a:lnB w="9525">
-                      <a:solidFill>
-                        <a:srgbClr val="DDE2EC"/>
-                      </a:solidFill>
-                    </a:lnB>
-                    <a:solidFill>
-                      <a:srgbClr val="FFFFFF"/>
-                    </a:solidFill>
-                  </a:tcPr>
-                </a:tc>
-                <a:tc>
-                  <a:txBody>
-                    <a:bodyPr wrap="square"/>
-                    <a:lstStyle/>
-                    <a:p>
-                      <a:pPr algn="ctr"/>
-                      <a:r>
-                        <a:rPr sz="1500" b="0">
-                          <a:solidFill>
-                            <a:srgbClr val="1B2437"/>
-                          </a:solidFill>
-                          <a:latin typeface="Malgun Gothic"/>
-                          <a:ea typeface="Malgun Gothic"/>
-                          <a:cs typeface="Malgun Gothic"/>
-                        </a:rPr>
-                        <a:t>32</a:t>
-                      </a:r>
-                    </a:p>
-                  </a:txBody>
-                  <a:tcPr marL="91440" marR="91440" marT="36576" marB="36576" anchor="ctr">
-                    <a:lnB w="9525">
-                      <a:solidFill>
-                        <a:srgbClr val="DDE2EC"/>
-                      </a:solidFill>
-                    </a:lnB>
-                    <a:solidFill>
-                      <a:srgbClr val="FFFFFF"/>
-                    </a:solidFill>
-                  </a:tcPr>
-                </a:tc>
-              </a:tr>
-              <a:tr h="457200">
-                <a:tc>
-                  <a:txBody>
-                    <a:bodyPr wrap="square"/>
-                    <a:lstStyle/>
-                    <a:p>
-                      <a:pPr algn="l"/>
-                      <a:r>
-                        <a:rPr sz="1500" b="0">
-                          <a:solidFill>
-                            <a:srgbClr val="1B2437"/>
-                          </a:solidFill>
-                          <a:latin typeface="Malgun Gothic"/>
-                          <a:ea typeface="Malgun Gothic"/>
-                          <a:cs typeface="Malgun Gothic"/>
-                        </a:rPr>
-                        <a:t>실제 MCP 통신</a:t>
-                      </a:r>
-                    </a:p>
-                  </a:txBody>
-                  <a:tcPr marL="91440" marR="91440" marT="36576" marB="36576" anchor="ctr">
-                    <a:lnB w="9525">
-                      <a:solidFill>
-                        <a:srgbClr val="DDE2EC"/>
-                      </a:solidFill>
-                    </a:lnB>
-                    <a:solidFill>
-                      <a:srgbClr val="FFFFFF"/>
-                    </a:solidFill>
-                  </a:tcPr>
-                </a:tc>
-                <a:tc>
-                  <a:txBody>
-                    <a:bodyPr wrap="square"/>
-                    <a:lstStyle/>
-                    <a:p>
-                      <a:pPr algn="ctr"/>
-                      <a:r>
-                        <a:rPr sz="1500" b="0">
-                          <a:solidFill>
-                            <a:srgbClr val="1B2437"/>
-                          </a:solidFill>
-                          <a:latin typeface="Malgun Gothic"/>
-                          <a:ea typeface="Malgun Gothic"/>
-                          <a:cs typeface="Malgun Gothic"/>
-                        </a:rPr>
-                        <a:t>2</a:t>
-                      </a:r>
-                    </a:p>
-                  </a:txBody>
-                  <a:tcPr marL="91440" marR="91440" marT="36576" marB="36576" anchor="ctr">
-                    <a:lnB w="9525">
-                      <a:solidFill>
-                        <a:srgbClr val="DDE2EC"/>
-                      </a:solidFill>
-                    </a:lnB>
-                    <a:solidFill>
-                      <a:srgbClr val="FFFFFF"/>
-                    </a:solidFill>
-                  </a:tcPr>
-                </a:tc>
-              </a:tr>
-            </a:tbl>
-          </a:graphicData>
-        </a:graphic>
-      </p:graphicFrame>
-      <p:sp>
-        <p:nvSpPr>
-          <p:cNvPr id="10" name="TextBox 9"/>
-          <p:cNvSpPr txBox="1"/>
-          <p:nvPr/>
-        </p:nvSpPr>
-        <p:spPr>
-          <a:xfrm>
-            <a:off x="6583680" y="4754880"/>
-            <a:ext cx="5120640" cy="1188720"/>
-          </a:xfrm>
-          <a:prstGeom prst="rect">
-            <a:avLst/>
-          </a:prstGeom>
-          <a:noFill/>
-        </p:spPr>
-        <p:txBody>
-          <a:bodyPr wrap="square" anchor="t" lIns="0" rIns="0" tIns="0" bIns="0">
-            <a:spAutoFit/>
-          </a:bodyPr>
-          <a:lstStyle/>
-          <a:p>
-            <a:pPr algn="l">
-              <a:spcAft>
-                <a:spcPts val="300"/>
-              </a:spcAft>
-            </a:pPr>
-            <a:r>
-              <a:rPr sz="1500" b="1">
-                <a:solidFill>
-                  <a:srgbClr val="1B2437"/>
-                </a:solidFill>
-                <a:latin typeface="Malgun Gothic"/>
-                <a:ea typeface="Malgun Gothic"/>
-                <a:cs typeface="Malgun Gothic"/>
-              </a:rPr>
-              <a:t>백엔드 178개 통과 · 프런트 43개 통과</a:t>
-            </a:r>
-          </a:p>
-          <a:p>
-            <a:pPr algn="l"/>
-            <a:r>
-              <a:rPr sz="1300" b="0">
-                <a:solidFill>
-                  <a:srgbClr val="5B6577"/>
-                </a:solidFill>
-                <a:latin typeface="Malgun Gothic"/>
-                <a:ea typeface="Malgun Gothic"/>
-                <a:cs typeface="Malgun Gothic"/>
-              </a:rPr>
-              <a:t>모델은 가짜로 대신해 과금 없음, 실제 stdio MCP 서버 테스트 포함</a:t>
-            </a:r>
-          </a:p>
-        </p:txBody>
-      </p:sp>
-    </p:spTree>
-  </p:cSld>
-  <p:clrMapOvr>
-    <a:masterClrMapping/>
-  </p:clrMapOvr>
-</p:sld>
-</file>
-
-<file path=ppt/slides/slide11.xml><?xml version="1.0" encoding="utf-8"?>
-<p:sld xmlns:a="http://schemas.openxmlformats.org/drawingml/2006/main" xmlns:p="http://schemas.openxmlformats.org/presentationml/2006/main" xmlns:r="http://schemas.openxmlformats.org/officeDocument/2006/relationships">
-  <p:cSld>
-    <p:bg>
-      <p:bgPr>
-        <a:solidFill>
-          <a:srgbClr val="FFFFFF"/>
-        </a:solidFill>
-        <a:effectLst/>
-      </p:bgPr>
-    </p:bg>
-    <p:spTree>
-      <p:nvGrpSpPr>
-        <p:cNvPr id="1" name=""/>
-        <p:cNvGrpSpPr/>
-        <p:nvPr/>
-      </p:nvGrpSpPr>
-      <p:grpSpPr/>
-      <p:sp>
-        <p:nvSpPr>
-          <p:cNvPr id="2" name="TextBox 1"/>
-          <p:cNvSpPr txBox="1"/>
-          <p:nvPr/>
-        </p:nvSpPr>
-        <p:spPr>
-          <a:xfrm>
-            <a:off x="548640" y="347472"/>
-            <a:ext cx="11064240" cy="868680"/>
-          </a:xfrm>
-          <a:prstGeom prst="rect">
-            <a:avLst/>
-          </a:prstGeom>
-          <a:noFill/>
-        </p:spPr>
-        <p:txBody>
-          <a:bodyPr wrap="square" anchor="ctr" lIns="0" rIns="0" tIns="0" bIns="0">
-            <a:spAutoFit/>
-          </a:bodyPr>
-          <a:lstStyle/>
-          <a:p>
-            <a:pPr algn="l">
-              <a:lnSpc>
-                <a:spcPct val="100000"/>
-              </a:lnSpc>
-            </a:pPr>
-            <a:r>
-              <a:rPr sz="3000" b="1">
-                <a:solidFill>
-                  <a:srgbClr val="1B2437"/>
-                </a:solidFill>
-                <a:latin typeface="Malgun Gothic"/>
-                <a:ea typeface="Malgun Gothic"/>
-                <a:cs typeface="Malgun Gothic"/>
-              </a:rPr>
-              <a:t>[백업] 이중 첫 검색: 번역 어휘 차이를 질문 원문 검색으로 보완</a:t>
-            </a:r>
-          </a:p>
-        </p:txBody>
-      </p:sp>
-      <p:sp>
-        <p:nvSpPr>
-          <p:cNvPr id="3" name="TextBox 2"/>
-          <p:cNvSpPr txBox="1"/>
-          <p:nvPr/>
-        </p:nvSpPr>
-        <p:spPr>
-          <a:xfrm>
-            <a:off x="548640" y="6428232"/>
-            <a:ext cx="5486400" cy="274320"/>
-          </a:xfrm>
-          <a:prstGeom prst="rect">
-            <a:avLst/>
-          </a:prstGeom>
-          <a:noFill/>
-        </p:spPr>
-        <p:txBody>
-          <a:bodyPr wrap="square" anchor="t" lIns="0" rIns="0" tIns="0" bIns="0">
-            <a:spAutoFit/>
-          </a:bodyPr>
-          <a:lstStyle/>
-          <a:p>
-            <a:pPr algn="l"/>
-            <a:r>
-              <a:rPr sz="1100" b="0">
-                <a:solidFill>
-                  <a:srgbClr val="8A93A8"/>
-                </a:solidFill>
-                <a:latin typeface="Malgun Gothic"/>
-                <a:ea typeface="Malgun Gothic"/>
-                <a:cs typeface="Malgun Gothic"/>
-              </a:rPr>
-              <a:t>광주 3반 G078 문희주  ·  WISH FINDER</a:t>
-            </a:r>
-          </a:p>
-        </p:txBody>
-      </p:sp>
-      <p:sp>
-        <p:nvSpPr>
-          <p:cNvPr id="4" name="TextBox 3"/>
-          <p:cNvSpPr txBox="1"/>
-          <p:nvPr/>
-        </p:nvSpPr>
-        <p:spPr>
-          <a:xfrm>
-            <a:off x="10881360" y="6428232"/>
-            <a:ext cx="777240" cy="274320"/>
-          </a:xfrm>
-          <a:prstGeom prst="rect">
-            <a:avLst/>
-          </a:prstGeom>
-          <a:noFill/>
-        </p:spPr>
-        <p:txBody>
-          <a:bodyPr wrap="square" anchor="t" lIns="0" rIns="0" tIns="0" bIns="0">
-            <a:spAutoFit/>
-          </a:bodyPr>
-          <a:lstStyle/>
-          <a:p>
-            <a:pPr algn="r"/>
-            <a:r>
-              <a:rPr sz="1100" b="0">
-                <a:solidFill>
-                  <a:srgbClr val="8A93A8"/>
-                </a:solidFill>
-                <a:latin typeface="Malgun Gothic"/>
-                <a:ea typeface="Malgun Gothic"/>
-                <a:cs typeface="Malgun Gothic"/>
-              </a:rPr>
-              <a:t>11</a:t>
             </a:r>
           </a:p>
         </p:txBody>
@@ -5398,7 +4328,7 @@
 </p:sld>
 </file>
 
-<file path=ppt/slides/slide12.xml><?xml version="1.0" encoding="utf-8"?>
+<file path=ppt/slides/slide11.xml><?xml version="1.0" encoding="utf-8"?>
 <p:sld xmlns:a="http://schemas.openxmlformats.org/drawingml/2006/main" xmlns:p="http://schemas.openxmlformats.org/presentationml/2006/main" xmlns:r="http://schemas.openxmlformats.org/officeDocument/2006/relationships">
   <p:cSld>
     <p:bg>
@@ -5526,7 +4456,7 @@
                 <a:ea typeface="Malgun Gothic"/>
                 <a:cs typeface="Malgun Gothic"/>
               </a:rPr>
-              <a:t>12</a:t>
+              <a:t>11</a:t>
             </a:r>
           </a:p>
         </p:txBody>
@@ -13228,7 +12158,7 @@
                 <a:ea typeface="Malgun Gothic"/>
                 <a:cs typeface="Malgun Gothic"/>
               </a:rPr>
-              <a:t>[백업] 한계와 트레이드오프</a:t>
+              <a:t>[백업] LangSmith로 노드별 시간·LLM 호출·토큰을 추적했다</a:t>
             </a:r>
           </a:p>
         </p:txBody>
@@ -13303,818 +12233,6 @@
                 <a:cs typeface="Malgun Gothic"/>
               </a:rPr>
               <a:t>8</a:t>
-            </a:r>
-          </a:p>
-        </p:txBody>
-      </p:sp>
-      <p:graphicFrame>
-        <p:nvGraphicFramePr>
-          <p:cNvPr id="5" name="Table 4"/>
-          <p:cNvGraphicFramePr>
-            <a:graphicFrameLocks noGrp="1"/>
-          </p:cNvGraphicFramePr>
-          <p:nvPr/>
-        </p:nvGraphicFramePr>
-        <p:xfrm>
-          <a:off x="548640" y="1371600"/>
-          <a:ext cx="11109960" cy="4736592"/>
-        </p:xfrm>
-        <a:graphic>
-          <a:graphicData uri="http://schemas.openxmlformats.org/drawingml/2006/table">
-            <a:tbl>
-              <a:tblPr firstRow="1" bandRow="0">
-                <a:tableStyleId>{5C22544A-7EE6-4342-B048-85BDC9FD1C3A}</a:tableStyleId>
-              </a:tblPr>
-              <a:tblGrid>
-                <a:gridCol w="1371600"/>
-                <a:gridCol w="7589520"/>
-                <a:gridCol w="2148840"/>
-              </a:tblGrid>
-              <a:tr h="676656">
-                <a:tc>
-                  <a:txBody>
-                    <a:bodyPr wrap="square"/>
-                    <a:lstStyle/>
-                    <a:p>
-                      <a:pPr algn="l"/>
-                      <a:r>
-                        <a:rPr sz="1400" b="1">
-                          <a:solidFill>
-                            <a:srgbClr val="1B2437"/>
-                          </a:solidFill>
-                          <a:latin typeface="Malgun Gothic"/>
-                          <a:ea typeface="Malgun Gothic"/>
-                          <a:cs typeface="Malgun Gothic"/>
-                        </a:rPr>
-                        <a:t>구분</a:t>
-                      </a:r>
-                    </a:p>
-                  </a:txBody>
-                  <a:tcPr marL="91440" marR="91440" marT="36576" marB="36576" anchor="ctr">
-                    <a:lnB w="9525">
-                      <a:solidFill>
-                        <a:srgbClr val="DDE2EC"/>
-                      </a:solidFill>
-                    </a:lnB>
-                    <a:solidFill>
-                      <a:srgbClr val="F3F5F9"/>
-                    </a:solidFill>
-                  </a:tcPr>
-                </a:tc>
-                <a:tc>
-                  <a:txBody>
-                    <a:bodyPr wrap="square"/>
-                    <a:lstStyle/>
-                    <a:p>
-                      <a:pPr algn="l"/>
-                      <a:r>
-                        <a:rPr sz="1400" b="1">
-                          <a:solidFill>
-                            <a:srgbClr val="1B2437"/>
-                          </a:solidFill>
-                          <a:latin typeface="Malgun Gothic"/>
-                          <a:ea typeface="Malgun Gothic"/>
-                          <a:cs typeface="Malgun Gothic"/>
-                        </a:rPr>
-                        <a:t>한계</a:t>
-                      </a:r>
-                    </a:p>
-                  </a:txBody>
-                  <a:tcPr marL="91440" marR="91440" marT="36576" marB="36576" anchor="ctr">
-                    <a:lnB w="9525">
-                      <a:solidFill>
-                        <a:srgbClr val="DDE2EC"/>
-                      </a:solidFill>
-                    </a:lnB>
-                    <a:solidFill>
-                      <a:srgbClr val="F3F5F9"/>
-                    </a:solidFill>
-                  </a:tcPr>
-                </a:tc>
-                <a:tc>
-                  <a:txBody>
-                    <a:bodyPr wrap="square"/>
-                    <a:lstStyle/>
-                    <a:p>
-                      <a:pPr algn="l"/>
-                      <a:r>
-                        <a:rPr sz="1400" b="1">
-                          <a:solidFill>
-                            <a:srgbClr val="1B2437"/>
-                          </a:solidFill>
-                          <a:latin typeface="Malgun Gothic"/>
-                          <a:ea typeface="Malgun Gothic"/>
-                          <a:cs typeface="Malgun Gothic"/>
-                        </a:rPr>
-                        <a:t>근거</a:t>
-                      </a:r>
-                    </a:p>
-                  </a:txBody>
-                  <a:tcPr marL="91440" marR="91440" marT="36576" marB="36576" anchor="ctr">
-                    <a:lnB w="9525">
-                      <a:solidFill>
-                        <a:srgbClr val="DDE2EC"/>
-                      </a:solidFill>
-                    </a:lnB>
-                    <a:solidFill>
-                      <a:srgbClr val="F3F5F9"/>
-                    </a:solidFill>
-                  </a:tcPr>
-                </a:tc>
-              </a:tr>
-              <a:tr h="676656">
-                <a:tc>
-                  <a:txBody>
-                    <a:bodyPr wrap="square"/>
-                    <a:lstStyle/>
-                    <a:p>
-                      <a:pPr algn="l"/>
-                      <a:r>
-                        <a:rPr sz="1400" b="1">
-                          <a:solidFill>
-                            <a:srgbClr val="1B2437"/>
-                          </a:solidFill>
-                          <a:latin typeface="Malgun Gothic"/>
-                          <a:ea typeface="Malgun Gothic"/>
-                          <a:cs typeface="Malgun Gothic"/>
-                        </a:rPr>
-                        <a:t>측정</a:t>
-                      </a:r>
-                    </a:p>
-                  </a:txBody>
-                  <a:tcPr marL="91440" marR="91440" marT="36576" marB="36576" anchor="ctr">
-                    <a:lnB w="9525">
-                      <a:solidFill>
-                        <a:srgbClr val="DDE2EC"/>
-                      </a:solidFill>
-                    </a:lnB>
-                    <a:solidFill>
-                      <a:srgbClr val="FFFFFF"/>
-                    </a:solidFill>
-                  </a:tcPr>
-                </a:tc>
-                <a:tc>
-                  <a:txBody>
-                    <a:bodyPr wrap="square"/>
-                    <a:lstStyle/>
-                    <a:p>
-                      <a:pPr algn="l"/>
-                      <a:r>
-                        <a:rPr sz="1400" b="0">
-                          <a:solidFill>
-                            <a:srgbClr val="1B2437"/>
-                          </a:solidFill>
-                          <a:latin typeface="Malgun Gothic"/>
-                          <a:ea typeface="Malgun Gothic"/>
-                          <a:cs typeface="Malgun Gothic"/>
-                        </a:rPr>
-                        <a:t>18문항·질문당 1회, Router 검색어가 실행마다 달라져 1~2문항 차이는 노이즈일 수 있다</a:t>
-                      </a:r>
-                    </a:p>
-                  </a:txBody>
-                  <a:tcPr marL="91440" marR="91440" marT="36576" marB="36576" anchor="ctr">
-                    <a:lnB w="9525">
-                      <a:solidFill>
-                        <a:srgbClr val="DDE2EC"/>
-                      </a:solidFill>
-                    </a:lnB>
-                    <a:solidFill>
-                      <a:srgbClr val="FFFFFF"/>
-                    </a:solidFill>
-                  </a:tcPr>
-                </a:tc>
-                <a:tc>
-                  <a:txBody>
-                    <a:bodyPr wrap="square"/>
-                    <a:lstStyle/>
-                    <a:p>
-                      <a:pPr algn="l"/>
-                      <a:r>
-                        <a:rPr sz="1400" b="0">
-                          <a:solidFill>
-                            <a:srgbClr val="1B2437"/>
-                          </a:solidFill>
-                          <a:latin typeface="Malgun Gothic"/>
-                          <a:ea typeface="Malgun Gothic"/>
-                          <a:cs typeface="Malgun Gothic"/>
-                        </a:rPr>
-                        <a:t>보고서 3.4·4.3절</a:t>
-                      </a:r>
-                    </a:p>
-                  </a:txBody>
-                  <a:tcPr marL="91440" marR="91440" marT="36576" marB="36576" anchor="ctr">
-                    <a:lnB w="9525">
-                      <a:solidFill>
-                        <a:srgbClr val="DDE2EC"/>
-                      </a:solidFill>
-                    </a:lnB>
-                    <a:solidFill>
-                      <a:srgbClr val="FFFFFF"/>
-                    </a:solidFill>
-                  </a:tcPr>
-                </a:tc>
-              </a:tr>
-              <a:tr h="676656">
-                <a:tc>
-                  <a:txBody>
-                    <a:bodyPr wrap="square"/>
-                    <a:lstStyle/>
-                    <a:p>
-                      <a:pPr algn="l"/>
-                      <a:r>
-                        <a:rPr sz="1400" b="1">
-                          <a:solidFill>
-                            <a:srgbClr val="1B2437"/>
-                          </a:solidFill>
-                          <a:latin typeface="Malgun Gothic"/>
-                          <a:ea typeface="Malgun Gothic"/>
-                          <a:cs typeface="Malgun Gothic"/>
-                        </a:rPr>
-                        <a:t>측정</a:t>
-                      </a:r>
-                    </a:p>
-                  </a:txBody>
-                  <a:tcPr marL="91440" marR="91440" marT="36576" marB="36576" anchor="ctr">
-                    <a:lnB w="9525">
-                      <a:solidFill>
-                        <a:srgbClr val="DDE2EC"/>
-                      </a:solidFill>
-                    </a:lnB>
-                    <a:solidFill>
-                      <a:srgbClr val="FFFFFF"/>
-                    </a:solidFill>
-                  </a:tcPr>
-                </a:tc>
-                <a:tc>
-                  <a:txBody>
-                    <a:bodyPr wrap="square"/>
-                    <a:lstStyle/>
-                    <a:p>
-                      <a:pPr algn="l"/>
-                      <a:r>
-                        <a:rPr sz="1400" b="0">
-                          <a:solidFill>
-                            <a:srgbClr val="1B2437"/>
-                          </a:solidFill>
-                          <a:latin typeface="Malgun Gothic"/>
-                          <a:ea typeface="Malgun Gothic"/>
-                          <a:cs typeface="Malgun Gothic"/>
-                        </a:rPr>
-                        <a:t>정답 라벨은 어시스턴트가 원본 cue를 검토해 제안하고 사용자가 승인. 영상 대조는 9곳 표본</a:t>
-                      </a:r>
-                    </a:p>
-                  </a:txBody>
-                  <a:tcPr marL="91440" marR="91440" marT="36576" marB="36576" anchor="ctr">
-                    <a:lnB w="9525">
-                      <a:solidFill>
-                        <a:srgbClr val="DDE2EC"/>
-                      </a:solidFill>
-                    </a:lnB>
-                    <a:solidFill>
-                      <a:srgbClr val="FFFFFF"/>
-                    </a:solidFill>
-                  </a:tcPr>
-                </a:tc>
-                <a:tc>
-                  <a:txBody>
-                    <a:bodyPr wrap="square"/>
-                    <a:lstStyle/>
-                    <a:p>
-                      <a:pPr algn="l"/>
-                      <a:r>
-                        <a:rPr sz="1400" b="0">
-                          <a:solidFill>
-                            <a:srgbClr val="1B2437"/>
-                          </a:solidFill>
-                          <a:latin typeface="Malgun Gothic"/>
-                          <a:ea typeface="Malgun Gothic"/>
-                          <a:cs typeface="Malgun Gothic"/>
-                        </a:rPr>
-                        <a:t>보고서 4.3절</a:t>
-                      </a:r>
-                    </a:p>
-                  </a:txBody>
-                  <a:tcPr marL="91440" marR="91440" marT="36576" marB="36576" anchor="ctr">
-                    <a:lnB w="9525">
-                      <a:solidFill>
-                        <a:srgbClr val="DDE2EC"/>
-                      </a:solidFill>
-                    </a:lnB>
-                    <a:solidFill>
-                      <a:srgbClr val="FFFFFF"/>
-                    </a:solidFill>
-                  </a:tcPr>
-                </a:tc>
-              </a:tr>
-              <a:tr h="676656">
-                <a:tc>
-                  <a:txBody>
-                    <a:bodyPr wrap="square"/>
-                    <a:lstStyle/>
-                    <a:p>
-                      <a:pPr algn="l"/>
-                      <a:r>
-                        <a:rPr sz="1400" b="1">
-                          <a:solidFill>
-                            <a:srgbClr val="1B2437"/>
-                          </a:solidFill>
-                          <a:latin typeface="Malgun Gothic"/>
-                          <a:ea typeface="Malgun Gothic"/>
-                          <a:cs typeface="Malgun Gothic"/>
-                        </a:rPr>
-                        <a:t>성능</a:t>
-                      </a:r>
-                    </a:p>
-                  </a:txBody>
-                  <a:tcPr marL="91440" marR="91440" marT="36576" marB="36576" anchor="ctr">
-                    <a:lnB w="9525">
-                      <a:solidFill>
-                        <a:srgbClr val="DDE2EC"/>
-                      </a:solidFill>
-                    </a:lnB>
-                    <a:solidFill>
-                      <a:srgbClr val="FFFFFF"/>
-                    </a:solidFill>
-                  </a:tcPr>
-                </a:tc>
-                <a:tc>
-                  <a:txBody>
-                    <a:bodyPr wrap="square"/>
-                    <a:lstStyle/>
-                    <a:p>
-                      <a:pPr algn="l"/>
-                      <a:r>
-                        <a:rPr sz="1400" b="0">
-                          <a:solidFill>
-                            <a:srgbClr val="1B2437"/>
-                          </a:solidFill>
-                          <a:latin typeface="Malgun Gothic"/>
-                          <a:ea typeface="Malgun Gothic"/>
-                          <a:cs typeface="Malgun Gothic"/>
-                        </a:rPr>
-                        <a:t>"찾음" 응답 17건 중 1건이 틀린 장면(16/17). 원본 대조는 의도 일치를 보장하지 않는다</a:t>
-                      </a:r>
-                    </a:p>
-                  </a:txBody>
-                  <a:tcPr marL="91440" marR="91440" marT="36576" marB="36576" anchor="ctr">
-                    <a:lnB w="9525">
-                      <a:solidFill>
-                        <a:srgbClr val="DDE2EC"/>
-                      </a:solidFill>
-                    </a:lnB>
-                    <a:solidFill>
-                      <a:srgbClr val="FFFFFF"/>
-                    </a:solidFill>
-                  </a:tcPr>
-                </a:tc>
-                <a:tc>
-                  <a:txBody>
-                    <a:bodyPr wrap="square"/>
-                    <a:lstStyle/>
-                    <a:p>
-                      <a:pPr algn="l"/>
-                      <a:r>
-                        <a:rPr sz="1400" b="0">
-                          <a:solidFill>
-                            <a:srgbClr val="1B2437"/>
-                          </a:solidFill>
-                          <a:latin typeface="Malgun Gothic"/>
-                          <a:ea typeface="Malgun Gothic"/>
-                          <a:cs typeface="Malgun Gothic"/>
-                        </a:rPr>
-                        <a:t>보고서 3.2·4.2절</a:t>
-                      </a:r>
-                    </a:p>
-                  </a:txBody>
-                  <a:tcPr marL="91440" marR="91440" marT="36576" marB="36576" anchor="ctr">
-                    <a:lnB w="9525">
-                      <a:solidFill>
-                        <a:srgbClr val="DDE2EC"/>
-                      </a:solidFill>
-                    </a:lnB>
-                    <a:solidFill>
-                      <a:srgbClr val="FFFFFF"/>
-                    </a:solidFill>
-                  </a:tcPr>
-                </a:tc>
-              </a:tr>
-              <a:tr h="676656">
-                <a:tc>
-                  <a:txBody>
-                    <a:bodyPr wrap="square"/>
-                    <a:lstStyle/>
-                    <a:p>
-                      <a:pPr algn="l"/>
-                      <a:r>
-                        <a:rPr sz="1400" b="1">
-                          <a:solidFill>
-                            <a:srgbClr val="1B2437"/>
-                          </a:solidFill>
-                          <a:latin typeface="Malgun Gothic"/>
-                          <a:ea typeface="Malgun Gothic"/>
-                          <a:cs typeface="Malgun Gothic"/>
-                        </a:rPr>
-                        <a:t>성능</a:t>
-                      </a:r>
-                    </a:p>
-                  </a:txBody>
-                  <a:tcPr marL="91440" marR="91440" marT="36576" marB="36576" anchor="ctr">
-                    <a:lnB w="9525">
-                      <a:solidFill>
-                        <a:srgbClr val="DDE2EC"/>
-                      </a:solidFill>
-                    </a:lnB>
-                    <a:solidFill>
-                      <a:srgbClr val="FFFFFF"/>
-                    </a:solidFill>
-                  </a:tcPr>
-                </a:tc>
-                <a:tc>
-                  <a:txBody>
-                    <a:bodyPr wrap="square"/>
-                    <a:lstStyle/>
-                    <a:p>
-                      <a:pPr algn="l"/>
-                      <a:r>
-                        <a:rPr sz="1400" b="0">
-                          <a:solidFill>
-                            <a:srgbClr val="1B2437"/>
-                          </a:solidFill>
-                          <a:latin typeface="Malgun Gothic"/>
-                          <a:ea typeface="Malgun Gothic"/>
-                          <a:cs typeface="Malgun Gothic"/>
-                        </a:rPr>
-                        <a:t>정답 청크가 후보 3개 밖(10위·18위)인 2문항은 판정 이전 단계의 한계. 번역 어휘·후속 질문도 약점</a:t>
-                      </a:r>
-                    </a:p>
-                  </a:txBody>
-                  <a:tcPr marL="91440" marR="91440" marT="36576" marB="36576" anchor="ctr">
-                    <a:lnB w="9525">
-                      <a:solidFill>
-                        <a:srgbClr val="DDE2EC"/>
-                      </a:solidFill>
-                    </a:lnB>
-                    <a:solidFill>
-                      <a:srgbClr val="FFFFFF"/>
-                    </a:solidFill>
-                  </a:tcPr>
-                </a:tc>
-                <a:tc>
-                  <a:txBody>
-                    <a:bodyPr wrap="square"/>
-                    <a:lstStyle/>
-                    <a:p>
-                      <a:pPr algn="l"/>
-                      <a:r>
-                        <a:rPr sz="1400" b="0">
-                          <a:solidFill>
-                            <a:srgbClr val="1B2437"/>
-                          </a:solidFill>
-                          <a:latin typeface="Malgun Gothic"/>
-                          <a:ea typeface="Malgun Gothic"/>
-                          <a:cs typeface="Malgun Gothic"/>
-                        </a:rPr>
-                        <a:t>보고서 4.2절</a:t>
-                      </a:r>
-                    </a:p>
-                  </a:txBody>
-                  <a:tcPr marL="91440" marR="91440" marT="36576" marB="36576" anchor="ctr">
-                    <a:lnB w="9525">
-                      <a:solidFill>
-                        <a:srgbClr val="DDE2EC"/>
-                      </a:solidFill>
-                    </a:lnB>
-                    <a:solidFill>
-                      <a:srgbClr val="FFFFFF"/>
-                    </a:solidFill>
-                  </a:tcPr>
-                </a:tc>
-              </a:tr>
-              <a:tr h="676656">
-                <a:tc>
-                  <a:txBody>
-                    <a:bodyPr wrap="square"/>
-                    <a:lstStyle/>
-                    <a:p>
-                      <a:pPr algn="l"/>
-                      <a:r>
-                        <a:rPr sz="1400" b="1">
-                          <a:solidFill>
-                            <a:srgbClr val="1B2437"/>
-                          </a:solidFill>
-                          <a:latin typeface="Malgun Gothic"/>
-                          <a:ea typeface="Malgun Gothic"/>
-                          <a:cs typeface="Malgun Gothic"/>
-                        </a:rPr>
-                        <a:t>비용</a:t>
-                      </a:r>
-                    </a:p>
-                  </a:txBody>
-                  <a:tcPr marL="91440" marR="91440" marT="36576" marB="36576" anchor="ctr">
-                    <a:lnB w="9525">
-                      <a:solidFill>
-                        <a:srgbClr val="DDE2EC"/>
-                      </a:solidFill>
-                    </a:lnB>
-                    <a:solidFill>
-                      <a:srgbClr val="FFFFFF"/>
-                    </a:solidFill>
-                  </a:tcPr>
-                </a:tc>
-                <a:tc>
-                  <a:txBody>
-                    <a:bodyPr wrap="square"/>
-                    <a:lstStyle/>
-                    <a:p>
-                      <a:pPr algn="l"/>
-                      <a:r>
-                        <a:rPr sz="1400" b="0">
-                          <a:solidFill>
-                            <a:srgbClr val="1B2437"/>
-                          </a:solidFill>
-                          <a:latin typeface="Malgun Gothic"/>
-                          <a:ea typeface="Malgun Gothic"/>
-                          <a:cs typeface="Malgun Gothic"/>
-                        </a:rPr>
-                        <a:t>입력 토큰 +24%, 평균 지연 2.6초(Hybrid 0.2초대), 이중 첫 검색은 검색 +1회</a:t>
-                      </a:r>
-                    </a:p>
-                  </a:txBody>
-                  <a:tcPr marL="91440" marR="91440" marT="36576" marB="36576" anchor="ctr">
-                    <a:lnB w="9525">
-                      <a:solidFill>
-                        <a:srgbClr val="DDE2EC"/>
-                      </a:solidFill>
-                    </a:lnB>
-                    <a:solidFill>
-                      <a:srgbClr val="FFFFFF"/>
-                    </a:solidFill>
-                  </a:tcPr>
-                </a:tc>
-                <a:tc>
-                  <a:txBody>
-                    <a:bodyPr wrap="square"/>
-                    <a:lstStyle/>
-                    <a:p>
-                      <a:pPr algn="l"/>
-                      <a:r>
-                        <a:rPr sz="1400" b="0">
-                          <a:solidFill>
-                            <a:srgbClr val="1B2437"/>
-                          </a:solidFill>
-                          <a:latin typeface="Malgun Gothic"/>
-                          <a:ea typeface="Malgun Gothic"/>
-                          <a:cs typeface="Malgun Gothic"/>
-                        </a:rPr>
-                        <a:t>보고서 3.2·3.3절</a:t>
-                      </a:r>
-                    </a:p>
-                  </a:txBody>
-                  <a:tcPr marL="91440" marR="91440" marT="36576" marB="36576" anchor="ctr">
-                    <a:lnB w="9525">
-                      <a:solidFill>
-                        <a:srgbClr val="DDE2EC"/>
-                      </a:solidFill>
-                    </a:lnB>
-                    <a:solidFill>
-                      <a:srgbClr val="FFFFFF"/>
-                    </a:solidFill>
-                  </a:tcPr>
-                </a:tc>
-              </a:tr>
-              <a:tr h="676656">
-                <a:tc>
-                  <a:txBody>
-                    <a:bodyPr wrap="square"/>
-                    <a:lstStyle/>
-                    <a:p>
-                      <a:pPr algn="l"/>
-                      <a:r>
-                        <a:rPr sz="1400" b="1">
-                          <a:solidFill>
-                            <a:srgbClr val="1B2437"/>
-                          </a:solidFill>
-                          <a:latin typeface="Malgun Gothic"/>
-                          <a:ea typeface="Malgun Gothic"/>
-                          <a:cs typeface="Malgun Gothic"/>
-                        </a:rPr>
-                        <a:t>범위</a:t>
-                      </a:r>
-                    </a:p>
-                  </a:txBody>
-                  <a:tcPr marL="91440" marR="91440" marT="36576" marB="36576" anchor="ctr">
-                    <a:lnB w="9525">
-                      <a:solidFill>
-                        <a:srgbClr val="DDE2EC"/>
-                      </a:solidFill>
-                    </a:lnB>
-                    <a:solidFill>
-                      <a:srgbClr val="FFFFFF"/>
-                    </a:solidFill>
-                  </a:tcPr>
-                </a:tc>
-                <a:tc>
-                  <a:txBody>
-                    <a:bodyPr wrap="square"/>
-                    <a:lstStyle/>
-                    <a:p>
-                      <a:pPr algn="l"/>
-                      <a:r>
-                        <a:rPr sz="1400" b="0">
-                          <a:solidFill>
-                            <a:srgbClr val="1B2437"/>
-                          </a:solidFill>
-                          <a:latin typeface="Malgun Gothic"/>
-                          <a:ea typeface="Malgun Gothic"/>
-                          <a:cs typeface="Malgun Gothic"/>
-                        </a:rPr>
-                        <a:t>Multi-Agent 미구현·미비교, 영어 번역 자막, 화자 단정 불가</a:t>
-                      </a:r>
-                    </a:p>
-                  </a:txBody>
-                  <a:tcPr marL="91440" marR="91440" marT="36576" marB="36576" anchor="ctr">
-                    <a:lnB w="9525">
-                      <a:solidFill>
-                        <a:srgbClr val="DDE2EC"/>
-                      </a:solidFill>
-                    </a:lnB>
-                    <a:solidFill>
-                      <a:srgbClr val="FFFFFF"/>
-                    </a:solidFill>
-                  </a:tcPr>
-                </a:tc>
-                <a:tc>
-                  <a:txBody>
-                    <a:bodyPr wrap="square"/>
-                    <a:lstStyle/>
-                    <a:p>
-                      <a:pPr algn="l"/>
-                      <a:r>
-                        <a:rPr sz="1400" b="0">
-                          <a:solidFill>
-                            <a:srgbClr val="1B2437"/>
-                          </a:solidFill>
-                          <a:latin typeface="Malgun Gothic"/>
-                          <a:ea typeface="Malgun Gothic"/>
-                          <a:cs typeface="Malgun Gothic"/>
-                        </a:rPr>
-                        <a:t>보고서 4.1·4.3절</a:t>
-                      </a:r>
-                    </a:p>
-                  </a:txBody>
-                  <a:tcPr marL="91440" marR="91440" marT="36576" marB="36576" anchor="ctr">
-                    <a:lnB w="9525">
-                      <a:solidFill>
-                        <a:srgbClr val="DDE2EC"/>
-                      </a:solidFill>
-                    </a:lnB>
-                    <a:solidFill>
-                      <a:srgbClr val="FFFFFF"/>
-                    </a:solidFill>
-                  </a:tcPr>
-                </a:tc>
-              </a:tr>
-            </a:tbl>
-          </a:graphicData>
-        </a:graphic>
-      </p:graphicFrame>
-    </p:spTree>
-  </p:cSld>
-  <p:clrMapOvr>
-    <a:masterClrMapping/>
-  </p:clrMapOvr>
-</p:sld>
-</file>
-
-<file path=ppt/slides/slide9.xml><?xml version="1.0" encoding="utf-8"?>
-<p:sld xmlns:a="http://schemas.openxmlformats.org/drawingml/2006/main" xmlns:p="http://schemas.openxmlformats.org/presentationml/2006/main" xmlns:r="http://schemas.openxmlformats.org/officeDocument/2006/relationships">
-  <p:cSld>
-    <p:bg>
-      <p:bgPr>
-        <a:solidFill>
-          <a:srgbClr val="FFFFFF"/>
-        </a:solidFill>
-        <a:effectLst/>
-      </p:bgPr>
-    </p:bg>
-    <p:spTree>
-      <p:nvGrpSpPr>
-        <p:cNvPr id="1" name=""/>
-        <p:cNvGrpSpPr/>
-        <p:nvPr/>
-      </p:nvGrpSpPr>
-      <p:grpSpPr/>
-      <p:sp>
-        <p:nvSpPr>
-          <p:cNvPr id="2" name="TextBox 1"/>
-          <p:cNvSpPr txBox="1"/>
-          <p:nvPr/>
-        </p:nvSpPr>
-        <p:spPr>
-          <a:xfrm>
-            <a:off x="548640" y="347472"/>
-            <a:ext cx="11064240" cy="868680"/>
-          </a:xfrm>
-          <a:prstGeom prst="rect">
-            <a:avLst/>
-          </a:prstGeom>
-          <a:noFill/>
-        </p:spPr>
-        <p:txBody>
-          <a:bodyPr wrap="square" anchor="ctr" lIns="0" rIns="0" tIns="0" bIns="0">
-            <a:spAutoFit/>
-          </a:bodyPr>
-          <a:lstStyle/>
-          <a:p>
-            <a:pPr algn="l">
-              <a:lnSpc>
-                <a:spcPct val="100000"/>
-              </a:lnSpc>
-            </a:pPr>
-            <a:r>
-              <a:rPr sz="3000" b="1">
-                <a:solidFill>
-                  <a:srgbClr val="1B2437"/>
-                </a:solidFill>
-                <a:latin typeface="Malgun Gothic"/>
-                <a:ea typeface="Malgun Gothic"/>
-                <a:cs typeface="Malgun Gothic"/>
-              </a:rPr>
-              <a:t>[백업] LangSmith로 노드별 시간·LLM 호출·토큰을 추적했다</a:t>
-            </a:r>
-          </a:p>
-        </p:txBody>
-      </p:sp>
-      <p:sp>
-        <p:nvSpPr>
-          <p:cNvPr id="3" name="TextBox 2"/>
-          <p:cNvSpPr txBox="1"/>
-          <p:nvPr/>
-        </p:nvSpPr>
-        <p:spPr>
-          <a:xfrm>
-            <a:off x="548640" y="6428232"/>
-            <a:ext cx="5486400" cy="274320"/>
-          </a:xfrm>
-          <a:prstGeom prst="rect">
-            <a:avLst/>
-          </a:prstGeom>
-          <a:noFill/>
-        </p:spPr>
-        <p:txBody>
-          <a:bodyPr wrap="square" anchor="t" lIns="0" rIns="0" tIns="0" bIns="0">
-            <a:spAutoFit/>
-          </a:bodyPr>
-          <a:lstStyle/>
-          <a:p>
-            <a:pPr algn="l"/>
-            <a:r>
-              <a:rPr sz="1100" b="0">
-                <a:solidFill>
-                  <a:srgbClr val="8A93A8"/>
-                </a:solidFill>
-                <a:latin typeface="Malgun Gothic"/>
-                <a:ea typeface="Malgun Gothic"/>
-                <a:cs typeface="Malgun Gothic"/>
-              </a:rPr>
-              <a:t>광주 3반 G078 문희주  ·  WISH FINDER</a:t>
-            </a:r>
-          </a:p>
-        </p:txBody>
-      </p:sp>
-      <p:sp>
-        <p:nvSpPr>
-          <p:cNvPr id="4" name="TextBox 3"/>
-          <p:cNvSpPr txBox="1"/>
-          <p:nvPr/>
-        </p:nvSpPr>
-        <p:spPr>
-          <a:xfrm>
-            <a:off x="10881360" y="6428232"/>
-            <a:ext cx="777240" cy="274320"/>
-          </a:xfrm>
-          <a:prstGeom prst="rect">
-            <a:avLst/>
-          </a:prstGeom>
-          <a:noFill/>
-        </p:spPr>
-        <p:txBody>
-          <a:bodyPr wrap="square" anchor="t" lIns="0" rIns="0" tIns="0" bIns="0">
-            <a:spAutoFit/>
-          </a:bodyPr>
-          <a:lstStyle/>
-          <a:p>
-            <a:pPr algn="r"/>
-            <a:r>
-              <a:rPr sz="1100" b="0">
-                <a:solidFill>
-                  <a:srgbClr val="8A93A8"/>
-                </a:solidFill>
-                <a:latin typeface="Malgun Gothic"/>
-                <a:ea typeface="Malgun Gothic"/>
-                <a:cs typeface="Malgun Gothic"/>
-              </a:rPr>
-              <a:t>9</a:t>
             </a:r>
           </a:p>
         </p:txBody>
@@ -14312,6 +12430,1075 @@
                 <a:cs typeface="Malgun Gothic"/>
               </a:rPr>
               <a:t>MCP 도구 호출은 LangSmith에 따로 잡히지 않는다 (한계)</a:t>
+            </a:r>
+          </a:p>
+        </p:txBody>
+      </p:sp>
+    </p:spTree>
+  </p:cSld>
+  <p:clrMapOvr>
+    <a:masterClrMapping/>
+  </p:clrMapOvr>
+</p:sld>
+</file>
+
+<file path=ppt/slides/slide9.xml><?xml version="1.0" encoding="utf-8"?>
+<p:sld xmlns:a="http://schemas.openxmlformats.org/drawingml/2006/main" xmlns:p="http://schemas.openxmlformats.org/presentationml/2006/main" xmlns:r="http://schemas.openxmlformats.org/officeDocument/2006/relationships">
+  <p:cSld>
+    <p:bg>
+      <p:bgPr>
+        <a:solidFill>
+          <a:srgbClr val="FFFFFF"/>
+        </a:solidFill>
+        <a:effectLst/>
+      </p:bgPr>
+    </p:bg>
+    <p:spTree>
+      <p:nvGrpSpPr>
+        <p:cNvPr id="1" name=""/>
+        <p:cNvGrpSpPr/>
+        <p:nvPr/>
+      </p:nvGrpSpPr>
+      <p:grpSpPr/>
+      <p:sp>
+        <p:nvSpPr>
+          <p:cNvPr id="2" name="TextBox 1"/>
+          <p:cNvSpPr txBox="1"/>
+          <p:nvPr/>
+        </p:nvSpPr>
+        <p:spPr>
+          <a:xfrm>
+            <a:off x="548640" y="347472"/>
+            <a:ext cx="11064240" cy="868680"/>
+          </a:xfrm>
+          <a:prstGeom prst="rect">
+            <a:avLst/>
+          </a:prstGeom>
+          <a:noFill/>
+        </p:spPr>
+        <p:txBody>
+          <a:bodyPr wrap="square" anchor="ctr" lIns="0" rIns="0" tIns="0" bIns="0">
+            <a:spAutoFit/>
+          </a:bodyPr>
+          <a:lstStyle/>
+          <a:p>
+            <a:pPr algn="l">
+              <a:lnSpc>
+                <a:spcPct val="100000"/>
+              </a:lnSpc>
+            </a:pPr>
+            <a:r>
+              <a:rPr sz="3000" b="1">
+                <a:solidFill>
+                  <a:srgbClr val="1B2437"/>
+                </a:solidFill>
+                <a:latin typeface="Malgun Gothic"/>
+                <a:ea typeface="Malgun Gothic"/>
+                <a:cs typeface="Malgun Gothic"/>
+              </a:rPr>
+              <a:t>[백업] 의존성 주입과 테스트</a:t>
+            </a:r>
+          </a:p>
+        </p:txBody>
+      </p:sp>
+      <p:sp>
+        <p:nvSpPr>
+          <p:cNvPr id="3" name="TextBox 2"/>
+          <p:cNvSpPr txBox="1"/>
+          <p:nvPr/>
+        </p:nvSpPr>
+        <p:spPr>
+          <a:xfrm>
+            <a:off x="548640" y="6428232"/>
+            <a:ext cx="5486400" cy="274320"/>
+          </a:xfrm>
+          <a:prstGeom prst="rect">
+            <a:avLst/>
+          </a:prstGeom>
+          <a:noFill/>
+        </p:spPr>
+        <p:txBody>
+          <a:bodyPr wrap="square" anchor="t" lIns="0" rIns="0" tIns="0" bIns="0">
+            <a:spAutoFit/>
+          </a:bodyPr>
+          <a:lstStyle/>
+          <a:p>
+            <a:pPr algn="l"/>
+            <a:r>
+              <a:rPr sz="1100" b="0">
+                <a:solidFill>
+                  <a:srgbClr val="8A93A8"/>
+                </a:solidFill>
+                <a:latin typeface="Malgun Gothic"/>
+                <a:ea typeface="Malgun Gothic"/>
+                <a:cs typeface="Malgun Gothic"/>
+              </a:rPr>
+              <a:t>광주 3반 G078 문희주  ·  WISH FINDER</a:t>
+            </a:r>
+          </a:p>
+        </p:txBody>
+      </p:sp>
+      <p:sp>
+        <p:nvSpPr>
+          <p:cNvPr id="4" name="TextBox 3"/>
+          <p:cNvSpPr txBox="1"/>
+          <p:nvPr/>
+        </p:nvSpPr>
+        <p:spPr>
+          <a:xfrm>
+            <a:off x="10881360" y="6428232"/>
+            <a:ext cx="777240" cy="274320"/>
+          </a:xfrm>
+          <a:prstGeom prst="rect">
+            <a:avLst/>
+          </a:prstGeom>
+          <a:noFill/>
+        </p:spPr>
+        <p:txBody>
+          <a:bodyPr wrap="square" anchor="t" lIns="0" rIns="0" tIns="0" bIns="0">
+            <a:spAutoFit/>
+          </a:bodyPr>
+          <a:lstStyle/>
+          <a:p>
+            <a:pPr algn="r"/>
+            <a:r>
+              <a:rPr sz="1100" b="0">
+                <a:solidFill>
+                  <a:srgbClr val="8A93A8"/>
+                </a:solidFill>
+                <a:latin typeface="Malgun Gothic"/>
+                <a:ea typeface="Malgun Gothic"/>
+                <a:cs typeface="Malgun Gothic"/>
+              </a:rPr>
+              <a:t>9</a:t>
+            </a:r>
+          </a:p>
+        </p:txBody>
+      </p:sp>
+      <p:sp>
+        <p:nvSpPr>
+          <p:cNvPr id="5" name="Rounded Rectangle 4"/>
+          <p:cNvSpPr/>
+          <p:nvPr/>
+        </p:nvSpPr>
+        <p:spPr>
+          <a:xfrm>
+            <a:off x="548640" y="1371600"/>
+            <a:ext cx="5760720" cy="3200400"/>
+          </a:xfrm>
+          <a:prstGeom prst="roundRect">
+            <a:avLst>
+              <a:gd name="adj" fmla="val 2500"/>
+            </a:avLst>
+          </a:prstGeom>
+          <a:solidFill>
+            <a:srgbClr val="1E2433"/>
+          </a:solidFill>
+          <a:ln>
+            <a:noFill/>
+          </a:ln>
+          <a:effectLst/>
+        </p:spPr>
+        <p:style>
+          <a:lnRef idx="1">
+            <a:schemeClr val="accent1"/>
+          </a:lnRef>
+          <a:fillRef idx="3">
+            <a:schemeClr val="accent1"/>
+          </a:fillRef>
+          <a:effectRef idx="2">
+            <a:schemeClr val="accent1"/>
+          </a:effectRef>
+          <a:fontRef idx="minor">
+            <a:schemeClr val="lt1"/>
+          </a:fontRef>
+        </p:style>
+        <p:txBody>
+          <a:bodyPr rtlCol="0" anchor="ctr"/>
+          <a:lstStyle/>
+          <a:p>
+            <a:pPr algn="ctr"/>
+          </a:p>
+        </p:txBody>
+      </p:sp>
+      <p:sp>
+        <p:nvSpPr>
+          <p:cNvPr id="6" name="TextBox 5"/>
+          <p:cNvSpPr txBox="1"/>
+          <p:nvPr/>
+        </p:nvSpPr>
+        <p:spPr>
+          <a:xfrm>
+            <a:off x="731520" y="1536192"/>
+            <a:ext cx="5394959" cy="2871216"/>
+          </a:xfrm>
+          <a:prstGeom prst="rect">
+            <a:avLst/>
+          </a:prstGeom>
+          <a:noFill/>
+        </p:spPr>
+        <p:txBody>
+          <a:bodyPr wrap="square" anchor="t" lIns="0" rIns="0" tIns="0" bIns="0">
+            <a:spAutoFit/>
+          </a:bodyPr>
+          <a:lstStyle/>
+          <a:p>
+            <a:pPr algn="l">
+              <a:lnSpc>
+                <a:spcPct val="108000"/>
+              </a:lnSpc>
+              <a:spcAft>
+                <a:spcPts val="0"/>
+              </a:spcAft>
+            </a:pPr>
+            <a:r>
+              <a:rPr sz="1300" b="0">
+                <a:solidFill>
+                  <a:srgbClr val="E6E9F2"/>
+                </a:solidFill>
+                <a:latin typeface="Consolas"/>
+                <a:ea typeface="Consolas"/>
+                <a:cs typeface="Consolas"/>
+              </a:rPr>
+              <a:t>class FinderAgent:</a:t>
+            </a:r>
+          </a:p>
+          <a:p>
+            <a:pPr algn="l">
+              <a:lnSpc>
+                <a:spcPct val="108000"/>
+              </a:lnSpc>
+              <a:spcAft>
+                <a:spcPts val="0"/>
+              </a:spcAft>
+            </a:pPr>
+            <a:r>
+              <a:rPr sz="1300" b="0">
+                <a:solidFill>
+                  <a:srgbClr val="9DB7FF"/>
+                </a:solidFill>
+                <a:latin typeface="Consolas"/>
+                <a:ea typeface="Consolas"/>
+                <a:cs typeface="Consolas"/>
+              </a:rPr>
+              <a:t>    def __init__(self, session, metadata, model, *,</a:t>
+            </a:r>
+          </a:p>
+          <a:p>
+            <a:pPr algn="l">
+              <a:lnSpc>
+                <a:spcPct val="108000"/>
+              </a:lnSpc>
+              <a:spcAft>
+                <a:spcPts val="0"/>
+              </a:spcAft>
+            </a:pPr>
+            <a:r>
+              <a:rPr sz="1300" b="0">
+                <a:solidFill>
+                  <a:srgbClr val="E6E9F2"/>
+                </a:solidFill>
+                <a:latin typeface="Consolas"/>
+                <a:ea typeface="Consolas"/>
+                <a:cs typeface="Consolas"/>
+              </a:rPr>
+              <a:t>                 mode='hybrid',</a:t>
+            </a:r>
+          </a:p>
+          <a:p>
+            <a:pPr algn="l">
+              <a:lnSpc>
+                <a:spcPct val="108000"/>
+              </a:lnSpc>
+              <a:spcAft>
+                <a:spcPts val="0"/>
+              </a:spcAft>
+            </a:pPr>
+            <a:r>
+              <a:rPr sz="1300" b="0">
+                <a:solidFill>
+                  <a:srgbClr val="E6E9F2"/>
+                </a:solidFill>
+                <a:latin typeface="Consolas"/>
+                <a:ea typeface="Consolas"/>
+                <a:cs typeface="Consolas"/>
+              </a:rPr>
+              <a:t>                 tool_call=call_tool,</a:t>
+            </a:r>
+          </a:p>
+          <a:p>
+            <a:pPr algn="l">
+              <a:lnSpc>
+                <a:spcPct val="108000"/>
+              </a:lnSpc>
+              <a:spcAft>
+                <a:spcPts val="0"/>
+              </a:spcAft>
+            </a:pPr>
+            <a:r>
+              <a:rPr sz="1300" b="0">
+                <a:solidFill>
+                  <a:srgbClr val="E6E9F2"/>
+                </a:solidFill>
+                <a:latin typeface="Consolas"/>
+                <a:ea typeface="Consolas"/>
+                <a:cs typeface="Consolas"/>
+              </a:rPr>
+              <a:t>                 timeout=60,</a:t>
+            </a:r>
+          </a:p>
+          <a:p>
+            <a:pPr algn="l">
+              <a:lnSpc>
+                <a:spcPct val="108000"/>
+              </a:lnSpc>
+              <a:spcAft>
+                <a:spcPts val="0"/>
+              </a:spcAft>
+            </a:pPr>
+            <a:r>
+              <a:rPr sz="1300" b="0">
+                <a:solidFill>
+                  <a:srgbClr val="E6E9F2"/>
+                </a:solidFill>
+                <a:latin typeface="Consolas"/>
+                <a:ea typeface="Consolas"/>
+                <a:cs typeface="Consolas"/>
+              </a:rPr>
+              <a:t>                 telemetry=None,</a:t>
+            </a:r>
+          </a:p>
+          <a:p>
+            <a:pPr algn="l">
+              <a:lnSpc>
+                <a:spcPct val="108000"/>
+              </a:lnSpc>
+              <a:spcAft>
+                <a:spcPts val="0"/>
+              </a:spcAft>
+            </a:pPr>
+            <a:r>
+              <a:rPr sz="1300" b="0">
+                <a:solidFill>
+                  <a:srgbClr val="E6E9F2"/>
+                </a:solidFill>
+                <a:latin typeface="Consolas"/>
+                <a:ea typeface="Consolas"/>
+                <a:cs typeface="Consolas"/>
+              </a:rPr>
+              <a:t>                 dual_query=False, ...):</a:t>
+            </a:r>
+          </a:p>
+          <a:p>
+            <a:pPr algn="l">
+              <a:lnSpc>
+                <a:spcPct val="108000"/>
+              </a:lnSpc>
+              <a:spcAft>
+                <a:spcPts val="0"/>
+              </a:spcAft>
+            </a:pPr>
+            <a:r>
+              <a:rPr sz="1300" b="0">
+                <a:solidFill>
+                  <a:srgbClr val="9DB7FF"/>
+                </a:solidFill>
+                <a:latin typeface="Consolas"/>
+                <a:ea typeface="Consolas"/>
+                <a:cs typeface="Consolas"/>
+              </a:rPr>
+              <a:t>        self.session = session   # MCP session</a:t>
+            </a:r>
+          </a:p>
+          <a:p>
+            <a:pPr algn="l">
+              <a:lnSpc>
+                <a:spcPct val="108000"/>
+              </a:lnSpc>
+              <a:spcAft>
+                <a:spcPts val="0"/>
+              </a:spcAft>
+            </a:pPr>
+            <a:r>
+              <a:rPr sz="1300" b="0">
+                <a:solidFill>
+                  <a:srgbClr val="9DB7FF"/>
+                </a:solidFill>
+                <a:latin typeface="Consolas"/>
+                <a:ea typeface="Consolas"/>
+                <a:cs typeface="Consolas"/>
+              </a:rPr>
+              <a:t>        self.model = model       # Ollama | OpenAI</a:t>
+            </a:r>
+          </a:p>
+          <a:p>
+            <a:pPr algn="l">
+              <a:lnSpc>
+                <a:spcPct val="108000"/>
+              </a:lnSpc>
+              <a:spcAft>
+                <a:spcPts val="0"/>
+              </a:spcAft>
+            </a:pPr>
+            <a:r>
+              <a:rPr sz="1300" b="0">
+                <a:solidFill>
+                  <a:srgbClr val="E6E9F2"/>
+                </a:solidFill>
+                <a:latin typeface="Consolas"/>
+                <a:ea typeface="Consolas"/>
+                <a:cs typeface="Consolas"/>
+              </a:rPr>
+              <a:t> </a:t>
+            </a:r>
+          </a:p>
+          <a:p>
+            <a:pPr algn="l">
+              <a:lnSpc>
+                <a:spcPct val="108000"/>
+              </a:lnSpc>
+              <a:spcAft>
+                <a:spcPts val="0"/>
+              </a:spcAft>
+            </a:pPr>
+            <a:r>
+              <a:rPr sz="1300" b="0">
+                <a:solidFill>
+                  <a:srgbClr val="8FA1C7"/>
+                </a:solidFill>
+                <a:latin typeface="Consolas"/>
+                <a:ea typeface="Consolas"/>
+                <a:cs typeface="Consolas"/>
+              </a:rPr>
+              <a:t># production: real session + build_model()</a:t>
+            </a:r>
+          </a:p>
+          <a:p>
+            <a:pPr algn="l">
+              <a:lnSpc>
+                <a:spcPct val="108000"/>
+              </a:lnSpc>
+              <a:spcAft>
+                <a:spcPts val="0"/>
+              </a:spcAft>
+            </a:pPr>
+            <a:r>
+              <a:rPr sz="1300" b="0">
+                <a:solidFill>
+                  <a:srgbClr val="8FA1C7"/>
+                </a:solidFill>
+                <a:latin typeface="Consolas"/>
+                <a:ea typeface="Consolas"/>
+                <a:cs typeface="Consolas"/>
+              </a:rPr>
+              <a:t># tests: FakeSession + ScriptedModel</a:t>
+            </a:r>
+          </a:p>
+        </p:txBody>
+      </p:sp>
+      <p:sp>
+        <p:nvSpPr>
+          <p:cNvPr id="7" name="TextBox 6"/>
+          <p:cNvSpPr txBox="1"/>
+          <p:nvPr/>
+        </p:nvSpPr>
+        <p:spPr>
+          <a:xfrm>
+            <a:off x="548640" y="4626864"/>
+            <a:ext cx="5760720" cy="274320"/>
+          </a:xfrm>
+          <a:prstGeom prst="rect">
+            <a:avLst/>
+          </a:prstGeom>
+          <a:noFill/>
+        </p:spPr>
+        <p:txBody>
+          <a:bodyPr wrap="square" anchor="t" lIns="0" rIns="0" tIns="0" bIns="0">
+            <a:spAutoFit/>
+          </a:bodyPr>
+          <a:lstStyle/>
+          <a:p>
+            <a:pPr algn="l"/>
+            <a:r>
+              <a:rPr sz="1100" b="0">
+                <a:solidFill>
+                  <a:srgbClr val="5B6577"/>
+                </a:solidFill>
+                <a:latin typeface="Malgun Gothic"/>
+                <a:ea typeface="Malgun Gothic"/>
+                <a:cs typeface="Malgun Gothic"/>
+              </a:rPr>
+              <a:t>backend/app/agent/graph.py (발췌)</a:t>
+            </a:r>
+          </a:p>
+        </p:txBody>
+      </p:sp>
+      <p:sp>
+        <p:nvSpPr>
+          <p:cNvPr id="8" name="TextBox 7"/>
+          <p:cNvSpPr txBox="1"/>
+          <p:nvPr/>
+        </p:nvSpPr>
+        <p:spPr>
+          <a:xfrm>
+            <a:off x="548640" y="5029200"/>
+            <a:ext cx="5760720" cy="1188720"/>
+          </a:xfrm>
+          <a:prstGeom prst="rect">
+            <a:avLst/>
+          </a:prstGeom>
+          <a:noFill/>
+        </p:spPr>
+        <p:txBody>
+          <a:bodyPr wrap="square" anchor="t" lIns="0" rIns="0" tIns="0" bIns="0">
+            <a:spAutoFit/>
+          </a:bodyPr>
+          <a:lstStyle/>
+          <a:p>
+            <a:pPr algn="l">
+              <a:spcAft>
+                <a:spcPts val="300"/>
+              </a:spcAft>
+            </a:pPr>
+            <a:r>
+              <a:rPr sz="1600" b="1">
+                <a:solidFill>
+                  <a:srgbClr val="1B2437"/>
+                </a:solidFill>
+                <a:latin typeface="Malgun Gothic"/>
+                <a:ea typeface="Malgun Gothic"/>
+                <a:cs typeface="Malgun Gothic"/>
+              </a:rPr>
+              <a:t>LLM 교체: WISH_LLM_BACKEND 환경변수 하나</a:t>
+            </a:r>
+          </a:p>
+          <a:p>
+            <a:pPr algn="l"/>
+            <a:r>
+              <a:rPr sz="1400" b="0">
+                <a:solidFill>
+                  <a:srgbClr val="5B6577"/>
+                </a:solidFill>
+                <a:latin typeface="Malgun Gothic"/>
+                <a:ea typeface="Malgun Gothic"/>
+                <a:cs typeface="Malgun Gothic"/>
+              </a:rPr>
+              <a:t>Ollama(개발) ↔ OpenAI(제출), 나머지 코드는 그대로</a:t>
+            </a:r>
+          </a:p>
+        </p:txBody>
+      </p:sp>
+      <p:graphicFrame>
+        <p:nvGraphicFramePr>
+          <p:cNvPr id="9" name="Table 8"/>
+          <p:cNvGraphicFramePr>
+            <a:graphicFrameLocks noGrp="1"/>
+          </p:cNvGraphicFramePr>
+          <p:nvPr/>
+        </p:nvGraphicFramePr>
+        <p:xfrm>
+          <a:off x="6583680" y="1417320"/>
+          <a:ext cx="5120640" cy="3200400"/>
+        </p:xfrm>
+        <a:graphic>
+          <a:graphicData uri="http://schemas.openxmlformats.org/drawingml/2006/table">
+            <a:tbl>
+              <a:tblPr firstRow="1" bandRow="0">
+                <a:tableStyleId>{5C22544A-7EE6-4342-B048-85BDC9FD1C3A}</a:tableStyleId>
+              </a:tblPr>
+              <a:tblGrid>
+                <a:gridCol w="3566160"/>
+                <a:gridCol w="1554480"/>
+              </a:tblGrid>
+              <a:tr h="457200">
+                <a:tc>
+                  <a:txBody>
+                    <a:bodyPr wrap="square"/>
+                    <a:lstStyle/>
+                    <a:p>
+                      <a:pPr algn="l"/>
+                      <a:r>
+                        <a:rPr sz="1500" b="1">
+                          <a:solidFill>
+                            <a:srgbClr val="1B2437"/>
+                          </a:solidFill>
+                          <a:latin typeface="Malgun Gothic"/>
+                          <a:ea typeface="Malgun Gothic"/>
+                          <a:cs typeface="Malgun Gothic"/>
+                        </a:rPr>
+                        <a:t>백엔드 테스트 영역</a:t>
+                      </a:r>
+                    </a:p>
+                  </a:txBody>
+                  <a:tcPr marL="91440" marR="91440" marT="36576" marB="36576" anchor="ctr">
+                    <a:lnB w="9525">
+                      <a:solidFill>
+                        <a:srgbClr val="DDE2EC"/>
+                      </a:solidFill>
+                    </a:lnB>
+                    <a:solidFill>
+                      <a:srgbClr val="F3F5F9"/>
+                    </a:solidFill>
+                  </a:tcPr>
+                </a:tc>
+                <a:tc>
+                  <a:txBody>
+                    <a:bodyPr wrap="square"/>
+                    <a:lstStyle/>
+                    <a:p>
+                      <a:pPr algn="ctr"/>
+                      <a:r>
+                        <a:rPr sz="1500" b="1">
+                          <a:solidFill>
+                            <a:srgbClr val="1B2437"/>
+                          </a:solidFill>
+                          <a:latin typeface="Malgun Gothic"/>
+                          <a:ea typeface="Malgun Gothic"/>
+                          <a:cs typeface="Malgun Gothic"/>
+                        </a:rPr>
+                        <a:t>개수</a:t>
+                      </a:r>
+                    </a:p>
+                  </a:txBody>
+                  <a:tcPr marL="91440" marR="91440" marT="36576" marB="36576" anchor="ctr">
+                    <a:lnB w="9525">
+                      <a:solidFill>
+                        <a:srgbClr val="DDE2EC"/>
+                      </a:solidFill>
+                    </a:lnB>
+                    <a:solidFill>
+                      <a:srgbClr val="F3F5F9"/>
+                    </a:solidFill>
+                  </a:tcPr>
+                </a:tc>
+              </a:tr>
+              <a:tr h="457200">
+                <a:tc>
+                  <a:txBody>
+                    <a:bodyPr wrap="square"/>
+                    <a:lstStyle/>
+                    <a:p>
+                      <a:pPr algn="l"/>
+                      <a:r>
+                        <a:rPr sz="1500" b="0">
+                          <a:solidFill>
+                            <a:srgbClr val="1B2437"/>
+                          </a:solidFill>
+                          <a:latin typeface="Malgun Gothic"/>
+                          <a:ea typeface="Malgun Gothic"/>
+                          <a:cs typeface="Malgun Gothic"/>
+                        </a:rPr>
+                        <a:t>Agent 그래프</a:t>
+                      </a:r>
+                    </a:p>
+                  </a:txBody>
+                  <a:tcPr marL="91440" marR="91440" marT="36576" marB="36576" anchor="ctr">
+                    <a:lnB w="9525">
+                      <a:solidFill>
+                        <a:srgbClr val="DDE2EC"/>
+                      </a:solidFill>
+                    </a:lnB>
+                    <a:solidFill>
+                      <a:srgbClr val="FFFFFF"/>
+                    </a:solidFill>
+                  </a:tcPr>
+                </a:tc>
+                <a:tc>
+                  <a:txBody>
+                    <a:bodyPr wrap="square"/>
+                    <a:lstStyle/>
+                    <a:p>
+                      <a:pPr algn="ctr"/>
+                      <a:r>
+                        <a:rPr sz="1500" b="0">
+                          <a:solidFill>
+                            <a:srgbClr val="1B2437"/>
+                          </a:solidFill>
+                          <a:latin typeface="Malgun Gothic"/>
+                          <a:ea typeface="Malgun Gothic"/>
+                          <a:cs typeface="Malgun Gothic"/>
+                        </a:rPr>
+                        <a:t>55</a:t>
+                      </a:r>
+                    </a:p>
+                  </a:txBody>
+                  <a:tcPr marL="91440" marR="91440" marT="36576" marB="36576" anchor="ctr">
+                    <a:lnB w="9525">
+                      <a:solidFill>
+                        <a:srgbClr val="DDE2EC"/>
+                      </a:solidFill>
+                    </a:lnB>
+                    <a:solidFill>
+                      <a:srgbClr val="FFFFFF"/>
+                    </a:solidFill>
+                  </a:tcPr>
+                </a:tc>
+              </a:tr>
+              <a:tr h="457200">
+                <a:tc>
+                  <a:txBody>
+                    <a:bodyPr wrap="square"/>
+                    <a:lstStyle/>
+                    <a:p>
+                      <a:pPr algn="l"/>
+                      <a:r>
+                        <a:rPr sz="1500" b="0">
+                          <a:solidFill>
+                            <a:srgbClr val="1B2437"/>
+                          </a:solidFill>
+                          <a:latin typeface="Malgun Gothic"/>
+                          <a:ea typeface="Malgun Gothic"/>
+                          <a:cs typeface="Malgun Gothic"/>
+                        </a:rPr>
+                        <a:t>LLM 교체</a:t>
+                      </a:r>
+                    </a:p>
+                  </a:txBody>
+                  <a:tcPr marL="91440" marR="91440" marT="36576" marB="36576" anchor="ctr">
+                    <a:lnB w="9525">
+                      <a:solidFill>
+                        <a:srgbClr val="DDE2EC"/>
+                      </a:solidFill>
+                    </a:lnB>
+                    <a:solidFill>
+                      <a:srgbClr val="FFFFFF"/>
+                    </a:solidFill>
+                  </a:tcPr>
+                </a:tc>
+                <a:tc>
+                  <a:txBody>
+                    <a:bodyPr wrap="square"/>
+                    <a:lstStyle/>
+                    <a:p>
+                      <a:pPr algn="ctr"/>
+                      <a:r>
+                        <a:rPr sz="1500" b="0">
+                          <a:solidFill>
+                            <a:srgbClr val="1B2437"/>
+                          </a:solidFill>
+                          <a:latin typeface="Malgun Gothic"/>
+                          <a:ea typeface="Malgun Gothic"/>
+                          <a:cs typeface="Malgun Gothic"/>
+                        </a:rPr>
+                        <a:t>19</a:t>
+                      </a:r>
+                    </a:p>
+                  </a:txBody>
+                  <a:tcPr marL="91440" marR="91440" marT="36576" marB="36576" anchor="ctr">
+                    <a:lnB w="9525">
+                      <a:solidFill>
+                        <a:srgbClr val="DDE2EC"/>
+                      </a:solidFill>
+                    </a:lnB>
+                    <a:solidFill>
+                      <a:srgbClr val="FFFFFF"/>
+                    </a:solidFill>
+                  </a:tcPr>
+                </a:tc>
+              </a:tr>
+              <a:tr h="457200">
+                <a:tc>
+                  <a:txBody>
+                    <a:bodyPr wrap="square"/>
+                    <a:lstStyle/>
+                    <a:p>
+                      <a:pPr algn="l"/>
+                      <a:r>
+                        <a:rPr sz="1500" b="0">
+                          <a:solidFill>
+                            <a:srgbClr val="1B2437"/>
+                          </a:solidFill>
+                          <a:latin typeface="Malgun Gothic"/>
+                          <a:ea typeface="Malgun Gothic"/>
+                          <a:cs typeface="Malgun Gothic"/>
+                        </a:rPr>
+                        <a:t>자막·검색</a:t>
+                      </a:r>
+                    </a:p>
+                  </a:txBody>
+                  <a:tcPr marL="91440" marR="91440" marT="36576" marB="36576" anchor="ctr">
+                    <a:lnB w="9525">
+                      <a:solidFill>
+                        <a:srgbClr val="DDE2EC"/>
+                      </a:solidFill>
+                    </a:lnB>
+                    <a:solidFill>
+                      <a:srgbClr val="FFFFFF"/>
+                    </a:solidFill>
+                  </a:tcPr>
+                </a:tc>
+                <a:tc>
+                  <a:txBody>
+                    <a:bodyPr wrap="square"/>
+                    <a:lstStyle/>
+                    <a:p>
+                      <a:pPr algn="ctr"/>
+                      <a:r>
+                        <a:rPr sz="1500" b="0">
+                          <a:solidFill>
+                            <a:srgbClr val="1B2437"/>
+                          </a:solidFill>
+                          <a:latin typeface="Malgun Gothic"/>
+                          <a:ea typeface="Malgun Gothic"/>
+                          <a:cs typeface="Malgun Gothic"/>
+                        </a:rPr>
+                        <a:t>37</a:t>
+                      </a:r>
+                    </a:p>
+                  </a:txBody>
+                  <a:tcPr marL="91440" marR="91440" marT="36576" marB="36576" anchor="ctr">
+                    <a:lnB w="9525">
+                      <a:solidFill>
+                        <a:srgbClr val="DDE2EC"/>
+                      </a:solidFill>
+                    </a:lnB>
+                    <a:solidFill>
+                      <a:srgbClr val="FFFFFF"/>
+                    </a:solidFill>
+                  </a:tcPr>
+                </a:tc>
+              </a:tr>
+              <a:tr h="457200">
+                <a:tc>
+                  <a:txBody>
+                    <a:bodyPr wrap="square"/>
+                    <a:lstStyle/>
+                    <a:p>
+                      <a:pPr algn="l"/>
+                      <a:r>
+                        <a:rPr sz="1500" b="0">
+                          <a:solidFill>
+                            <a:srgbClr val="1B2437"/>
+                          </a:solidFill>
+                          <a:latin typeface="Malgun Gothic"/>
+                          <a:ea typeface="Malgun Gothic"/>
+                          <a:cs typeface="Malgun Gothic"/>
+                        </a:rPr>
+                        <a:t>설정·API·실시간 전송</a:t>
+                      </a:r>
+                    </a:p>
+                  </a:txBody>
+                  <a:tcPr marL="91440" marR="91440" marT="36576" marB="36576" anchor="ctr">
+                    <a:lnB w="9525">
+                      <a:solidFill>
+                        <a:srgbClr val="DDE2EC"/>
+                      </a:solidFill>
+                    </a:lnB>
+                    <a:solidFill>
+                      <a:srgbClr val="FFFFFF"/>
+                    </a:solidFill>
+                  </a:tcPr>
+                </a:tc>
+                <a:tc>
+                  <a:txBody>
+                    <a:bodyPr wrap="square"/>
+                    <a:lstStyle/>
+                    <a:p>
+                      <a:pPr algn="ctr"/>
+                      <a:r>
+                        <a:rPr sz="1500" b="0">
+                          <a:solidFill>
+                            <a:srgbClr val="1B2437"/>
+                          </a:solidFill>
+                          <a:latin typeface="Malgun Gothic"/>
+                          <a:ea typeface="Malgun Gothic"/>
+                          <a:cs typeface="Malgun Gothic"/>
+                        </a:rPr>
+                        <a:t>33</a:t>
+                      </a:r>
+                    </a:p>
+                  </a:txBody>
+                  <a:tcPr marL="91440" marR="91440" marT="36576" marB="36576" anchor="ctr">
+                    <a:lnB w="9525">
+                      <a:solidFill>
+                        <a:srgbClr val="DDE2EC"/>
+                      </a:solidFill>
+                    </a:lnB>
+                    <a:solidFill>
+                      <a:srgbClr val="FFFFFF"/>
+                    </a:solidFill>
+                  </a:tcPr>
+                </a:tc>
+              </a:tr>
+              <a:tr h="457200">
+                <a:tc>
+                  <a:txBody>
+                    <a:bodyPr wrap="square"/>
+                    <a:lstStyle/>
+                    <a:p>
+                      <a:pPr algn="l"/>
+                      <a:r>
+                        <a:rPr sz="1500" b="0">
+                          <a:solidFill>
+                            <a:srgbClr val="1B2437"/>
+                          </a:solidFill>
+                          <a:latin typeface="Malgun Gothic"/>
+                          <a:ea typeface="Malgun Gothic"/>
+                          <a:cs typeface="Malgun Gothic"/>
+                        </a:rPr>
+                        <a:t>평가 도구</a:t>
+                      </a:r>
+                    </a:p>
+                  </a:txBody>
+                  <a:tcPr marL="91440" marR="91440" marT="36576" marB="36576" anchor="ctr">
+                    <a:lnB w="9525">
+                      <a:solidFill>
+                        <a:srgbClr val="DDE2EC"/>
+                      </a:solidFill>
+                    </a:lnB>
+                    <a:solidFill>
+                      <a:srgbClr val="FFFFFF"/>
+                    </a:solidFill>
+                  </a:tcPr>
+                </a:tc>
+                <a:tc>
+                  <a:txBody>
+                    <a:bodyPr wrap="square"/>
+                    <a:lstStyle/>
+                    <a:p>
+                      <a:pPr algn="ctr"/>
+                      <a:r>
+                        <a:rPr sz="1500" b="0">
+                          <a:solidFill>
+                            <a:srgbClr val="1B2437"/>
+                          </a:solidFill>
+                          <a:latin typeface="Malgun Gothic"/>
+                          <a:ea typeface="Malgun Gothic"/>
+                          <a:cs typeface="Malgun Gothic"/>
+                        </a:rPr>
+                        <a:t>32</a:t>
+                      </a:r>
+                    </a:p>
+                  </a:txBody>
+                  <a:tcPr marL="91440" marR="91440" marT="36576" marB="36576" anchor="ctr">
+                    <a:lnB w="9525">
+                      <a:solidFill>
+                        <a:srgbClr val="DDE2EC"/>
+                      </a:solidFill>
+                    </a:lnB>
+                    <a:solidFill>
+                      <a:srgbClr val="FFFFFF"/>
+                    </a:solidFill>
+                  </a:tcPr>
+                </a:tc>
+              </a:tr>
+              <a:tr h="457200">
+                <a:tc>
+                  <a:txBody>
+                    <a:bodyPr wrap="square"/>
+                    <a:lstStyle/>
+                    <a:p>
+                      <a:pPr algn="l"/>
+                      <a:r>
+                        <a:rPr sz="1500" b="0">
+                          <a:solidFill>
+                            <a:srgbClr val="1B2437"/>
+                          </a:solidFill>
+                          <a:latin typeface="Malgun Gothic"/>
+                          <a:ea typeface="Malgun Gothic"/>
+                          <a:cs typeface="Malgun Gothic"/>
+                        </a:rPr>
+                        <a:t>실제 MCP 통신</a:t>
+                      </a:r>
+                    </a:p>
+                  </a:txBody>
+                  <a:tcPr marL="91440" marR="91440" marT="36576" marB="36576" anchor="ctr">
+                    <a:lnB w="9525">
+                      <a:solidFill>
+                        <a:srgbClr val="DDE2EC"/>
+                      </a:solidFill>
+                    </a:lnB>
+                    <a:solidFill>
+                      <a:srgbClr val="FFFFFF"/>
+                    </a:solidFill>
+                  </a:tcPr>
+                </a:tc>
+                <a:tc>
+                  <a:txBody>
+                    <a:bodyPr wrap="square"/>
+                    <a:lstStyle/>
+                    <a:p>
+                      <a:pPr algn="ctr"/>
+                      <a:r>
+                        <a:rPr sz="1500" b="0">
+                          <a:solidFill>
+                            <a:srgbClr val="1B2437"/>
+                          </a:solidFill>
+                          <a:latin typeface="Malgun Gothic"/>
+                          <a:ea typeface="Malgun Gothic"/>
+                          <a:cs typeface="Malgun Gothic"/>
+                        </a:rPr>
+                        <a:t>2</a:t>
+                      </a:r>
+                    </a:p>
+                  </a:txBody>
+                  <a:tcPr marL="91440" marR="91440" marT="36576" marB="36576" anchor="ctr">
+                    <a:lnB w="9525">
+                      <a:solidFill>
+                        <a:srgbClr val="DDE2EC"/>
+                      </a:solidFill>
+                    </a:lnB>
+                    <a:solidFill>
+                      <a:srgbClr val="FFFFFF"/>
+                    </a:solidFill>
+                  </a:tcPr>
+                </a:tc>
+              </a:tr>
+            </a:tbl>
+          </a:graphicData>
+        </a:graphic>
+      </p:graphicFrame>
+      <p:sp>
+        <p:nvSpPr>
+          <p:cNvPr id="10" name="TextBox 9"/>
+          <p:cNvSpPr txBox="1"/>
+          <p:nvPr/>
+        </p:nvSpPr>
+        <p:spPr>
+          <a:xfrm>
+            <a:off x="6583680" y="4754880"/>
+            <a:ext cx="5120640" cy="1188720"/>
+          </a:xfrm>
+          <a:prstGeom prst="rect">
+            <a:avLst/>
+          </a:prstGeom>
+          <a:noFill/>
+        </p:spPr>
+        <p:txBody>
+          <a:bodyPr wrap="square" anchor="t" lIns="0" rIns="0" tIns="0" bIns="0">
+            <a:spAutoFit/>
+          </a:bodyPr>
+          <a:lstStyle/>
+          <a:p>
+            <a:pPr algn="l">
+              <a:spcAft>
+                <a:spcPts val="300"/>
+              </a:spcAft>
+            </a:pPr>
+            <a:r>
+              <a:rPr sz="1500" b="1">
+                <a:solidFill>
+                  <a:srgbClr val="1B2437"/>
+                </a:solidFill>
+                <a:latin typeface="Malgun Gothic"/>
+                <a:ea typeface="Malgun Gothic"/>
+                <a:cs typeface="Malgun Gothic"/>
+              </a:rPr>
+              <a:t>백엔드 178개 통과 · 프런트 43개 통과</a:t>
+            </a:r>
+          </a:p>
+          <a:p>
+            <a:pPr algn="l"/>
+            <a:r>
+              <a:rPr sz="1300" b="0">
+                <a:solidFill>
+                  <a:srgbClr val="5B6577"/>
+                </a:solidFill>
+                <a:latin typeface="Malgun Gothic"/>
+                <a:ea typeface="Malgun Gothic"/>
+                <a:cs typeface="Malgun Gothic"/>
+              </a:rPr>
+              <a:t>모델은 가짜로 대신해 과금 없음, 실제 stdio MCP 서버 테스트 포함</a:t>
             </a:r>
           </a:p>
         </p:txBody>

</xml_diff>

<commit_message>
docs: align the token row to the C-only basis and rename backup slides to appendix
- Results slide: the input-token row now uses the Agent (C) run only
  (29,351 -> 33,753, +15%), matching the other rows; it no longer sums the
  C and C-ko evaluation runs.
- Rename the "[백업]" slides to "[부록]".
- Regenerate the deck and its PDF preview; update 발표대본.md with the
  author's edits.

Co-Authored-By: Claude Sonnet 5.5 <noreply@anthropic.com>
</commit_message>
<xml_diff>
--- a/docs/exec/G078_문희주_발표.pptx
+++ b/docs/exec/G078_문희주_발표.pptx
@@ -3596,7 +3596,7 @@
                 <a:ea typeface="Malgun Gothic"/>
                 <a:cs typeface="Malgun Gothic"/>
               </a:rPr>
-              <a:t>[백업] 이중 첫 검색: 번역 어휘 차이를 질문 원문 검색으로 보완</a:t>
+              <a:t>[부록] 이중 첫 검색: 번역 어휘 차이를 질문 원문 검색으로 보완</a:t>
             </a:r>
           </a:p>
         </p:txBody>
@@ -4382,7 +4382,7 @@
                 <a:ea typeface="Malgun Gothic"/>
                 <a:cs typeface="Malgun Gothic"/>
               </a:rPr>
-              <a:t>[백업] 기술 요소 정리와 Multi-Agent를 쓰지 않은 이유</a:t>
+              <a:t>[부록] 기술 요소 정리와 Multi-Agent를 쓰지 않은 이유</a:t>
             </a:r>
           </a:p>
         </p:txBody>
@@ -7030,7 +7030,7 @@
                           <a:ea typeface="Malgun Gothic"/>
                           <a:cs typeface="Malgun Gothic"/>
                         </a:rPr>
-                        <a:t>입력 토큰 (C+C-ko)</a:t>
+                        <a:t>입력 토큰</a:t>
                       </a:r>
                     </a:p>
                   </a:txBody>
@@ -7060,7 +7060,7 @@
                           <a:ea typeface="Malgun Gothic"/>
                           <a:cs typeface="Malgun Gothic"/>
                         </a:rPr>
-                        <a:t>56,941</a:t>
+                        <a:t>29,351</a:t>
                       </a:r>
                     </a:p>
                   </a:txBody>
@@ -7090,7 +7090,7 @@
                           <a:ea typeface="Malgun Gothic"/>
                           <a:cs typeface="Malgun Gothic"/>
                         </a:rPr>
-                        <a:t>70,770</a:t>
+                        <a:t>33,753</a:t>
                       </a:r>
                     </a:p>
                   </a:txBody>
@@ -7120,7 +7120,7 @@
                           <a:ea typeface="Malgun Gothic"/>
                           <a:cs typeface="Malgun Gothic"/>
                         </a:rPr>
-                        <a:t>+24%</a:t>
+                        <a:t>+15%</a:t>
                       </a:r>
                     </a:p>
                   </a:txBody>
@@ -12158,7 +12158,7 @@
                 <a:ea typeface="Malgun Gothic"/>
                 <a:cs typeface="Malgun Gothic"/>
               </a:rPr>
-              <a:t>[백업] LangSmith로 노드별 시간·LLM 호출·토큰을 추적했다</a:t>
+              <a:t>[부록] LangSmith로 노드별 시간·LLM 호출·토큰을 추적했다</a:t>
             </a:r>
           </a:p>
         </p:txBody>
@@ -12496,7 +12496,7 @@
                 <a:ea typeface="Malgun Gothic"/>
                 <a:cs typeface="Malgun Gothic"/>
               </a:rPr>
-              <a:t>[백업] 의존성 주입과 테스트</a:t>
+              <a:t>[부록] 의존성 주입과 테스트</a:t>
             </a:r>
           </a:p>
         </p:txBody>

</xml_diff>

<commit_message>
docs: retitle the RAG slide ("pick the representative cue") and update the script
- RAG slide: the title and the last flow step now say that the search picks
  the cue closest to the question; the original text is fetched later by
  the Agent through get_scene_context.
- Regenerate the deck and its PDF preview; update 발표대본.md with the
  author's edits.

Co-Authored-By: Claude Sonnet 5.5 <noreply@anthropic.com>
</commit_message>
<xml_diff>
--- a/docs/exec/G078_문희주_발표.pptx
+++ b/docs/exec/G078_문희주_발표.pptx
@@ -10985,7 +10985,7 @@
                 <a:ea typeface="Malgun Gothic"/>
                 <a:cs typeface="Malgun Gothic"/>
               </a:rPr>
-              <a:t>RAG: 두 검색을 RRF로 합치고 원본 cue로 되돌린다</a:t>
+              <a:t>RAG: 두 검색을 RRF로 합치고 대표 cue를 고른다</a:t>
             </a:r>
           </a:p>
         </p:txBody>
@@ -11632,7 +11632,7 @@
                 <a:ea typeface="Malgun Gothic"/>
                 <a:cs typeface="Malgun Gothic"/>
               </a:rPr>
-              <a:t>원본 cue로 되돌리기</a:t>
+              <a:t>질문과 가장 가까운 cue 고르기</a:t>
             </a:r>
           </a:p>
         </p:txBody>

</xml_diff>